<commit_message>
docs(quick): add QR noise definition slide to presentation
</commit_message>
<xml_diff>
--- a/TP4/docs/presentacion/TP4-presentacion.pptx
+++ b/TP4/docs/presentacion/TP4-presentacion.pptx
@@ -44,6 +44,7 @@
     <p:sldId id="292" r:id="rId43"/>
     <p:sldId id="293" r:id="rId44"/>
     <p:sldId id="294" r:id="rId45"/>
+    <p:sldId id="295" r:id="rId46"/>
   </p:sldIdLst>
   <p:sldSz cx="12191695" cy="6858000" type="screen4x3"/>
   <p:notesSz cx="6858000" cy="9144000"/>
@@ -16861,7 +16862,7 @@
                 </a:solidFill>
                 <a:latin typeface="Calibri"/>
               </a:rPr>
-              <a:t>Hebb no recupera ningún código QR</a:t>
+              <a:t>Cómo deterioramos un código QR</a:t>
             </a:r>
           </a:p>
         </p:txBody>
@@ -16916,8 +16917,244 @@
         </p:nvSpPr>
         <p:spPr>
           <a:xfrm>
-            <a:off x="1251654" y="1600200"/>
-            <a:ext cx="9688386" cy="3840480"/>
+            <a:off x="685800" y="1691640"/>
+            <a:ext cx="5120640" cy="4480560"/>
+          </a:xfrm>
+          <a:prstGeom prst="roundRect">
+            <a:avLst>
+              <a:gd name="adj" fmla="val 5000"/>
+            </a:avLst>
+          </a:prstGeom>
+          <a:solidFill>
+            <a:srgbClr val="3D2B2F"/>
+          </a:solidFill>
+          <a:ln>
+            <a:noFill/>
+          </a:ln>
+          <a:effectLst/>
+        </p:spPr>
+        <p:style>
+          <a:lnRef idx="1">
+            <a:schemeClr val="accent1"/>
+          </a:lnRef>
+          <a:fillRef idx="3">
+            <a:schemeClr val="accent1"/>
+          </a:fillRef>
+          <a:effectRef idx="2">
+            <a:schemeClr val="accent1"/>
+          </a:effectRef>
+          <a:fontRef idx="minor">
+            <a:schemeClr val="lt1"/>
+          </a:fontRef>
+        </p:style>
+        <p:txBody>
+          <a:bodyPr rtlCol="0" anchor="ctr"/>
+          <a:lstStyle/>
+          <a:p>
+            <a:pPr algn="ctr"/>
+          </a:p>
+        </p:txBody>
+      </p:sp>
+      <p:sp>
+        <p:nvSpPr>
+          <p:cNvPr id="10" name="TextBox 9"/>
+          <p:cNvSpPr txBox="1"/>
+          <p:nvPr/>
+        </p:nvSpPr>
+        <p:spPr>
+          <a:xfrm>
+            <a:off x="868680" y="1828800"/>
+            <a:ext cx="4754879" cy="4206240"/>
+          </a:xfrm>
+          <a:prstGeom prst="rect">
+            <a:avLst/>
+          </a:prstGeom>
+          <a:noFill/>
+        </p:spPr>
+        <p:txBody>
+          <a:bodyPr wrap="square" anchor="t" lIns="45720" rIns="45720" tIns="27432" bIns="27432">
+            <a:spAutoFit/>
+          </a:bodyPr>
+          <a:lstStyle/>
+          <a:p>
+            <a:pPr algn="l">
+              <a:lnSpc>
+                <a:spcPct val="105000"/>
+              </a:lnSpc>
+              <a:spcAft>
+                <a:spcPts val="900"/>
+              </a:spcAft>
+            </a:pPr>
+            <a:r>
+              <a:rPr sz="1800" b="1">
+                <a:solidFill>
+                  <a:srgbClr val="FF8A75"/>
+                </a:solidFill>
+                <a:latin typeface="Calibri"/>
+              </a:rPr>
+              <a:t>Funciones de ruido</a:t>
+            </a:r>
+          </a:p>
+          <a:p>
+            <a:pPr algn="l">
+              <a:lnSpc>
+                <a:spcPct val="105000"/>
+              </a:lnSpc>
+              <a:spcAft>
+                <a:spcPts val="900"/>
+              </a:spcAft>
+            </a:pPr>
+            <a:r>
+              <a:rPr sz="1500" b="0">
+                <a:solidFill>
+                  <a:srgbClr val="FF8A75"/>
+                </a:solidFill>
+                <a:latin typeface="Calibri"/>
+              </a:rPr>
+              <a:t>•  </a:t>
+            </a:r>
+            <a:r>
+              <a:rPr sz="1500" b="1">
+                <a:solidFill>
+                  <a:srgbClr val="F6E9E6"/>
+                </a:solidFill>
+                <a:latin typeface="Calibri"/>
+              </a:rPr>
+              <a:t>Ruido aleatorio: </a:t>
+            </a:r>
+            <a:r>
+              <a:rPr sz="1500" b="0">
+                <a:solidFill>
+                  <a:srgbClr val="F6E9E6"/>
+                </a:solidFill>
+                <a:latin typeface="Calibri"/>
+              </a:rPr>
+              <a:t>nivel p entre 0 y 0,5 → se invierten k = round(p · 1369) módulos distintos, elegidos al azar (±1 → ∓1). Ej.: p = 0,05 → 68; p = 0,35 → 479.</a:t>
+            </a:r>
+          </a:p>
+          <a:p>
+            <a:pPr algn="l">
+              <a:lnSpc>
+                <a:spcPct val="105000"/>
+              </a:lnSpc>
+              <a:spcAft>
+                <a:spcPts val="900"/>
+              </a:spcAft>
+            </a:pPr>
+            <a:r>
+              <a:rPr sz="1500" b="0">
+                <a:solidFill>
+                  <a:srgbClr val="FF8A75"/>
+                </a:solidFill>
+                <a:latin typeface="Calibri"/>
+              </a:rPr>
+              <a:t>•  </a:t>
+            </a:r>
+            <a:r>
+              <a:rPr sz="1500" b="1">
+                <a:solidFill>
+                  <a:srgbClr val="F6E9E6"/>
+                </a:solidFill>
+                <a:latin typeface="Calibri"/>
+              </a:rPr>
+              <a:t>Esquina rota: </a:t>
+            </a:r>
+            <a:r>
+              <a:rPr sz="1500" b="0">
+                <a:solidFill>
+                  <a:srgbClr val="F6E9E6"/>
+                </a:solidFill>
+                <a:latin typeface="Calibri"/>
+              </a:rPr>
+              <a:t>triángulo blanco de tamaño 8 a 32 en una de las 4 esquinas.</a:t>
+            </a:r>
+          </a:p>
+          <a:p>
+            <a:pPr algn="l">
+              <a:lnSpc>
+                <a:spcPct val="105000"/>
+              </a:lnSpc>
+              <a:spcAft>
+                <a:spcPts val="900"/>
+              </a:spcAft>
+            </a:pPr>
+            <a:r>
+              <a:rPr sz="1500" b="0">
+                <a:solidFill>
+                  <a:srgbClr val="FF8A75"/>
+                </a:solidFill>
+                <a:latin typeface="Calibri"/>
+              </a:rPr>
+              <a:t>•  </a:t>
+            </a:r>
+            <a:r>
+              <a:rPr sz="1500" b="1">
+                <a:solidFill>
+                  <a:srgbClr val="F6E9E6"/>
+                </a:solidFill>
+                <a:latin typeface="Calibri"/>
+              </a:rPr>
+              <a:t>Mancha: </a:t>
+            </a:r>
+            <a:r>
+              <a:rPr sz="1500" b="0">
+                <a:solidFill>
+                  <a:srgbClr val="F6E9E6"/>
+                </a:solidFill>
+                <a:latin typeface="Calibri"/>
+              </a:rPr>
+              <a:t>bloque negro cuadrado de lado 8 a 24 en una posición al azar.</a:t>
+            </a:r>
+          </a:p>
+          <a:p>
+            <a:pPr algn="l">
+              <a:lnSpc>
+                <a:spcPct val="105000"/>
+              </a:lnSpc>
+              <a:spcAft>
+                <a:spcPts val="900"/>
+              </a:spcAft>
+            </a:pPr>
+            <a:r>
+              <a:rPr sz="1500" b="0">
+                <a:solidFill>
+                  <a:srgbClr val="FF8A75"/>
+                </a:solidFill>
+                <a:latin typeface="Calibri"/>
+              </a:rPr>
+              <a:t>•  </a:t>
+            </a:r>
+            <a:r>
+              <a:rPr sz="1500" b="1">
+                <a:solidFill>
+                  <a:srgbClr val="F6E9E6"/>
+                </a:solidFill>
+                <a:latin typeface="Calibri"/>
+              </a:rPr>
+              <a:t>Recuperada </a:t>
+            </a:r>
+            <a:r>
+              <a:rPr sz="1500" b="0">
+                <a:solidFill>
+                  <a:srgbClr val="F6E9E6"/>
+                </a:solidFill>
+                <a:latin typeface="Calibri"/>
+              </a:rPr>
+              <a:t>si el estado final es exactamente el código de origen. Semilla fija.</a:t>
+            </a:r>
+          </a:p>
+        </p:txBody>
+      </p:sp>
+      <p:sp>
+        <p:nvSpPr>
+          <p:cNvPr id="11" name="Rounded Rectangle 10"/>
+          <p:cNvSpPr/>
+          <p:nvPr/>
+        </p:nvSpPr>
+        <p:spPr>
+          <a:xfrm>
+            <a:off x="7067290" y="1645920"/>
+            <a:ext cx="3223473" cy="4572000"/>
           </a:xfrm>
           <a:prstGeom prst="roundRect">
             <a:avLst>
@@ -16956,7 +17193,7 @@
       </p:sp>
       <p:pic>
         <p:nvPicPr>
-          <p:cNvPr id="10" name="Picture 9" descr="hopfield_qr__hebb_attractor.png"/>
+          <p:cNvPr id="12" name="Picture 11" descr="hopfield_qr__damage_examples.png"/>
           <p:cNvPicPr>
             <a:picLocks noChangeAspect="1"/>
           </p:cNvPicPr>
@@ -16970,102 +17207,14 @@
         </p:blipFill>
         <p:spPr>
           <a:xfrm>
-            <a:off x="1343094" y="1691640"/>
-            <a:ext cx="9505506" cy="3657600"/>
+            <a:off x="7158730" y="1737360"/>
+            <a:ext cx="3040593" cy="4389120"/>
           </a:xfrm>
           <a:prstGeom prst="rect">
             <a:avLst/>
           </a:prstGeom>
         </p:spPr>
       </p:pic>
-      <p:sp>
-        <p:nvSpPr>
-          <p:cNvPr id="11" name="Rounded Rectangle 10"/>
-          <p:cNvSpPr/>
-          <p:nvPr/>
-        </p:nvSpPr>
-        <p:spPr>
-          <a:xfrm>
-            <a:off x="685800" y="5550408"/>
-            <a:ext cx="10820095" cy="713231"/>
-          </a:xfrm>
-          <a:prstGeom prst="roundRect">
-            <a:avLst>
-              <a:gd name="adj" fmla="val 12000"/>
-            </a:avLst>
-          </a:prstGeom>
-          <a:solidFill>
-            <a:srgbClr val="3D2B2F"/>
-          </a:solidFill>
-          <a:ln>
-            <a:noFill/>
-          </a:ln>
-          <a:effectLst/>
-        </p:spPr>
-        <p:style>
-          <a:lnRef idx="1">
-            <a:schemeClr val="accent1"/>
-          </a:lnRef>
-          <a:fillRef idx="3">
-            <a:schemeClr val="accent1"/>
-          </a:fillRef>
-          <a:effectRef idx="2">
-            <a:schemeClr val="accent1"/>
-          </a:effectRef>
-          <a:fontRef idx="minor">
-            <a:schemeClr val="lt1"/>
-          </a:fontRef>
-        </p:style>
-        <p:txBody>
-          <a:bodyPr rtlCol="0" anchor="ctr"/>
-          <a:lstStyle/>
-          <a:p>
-            <a:pPr algn="ctr"/>
-          </a:p>
-        </p:txBody>
-      </p:sp>
-      <p:sp>
-        <p:nvSpPr>
-          <p:cNvPr id="12" name="TextBox 11"/>
-          <p:cNvSpPr txBox="1"/>
-          <p:nvPr/>
-        </p:nvSpPr>
-        <p:spPr>
-          <a:xfrm>
-            <a:off x="868680" y="5550408"/>
-            <a:ext cx="10454335" cy="713231"/>
-          </a:xfrm>
-          <a:prstGeom prst="rect">
-            <a:avLst/>
-          </a:prstGeom>
-          <a:noFill/>
-        </p:spPr>
-        <p:txBody>
-          <a:bodyPr wrap="square" anchor="ctr" lIns="45720" rIns="45720" tIns="27432" bIns="27432">
-            <a:spAutoFit/>
-          </a:bodyPr>
-          <a:lstStyle/>
-          <a:p>
-            <a:pPr algn="l">
-              <a:lnSpc>
-                <a:spcPct val="100000"/>
-              </a:lnSpc>
-              <a:spcAft>
-                <a:spcPts val="0"/>
-              </a:spcAft>
-            </a:pPr>
-            <a:r>
-              <a:rPr sz="1600" b="0">
-                <a:solidFill>
-                  <a:srgbClr val="F6E9E6"/>
-                </a:solidFill>
-                <a:latin typeface="Calibri"/>
-              </a:rPr>
-              <a:t>Ninguno de los 5 códigos es un punto fijo, y 97,47% de las consultas termina en el mismo "QR promedio". Es la interferencia que las letras ortogonales evitaban.</a:t>
-            </a:r>
-          </a:p>
-        </p:txBody>
-      </p:sp>
     </p:spTree>
   </p:cSld>
   <p:clrMapOvr>
@@ -17343,7 +17492,7 @@
                 </a:solidFill>
                 <a:latin typeface="Calibri"/>
               </a:rPr>
-              <a:t>Con pseudoinversa: la misma red, sin interferencia</a:t>
+              <a:t>Hebb no recupera ningún código QR</a:t>
             </a:r>
           </a:p>
         </p:txBody>
@@ -17398,8 +17547,8 @@
         </p:nvSpPr>
         <p:spPr>
           <a:xfrm>
-            <a:off x="685799" y="1668382"/>
-            <a:ext cx="10820095" cy="3429795"/>
+            <a:off x="1251654" y="1600200"/>
+            <a:ext cx="9688386" cy="3840480"/>
           </a:xfrm>
           <a:prstGeom prst="roundRect">
             <a:avLst>
@@ -17438,7 +17587,7 @@
       </p:sp>
       <p:pic>
         <p:nvPicPr>
-          <p:cNvPr id="10" name="Picture 9" descr="hopfield_qr__recovery_vs_noise.png"/>
+          <p:cNvPr id="10" name="Picture 9" descr="hopfield_qr__hebb_attractor.png"/>
           <p:cNvPicPr>
             <a:picLocks noChangeAspect="1"/>
           </p:cNvPicPr>
@@ -17452,8 +17601,8 @@
         </p:blipFill>
         <p:spPr>
           <a:xfrm>
-            <a:off x="777239" y="1759822"/>
-            <a:ext cx="10637215" cy="3246915"/>
+            <a:off x="1343094" y="1691640"/>
+            <a:ext cx="9505506" cy="3657600"/>
           </a:xfrm>
           <a:prstGeom prst="rect">
             <a:avLst/>
@@ -17468,8 +17617,8 @@
         </p:nvSpPr>
         <p:spPr>
           <a:xfrm>
-            <a:off x="685800" y="5276088"/>
-            <a:ext cx="10820095" cy="987551"/>
+            <a:off x="685800" y="5550408"/>
+            <a:ext cx="10820095" cy="713231"/>
           </a:xfrm>
           <a:prstGeom prst="roundRect">
             <a:avLst>
@@ -17514,8 +17663,8 @@
         </p:nvSpPr>
         <p:spPr>
           <a:xfrm>
-            <a:off x="868680" y="5276088"/>
-            <a:ext cx="10454335" cy="987551"/>
+            <a:off x="868680" y="5550408"/>
+            <a:ext cx="10454335" cy="713231"/>
           </a:xfrm>
           <a:prstGeom prst="rect">
             <a:avLst/>
@@ -17543,7 +17692,7 @@
                 </a:solidFill>
                 <a:latin typeface="Calibri"/>
               </a:rPr>
-              <a:t>Los 5 códigos pasan a ser puntos fijos y se recupera todo hasta 0,35 de ruido. No es la regla del curso: prueba que lo que rompe a Hebb es la correlación, no la cantidad de patrones.</a:t>
+              <a:t>Ninguno de los 5 códigos es un punto fijo, y 97,47% de las consultas termina en el mismo "QR promedio". Es la interferencia que las letras ortogonales evitaban.</a:t>
             </a:r>
           </a:p>
         </p:txBody>
@@ -17825,7 +17974,7 @@
                 </a:solidFill>
                 <a:latin typeface="Calibri"/>
               </a:rPr>
-              <a:t>Iteraciones y energía en cada paso</a:t>
+              <a:t>Con pseudoinversa: la misma red, sin interferencia</a:t>
             </a:r>
           </a:p>
         </p:txBody>
@@ -17880,12 +18029,82 @@
         </p:nvSpPr>
         <p:spPr>
           <a:xfrm>
-            <a:off x="685800" y="1691640"/>
-            <a:ext cx="4023360" cy="4480560"/>
+            <a:off x="685799" y="1668382"/>
+            <a:ext cx="10820095" cy="3429795"/>
           </a:xfrm>
           <a:prstGeom prst="roundRect">
             <a:avLst>
-              <a:gd name="adj" fmla="val 5000"/>
+              <a:gd name="adj" fmla="val 3000"/>
+            </a:avLst>
+          </a:prstGeom>
+          <a:solidFill>
+            <a:srgbClr val="FFFFFF"/>
+          </a:solidFill>
+          <a:ln>
+            <a:noFill/>
+          </a:ln>
+          <a:effectLst/>
+        </p:spPr>
+        <p:style>
+          <a:lnRef idx="1">
+            <a:schemeClr val="accent1"/>
+          </a:lnRef>
+          <a:fillRef idx="3">
+            <a:schemeClr val="accent1"/>
+          </a:fillRef>
+          <a:effectRef idx="2">
+            <a:schemeClr val="accent1"/>
+          </a:effectRef>
+          <a:fontRef idx="minor">
+            <a:schemeClr val="lt1"/>
+          </a:fontRef>
+        </p:style>
+        <p:txBody>
+          <a:bodyPr rtlCol="0" anchor="ctr"/>
+          <a:lstStyle/>
+          <a:p>
+            <a:pPr algn="ctr"/>
+          </a:p>
+        </p:txBody>
+      </p:sp>
+      <p:pic>
+        <p:nvPicPr>
+          <p:cNvPr id="10" name="Picture 9" descr="hopfield_qr__recovery_vs_noise.png"/>
+          <p:cNvPicPr>
+            <a:picLocks noChangeAspect="1"/>
+          </p:cNvPicPr>
+          <p:nvPr/>
+        </p:nvPicPr>
+        <p:blipFill>
+          <a:blip r:embed="rId2"/>
+          <a:stretch>
+            <a:fillRect/>
+          </a:stretch>
+        </p:blipFill>
+        <p:spPr>
+          <a:xfrm>
+            <a:off x="777239" y="1759822"/>
+            <a:ext cx="10637215" cy="3246915"/>
+          </a:xfrm>
+          <a:prstGeom prst="rect">
+            <a:avLst/>
+          </a:prstGeom>
+        </p:spPr>
+      </p:pic>
+      <p:sp>
+        <p:nvSpPr>
+          <p:cNvPr id="11" name="Rounded Rectangle 10"/>
+          <p:cNvSpPr/>
+          <p:nvPr/>
+        </p:nvSpPr>
+        <p:spPr>
+          <a:xfrm>
+            <a:off x="685800" y="5276088"/>
+            <a:ext cx="10820095" cy="987551"/>
+          </a:xfrm>
+          <a:prstGeom prst="roundRect">
+            <a:avLst>
+              <a:gd name="adj" fmla="val 12000"/>
             </a:avLst>
           </a:prstGeom>
           <a:solidFill>
@@ -17920,200 +18139,46 @@
       </p:sp>
       <p:sp>
         <p:nvSpPr>
-          <p:cNvPr id="10" name="TextBox 9"/>
-          <p:cNvSpPr txBox="1"/>
-          <p:nvPr/>
-        </p:nvSpPr>
-        <p:spPr>
-          <a:xfrm>
-            <a:off x="868680" y="1828800"/>
-            <a:ext cx="3657600" cy="4206240"/>
-          </a:xfrm>
-          <a:prstGeom prst="rect">
-            <a:avLst/>
-          </a:prstGeom>
-          <a:noFill/>
-        </p:spPr>
-        <p:txBody>
-          <a:bodyPr wrap="square" anchor="t" lIns="45720" rIns="45720" tIns="27432" bIns="27432">
+          <p:cNvPr id="12" name="TextBox 11"/>
+          <p:cNvSpPr txBox="1"/>
+          <p:nvPr/>
+        </p:nvSpPr>
+        <p:spPr>
+          <a:xfrm>
+            <a:off x="868680" y="5276088"/>
+            <a:ext cx="10454335" cy="987551"/>
+          </a:xfrm>
+          <a:prstGeom prst="rect">
+            <a:avLst/>
+          </a:prstGeom>
+          <a:noFill/>
+        </p:spPr>
+        <p:txBody>
+          <a:bodyPr wrap="square" anchor="ctr" lIns="45720" rIns="45720" tIns="27432" bIns="27432">
             <a:spAutoFit/>
           </a:bodyPr>
           <a:lstStyle/>
           <a:p>
             <a:pPr algn="l">
               <a:lnSpc>
-                <a:spcPct val="105000"/>
-              </a:lnSpc>
-              <a:spcAft>
-                <a:spcPts val="900"/>
-              </a:spcAft>
-            </a:pPr>
-            <a:r>
-              <a:rPr sz="1900" b="1">
-                <a:solidFill>
-                  <a:srgbClr val="FF8A75"/>
-                </a:solidFill>
-                <a:latin typeface="Calibri"/>
-              </a:rPr>
-              <a:t>Convergencia</a:t>
-            </a:r>
-          </a:p>
-          <a:p>
-            <a:pPr algn="l">
-              <a:lnSpc>
-                <a:spcPct val="105000"/>
-              </a:lnSpc>
-              <a:spcAft>
-                <a:spcPts val="900"/>
+                <a:spcPct val="100000"/>
+              </a:lnSpc>
+              <a:spcAft>
+                <a:spcPts val="0"/>
               </a:spcAft>
             </a:pPr>
             <a:r>
               <a:rPr sz="1600" b="0">
                 <a:solidFill>
-                  <a:srgbClr val="FF8A75"/>
-                </a:solidFill>
-                <a:latin typeface="Calibri"/>
-              </a:rPr>
-              <a:t>•  </a:t>
-            </a:r>
-            <a:r>
-              <a:rPr sz="1600" b="0">
-                <a:solidFill>
                   <a:srgbClr val="F6E9E6"/>
                 </a:solidFill>
                 <a:latin typeface="Calibri"/>
               </a:rPr>
-              <a:t>La energía no sube en ningún paso.</a:t>
-            </a:r>
-          </a:p>
-          <a:p>
-            <a:pPr algn="l">
-              <a:lnSpc>
-                <a:spcPct val="105000"/>
-              </a:lnSpc>
-              <a:spcAft>
-                <a:spcPts val="900"/>
-              </a:spcAft>
-            </a:pPr>
-            <a:r>
-              <a:rPr sz="1600" b="0">
-                <a:solidFill>
-                  <a:srgbClr val="FF8A75"/>
-                </a:solidFill>
-                <a:latin typeface="Calibri"/>
-              </a:rPr>
-              <a:t>•  </a:t>
-            </a:r>
-            <a:r>
-              <a:rPr sz="1600" b="0">
-                <a:solidFill>
-                  <a:srgbClr val="F6E9E6"/>
-                </a:solidFill>
-                <a:latin typeface="Calibri"/>
-              </a:rPr>
-              <a:t>Casi todas las consultas convergen en pocos barridos.</a:t>
-            </a:r>
-          </a:p>
-          <a:p>
-            <a:pPr algn="l">
-              <a:lnSpc>
-                <a:spcPct val="105000"/>
-              </a:lnSpc>
-              <a:spcAft>
-                <a:spcPts val="900"/>
-              </a:spcAft>
-            </a:pPr>
-            <a:r>
-              <a:rPr sz="1600" b="0">
-                <a:solidFill>
-                  <a:srgbClr val="FF8A75"/>
-                </a:solidFill>
-                <a:latin typeface="Calibri"/>
-              </a:rPr>
-              <a:t>•  </a:t>
-            </a:r>
-            <a:r>
-              <a:rPr sz="1600" b="0">
-                <a:solidFill>
-                  <a:srgbClr val="F6E9E6"/>
-                </a:solidFill>
-                <a:latin typeface="Calibri"/>
-              </a:rPr>
-              <a:t>Pero la red baja al mínimo más cercano, que con Hebb es el equivocado.</a:t>
-            </a:r>
-          </a:p>
-        </p:txBody>
-      </p:sp>
-      <p:sp>
-        <p:nvSpPr>
-          <p:cNvPr id="11" name="Rounded Rectangle 10"/>
-          <p:cNvSpPr/>
-          <p:nvPr/>
-        </p:nvSpPr>
-        <p:spPr>
-          <a:xfrm>
-            <a:off x="4983480" y="2702663"/>
-            <a:ext cx="6293815" cy="2458512"/>
-          </a:xfrm>
-          <a:prstGeom prst="roundRect">
-            <a:avLst>
-              <a:gd name="adj" fmla="val 3000"/>
-            </a:avLst>
-          </a:prstGeom>
-          <a:solidFill>
-            <a:srgbClr val="FFFFFF"/>
-          </a:solidFill>
-          <a:ln>
-            <a:noFill/>
-          </a:ln>
-          <a:effectLst/>
-        </p:spPr>
-        <p:style>
-          <a:lnRef idx="1">
-            <a:schemeClr val="accent1"/>
-          </a:lnRef>
-          <a:fillRef idx="3">
-            <a:schemeClr val="accent1"/>
-          </a:fillRef>
-          <a:effectRef idx="2">
-            <a:schemeClr val="accent1"/>
-          </a:effectRef>
-          <a:fontRef idx="minor">
-            <a:schemeClr val="lt1"/>
-          </a:fontRef>
-        </p:style>
-        <p:txBody>
-          <a:bodyPr rtlCol="0" anchor="ctr"/>
-          <a:lstStyle/>
-          <a:p>
-            <a:pPr algn="ctr"/>
-          </a:p>
-        </p:txBody>
-      </p:sp>
-      <p:pic>
-        <p:nvPicPr>
-          <p:cNvPr id="12" name="Picture 11" descr="hopfield_qr__energy_per_step.png"/>
-          <p:cNvPicPr>
-            <a:picLocks noChangeAspect="1"/>
-          </p:cNvPicPr>
-          <p:nvPr/>
-        </p:nvPicPr>
-        <p:blipFill>
-          <a:blip r:embed="rId2"/>
-          <a:stretch>
-            <a:fillRect/>
-          </a:stretch>
-        </p:blipFill>
-        <p:spPr>
-          <a:xfrm>
-            <a:off x="5074920" y="2794103"/>
-            <a:ext cx="6110935" cy="2275632"/>
-          </a:xfrm>
-          <a:prstGeom prst="rect">
-            <a:avLst/>
-          </a:prstGeom>
-        </p:spPr>
-      </p:pic>
+              <a:t>Los 5 códigos pasan a ser puntos fijos y se recupera todo hasta 0,35 de ruido. No es la regla del curso: prueba que lo que rompe a Hebb es la correlación, no la cantidad de patrones.</a:t>
+            </a:r>
+          </a:p>
+        </p:txBody>
+      </p:sp>
     </p:spTree>
   </p:cSld>
   <p:clrMapOvr>
@@ -18391,7 +18456,7 @@
                 </a:solidFill>
                 <a:latin typeface="Calibri"/>
               </a:rPr>
-              <a:t>Lectura con un decodificador QR</a:t>
+              <a:t>Iteraciones y energía en cada paso</a:t>
             </a:r>
           </a:p>
         </p:txBody>
@@ -18446,8 +18511,180 @@
         </p:nvSpPr>
         <p:spPr>
           <a:xfrm>
-            <a:off x="818596" y="1600199"/>
-            <a:ext cx="10554503" cy="3566160"/>
+            <a:off x="685800" y="1691640"/>
+            <a:ext cx="4023360" cy="4480560"/>
+          </a:xfrm>
+          <a:prstGeom prst="roundRect">
+            <a:avLst>
+              <a:gd name="adj" fmla="val 5000"/>
+            </a:avLst>
+          </a:prstGeom>
+          <a:solidFill>
+            <a:srgbClr val="3D2B2F"/>
+          </a:solidFill>
+          <a:ln>
+            <a:noFill/>
+          </a:ln>
+          <a:effectLst/>
+        </p:spPr>
+        <p:style>
+          <a:lnRef idx="1">
+            <a:schemeClr val="accent1"/>
+          </a:lnRef>
+          <a:fillRef idx="3">
+            <a:schemeClr val="accent1"/>
+          </a:fillRef>
+          <a:effectRef idx="2">
+            <a:schemeClr val="accent1"/>
+          </a:effectRef>
+          <a:fontRef idx="minor">
+            <a:schemeClr val="lt1"/>
+          </a:fontRef>
+        </p:style>
+        <p:txBody>
+          <a:bodyPr rtlCol="0" anchor="ctr"/>
+          <a:lstStyle/>
+          <a:p>
+            <a:pPr algn="ctr"/>
+          </a:p>
+        </p:txBody>
+      </p:sp>
+      <p:sp>
+        <p:nvSpPr>
+          <p:cNvPr id="10" name="TextBox 9"/>
+          <p:cNvSpPr txBox="1"/>
+          <p:nvPr/>
+        </p:nvSpPr>
+        <p:spPr>
+          <a:xfrm>
+            <a:off x="868680" y="1828800"/>
+            <a:ext cx="3657600" cy="4206240"/>
+          </a:xfrm>
+          <a:prstGeom prst="rect">
+            <a:avLst/>
+          </a:prstGeom>
+          <a:noFill/>
+        </p:spPr>
+        <p:txBody>
+          <a:bodyPr wrap="square" anchor="t" lIns="45720" rIns="45720" tIns="27432" bIns="27432">
+            <a:spAutoFit/>
+          </a:bodyPr>
+          <a:lstStyle/>
+          <a:p>
+            <a:pPr algn="l">
+              <a:lnSpc>
+                <a:spcPct val="105000"/>
+              </a:lnSpc>
+              <a:spcAft>
+                <a:spcPts val="900"/>
+              </a:spcAft>
+            </a:pPr>
+            <a:r>
+              <a:rPr sz="1900" b="1">
+                <a:solidFill>
+                  <a:srgbClr val="FF8A75"/>
+                </a:solidFill>
+                <a:latin typeface="Calibri"/>
+              </a:rPr>
+              <a:t>Convergencia</a:t>
+            </a:r>
+          </a:p>
+          <a:p>
+            <a:pPr algn="l">
+              <a:lnSpc>
+                <a:spcPct val="105000"/>
+              </a:lnSpc>
+              <a:spcAft>
+                <a:spcPts val="900"/>
+              </a:spcAft>
+            </a:pPr>
+            <a:r>
+              <a:rPr sz="1600" b="0">
+                <a:solidFill>
+                  <a:srgbClr val="FF8A75"/>
+                </a:solidFill>
+                <a:latin typeface="Calibri"/>
+              </a:rPr>
+              <a:t>•  </a:t>
+            </a:r>
+            <a:r>
+              <a:rPr sz="1600" b="0">
+                <a:solidFill>
+                  <a:srgbClr val="F6E9E6"/>
+                </a:solidFill>
+                <a:latin typeface="Calibri"/>
+              </a:rPr>
+              <a:t>La energía no sube en ningún paso.</a:t>
+            </a:r>
+          </a:p>
+          <a:p>
+            <a:pPr algn="l">
+              <a:lnSpc>
+                <a:spcPct val="105000"/>
+              </a:lnSpc>
+              <a:spcAft>
+                <a:spcPts val="900"/>
+              </a:spcAft>
+            </a:pPr>
+            <a:r>
+              <a:rPr sz="1600" b="0">
+                <a:solidFill>
+                  <a:srgbClr val="FF8A75"/>
+                </a:solidFill>
+                <a:latin typeface="Calibri"/>
+              </a:rPr>
+              <a:t>•  </a:t>
+            </a:r>
+            <a:r>
+              <a:rPr sz="1600" b="0">
+                <a:solidFill>
+                  <a:srgbClr val="F6E9E6"/>
+                </a:solidFill>
+                <a:latin typeface="Calibri"/>
+              </a:rPr>
+              <a:t>Casi todas las consultas convergen en pocos barridos.</a:t>
+            </a:r>
+          </a:p>
+          <a:p>
+            <a:pPr algn="l">
+              <a:lnSpc>
+                <a:spcPct val="105000"/>
+              </a:lnSpc>
+              <a:spcAft>
+                <a:spcPts val="900"/>
+              </a:spcAft>
+            </a:pPr>
+            <a:r>
+              <a:rPr sz="1600" b="0">
+                <a:solidFill>
+                  <a:srgbClr val="FF8A75"/>
+                </a:solidFill>
+                <a:latin typeface="Calibri"/>
+              </a:rPr>
+              <a:t>•  </a:t>
+            </a:r>
+            <a:r>
+              <a:rPr sz="1600" b="0">
+                <a:solidFill>
+                  <a:srgbClr val="F6E9E6"/>
+                </a:solidFill>
+                <a:latin typeface="Calibri"/>
+              </a:rPr>
+              <a:t>Pero la red baja al mínimo más cercano, que con Hebb es el equivocado.</a:t>
+            </a:r>
+          </a:p>
+        </p:txBody>
+      </p:sp>
+      <p:sp>
+        <p:nvSpPr>
+          <p:cNvPr id="11" name="Rounded Rectangle 10"/>
+          <p:cNvSpPr/>
+          <p:nvPr/>
+        </p:nvSpPr>
+        <p:spPr>
+          <a:xfrm>
+            <a:off x="4983480" y="2702663"/>
+            <a:ext cx="6293815" cy="2458512"/>
           </a:xfrm>
           <a:prstGeom prst="roundRect">
             <a:avLst>
@@ -18486,7 +18723,7 @@
       </p:sp>
       <p:pic>
         <p:nvPicPr>
-          <p:cNvPr id="10" name="Picture 9" descr="hopfield_qr__decode_vs_noise.png"/>
+          <p:cNvPr id="12" name="Picture 11" descr="hopfield_qr__energy_per_step.png"/>
           <p:cNvPicPr>
             <a:picLocks noChangeAspect="1"/>
           </p:cNvPicPr>
@@ -18500,102 +18737,14 @@
         </p:blipFill>
         <p:spPr>
           <a:xfrm>
-            <a:off x="910036" y="1691639"/>
-            <a:ext cx="10371623" cy="3383280"/>
+            <a:off x="5074920" y="2794103"/>
+            <a:ext cx="6110935" cy="2275632"/>
           </a:xfrm>
           <a:prstGeom prst="rect">
             <a:avLst/>
           </a:prstGeom>
         </p:spPr>
       </p:pic>
-      <p:sp>
-        <p:nvSpPr>
-          <p:cNvPr id="11" name="Rounded Rectangle 10"/>
-          <p:cNvSpPr/>
-          <p:nvPr/>
-        </p:nvSpPr>
-        <p:spPr>
-          <a:xfrm>
-            <a:off x="685800" y="5276088"/>
-            <a:ext cx="10820095" cy="987551"/>
-          </a:xfrm>
-          <a:prstGeom prst="roundRect">
-            <a:avLst>
-              <a:gd name="adj" fmla="val 12000"/>
-            </a:avLst>
-          </a:prstGeom>
-          <a:solidFill>
-            <a:srgbClr val="3D2B2F"/>
-          </a:solidFill>
-          <a:ln>
-            <a:noFill/>
-          </a:ln>
-          <a:effectLst/>
-        </p:spPr>
-        <p:style>
-          <a:lnRef idx="1">
-            <a:schemeClr val="accent1"/>
-          </a:lnRef>
-          <a:fillRef idx="3">
-            <a:schemeClr val="accent1"/>
-          </a:fillRef>
-          <a:effectRef idx="2">
-            <a:schemeClr val="accent1"/>
-          </a:effectRef>
-          <a:fontRef idx="minor">
-            <a:schemeClr val="lt1"/>
-          </a:fontRef>
-        </p:style>
-        <p:txBody>
-          <a:bodyPr rtlCol="0" anchor="ctr"/>
-          <a:lstStyle/>
-          <a:p>
-            <a:pPr algn="ctr"/>
-          </a:p>
-        </p:txBody>
-      </p:sp>
-      <p:sp>
-        <p:nvSpPr>
-          <p:cNvPr id="12" name="TextBox 11"/>
-          <p:cNvSpPr txBox="1"/>
-          <p:nvPr/>
-        </p:nvSpPr>
-        <p:spPr>
-          <a:xfrm>
-            <a:off x="868680" y="5276088"/>
-            <a:ext cx="10454335" cy="987551"/>
-          </a:xfrm>
-          <a:prstGeom prst="rect">
-            <a:avLst/>
-          </a:prstGeom>
-          <a:noFill/>
-        </p:spPr>
-        <p:txBody>
-          <a:bodyPr wrap="square" anchor="ctr" lIns="45720" rIns="45720" tIns="27432" bIns="27432">
-            <a:spAutoFit/>
-          </a:bodyPr>
-          <a:lstStyle/>
-          <a:p>
-            <a:pPr algn="l">
-              <a:lnSpc>
-                <a:spcPct val="100000"/>
-              </a:lnSpc>
-              <a:spcAft>
-                <a:spcPts val="0"/>
-              </a:spcAft>
-            </a:pPr>
-            <a:r>
-              <a:rPr sz="1600" b="0">
-                <a:solidFill>
-                  <a:srgbClr val="F6E9E6"/>
-                </a:solidFill>
-                <a:latin typeface="Calibri"/>
-              </a:rPr>
-              <a:t>El lector decodifica los 5 originales. Tras la pseudoinversa un código se lee igual de bien que se recupera; tras Hebb no lee ninguno: el "QR promedio" falla de manera visible.</a:t>
-            </a:r>
-          </a:p>
-        </p:txBody>
-      </p:sp>
     </p:spTree>
   </p:cSld>
   <p:clrMapOvr>
@@ -18873,7 +19022,7 @@
                 </a:solidFill>
                 <a:latin typeface="Calibri"/>
               </a:rPr>
-              <a:t>Limitaciones del caso de uso</a:t>
+              <a:t>Lectura con un decodificador QR</a:t>
             </a:r>
           </a:p>
         </p:txBody>
@@ -18928,12 +19077,82 @@
         </p:nvSpPr>
         <p:spPr>
           <a:xfrm>
-            <a:off x="685800" y="1737360"/>
-            <a:ext cx="5349240" cy="2103120"/>
+            <a:off x="818596" y="1600199"/>
+            <a:ext cx="10554503" cy="3566160"/>
           </a:xfrm>
           <a:prstGeom prst="roundRect">
             <a:avLst>
-              <a:gd name="adj" fmla="val 7000"/>
+              <a:gd name="adj" fmla="val 3000"/>
+            </a:avLst>
+          </a:prstGeom>
+          <a:solidFill>
+            <a:srgbClr val="FFFFFF"/>
+          </a:solidFill>
+          <a:ln>
+            <a:noFill/>
+          </a:ln>
+          <a:effectLst/>
+        </p:spPr>
+        <p:style>
+          <a:lnRef idx="1">
+            <a:schemeClr val="accent1"/>
+          </a:lnRef>
+          <a:fillRef idx="3">
+            <a:schemeClr val="accent1"/>
+          </a:fillRef>
+          <a:effectRef idx="2">
+            <a:schemeClr val="accent1"/>
+          </a:effectRef>
+          <a:fontRef idx="minor">
+            <a:schemeClr val="lt1"/>
+          </a:fontRef>
+        </p:style>
+        <p:txBody>
+          <a:bodyPr rtlCol="0" anchor="ctr"/>
+          <a:lstStyle/>
+          <a:p>
+            <a:pPr algn="ctr"/>
+          </a:p>
+        </p:txBody>
+      </p:sp>
+      <p:pic>
+        <p:nvPicPr>
+          <p:cNvPr id="10" name="Picture 9" descr="hopfield_qr__decode_vs_noise.png"/>
+          <p:cNvPicPr>
+            <a:picLocks noChangeAspect="1"/>
+          </p:cNvPicPr>
+          <p:nvPr/>
+        </p:nvPicPr>
+        <p:blipFill>
+          <a:blip r:embed="rId2"/>
+          <a:stretch>
+            <a:fillRect/>
+          </a:stretch>
+        </p:blipFill>
+        <p:spPr>
+          <a:xfrm>
+            <a:off x="910036" y="1691639"/>
+            <a:ext cx="10371623" cy="3383280"/>
+          </a:xfrm>
+          <a:prstGeom prst="rect">
+            <a:avLst/>
+          </a:prstGeom>
+        </p:spPr>
+      </p:pic>
+      <p:sp>
+        <p:nvSpPr>
+          <p:cNvPr id="11" name="Rounded Rectangle 10"/>
+          <p:cNvSpPr/>
+          <p:nvPr/>
+        </p:nvSpPr>
+        <p:spPr>
+          <a:xfrm>
+            <a:off x="685800" y="5276088"/>
+            <a:ext cx="10820095" cy="987551"/>
+          </a:xfrm>
+          <a:prstGeom prst="roundRect">
+            <a:avLst>
+              <a:gd name="adj" fmla="val 12000"/>
             </a:avLst>
           </a:prstGeom>
           <a:solidFill>
@@ -18968,22 +19187,22 @@
       </p:sp>
       <p:sp>
         <p:nvSpPr>
-          <p:cNvPr id="10" name="TextBox 9"/>
-          <p:cNvSpPr txBox="1"/>
-          <p:nvPr/>
-        </p:nvSpPr>
-        <p:spPr>
-          <a:xfrm>
-            <a:off x="914400" y="1920240"/>
-            <a:ext cx="4937760" cy="548640"/>
-          </a:xfrm>
-          <a:prstGeom prst="rect">
-            <a:avLst/>
-          </a:prstGeom>
-          <a:noFill/>
-        </p:spPr>
-        <p:txBody>
-          <a:bodyPr wrap="square" anchor="t" lIns="45720" rIns="45720" tIns="27432" bIns="27432">
+          <p:cNvPr id="12" name="TextBox 11"/>
+          <p:cNvSpPr txBox="1"/>
+          <p:nvPr/>
+        </p:nvSpPr>
+        <p:spPr>
+          <a:xfrm>
+            <a:off x="868680" y="5276088"/>
+            <a:ext cx="10454335" cy="987551"/>
+          </a:xfrm>
+          <a:prstGeom prst="rect">
+            <a:avLst/>
+          </a:prstGeom>
+          <a:noFill/>
+        </p:spPr>
+        <p:txBody>
+          <a:bodyPr wrap="square" anchor="ctr" lIns="45720" rIns="45720" tIns="27432" bIns="27432">
             <a:spAutoFit/>
           </a:bodyPr>
           <a:lstStyle/>
@@ -18997,445 +19216,13 @@
               </a:spcAft>
             </a:pPr>
             <a:r>
-              <a:rPr sz="2200" b="1">
-                <a:solidFill>
-                  <a:srgbClr val="FF8A75"/>
-                </a:solidFill>
-                <a:latin typeface="Calibri"/>
-              </a:rPr>
-              <a:t>Correlación entre códigos</a:t>
-            </a:r>
-          </a:p>
-        </p:txBody>
-      </p:sp>
-      <p:sp>
-        <p:nvSpPr>
-          <p:cNvPr id="11" name="TextBox 10"/>
-          <p:cNvSpPr txBox="1"/>
-          <p:nvPr/>
-        </p:nvSpPr>
-        <p:spPr>
-          <a:xfrm>
-            <a:off x="914400" y="2514600"/>
-            <a:ext cx="4937760" cy="1280160"/>
-          </a:xfrm>
-          <a:prstGeom prst="rect">
-            <a:avLst/>
-          </a:prstGeom>
-          <a:noFill/>
-        </p:spPr>
-        <p:txBody>
-          <a:bodyPr wrap="square" anchor="t" lIns="45720" rIns="45720" tIns="27432" bIns="27432">
-            <a:spAutoFit/>
-          </a:bodyPr>
-          <a:lstStyle/>
-          <a:p>
-            <a:pPr algn="l">
-              <a:lnSpc>
-                <a:spcPct val="100000"/>
-              </a:lnSpc>
-              <a:spcAft>
-                <a:spcPts val="0"/>
-              </a:spcAft>
-            </a:pPr>
-            <a:r>
-              <a:rPr sz="1700" b="0">
+              <a:rPr sz="1600" b="0">
                 <a:solidFill>
                   <a:srgbClr val="F6E9E6"/>
                 </a:solidFill>
                 <a:latin typeface="Calibri"/>
               </a:rPr>
-              <a:t>Hebb no guarda ninguno aunque la cota (188,922 patrones) esté muy por encima de cinco.</a:t>
-            </a:r>
-          </a:p>
-        </p:txBody>
-      </p:sp>
-      <p:sp>
-        <p:nvSpPr>
-          <p:cNvPr id="12" name="Rounded Rectangle 11"/>
-          <p:cNvSpPr/>
-          <p:nvPr/>
-        </p:nvSpPr>
-        <p:spPr>
-          <a:xfrm>
-            <a:off x="6217920" y="1737360"/>
-            <a:ext cx="5349240" cy="2103120"/>
-          </a:xfrm>
-          <a:prstGeom prst="roundRect">
-            <a:avLst>
-              <a:gd name="adj" fmla="val 7000"/>
-            </a:avLst>
-          </a:prstGeom>
-          <a:solidFill>
-            <a:srgbClr val="3D2B2F"/>
-          </a:solidFill>
-          <a:ln>
-            <a:noFill/>
-          </a:ln>
-          <a:effectLst/>
-        </p:spPr>
-        <p:style>
-          <a:lnRef idx="1">
-            <a:schemeClr val="accent1"/>
-          </a:lnRef>
-          <a:fillRef idx="3">
-            <a:schemeClr val="accent1"/>
-          </a:fillRef>
-          <a:effectRef idx="2">
-            <a:schemeClr val="accent1"/>
-          </a:effectRef>
-          <a:fontRef idx="minor">
-            <a:schemeClr val="lt1"/>
-          </a:fontRef>
-        </p:style>
-        <p:txBody>
-          <a:bodyPr rtlCol="0" anchor="ctr"/>
-          <a:lstStyle/>
-          <a:p>
-            <a:pPr algn="ctr"/>
-          </a:p>
-        </p:txBody>
-      </p:sp>
-      <p:sp>
-        <p:nvSpPr>
-          <p:cNvPr id="13" name="TextBox 12"/>
-          <p:cNvSpPr txBox="1"/>
-          <p:nvPr/>
-        </p:nvSpPr>
-        <p:spPr>
-          <a:xfrm>
-            <a:off x="6446520" y="1920240"/>
-            <a:ext cx="4937760" cy="548640"/>
-          </a:xfrm>
-          <a:prstGeom prst="rect">
-            <a:avLst/>
-          </a:prstGeom>
-          <a:noFill/>
-        </p:spPr>
-        <p:txBody>
-          <a:bodyPr wrap="square" anchor="t" lIns="45720" rIns="45720" tIns="27432" bIns="27432">
-            <a:spAutoFit/>
-          </a:bodyPr>
-          <a:lstStyle/>
-          <a:p>
-            <a:pPr algn="l">
-              <a:lnSpc>
-                <a:spcPct val="100000"/>
-              </a:lnSpc>
-              <a:spcAft>
-                <a:spcPts val="0"/>
-              </a:spcAft>
-            </a:pPr>
-            <a:r>
-              <a:rPr sz="2200" b="1">
-                <a:solidFill>
-                  <a:srgbClr val="FF8A75"/>
-                </a:solidFill>
-                <a:latin typeface="Calibri"/>
-              </a:rPr>
-              <a:t>Estados espúreos</a:t>
-            </a:r>
-          </a:p>
-        </p:txBody>
-      </p:sp>
-      <p:sp>
-        <p:nvSpPr>
-          <p:cNvPr id="14" name="TextBox 13"/>
-          <p:cNvSpPr txBox="1"/>
-          <p:nvPr/>
-        </p:nvSpPr>
-        <p:spPr>
-          <a:xfrm>
-            <a:off x="6446520" y="2514600"/>
-            <a:ext cx="4937760" cy="1280160"/>
-          </a:xfrm>
-          <a:prstGeom prst="rect">
-            <a:avLst/>
-          </a:prstGeom>
-          <a:noFill/>
-        </p:spPr>
-        <p:txBody>
-          <a:bodyPr wrap="square" anchor="t" lIns="45720" rIns="45720" tIns="27432" bIns="27432">
-            <a:spAutoFit/>
-          </a:bodyPr>
-          <a:lstStyle/>
-          <a:p>
-            <a:pPr algn="l">
-              <a:lnSpc>
-                <a:spcPct val="100000"/>
-              </a:lnSpc>
-              <a:spcAft>
-                <a:spcPts val="0"/>
-              </a:spcAft>
-            </a:pPr>
-            <a:r>
-              <a:rPr sz="1700" b="0">
-                <a:solidFill>
-                  <a:srgbClr val="F6E9E6"/>
-                </a:solidFill>
-                <a:latin typeface="Calibri"/>
-              </a:rPr>
-              <a:t>Con mucho ruido la red termina en mezclas que no son ningún menú.</a:t>
-            </a:r>
-          </a:p>
-        </p:txBody>
-      </p:sp>
-      <p:sp>
-        <p:nvSpPr>
-          <p:cNvPr id="15" name="Rounded Rectangle 14"/>
-          <p:cNvSpPr/>
-          <p:nvPr/>
-        </p:nvSpPr>
-        <p:spPr>
-          <a:xfrm>
-            <a:off x="685800" y="4023360"/>
-            <a:ext cx="5349240" cy="2103120"/>
-          </a:xfrm>
-          <a:prstGeom prst="roundRect">
-            <a:avLst>
-              <a:gd name="adj" fmla="val 7000"/>
-            </a:avLst>
-          </a:prstGeom>
-          <a:solidFill>
-            <a:srgbClr val="3D2B2F"/>
-          </a:solidFill>
-          <a:ln>
-            <a:noFill/>
-          </a:ln>
-          <a:effectLst/>
-        </p:spPr>
-        <p:style>
-          <a:lnRef idx="1">
-            <a:schemeClr val="accent1"/>
-          </a:lnRef>
-          <a:fillRef idx="3">
-            <a:schemeClr val="accent1"/>
-          </a:fillRef>
-          <a:effectRef idx="2">
-            <a:schemeClr val="accent1"/>
-          </a:effectRef>
-          <a:fontRef idx="minor">
-            <a:schemeClr val="lt1"/>
-          </a:fontRef>
-        </p:style>
-        <p:txBody>
-          <a:bodyPr rtlCol="0" anchor="ctr"/>
-          <a:lstStyle/>
-          <a:p>
-            <a:pPr algn="ctr"/>
-          </a:p>
-        </p:txBody>
-      </p:sp>
-      <p:sp>
-        <p:nvSpPr>
-          <p:cNvPr id="16" name="TextBox 15"/>
-          <p:cNvSpPr txBox="1"/>
-          <p:nvPr/>
-        </p:nvSpPr>
-        <p:spPr>
-          <a:xfrm>
-            <a:off x="914400" y="4206240"/>
-            <a:ext cx="4937760" cy="548640"/>
-          </a:xfrm>
-          <a:prstGeom prst="rect">
-            <a:avLst/>
-          </a:prstGeom>
-          <a:noFill/>
-        </p:spPr>
-        <p:txBody>
-          <a:bodyPr wrap="square" anchor="t" lIns="45720" rIns="45720" tIns="27432" bIns="27432">
-            <a:spAutoFit/>
-          </a:bodyPr>
-          <a:lstStyle/>
-          <a:p>
-            <a:pPr algn="l">
-              <a:lnSpc>
-                <a:spcPct val="100000"/>
-              </a:lnSpc>
-              <a:spcAft>
-                <a:spcPts val="0"/>
-              </a:spcAft>
-            </a:pPr>
-            <a:r>
-              <a:rPr sz="2200" b="1">
-                <a:solidFill>
-                  <a:srgbClr val="FF8A75"/>
-                </a:solidFill>
-                <a:latin typeface="Calibri"/>
-              </a:rPr>
-              <a:t>Capacidad efectiva</a:t>
-            </a:r>
-          </a:p>
-        </p:txBody>
-      </p:sp>
-      <p:sp>
-        <p:nvSpPr>
-          <p:cNvPr id="17" name="TextBox 16"/>
-          <p:cNvSpPr txBox="1"/>
-          <p:nvPr/>
-        </p:nvSpPr>
-        <p:spPr>
-          <a:xfrm>
-            <a:off x="914400" y="4800600"/>
-            <a:ext cx="4937760" cy="1280160"/>
-          </a:xfrm>
-          <a:prstGeom prst="rect">
-            <a:avLst/>
-          </a:prstGeom>
-          <a:noFill/>
-        </p:spPr>
-        <p:txBody>
-          <a:bodyPr wrap="square" anchor="t" lIns="45720" rIns="45720" tIns="27432" bIns="27432">
-            <a:spAutoFit/>
-          </a:bodyPr>
-          <a:lstStyle/>
-          <a:p>
-            <a:pPr algn="l">
-              <a:lnSpc>
-                <a:spcPct val="100000"/>
-              </a:lnSpc>
-              <a:spcAft>
-                <a:spcPts val="0"/>
-              </a:spcAft>
-            </a:pPr>
-            <a:r>
-              <a:rPr sz="1700" b="0">
-                <a:solidFill>
-                  <a:srgbClr val="F6E9E6"/>
-                </a:solidFill>
-                <a:latin typeface="Calibri"/>
-              </a:rPr>
-              <a:t>Mucho menor que la cota teórica cuando los patrones se parecen.</a:t>
-            </a:r>
-          </a:p>
-        </p:txBody>
-      </p:sp>
-      <p:sp>
-        <p:nvSpPr>
-          <p:cNvPr id="18" name="Rounded Rectangle 17"/>
-          <p:cNvSpPr/>
-          <p:nvPr/>
-        </p:nvSpPr>
-        <p:spPr>
-          <a:xfrm>
-            <a:off x="6217920" y="4023360"/>
-            <a:ext cx="5349240" cy="2103120"/>
-          </a:xfrm>
-          <a:prstGeom prst="roundRect">
-            <a:avLst>
-              <a:gd name="adj" fmla="val 7000"/>
-            </a:avLst>
-          </a:prstGeom>
-          <a:solidFill>
-            <a:srgbClr val="3D2B2F"/>
-          </a:solidFill>
-          <a:ln>
-            <a:noFill/>
-          </a:ln>
-          <a:effectLst/>
-        </p:spPr>
-        <p:style>
-          <a:lnRef idx="1">
-            <a:schemeClr val="accent1"/>
-          </a:lnRef>
-          <a:fillRef idx="3">
-            <a:schemeClr val="accent1"/>
-          </a:fillRef>
-          <a:effectRef idx="2">
-            <a:schemeClr val="accent1"/>
-          </a:effectRef>
-          <a:fontRef idx="minor">
-            <a:schemeClr val="lt1"/>
-          </a:fontRef>
-        </p:style>
-        <p:txBody>
-          <a:bodyPr rtlCol="0" anchor="ctr"/>
-          <a:lstStyle/>
-          <a:p>
-            <a:pPr algn="ctr"/>
-          </a:p>
-        </p:txBody>
-      </p:sp>
-      <p:sp>
-        <p:nvSpPr>
-          <p:cNvPr id="19" name="TextBox 18"/>
-          <p:cNvSpPr txBox="1"/>
-          <p:nvPr/>
-        </p:nvSpPr>
-        <p:spPr>
-          <a:xfrm>
-            <a:off x="6446520" y="4206240"/>
-            <a:ext cx="4937760" cy="548640"/>
-          </a:xfrm>
-          <a:prstGeom prst="rect">
-            <a:avLst/>
-          </a:prstGeom>
-          <a:noFill/>
-        </p:spPr>
-        <p:txBody>
-          <a:bodyPr wrap="square" anchor="t" lIns="45720" rIns="45720" tIns="27432" bIns="27432">
-            <a:spAutoFit/>
-          </a:bodyPr>
-          <a:lstStyle/>
-          <a:p>
-            <a:pPr algn="l">
-              <a:lnSpc>
-                <a:spcPct val="100000"/>
-              </a:lnSpc>
-              <a:spcAft>
-                <a:spcPts val="0"/>
-              </a:spcAft>
-            </a:pPr>
-            <a:r>
-              <a:rPr sz="2200" b="1">
-                <a:solidFill>
-                  <a:srgbClr val="FF8A75"/>
-                </a:solidFill>
-                <a:latin typeface="Calibri"/>
-              </a:rPr>
-              <a:t>Umbral de ruido</a:t>
-            </a:r>
-          </a:p>
-        </p:txBody>
-      </p:sp>
-      <p:sp>
-        <p:nvSpPr>
-          <p:cNvPr id="20" name="TextBox 19"/>
-          <p:cNvSpPr txBox="1"/>
-          <p:nvPr/>
-        </p:nvSpPr>
-        <p:spPr>
-          <a:xfrm>
-            <a:off x="6446520" y="4800600"/>
-            <a:ext cx="4937760" cy="1280160"/>
-          </a:xfrm>
-          <a:prstGeom prst="rect">
-            <a:avLst/>
-          </a:prstGeom>
-          <a:noFill/>
-        </p:spPr>
-        <p:txBody>
-          <a:bodyPr wrap="square" anchor="t" lIns="45720" rIns="45720" tIns="27432" bIns="27432">
-            <a:spAutoFit/>
-          </a:bodyPr>
-          <a:lstStyle/>
-          <a:p>
-            <a:pPr algn="l">
-              <a:lnSpc>
-                <a:spcPct val="100000"/>
-              </a:lnSpc>
-              <a:spcAft>
-                <a:spcPts val="0"/>
-              </a:spcAft>
-            </a:pPr>
-            <a:r>
-              <a:rPr sz="1700" b="0">
-                <a:solidFill>
-                  <a:srgbClr val="F6E9E6"/>
-                </a:solidFill>
-                <a:latin typeface="Calibri"/>
-              </a:rPr>
-              <a:t>El umbral de 0,35 es el de la pseudoinversa; una foto real no es una matriz limpia y alineada.</a:t>
+              <a:t>El lector decodifica los 5 originales. Tras la pseudoinversa un código se lee igual de bien que se recupera; tras Hebb no lee ninguno: el "QR promedio" falla de manera visible.</a:t>
             </a:r>
           </a:p>
         </p:txBody>
@@ -19688,8 +19475,8 @@
         </p:nvSpPr>
         <p:spPr>
           <a:xfrm>
-            <a:off x="1097280" y="2286000"/>
-            <a:ext cx="9144000" cy="1005840"/>
+            <a:off x="685800" y="320040"/>
+            <a:ext cx="9418320" cy="822960"/>
           </a:xfrm>
           <a:prstGeom prst="rect">
             <a:avLst/>
@@ -19711,13 +19498,13 @@
               </a:spcAft>
             </a:pPr>
             <a:r>
-              <a:rPr sz="6600" b="1">
+              <a:rPr sz="3600" b="1">
                 <a:solidFill>
                   <a:srgbClr val="FFD9D0"/>
                 </a:solidFill>
                 <a:latin typeface="Calibri"/>
               </a:rPr>
-              <a:t>06</a:t>
+              <a:t>Limitaciones del caso de uso</a:t>
             </a:r>
           </a:p>
         </p:txBody>
@@ -19730,8 +19517,8 @@
         </p:nvSpPr>
         <p:spPr>
           <a:xfrm>
-            <a:off x="1097280" y="3246120"/>
-            <a:ext cx="10058400" cy="1188720"/>
+            <a:off x="685800" y="1051560"/>
+            <a:ext cx="9144000" cy="457200"/>
           </a:xfrm>
           <a:prstGeom prst="rect">
             <a:avLst/>
@@ -19753,13 +19540,533 @@
               </a:spcAft>
             </a:pPr>
             <a:r>
-              <a:rPr sz="6000" b="1">
+              <a:rPr sz="2000" b="1">
                 <a:solidFill>
                   <a:srgbClr val="FF8A75"/>
                 </a:solidFill>
                 <a:latin typeface="Calibri"/>
               </a:rPr>
-              <a:t>Conclusiones</a:t>
+              <a:t>05. Hopfield · códigos QR 37×37</a:t>
+            </a:r>
+          </a:p>
+        </p:txBody>
+      </p:sp>
+      <p:sp>
+        <p:nvSpPr>
+          <p:cNvPr id="9" name="Rounded Rectangle 8"/>
+          <p:cNvSpPr/>
+          <p:nvPr/>
+        </p:nvSpPr>
+        <p:spPr>
+          <a:xfrm>
+            <a:off x="685800" y="1737360"/>
+            <a:ext cx="5349240" cy="2103120"/>
+          </a:xfrm>
+          <a:prstGeom prst="roundRect">
+            <a:avLst>
+              <a:gd name="adj" fmla="val 7000"/>
+            </a:avLst>
+          </a:prstGeom>
+          <a:solidFill>
+            <a:srgbClr val="3D2B2F"/>
+          </a:solidFill>
+          <a:ln>
+            <a:noFill/>
+          </a:ln>
+          <a:effectLst/>
+        </p:spPr>
+        <p:style>
+          <a:lnRef idx="1">
+            <a:schemeClr val="accent1"/>
+          </a:lnRef>
+          <a:fillRef idx="3">
+            <a:schemeClr val="accent1"/>
+          </a:fillRef>
+          <a:effectRef idx="2">
+            <a:schemeClr val="accent1"/>
+          </a:effectRef>
+          <a:fontRef idx="minor">
+            <a:schemeClr val="lt1"/>
+          </a:fontRef>
+        </p:style>
+        <p:txBody>
+          <a:bodyPr rtlCol="0" anchor="ctr"/>
+          <a:lstStyle/>
+          <a:p>
+            <a:pPr algn="ctr"/>
+          </a:p>
+        </p:txBody>
+      </p:sp>
+      <p:sp>
+        <p:nvSpPr>
+          <p:cNvPr id="10" name="TextBox 9"/>
+          <p:cNvSpPr txBox="1"/>
+          <p:nvPr/>
+        </p:nvSpPr>
+        <p:spPr>
+          <a:xfrm>
+            <a:off x="914400" y="1920240"/>
+            <a:ext cx="4937760" cy="548640"/>
+          </a:xfrm>
+          <a:prstGeom prst="rect">
+            <a:avLst/>
+          </a:prstGeom>
+          <a:noFill/>
+        </p:spPr>
+        <p:txBody>
+          <a:bodyPr wrap="square" anchor="t" lIns="45720" rIns="45720" tIns="27432" bIns="27432">
+            <a:spAutoFit/>
+          </a:bodyPr>
+          <a:lstStyle/>
+          <a:p>
+            <a:pPr algn="l">
+              <a:lnSpc>
+                <a:spcPct val="100000"/>
+              </a:lnSpc>
+              <a:spcAft>
+                <a:spcPts val="0"/>
+              </a:spcAft>
+            </a:pPr>
+            <a:r>
+              <a:rPr sz="2200" b="1">
+                <a:solidFill>
+                  <a:srgbClr val="FF8A75"/>
+                </a:solidFill>
+                <a:latin typeface="Calibri"/>
+              </a:rPr>
+              <a:t>Correlación entre códigos</a:t>
+            </a:r>
+          </a:p>
+        </p:txBody>
+      </p:sp>
+      <p:sp>
+        <p:nvSpPr>
+          <p:cNvPr id="11" name="TextBox 10"/>
+          <p:cNvSpPr txBox="1"/>
+          <p:nvPr/>
+        </p:nvSpPr>
+        <p:spPr>
+          <a:xfrm>
+            <a:off x="914400" y="2514600"/>
+            <a:ext cx="4937760" cy="1280160"/>
+          </a:xfrm>
+          <a:prstGeom prst="rect">
+            <a:avLst/>
+          </a:prstGeom>
+          <a:noFill/>
+        </p:spPr>
+        <p:txBody>
+          <a:bodyPr wrap="square" anchor="t" lIns="45720" rIns="45720" tIns="27432" bIns="27432">
+            <a:spAutoFit/>
+          </a:bodyPr>
+          <a:lstStyle/>
+          <a:p>
+            <a:pPr algn="l">
+              <a:lnSpc>
+                <a:spcPct val="100000"/>
+              </a:lnSpc>
+              <a:spcAft>
+                <a:spcPts val="0"/>
+              </a:spcAft>
+            </a:pPr>
+            <a:r>
+              <a:rPr sz="1700" b="0">
+                <a:solidFill>
+                  <a:srgbClr val="F6E9E6"/>
+                </a:solidFill>
+                <a:latin typeface="Calibri"/>
+              </a:rPr>
+              <a:t>Hebb no guarda ninguno aunque la cota (188,922 patrones) esté muy por encima de cinco.</a:t>
+            </a:r>
+          </a:p>
+        </p:txBody>
+      </p:sp>
+      <p:sp>
+        <p:nvSpPr>
+          <p:cNvPr id="12" name="Rounded Rectangle 11"/>
+          <p:cNvSpPr/>
+          <p:nvPr/>
+        </p:nvSpPr>
+        <p:spPr>
+          <a:xfrm>
+            <a:off x="6217920" y="1737360"/>
+            <a:ext cx="5349240" cy="2103120"/>
+          </a:xfrm>
+          <a:prstGeom prst="roundRect">
+            <a:avLst>
+              <a:gd name="adj" fmla="val 7000"/>
+            </a:avLst>
+          </a:prstGeom>
+          <a:solidFill>
+            <a:srgbClr val="3D2B2F"/>
+          </a:solidFill>
+          <a:ln>
+            <a:noFill/>
+          </a:ln>
+          <a:effectLst/>
+        </p:spPr>
+        <p:style>
+          <a:lnRef idx="1">
+            <a:schemeClr val="accent1"/>
+          </a:lnRef>
+          <a:fillRef idx="3">
+            <a:schemeClr val="accent1"/>
+          </a:fillRef>
+          <a:effectRef idx="2">
+            <a:schemeClr val="accent1"/>
+          </a:effectRef>
+          <a:fontRef idx="minor">
+            <a:schemeClr val="lt1"/>
+          </a:fontRef>
+        </p:style>
+        <p:txBody>
+          <a:bodyPr rtlCol="0" anchor="ctr"/>
+          <a:lstStyle/>
+          <a:p>
+            <a:pPr algn="ctr"/>
+          </a:p>
+        </p:txBody>
+      </p:sp>
+      <p:sp>
+        <p:nvSpPr>
+          <p:cNvPr id="13" name="TextBox 12"/>
+          <p:cNvSpPr txBox="1"/>
+          <p:nvPr/>
+        </p:nvSpPr>
+        <p:spPr>
+          <a:xfrm>
+            <a:off x="6446520" y="1920240"/>
+            <a:ext cx="4937760" cy="548640"/>
+          </a:xfrm>
+          <a:prstGeom prst="rect">
+            <a:avLst/>
+          </a:prstGeom>
+          <a:noFill/>
+        </p:spPr>
+        <p:txBody>
+          <a:bodyPr wrap="square" anchor="t" lIns="45720" rIns="45720" tIns="27432" bIns="27432">
+            <a:spAutoFit/>
+          </a:bodyPr>
+          <a:lstStyle/>
+          <a:p>
+            <a:pPr algn="l">
+              <a:lnSpc>
+                <a:spcPct val="100000"/>
+              </a:lnSpc>
+              <a:spcAft>
+                <a:spcPts val="0"/>
+              </a:spcAft>
+            </a:pPr>
+            <a:r>
+              <a:rPr sz="2200" b="1">
+                <a:solidFill>
+                  <a:srgbClr val="FF8A75"/>
+                </a:solidFill>
+                <a:latin typeface="Calibri"/>
+              </a:rPr>
+              <a:t>Estados espúreos</a:t>
+            </a:r>
+          </a:p>
+        </p:txBody>
+      </p:sp>
+      <p:sp>
+        <p:nvSpPr>
+          <p:cNvPr id="14" name="TextBox 13"/>
+          <p:cNvSpPr txBox="1"/>
+          <p:nvPr/>
+        </p:nvSpPr>
+        <p:spPr>
+          <a:xfrm>
+            <a:off x="6446520" y="2514600"/>
+            <a:ext cx="4937760" cy="1280160"/>
+          </a:xfrm>
+          <a:prstGeom prst="rect">
+            <a:avLst/>
+          </a:prstGeom>
+          <a:noFill/>
+        </p:spPr>
+        <p:txBody>
+          <a:bodyPr wrap="square" anchor="t" lIns="45720" rIns="45720" tIns="27432" bIns="27432">
+            <a:spAutoFit/>
+          </a:bodyPr>
+          <a:lstStyle/>
+          <a:p>
+            <a:pPr algn="l">
+              <a:lnSpc>
+                <a:spcPct val="100000"/>
+              </a:lnSpc>
+              <a:spcAft>
+                <a:spcPts val="0"/>
+              </a:spcAft>
+            </a:pPr>
+            <a:r>
+              <a:rPr sz="1700" b="0">
+                <a:solidFill>
+                  <a:srgbClr val="F6E9E6"/>
+                </a:solidFill>
+                <a:latin typeface="Calibri"/>
+              </a:rPr>
+              <a:t>Con mucho ruido la red termina en mezclas que no son ningún menú.</a:t>
+            </a:r>
+          </a:p>
+        </p:txBody>
+      </p:sp>
+      <p:sp>
+        <p:nvSpPr>
+          <p:cNvPr id="15" name="Rounded Rectangle 14"/>
+          <p:cNvSpPr/>
+          <p:nvPr/>
+        </p:nvSpPr>
+        <p:spPr>
+          <a:xfrm>
+            <a:off x="685800" y="4023360"/>
+            <a:ext cx="5349240" cy="2103120"/>
+          </a:xfrm>
+          <a:prstGeom prst="roundRect">
+            <a:avLst>
+              <a:gd name="adj" fmla="val 7000"/>
+            </a:avLst>
+          </a:prstGeom>
+          <a:solidFill>
+            <a:srgbClr val="3D2B2F"/>
+          </a:solidFill>
+          <a:ln>
+            <a:noFill/>
+          </a:ln>
+          <a:effectLst/>
+        </p:spPr>
+        <p:style>
+          <a:lnRef idx="1">
+            <a:schemeClr val="accent1"/>
+          </a:lnRef>
+          <a:fillRef idx="3">
+            <a:schemeClr val="accent1"/>
+          </a:fillRef>
+          <a:effectRef idx="2">
+            <a:schemeClr val="accent1"/>
+          </a:effectRef>
+          <a:fontRef idx="minor">
+            <a:schemeClr val="lt1"/>
+          </a:fontRef>
+        </p:style>
+        <p:txBody>
+          <a:bodyPr rtlCol="0" anchor="ctr"/>
+          <a:lstStyle/>
+          <a:p>
+            <a:pPr algn="ctr"/>
+          </a:p>
+        </p:txBody>
+      </p:sp>
+      <p:sp>
+        <p:nvSpPr>
+          <p:cNvPr id="16" name="TextBox 15"/>
+          <p:cNvSpPr txBox="1"/>
+          <p:nvPr/>
+        </p:nvSpPr>
+        <p:spPr>
+          <a:xfrm>
+            <a:off x="914400" y="4206240"/>
+            <a:ext cx="4937760" cy="548640"/>
+          </a:xfrm>
+          <a:prstGeom prst="rect">
+            <a:avLst/>
+          </a:prstGeom>
+          <a:noFill/>
+        </p:spPr>
+        <p:txBody>
+          <a:bodyPr wrap="square" anchor="t" lIns="45720" rIns="45720" tIns="27432" bIns="27432">
+            <a:spAutoFit/>
+          </a:bodyPr>
+          <a:lstStyle/>
+          <a:p>
+            <a:pPr algn="l">
+              <a:lnSpc>
+                <a:spcPct val="100000"/>
+              </a:lnSpc>
+              <a:spcAft>
+                <a:spcPts val="0"/>
+              </a:spcAft>
+            </a:pPr>
+            <a:r>
+              <a:rPr sz="2200" b="1">
+                <a:solidFill>
+                  <a:srgbClr val="FF8A75"/>
+                </a:solidFill>
+                <a:latin typeface="Calibri"/>
+              </a:rPr>
+              <a:t>Capacidad efectiva</a:t>
+            </a:r>
+          </a:p>
+        </p:txBody>
+      </p:sp>
+      <p:sp>
+        <p:nvSpPr>
+          <p:cNvPr id="17" name="TextBox 16"/>
+          <p:cNvSpPr txBox="1"/>
+          <p:nvPr/>
+        </p:nvSpPr>
+        <p:spPr>
+          <a:xfrm>
+            <a:off x="914400" y="4800600"/>
+            <a:ext cx="4937760" cy="1280160"/>
+          </a:xfrm>
+          <a:prstGeom prst="rect">
+            <a:avLst/>
+          </a:prstGeom>
+          <a:noFill/>
+        </p:spPr>
+        <p:txBody>
+          <a:bodyPr wrap="square" anchor="t" lIns="45720" rIns="45720" tIns="27432" bIns="27432">
+            <a:spAutoFit/>
+          </a:bodyPr>
+          <a:lstStyle/>
+          <a:p>
+            <a:pPr algn="l">
+              <a:lnSpc>
+                <a:spcPct val="100000"/>
+              </a:lnSpc>
+              <a:spcAft>
+                <a:spcPts val="0"/>
+              </a:spcAft>
+            </a:pPr>
+            <a:r>
+              <a:rPr sz="1700" b="0">
+                <a:solidFill>
+                  <a:srgbClr val="F6E9E6"/>
+                </a:solidFill>
+                <a:latin typeface="Calibri"/>
+              </a:rPr>
+              <a:t>Mucho menor que la cota teórica cuando los patrones se parecen.</a:t>
+            </a:r>
+          </a:p>
+        </p:txBody>
+      </p:sp>
+      <p:sp>
+        <p:nvSpPr>
+          <p:cNvPr id="18" name="Rounded Rectangle 17"/>
+          <p:cNvSpPr/>
+          <p:nvPr/>
+        </p:nvSpPr>
+        <p:spPr>
+          <a:xfrm>
+            <a:off x="6217920" y="4023360"/>
+            <a:ext cx="5349240" cy="2103120"/>
+          </a:xfrm>
+          <a:prstGeom prst="roundRect">
+            <a:avLst>
+              <a:gd name="adj" fmla="val 7000"/>
+            </a:avLst>
+          </a:prstGeom>
+          <a:solidFill>
+            <a:srgbClr val="3D2B2F"/>
+          </a:solidFill>
+          <a:ln>
+            <a:noFill/>
+          </a:ln>
+          <a:effectLst/>
+        </p:spPr>
+        <p:style>
+          <a:lnRef idx="1">
+            <a:schemeClr val="accent1"/>
+          </a:lnRef>
+          <a:fillRef idx="3">
+            <a:schemeClr val="accent1"/>
+          </a:fillRef>
+          <a:effectRef idx="2">
+            <a:schemeClr val="accent1"/>
+          </a:effectRef>
+          <a:fontRef idx="minor">
+            <a:schemeClr val="lt1"/>
+          </a:fontRef>
+        </p:style>
+        <p:txBody>
+          <a:bodyPr rtlCol="0" anchor="ctr"/>
+          <a:lstStyle/>
+          <a:p>
+            <a:pPr algn="ctr"/>
+          </a:p>
+        </p:txBody>
+      </p:sp>
+      <p:sp>
+        <p:nvSpPr>
+          <p:cNvPr id="19" name="TextBox 18"/>
+          <p:cNvSpPr txBox="1"/>
+          <p:nvPr/>
+        </p:nvSpPr>
+        <p:spPr>
+          <a:xfrm>
+            <a:off x="6446520" y="4206240"/>
+            <a:ext cx="4937760" cy="548640"/>
+          </a:xfrm>
+          <a:prstGeom prst="rect">
+            <a:avLst/>
+          </a:prstGeom>
+          <a:noFill/>
+        </p:spPr>
+        <p:txBody>
+          <a:bodyPr wrap="square" anchor="t" lIns="45720" rIns="45720" tIns="27432" bIns="27432">
+            <a:spAutoFit/>
+          </a:bodyPr>
+          <a:lstStyle/>
+          <a:p>
+            <a:pPr algn="l">
+              <a:lnSpc>
+                <a:spcPct val="100000"/>
+              </a:lnSpc>
+              <a:spcAft>
+                <a:spcPts val="0"/>
+              </a:spcAft>
+            </a:pPr>
+            <a:r>
+              <a:rPr sz="2200" b="1">
+                <a:solidFill>
+                  <a:srgbClr val="FF8A75"/>
+                </a:solidFill>
+                <a:latin typeface="Calibri"/>
+              </a:rPr>
+              <a:t>Umbral de ruido</a:t>
+            </a:r>
+          </a:p>
+        </p:txBody>
+      </p:sp>
+      <p:sp>
+        <p:nvSpPr>
+          <p:cNvPr id="20" name="TextBox 19"/>
+          <p:cNvSpPr txBox="1"/>
+          <p:nvPr/>
+        </p:nvSpPr>
+        <p:spPr>
+          <a:xfrm>
+            <a:off x="6446520" y="4800600"/>
+            <a:ext cx="4937760" cy="1280160"/>
+          </a:xfrm>
+          <a:prstGeom prst="rect">
+            <a:avLst/>
+          </a:prstGeom>
+          <a:noFill/>
+        </p:spPr>
+        <p:txBody>
+          <a:bodyPr wrap="square" anchor="t" lIns="45720" rIns="45720" tIns="27432" bIns="27432">
+            <a:spAutoFit/>
+          </a:bodyPr>
+          <a:lstStyle/>
+          <a:p>
+            <a:pPr algn="l">
+              <a:lnSpc>
+                <a:spcPct val="100000"/>
+              </a:lnSpc>
+              <a:spcAft>
+                <a:spcPts val="0"/>
+              </a:spcAft>
+            </a:pPr>
+            <a:r>
+              <a:rPr sz="1700" b="0">
+                <a:solidFill>
+                  <a:srgbClr val="F6E9E6"/>
+                </a:solidFill>
+                <a:latin typeface="Calibri"/>
+              </a:rPr>
+              <a:t>El umbral de 0,35 es el de la pseudoinversa; una foto real no es una matriz limpia y alineada.</a:t>
             </a:r>
           </a:p>
         </p:txBody>
@@ -20012,8 +20319,8 @@
         </p:nvSpPr>
         <p:spPr>
           <a:xfrm>
-            <a:off x="685800" y="320040"/>
-            <a:ext cx="9418320" cy="822960"/>
+            <a:off x="1097280" y="2286000"/>
+            <a:ext cx="9144000" cy="1005840"/>
           </a:xfrm>
           <a:prstGeom prst="rect">
             <a:avLst/>
@@ -20035,13 +20342,13 @@
               </a:spcAft>
             </a:pPr>
             <a:r>
-              <a:rPr sz="3600" b="1">
+              <a:rPr sz="6600" b="1">
                 <a:solidFill>
                   <a:srgbClr val="FFD9D0"/>
                 </a:solidFill>
                 <a:latin typeface="Calibri"/>
               </a:rPr>
-              <a:t>Ejercicio 1: un eje domina</a:t>
+              <a:t>06</a:t>
             </a:r>
           </a:p>
         </p:txBody>
@@ -20054,8 +20361,8 @@
         </p:nvSpPr>
         <p:spPr>
           <a:xfrm>
-            <a:off x="685800" y="1051560"/>
-            <a:ext cx="9144000" cy="457200"/>
+            <a:off x="1097280" y="3246120"/>
+            <a:ext cx="10058400" cy="1188720"/>
           </a:xfrm>
           <a:prstGeom prst="rect">
             <a:avLst/>
@@ -20077,267 +20384,13 @@
               </a:spcAft>
             </a:pPr>
             <a:r>
-              <a:rPr sz="2000" b="1">
+              <a:rPr sz="6000" b="1">
                 <a:solidFill>
                   <a:srgbClr val="FF8A75"/>
                 </a:solidFill>
                 <a:latin typeface="Calibri"/>
               </a:rPr>
-              <a:t>06. Conclusiones</a:t>
-            </a:r>
-          </a:p>
-        </p:txBody>
-      </p:sp>
-      <p:sp>
-        <p:nvSpPr>
-          <p:cNvPr id="9" name="Rounded Rectangle 8"/>
-          <p:cNvSpPr/>
-          <p:nvPr/>
-        </p:nvSpPr>
-        <p:spPr>
-          <a:xfrm>
-            <a:off x="685800" y="1691640"/>
-            <a:ext cx="10820095" cy="4526280"/>
-          </a:xfrm>
-          <a:prstGeom prst="roundRect">
-            <a:avLst>
-              <a:gd name="adj" fmla="val 5000"/>
-            </a:avLst>
-          </a:prstGeom>
-          <a:solidFill>
-            <a:srgbClr val="3D2B2F"/>
-          </a:solidFill>
-          <a:ln>
-            <a:noFill/>
-          </a:ln>
-          <a:effectLst/>
-        </p:spPr>
-        <p:style>
-          <a:lnRef idx="1">
-            <a:schemeClr val="accent1"/>
-          </a:lnRef>
-          <a:fillRef idx="3">
-            <a:schemeClr val="accent1"/>
-          </a:fillRef>
-          <a:effectRef idx="2">
-            <a:schemeClr val="accent1"/>
-          </a:effectRef>
-          <a:fontRef idx="minor">
-            <a:schemeClr val="lt1"/>
-          </a:fontRef>
-        </p:style>
-        <p:txBody>
-          <a:bodyPr rtlCol="0" anchor="ctr"/>
-          <a:lstStyle/>
-          <a:p>
-            <a:pPr algn="ctr"/>
-          </a:p>
-        </p:txBody>
-      </p:sp>
-      <p:sp>
-        <p:nvSpPr>
-          <p:cNvPr id="10" name="TextBox 9"/>
-          <p:cNvSpPr txBox="1"/>
-          <p:nvPr/>
-        </p:nvSpPr>
-        <p:spPr>
-          <a:xfrm>
-            <a:off x="868680" y="1828800"/>
-            <a:ext cx="10454335" cy="4251960"/>
-          </a:xfrm>
-          <a:prstGeom prst="rect">
-            <a:avLst/>
-          </a:prstGeom>
-          <a:noFill/>
-        </p:spPr>
-        <p:txBody>
-          <a:bodyPr wrap="square" anchor="t" lIns="45720" rIns="45720" tIns="27432" bIns="27432">
-            <a:spAutoFit/>
-          </a:bodyPr>
-          <a:lstStyle/>
-          <a:p>
-            <a:pPr algn="l">
-              <a:lnSpc>
-                <a:spcPct val="105000"/>
-              </a:lnSpc>
-              <a:spcAft>
-                <a:spcPts val="900"/>
-              </a:spcAft>
-            </a:pPr>
-            <a:r>
-              <a:rPr sz="1900" b="0">
-                <a:solidFill>
-                  <a:srgbClr val="FF8A75"/>
-                </a:solidFill>
-                <a:latin typeface="Calibri"/>
-              </a:rPr>
-              <a:t>•  </a:t>
-            </a:r>
-            <a:r>
-              <a:rPr sz="1900" b="1">
-                <a:solidFill>
-                  <a:srgbClr val="F6E9E6"/>
-                </a:solidFill>
-                <a:latin typeface="Calibri"/>
-              </a:rPr>
-              <a:t>PC1 ordena a los creadores por tamaño y estilo </a:t>
-            </a:r>
-            <a:r>
-              <a:rPr sz="1900" b="0">
-                <a:solidFill>
-                  <a:srgbClr val="F6E9E6"/>
-                </a:solidFill>
-                <a:latin typeface="Calibri"/>
-              </a:rPr>
-              <a:t>y concentra 53,2% de la varianza.</a:t>
-            </a:r>
-          </a:p>
-          <a:p>
-            <a:pPr algn="l">
-              <a:lnSpc>
-                <a:spcPct val="105000"/>
-              </a:lnSpc>
-              <a:spcAft>
-                <a:spcPts val="900"/>
-              </a:spcAft>
-            </a:pPr>
-            <a:r>
-              <a:rPr sz="1900" b="0">
-                <a:solidFill>
-                  <a:srgbClr val="FF8A75"/>
-                </a:solidFill>
-                <a:latin typeface="Calibri"/>
-              </a:rPr>
-              <a:t>•  </a:t>
-            </a:r>
-            <a:r>
-              <a:rPr sz="1900" b="1">
-                <a:solidFill>
-                  <a:srgbClr val="F6E9E6"/>
-                </a:solidFill>
-                <a:latin typeface="Calibri"/>
-              </a:rPr>
-              <a:t>Kohonen y Oja encuentran lo mismo: </a:t>
-            </a:r>
-            <a:r>
-              <a:rPr sz="1900" b="0">
-                <a:solidFill>
-                  <a:srgbClr val="F6E9E6"/>
-                </a:solidFill>
-                <a:latin typeface="Calibri"/>
-              </a:rPr>
-              <a:t>las regiones siguen PC1 (0,8314 contra 0,2066) y Oja converge a PC1 (coseno 0,999993).</a:t>
-            </a:r>
-          </a:p>
-          <a:p>
-            <a:pPr algn="l">
-              <a:lnSpc>
-                <a:spcPct val="105000"/>
-              </a:lnSpc>
-              <a:spcAft>
-                <a:spcPts val="900"/>
-              </a:spcAft>
-            </a:pPr>
-            <a:r>
-              <a:rPr sz="1900" b="0">
-                <a:solidFill>
-                  <a:srgbClr val="FF8A75"/>
-                </a:solidFill>
-                <a:latin typeface="Calibri"/>
-              </a:rPr>
-              <a:t>•  </a:t>
-            </a:r>
-            <a:r>
-              <a:rPr sz="1900" b="1">
-                <a:solidFill>
-                  <a:srgbClr val="F6E9E6"/>
-                </a:solidFill>
-                <a:latin typeface="Calibri"/>
-              </a:rPr>
-              <a:t>Por eso ningún índice único decide una campaña: </a:t>
-            </a:r>
-            <a:r>
-              <a:rPr sz="1900" b="0">
-                <a:solidFill>
-                  <a:srgbClr val="F6E9E6"/>
-                </a:solidFill>
-                <a:latin typeface="Calibri"/>
-              </a:rPr>
-              <a:t>el primero del ranking no lo eligió ningún cliente.</a:t>
-            </a:r>
-          </a:p>
-          <a:p>
-            <a:pPr algn="l">
-              <a:lnSpc>
-                <a:spcPct val="105000"/>
-              </a:lnSpc>
-              <a:spcAft>
-                <a:spcPts val="900"/>
-              </a:spcAft>
-            </a:pPr>
-            <a:r>
-              <a:rPr sz="1900" b="0">
-                <a:solidFill>
-                  <a:srgbClr val="FF8A75"/>
-                </a:solidFill>
-                <a:latin typeface="Calibri"/>
-              </a:rPr>
-              <a:t>•  </a:t>
-            </a:r>
-            <a:r>
-              <a:rPr sz="1900" b="1">
-                <a:solidFill>
-                  <a:srgbClr val="F6E9E6"/>
-                </a:solidFill>
-                <a:latin typeface="Calibri"/>
-              </a:rPr>
-              <a:t>Reglas por cliente: </a:t>
-            </a:r>
-            <a:r>
-              <a:rPr sz="1900" b="0">
-                <a:solidFill>
-                  <a:srgbClr val="F6E9E6"/>
-                </a:solidFill>
-                <a:latin typeface="Calibri"/>
-              </a:rPr>
-              <a:t>mejor audiencia argentina que elegir por seguidores en los 4 clientes, y menor costo por mil en fútbol, maquillaje y arte.</a:t>
-            </a:r>
-          </a:p>
-          <a:p>
-            <a:pPr algn="l">
-              <a:lnSpc>
-                <a:spcPct val="105000"/>
-              </a:lnSpc>
-              <a:spcAft>
-                <a:spcPts val="900"/>
-              </a:spcAft>
-            </a:pPr>
-            <a:r>
-              <a:rPr sz="1900" b="0">
-                <a:solidFill>
-                  <a:srgbClr val="FF8A75"/>
-                </a:solidFill>
-                <a:latin typeface="Calibri"/>
-              </a:rPr>
-              <a:t>•  </a:t>
-            </a:r>
-            <a:r>
-              <a:rPr sz="1900" b="1">
-                <a:solidFill>
-                  <a:srgbClr val="F6E9E6"/>
-                </a:solidFill>
-                <a:latin typeface="Calibri"/>
-              </a:rPr>
-              <a:t>Límite: </a:t>
-            </a:r>
-            <a:r>
-              <a:rPr sz="1900" b="0">
-                <a:solidFill>
-                  <a:srgbClr val="F6E9E6"/>
-                </a:solidFill>
-                <a:latin typeface="Calibri"/>
-              </a:rPr>
-              <a:t>todo se argumenta con proxies, sin datos de ventas ni conversión; reglas y umbrales son criterios del grupo.</a:t>
+              <a:t>Conclusiones</a:t>
             </a:r>
           </a:p>
         </p:txBody>
@@ -20619,7 +20672,7 @@
                 </a:solidFill>
                 <a:latin typeface="Calibri"/>
               </a:rPr>
-              <a:t>Ejercicio 2: la ortogonalidad es el hilo</a:t>
+              <a:t>Ejercicio 1: un eje domina</a:t>
             </a:r>
           </a:p>
         </p:txBody>
@@ -20758,7 +20811,7 @@
                 </a:solidFill>
                 <a:latin typeface="Calibri"/>
               </a:rPr>
-              <a:t>Letras: </a:t>
+              <a:t>PC1 ordena a los creadores por tamaño y estilo </a:t>
             </a:r>
             <a:r>
               <a:rPr sz="1900" b="0">
@@ -20767,7 +20820,7 @@
                 </a:solidFill>
                 <a:latin typeface="Calibri"/>
               </a:rPr>
-              <a:t>G, R, T y V (producto interno máximo 1) se recuperan sin errores hasta ruido 0,12; con mucho ruido aparecen estados espúreos.</a:t>
+              <a:t>y concentra 53,2% de la varianza.</a:t>
             </a:r>
           </a:p>
           <a:p>
@@ -20795,7 +20848,7 @@
                 </a:solidFill>
                 <a:latin typeface="Calibri"/>
               </a:rPr>
-              <a:t>QR: </a:t>
+              <a:t>Kohonen y Oja encuentran lo mismo: </a:t>
             </a:r>
             <a:r>
               <a:rPr sz="1900" b="0">
@@ -20804,7 +20857,7 @@
                 </a:solidFill>
                 <a:latin typeface="Calibri"/>
               </a:rPr>
-              <a:t>comparten ~70% de sus módulos; con Hebb ninguno es punto fijo y 97,47% de las consultas cae en el mismo "QR promedio".</a:t>
+              <a:t>las regiones siguen PC1 (0,8314 contra 0,2066) y Oja converge a PC1 (coseno 0,999993).</a:t>
             </a:r>
           </a:p>
           <a:p>
@@ -20832,7 +20885,7 @@
                 </a:solidFill>
                 <a:latin typeface="Calibri"/>
               </a:rPr>
-              <a:t>Pseudoinversa: </a:t>
+              <a:t>Por eso ningún índice único decide una campaña: </a:t>
             </a:r>
             <a:r>
               <a:rPr sz="1900" b="0">
@@ -20841,7 +20894,7 @@
                 </a:solidFill>
                 <a:latin typeface="Calibri"/>
               </a:rPr>
-              <a:t>recupera todo hasta 0,35 de ruido, lo que confirma que la causa es la correlación y no la cantidad.</a:t>
+              <a:t>el primero del ranking no lo eligió ningún cliente.</a:t>
             </a:r>
           </a:p>
           <a:p>
@@ -20869,7 +20922,7 @@
                 </a:solidFill>
                 <a:latin typeface="Calibri"/>
               </a:rPr>
-              <a:t>Caso de uso: </a:t>
+              <a:t>Reglas por cliente: </a:t>
             </a:r>
             <a:r>
               <a:rPr sz="1900" b="0">
@@ -20878,7 +20931,44 @@
                 </a:solidFill>
                 <a:latin typeface="Calibri"/>
               </a:rPr>
-              <a:t>limitado por correlación, estados espúreos, capacidad efectiva y umbral de ruido.</a:t>
+              <a:t>mejor audiencia argentina que elegir por seguidores en los 4 clientes, y menor costo por mil en fútbol, maquillaje y arte.</a:t>
+            </a:r>
+          </a:p>
+          <a:p>
+            <a:pPr algn="l">
+              <a:lnSpc>
+                <a:spcPct val="105000"/>
+              </a:lnSpc>
+              <a:spcAft>
+                <a:spcPts val="900"/>
+              </a:spcAft>
+            </a:pPr>
+            <a:r>
+              <a:rPr sz="1900" b="0">
+                <a:solidFill>
+                  <a:srgbClr val="FF8A75"/>
+                </a:solidFill>
+                <a:latin typeface="Calibri"/>
+              </a:rPr>
+              <a:t>•  </a:t>
+            </a:r>
+            <a:r>
+              <a:rPr sz="1900" b="1">
+                <a:solidFill>
+                  <a:srgbClr val="F6E9E6"/>
+                </a:solidFill>
+                <a:latin typeface="Calibri"/>
+              </a:rPr>
+              <a:t>Límite: </a:t>
+            </a:r>
+            <a:r>
+              <a:rPr sz="1900" b="0">
+                <a:solidFill>
+                  <a:srgbClr val="F6E9E6"/>
+                </a:solidFill>
+                <a:latin typeface="Calibri"/>
+              </a:rPr>
+              <a:t>todo se argumenta con proxies, sin datos de ventas ni conversión; reglas y umbrales son criterios del grupo.</a:t>
             </a:r>
           </a:p>
         </p:txBody>
@@ -21160,7 +21250,7 @@
                 </a:solidFill>
                 <a:latin typeface="Calibri"/>
               </a:rPr>
-              <a:t>¿Preguntas?</a:t>
+              <a:t>Ejercicio 2: la ortogonalidad es el hilo</a:t>
             </a:r>
           </a:p>
         </p:txBody>
@@ -21173,8 +21263,8 @@
         </p:nvSpPr>
         <p:spPr>
           <a:xfrm>
-            <a:off x="1097280" y="2560320"/>
-            <a:ext cx="10058400" cy="1097280"/>
+            <a:off x="685800" y="1051560"/>
+            <a:ext cx="9144000" cy="457200"/>
           </a:xfrm>
           <a:prstGeom prst="rect">
             <a:avLst/>
@@ -21196,27 +21286,73 @@
               </a:spcAft>
             </a:pPr>
             <a:r>
-              <a:rPr sz="6000" b="1">
+              <a:rPr sz="2000" b="1">
                 <a:solidFill>
                   <a:srgbClr val="FF8A75"/>
                 </a:solidFill>
                 <a:latin typeface="Calibri"/>
               </a:rPr>
-              <a:t>¡Gracias!</a:t>
-            </a:r>
-          </a:p>
-        </p:txBody>
-      </p:sp>
-      <p:sp>
-        <p:nvSpPr>
-          <p:cNvPr id="9" name="TextBox 8"/>
-          <p:cNvSpPr txBox="1"/>
-          <p:nvPr/>
-        </p:nvSpPr>
-        <p:spPr>
-          <a:xfrm>
-            <a:off x="1097280" y="3840480"/>
-            <a:ext cx="10058400" cy="914400"/>
+              <a:t>06. Conclusiones</a:t>
+            </a:r>
+          </a:p>
+        </p:txBody>
+      </p:sp>
+      <p:sp>
+        <p:nvSpPr>
+          <p:cNvPr id="9" name="Rounded Rectangle 8"/>
+          <p:cNvSpPr/>
+          <p:nvPr/>
+        </p:nvSpPr>
+        <p:spPr>
+          <a:xfrm>
+            <a:off x="685800" y="1691640"/>
+            <a:ext cx="10820095" cy="4526280"/>
+          </a:xfrm>
+          <a:prstGeom prst="roundRect">
+            <a:avLst>
+              <a:gd name="adj" fmla="val 5000"/>
+            </a:avLst>
+          </a:prstGeom>
+          <a:solidFill>
+            <a:srgbClr val="3D2B2F"/>
+          </a:solidFill>
+          <a:ln>
+            <a:noFill/>
+          </a:ln>
+          <a:effectLst/>
+        </p:spPr>
+        <p:style>
+          <a:lnRef idx="1">
+            <a:schemeClr val="accent1"/>
+          </a:lnRef>
+          <a:fillRef idx="3">
+            <a:schemeClr val="accent1"/>
+          </a:fillRef>
+          <a:effectRef idx="2">
+            <a:schemeClr val="accent1"/>
+          </a:effectRef>
+          <a:fontRef idx="minor">
+            <a:schemeClr val="lt1"/>
+          </a:fontRef>
+        </p:style>
+        <p:txBody>
+          <a:bodyPr rtlCol="0" anchor="ctr"/>
+          <a:lstStyle/>
+          <a:p>
+            <a:pPr algn="ctr"/>
+          </a:p>
+        </p:txBody>
+      </p:sp>
+      <p:sp>
+        <p:nvSpPr>
+          <p:cNvPr id="10" name="TextBox 9"/>
+          <p:cNvSpPr txBox="1"/>
+          <p:nvPr/>
+        </p:nvSpPr>
+        <p:spPr>
+          <a:xfrm>
+            <a:off x="868680" y="1828800"/>
+            <a:ext cx="10454335" cy="4251960"/>
           </a:xfrm>
           <a:prstGeom prst="rect">
             <a:avLst/>
@@ -21231,20 +21367,149 @@
           <a:p>
             <a:pPr algn="l">
               <a:lnSpc>
-                <a:spcPct val="100000"/>
-              </a:lnSpc>
-              <a:spcAft>
-                <a:spcPts val="0"/>
-              </a:spcAft>
-            </a:pPr>
-            <a:r>
-              <a:rPr sz="2000" b="0">
-                <a:solidFill>
-                  <a:srgbClr val="B59A97"/>
-                </a:solidFill>
-                <a:latin typeface="Calibri"/>
-              </a:rPr>
-              <a:t>Todo el trabajo se regenera con un comando: python -m tp4.delivery verify</a:t>
+                <a:spcPct val="105000"/>
+              </a:lnSpc>
+              <a:spcAft>
+                <a:spcPts val="900"/>
+              </a:spcAft>
+            </a:pPr>
+            <a:r>
+              <a:rPr sz="1900" b="0">
+                <a:solidFill>
+                  <a:srgbClr val="FF8A75"/>
+                </a:solidFill>
+                <a:latin typeface="Calibri"/>
+              </a:rPr>
+              <a:t>•  </a:t>
+            </a:r>
+            <a:r>
+              <a:rPr sz="1900" b="1">
+                <a:solidFill>
+                  <a:srgbClr val="F6E9E6"/>
+                </a:solidFill>
+                <a:latin typeface="Calibri"/>
+              </a:rPr>
+              <a:t>Letras: </a:t>
+            </a:r>
+            <a:r>
+              <a:rPr sz="1900" b="0">
+                <a:solidFill>
+                  <a:srgbClr val="F6E9E6"/>
+                </a:solidFill>
+                <a:latin typeface="Calibri"/>
+              </a:rPr>
+              <a:t>G, R, T y V (producto interno máximo 1) se recuperan sin errores hasta ruido 0,12; con mucho ruido aparecen estados espúreos.</a:t>
+            </a:r>
+          </a:p>
+          <a:p>
+            <a:pPr algn="l">
+              <a:lnSpc>
+                <a:spcPct val="105000"/>
+              </a:lnSpc>
+              <a:spcAft>
+                <a:spcPts val="900"/>
+              </a:spcAft>
+            </a:pPr>
+            <a:r>
+              <a:rPr sz="1900" b="0">
+                <a:solidFill>
+                  <a:srgbClr val="FF8A75"/>
+                </a:solidFill>
+                <a:latin typeface="Calibri"/>
+              </a:rPr>
+              <a:t>•  </a:t>
+            </a:r>
+            <a:r>
+              <a:rPr sz="1900" b="1">
+                <a:solidFill>
+                  <a:srgbClr val="F6E9E6"/>
+                </a:solidFill>
+                <a:latin typeface="Calibri"/>
+              </a:rPr>
+              <a:t>QR: </a:t>
+            </a:r>
+            <a:r>
+              <a:rPr sz="1900" b="0">
+                <a:solidFill>
+                  <a:srgbClr val="F6E9E6"/>
+                </a:solidFill>
+                <a:latin typeface="Calibri"/>
+              </a:rPr>
+              <a:t>comparten ~70% de sus módulos; con Hebb ninguno es punto fijo y 97,47% de las consultas cae en el mismo "QR promedio".</a:t>
+            </a:r>
+          </a:p>
+          <a:p>
+            <a:pPr algn="l">
+              <a:lnSpc>
+                <a:spcPct val="105000"/>
+              </a:lnSpc>
+              <a:spcAft>
+                <a:spcPts val="900"/>
+              </a:spcAft>
+            </a:pPr>
+            <a:r>
+              <a:rPr sz="1900" b="0">
+                <a:solidFill>
+                  <a:srgbClr val="FF8A75"/>
+                </a:solidFill>
+                <a:latin typeface="Calibri"/>
+              </a:rPr>
+              <a:t>•  </a:t>
+            </a:r>
+            <a:r>
+              <a:rPr sz="1900" b="1">
+                <a:solidFill>
+                  <a:srgbClr val="F6E9E6"/>
+                </a:solidFill>
+                <a:latin typeface="Calibri"/>
+              </a:rPr>
+              <a:t>Pseudoinversa: </a:t>
+            </a:r>
+            <a:r>
+              <a:rPr sz="1900" b="0">
+                <a:solidFill>
+                  <a:srgbClr val="F6E9E6"/>
+                </a:solidFill>
+                <a:latin typeface="Calibri"/>
+              </a:rPr>
+              <a:t>recupera todo hasta 0,35 de ruido, lo que confirma que la causa es la correlación y no la cantidad.</a:t>
+            </a:r>
+          </a:p>
+          <a:p>
+            <a:pPr algn="l">
+              <a:lnSpc>
+                <a:spcPct val="105000"/>
+              </a:lnSpc>
+              <a:spcAft>
+                <a:spcPts val="900"/>
+              </a:spcAft>
+            </a:pPr>
+            <a:r>
+              <a:rPr sz="1900" b="0">
+                <a:solidFill>
+                  <a:srgbClr val="FF8A75"/>
+                </a:solidFill>
+                <a:latin typeface="Calibri"/>
+              </a:rPr>
+              <a:t>•  </a:t>
+            </a:r>
+            <a:r>
+              <a:rPr sz="1900" b="1">
+                <a:solidFill>
+                  <a:srgbClr val="F6E9E6"/>
+                </a:solidFill>
+                <a:latin typeface="Calibri"/>
+              </a:rPr>
+              <a:t>Caso de uso: </a:t>
+            </a:r>
+            <a:r>
+              <a:rPr sz="1900" b="0">
+                <a:solidFill>
+                  <a:srgbClr val="F6E9E6"/>
+                </a:solidFill>
+                <a:latin typeface="Calibri"/>
+              </a:rPr>
+              <a:t>limitado por correlación, estados espúreos, capacidad efectiva y umbral de ruido.</a:t>
             </a:r>
           </a:p>
         </p:txBody>
@@ -22343,6 +22608,372 @@
                 <a:latin typeface="Calibri"/>
               </a:rPr>
               <a:t>6 columnas que son combinaciones exactas de otras (precio en ARS, interacción total, alcance estimado, orgánico, arte y showcase). El arte no desaparece: se reconstruye como 100 menos los otros tres tópicos.</a:t>
+            </a:r>
+          </a:p>
+        </p:txBody>
+      </p:sp>
+    </p:spTree>
+  </p:cSld>
+  <p:clrMapOvr>
+    <a:masterClrMapping/>
+  </p:clrMapOvr>
+</p:sld>
+</file>
+
+<file path=ppt/slides/slide40.xml><?xml version="1.0" encoding="utf-8"?>
+<p:sld xmlns:a="http://schemas.openxmlformats.org/drawingml/2006/main" xmlns:p="http://schemas.openxmlformats.org/presentationml/2006/main" xmlns:r="http://schemas.openxmlformats.org/officeDocument/2006/relationships">
+  <p:cSld>
+    <p:bg>
+      <p:bgPr>
+        <a:solidFill>
+          <a:srgbClr val="2A1F22"/>
+        </a:solidFill>
+        <a:effectLst/>
+      </p:bgPr>
+    </p:bg>
+    <p:spTree>
+      <p:nvGrpSpPr>
+        <p:cNvPr id="1" name=""/>
+        <p:cNvGrpSpPr/>
+        <p:nvPr/>
+      </p:nvGrpSpPr>
+      <p:grpSpPr/>
+      <p:sp>
+        <p:nvSpPr>
+          <p:cNvPr id="2" name="Rectangle 1"/>
+          <p:cNvSpPr/>
+          <p:nvPr/>
+        </p:nvSpPr>
+        <p:spPr>
+          <a:xfrm>
+            <a:off x="0" y="0"/>
+            <a:ext cx="201168" cy="6858000"/>
+          </a:xfrm>
+          <a:prstGeom prst="rect">
+            <a:avLst/>
+          </a:prstGeom>
+          <a:solidFill>
+            <a:srgbClr val="FF7F6E"/>
+          </a:solidFill>
+          <a:ln>
+            <a:noFill/>
+          </a:ln>
+          <a:effectLst/>
+        </p:spPr>
+        <p:style>
+          <a:lnRef idx="1">
+            <a:schemeClr val="accent1"/>
+          </a:lnRef>
+          <a:fillRef idx="3">
+            <a:schemeClr val="accent1"/>
+          </a:fillRef>
+          <a:effectRef idx="2">
+            <a:schemeClr val="accent1"/>
+          </a:effectRef>
+          <a:fontRef idx="minor">
+            <a:schemeClr val="lt1"/>
+          </a:fontRef>
+        </p:style>
+        <p:txBody>
+          <a:bodyPr rtlCol="0" anchor="ctr"/>
+          <a:lstStyle/>
+          <a:p>
+            <a:pPr algn="ctr"/>
+          </a:p>
+        </p:txBody>
+      </p:sp>
+      <p:sp>
+        <p:nvSpPr>
+          <p:cNvPr id="3" name="Rectangle 2"/>
+          <p:cNvSpPr/>
+          <p:nvPr/>
+        </p:nvSpPr>
+        <p:spPr>
+          <a:xfrm>
+            <a:off x="548640" y="6400800"/>
+            <a:ext cx="11094415" cy="13716"/>
+          </a:xfrm>
+          <a:prstGeom prst="rect">
+            <a:avLst/>
+          </a:prstGeom>
+          <a:solidFill>
+            <a:srgbClr val="B59A97"/>
+          </a:solidFill>
+          <a:ln>
+            <a:noFill/>
+          </a:ln>
+          <a:effectLst/>
+        </p:spPr>
+        <p:style>
+          <a:lnRef idx="1">
+            <a:schemeClr val="accent1"/>
+          </a:lnRef>
+          <a:fillRef idx="3">
+            <a:schemeClr val="accent1"/>
+          </a:fillRef>
+          <a:effectRef idx="2">
+            <a:schemeClr val="accent1"/>
+          </a:effectRef>
+          <a:fontRef idx="minor">
+            <a:schemeClr val="lt1"/>
+          </a:fontRef>
+        </p:style>
+        <p:txBody>
+          <a:bodyPr rtlCol="0" anchor="ctr"/>
+          <a:lstStyle/>
+          <a:p>
+            <a:pPr algn="ctr"/>
+          </a:p>
+        </p:txBody>
+      </p:sp>
+      <p:sp>
+        <p:nvSpPr>
+          <p:cNvPr id="4" name="TextBox 3"/>
+          <p:cNvSpPr txBox="1"/>
+          <p:nvPr/>
+        </p:nvSpPr>
+        <p:spPr>
+          <a:xfrm>
+            <a:off x="594360" y="6446520"/>
+            <a:ext cx="2743200" cy="320040"/>
+          </a:xfrm>
+          <a:prstGeom prst="rect">
+            <a:avLst/>
+          </a:prstGeom>
+          <a:noFill/>
+        </p:spPr>
+        <p:txBody>
+          <a:bodyPr wrap="square" anchor="t" lIns="45720" rIns="45720" tIns="27432" bIns="27432">
+            <a:spAutoFit/>
+          </a:bodyPr>
+          <a:lstStyle/>
+          <a:p>
+            <a:pPr algn="l">
+              <a:lnSpc>
+                <a:spcPct val="100000"/>
+              </a:lnSpc>
+              <a:spcAft>
+                <a:spcPts val="0"/>
+              </a:spcAft>
+            </a:pPr>
+            <a:r>
+              <a:rPr sz="1200" b="0">
+                <a:solidFill>
+                  <a:srgbClr val="B59A97"/>
+                </a:solidFill>
+                <a:latin typeface="Calibri"/>
+              </a:rPr>
+              <a:t>Grupo 3</a:t>
+            </a:r>
+          </a:p>
+        </p:txBody>
+      </p:sp>
+      <p:sp>
+        <p:nvSpPr>
+          <p:cNvPr id="5" name="TextBox 4"/>
+          <p:cNvSpPr txBox="1"/>
+          <p:nvPr/>
+        </p:nvSpPr>
+        <p:spPr>
+          <a:xfrm>
+            <a:off x="10728655" y="6446520"/>
+            <a:ext cx="914400" cy="320040"/>
+          </a:xfrm>
+          <a:prstGeom prst="rect">
+            <a:avLst/>
+          </a:prstGeom>
+          <a:noFill/>
+        </p:spPr>
+        <p:txBody>
+          <a:bodyPr wrap="square" anchor="t" lIns="45720" rIns="45720" tIns="27432" bIns="27432">
+            <a:spAutoFit/>
+          </a:bodyPr>
+          <a:lstStyle/>
+          <a:p>
+            <a:pPr algn="r">
+              <a:lnSpc>
+                <a:spcPct val="100000"/>
+              </a:lnSpc>
+              <a:spcAft>
+                <a:spcPts val="0"/>
+              </a:spcAft>
+            </a:pPr>
+            <a:r>
+              <a:rPr sz="1200" b="0">
+                <a:solidFill>
+                  <a:srgbClr val="B59A97"/>
+                </a:solidFill>
+                <a:latin typeface="Calibri"/>
+              </a:rPr>
+              <a:t>40</a:t>
+            </a:r>
+          </a:p>
+        </p:txBody>
+      </p:sp>
+      <p:sp>
+        <p:nvSpPr>
+          <p:cNvPr id="6" name="TextBox 5"/>
+          <p:cNvSpPr txBox="1"/>
+          <p:nvPr/>
+        </p:nvSpPr>
+        <p:spPr>
+          <a:xfrm>
+            <a:off x="9814255" y="228600"/>
+            <a:ext cx="1828800" cy="365760"/>
+          </a:xfrm>
+          <a:prstGeom prst="rect">
+            <a:avLst/>
+          </a:prstGeom>
+          <a:noFill/>
+        </p:spPr>
+        <p:txBody>
+          <a:bodyPr wrap="square" anchor="t" lIns="45720" rIns="45720" tIns="27432" bIns="27432">
+            <a:spAutoFit/>
+          </a:bodyPr>
+          <a:lstStyle/>
+          <a:p>
+            <a:pPr algn="r">
+              <a:lnSpc>
+                <a:spcPct val="100000"/>
+              </a:lnSpc>
+              <a:spcAft>
+                <a:spcPts val="0"/>
+              </a:spcAft>
+            </a:pPr>
+            <a:r>
+              <a:rPr sz="1200" b="0">
+                <a:solidFill>
+                  <a:srgbClr val="B59A97"/>
+                </a:solidFill>
+                <a:latin typeface="Calibri"/>
+              </a:rPr>
+              <a:t>ITBA · SIA · TP4</a:t>
+            </a:r>
+          </a:p>
+        </p:txBody>
+      </p:sp>
+      <p:sp>
+        <p:nvSpPr>
+          <p:cNvPr id="7" name="TextBox 6"/>
+          <p:cNvSpPr txBox="1"/>
+          <p:nvPr/>
+        </p:nvSpPr>
+        <p:spPr>
+          <a:xfrm>
+            <a:off x="685800" y="320040"/>
+            <a:ext cx="9418320" cy="822960"/>
+          </a:xfrm>
+          <a:prstGeom prst="rect">
+            <a:avLst/>
+          </a:prstGeom>
+          <a:noFill/>
+        </p:spPr>
+        <p:txBody>
+          <a:bodyPr wrap="square" anchor="t" lIns="45720" rIns="45720" tIns="27432" bIns="27432">
+            <a:spAutoFit/>
+          </a:bodyPr>
+          <a:lstStyle/>
+          <a:p>
+            <a:pPr algn="l">
+              <a:lnSpc>
+                <a:spcPct val="100000"/>
+              </a:lnSpc>
+              <a:spcAft>
+                <a:spcPts val="0"/>
+              </a:spcAft>
+            </a:pPr>
+            <a:r>
+              <a:rPr sz="3600" b="1">
+                <a:solidFill>
+                  <a:srgbClr val="FFD9D0"/>
+                </a:solidFill>
+                <a:latin typeface="Calibri"/>
+              </a:rPr>
+              <a:t>¿Preguntas?</a:t>
+            </a:r>
+          </a:p>
+        </p:txBody>
+      </p:sp>
+      <p:sp>
+        <p:nvSpPr>
+          <p:cNvPr id="8" name="TextBox 7"/>
+          <p:cNvSpPr txBox="1"/>
+          <p:nvPr/>
+        </p:nvSpPr>
+        <p:spPr>
+          <a:xfrm>
+            <a:off x="1097280" y="2560320"/>
+            <a:ext cx="10058400" cy="1097280"/>
+          </a:xfrm>
+          <a:prstGeom prst="rect">
+            <a:avLst/>
+          </a:prstGeom>
+          <a:noFill/>
+        </p:spPr>
+        <p:txBody>
+          <a:bodyPr wrap="square" anchor="t" lIns="45720" rIns="45720" tIns="27432" bIns="27432">
+            <a:spAutoFit/>
+          </a:bodyPr>
+          <a:lstStyle/>
+          <a:p>
+            <a:pPr algn="l">
+              <a:lnSpc>
+                <a:spcPct val="100000"/>
+              </a:lnSpc>
+              <a:spcAft>
+                <a:spcPts val="0"/>
+              </a:spcAft>
+            </a:pPr>
+            <a:r>
+              <a:rPr sz="6000" b="1">
+                <a:solidFill>
+                  <a:srgbClr val="FF8A75"/>
+                </a:solidFill>
+                <a:latin typeface="Calibri"/>
+              </a:rPr>
+              <a:t>¡Gracias!</a:t>
+            </a:r>
+          </a:p>
+        </p:txBody>
+      </p:sp>
+      <p:sp>
+        <p:nvSpPr>
+          <p:cNvPr id="9" name="TextBox 8"/>
+          <p:cNvSpPr txBox="1"/>
+          <p:nvPr/>
+        </p:nvSpPr>
+        <p:spPr>
+          <a:xfrm>
+            <a:off x="1097280" y="3840480"/>
+            <a:ext cx="10058400" cy="914400"/>
+          </a:xfrm>
+          <a:prstGeom prst="rect">
+            <a:avLst/>
+          </a:prstGeom>
+          <a:noFill/>
+        </p:spPr>
+        <p:txBody>
+          <a:bodyPr wrap="square" anchor="t" lIns="45720" rIns="45720" tIns="27432" bIns="27432">
+            <a:spAutoFit/>
+          </a:bodyPr>
+          <a:lstStyle/>
+          <a:p>
+            <a:pPr algn="l">
+              <a:lnSpc>
+                <a:spcPct val="100000"/>
+              </a:lnSpc>
+              <a:spcAft>
+                <a:spcPts val="0"/>
+              </a:spcAft>
+            </a:pPr>
+            <a:r>
+              <a:rPr sz="2000" b="0">
+                <a:solidFill>
+                  <a:srgbClr val="B59A97"/>
+                </a:solidFill>
+                <a:latin typeface="Calibri"/>
+              </a:rPr>
+              <a:t>Todo el trabajo se regenera con un comando: python -m tp4.delivery verify</a:t>
             </a:r>
           </a:p>
         </p:txBody>

</xml_diff>

<commit_message>
docs(261025-r6p): pesos de Oja completos, índice por tópico, estrategias de fútbol, seguidores y mantenimiento
- diapositiva 16 con las 27 variables en barras; 17 responde si conviene elegir el máximo del índice
- diapositiva 18 compara masivo, descubrimiento y profundidad; nueva 20 compara con solo seguidores
- diapositiva 21 con cuatro escenarios de mantenimiento
- se eliminan oja_scores.png y football_profiles.png
</commit_message>
<xml_diff>
--- a/TP4/docs/presentacion/TP4-presentacion.pptx
+++ b/TP4/docs/presentacion/TP4-presentacion.pptx
@@ -35,6 +35,7 @@
     <p:sldId id="283" r:id="rId35"/>
     <p:sldId id="284" r:id="rId36"/>
     <p:sldId id="285" r:id="rId37"/>
+    <p:sldId id="286" r:id="rId38"/>
   </p:sldIdLst>
   <p:sldSz cx="14630400" cy="8229600" type="screen4x3"/>
   <p:notesSz cx="6858000" cy="9144000"/>
@@ -1231,7 +1232,17 @@
           </a:p>
           <a:p>
             <a:r>
-              <a:t>• Mostramos seis coeficientes interpretables; pesos completos y dispersiones en weights_stats.csv.</a:t>
+              <a:t>• Antes mostrábamos seis coeficientes; ahora van las 27 variables, ordenadas por su coeficiente en PC1, para que no falte ninguna.</a:t>
+            </a:r>
+          </a:p>
+          <a:p>
+            <a:r>
+              <a:t>• Cada variable tiene dos barras: coeficiente de Oja (media ± DE entre 30 semillas) y de PC1. Casi se superponen, que es lo esperable.</a:t>
+            </a:r>
+          </a:p>
+          <a:p>
+            <a:r>
+              <a:t>• No hace falta agrupar por tipo: ordenar por coeficiente ya separa las variables de volumen (negativas: impresiones, vistas de video, alcance, tendencias, seguidores, precio) de las de profundidad (positivas: epígrafe, guardados, visitas al perfil, comentarios, tutoriales).</a:t>
             </a:r>
           </a:p>
           <a:p>
@@ -1321,32 +1332,37 @@
           <a:lstStyle/>
           <a:p>
             <a:r>
-              <a:t>• Cada punto es un creador; eje Y muestra media y DE del índice entre semillas.</a:t>
-            </a:r>
-          </a:p>
-          <a:p>
-            <a:r>
-              <a:t>• Normalizamos y alineamos el signo de los vectores aprendidos para informar; nunca renormalizamos durante el entrenamiento.</a:t>
-            </a:r>
-          </a:p>
-          <a:p>
-            <a:r>
-              <a:t>• Los cinco primeros aparecen en top5 en los 30 entrenamientos; las cinco cuentas corresponden al extremo positivo de PC1.</a:t>
-            </a:r>
-          </a:p>
-          <a:p>
-            <a:r>
-              <a:t>• Índice alto no mide ventas, adopciones ni adecuación universal. Invertir el signo invierte el ranking.</a:t>
-            </a:r>
-          </a:p>
-          <a:p>
-            <a:r>
-              <a:t>• La decisión necesita el objetivo de campaña y las variables observadas, no el máximo automático.</a:t>
-            </a:r>
-          </a:p>
-          <a:p>
-            <a:r>
-              <a:t>• Fuente: clase PCA p.46; Oja pp.12-16; runs/oja/index_stats.csv y ranking.csv.</a:t>
+              <a:t>• Qué representa: es la proyección de cada creador sobre el vector que aprende Oja, normalizado y orientado para informar. Coincide con PC1 (coseno 0,999891, correlación de puntajes 0,999990).</a:t>
+            </a:r>
+          </a:p>
+          <a:p>
+            <a:r>
+              <a:t>• Cómo se interpreta: es el eje de mayor variación, volumen y alcance contra profundidad de interacción y epígrafes largos. No mide calidad, ventas ni adecuación.</a:t>
+            </a:r>
+          </a:p>
+          <a:p>
+            <a:r>
+              <a:t>• ¿Es correcto elegir automáticamente al creador con el valor más alto para cualquier campaña? No. Los cinco más altos son de perros (@huellasyconsejos, @perrosfelices.ar, @ideasconhuella, @mundoanimal.ar, @consejoscaninos) y aparecen en el top 5 en las 30 semillas; maximizar el índice elegiría un estilo y favorecería ciertos tópicos sin mirar objetivo, público ni precio.</a:t>
+            </a:r>
+          </a:p>
+          <a:p>
+            <a:r>
+              <a:t>• Invertir el signo invierte el ranking sin cambiar la componente: el máximo no tiene significado propio.</a:t>
+            </a:r>
+          </a:p>
+          <a:p>
+            <a:r>
+              <a:t>• Dentro de un tópico el índice sí ordena de forma razonable: @pasionalbirroja es el puesto 1 de 15 en fútbol, @futbolentrepases es el puesto 3 de 15 en fútbol, @pasiondepotrero es el puesto 2 de 15 en fútbol. Por eso las campañas filtran primero por tópico y después ordenan por una variable observada.</a:t>
+            </a:r>
+          </a:p>
+          <a:p>
+            <a:r>
+              <a:t>• Medianas del índice por tópico: Perros +3,96, Arte −0,37, Fútbol −0,87, Belleza −2,10.</a:t>
+            </a:r>
+          </a:p>
+          <a:p>
+            <a:r>
+              <a:t>• Fuente: enunciado 1.3; clase PCA p.46; Oja pp.12-16; runs/oja/{ranking,index_stats,summary}.json y csv; ej1.md 1.3.</a:t>
             </a:r>
           </a:p>
         </p:txBody>
@@ -1416,32 +1432,42 @@
           <a:lstStyle/>
           <a:p>
             <a:r>
-              <a:t>• Supuesto: explicar ropa de entrenamiento; filtro de contenido de fútbol &gt;=40%, orden por guardados por 1000.</a:t>
-            </a:r>
-          </a:p>
-          <a:p>
-            <a:r>
-              <a:t>• Comparamos solo candidatos de fútbol de cada celda. No usar medias de toda la celda como si fueran ese subconjunto.</a:t>
-            </a:r>
-          </a:p>
-          <a:p>
-            <a:r>
-              <a:t>• Celda 5 agrupa los tres elegidos de fútbol; celda 13 concentra más volumen y menos profundidad educativa.</a:t>
-            </a:r>
-          </a:p>
-          <a:p>
-            <a:r>
-              <a:t>• Una campaña de reconocimiento podría priorizar alcance o descubrimiento; el objetivo cambia la decisión.</a:t>
-            </a:r>
-          </a:p>
-          <a:p>
-            <a:r>
-              <a:t>• No hay ventas, conversiones ni adopciones en el catálogo: estos proxies no prueban rentabilidad.</a:t>
-            </a:r>
-          </a:p>
-          <a:p>
-            <a:r>
-              <a:t>• Fuente: enunciado 1.4; configs/campaigns.json; runs/campaigns/strategy_profiles.csv.</a:t>
+              <a:t>• Pregunta del enunciado: para una campaña de fútbol, ¿conviene alcance masivo, descubrimiento o profundidad educativa?</a:t>
+            </a:r>
+          </a:p>
+          <a:p>
+            <a:r>
+              <a:t>• Alcance masivo (celda 13): 566.704 seguidores medios, 388.879 de alcance argentino sumado, 71,46% de alcance a no seguidores, 7,01 guardados por 1000, 7,22% de tutoriales, USD 10.712,71.</a:t>
+            </a:r>
+          </a:p>
+          <a:p>
+            <a:r>
+              <a:t>• Descubrimiento (celda 0): 76,45% de alcance a no seguidores y 27,19% de audiencia argentina; 10,59 guardados por 1000, USD 13.329,89.</a:t>
+            </a:r>
+          </a:p>
+          <a:p>
+            <a:r>
+              <a:t>• Profundidad (celda 5): 42,77% de tutoriales, 19,93 guardados por 1000, 25.456 seguidores medios, USD 740,15.</a:t>
+            </a:r>
+          </a:p>
+          <a:p>
+            <a:r>
+              <a:t>• Cada estrategia gana su propia métrica: la celda 13 en seguidores, la celda 0 en alcance a no seguidores, la celda 5 en guardados, tutoriales y costo.</a:t>
+            </a:r>
+          </a:p>
+          <a:p>
+            <a:r>
+              <a:t>• Elegimos profundidad por un supuesto comercial: la ropa de entrenamiento se compra después de aprender a usarla, así que guardados y tutoriales pesan más que los seguidores. No hay ventas, conversiones ni adopciones en el catálogo: los proxies no prueban rentabilidad. Una campaña de reconocimiento podría elegir alcance o descubrimiento.</a:t>
+            </a:r>
+          </a:p>
+          <a:p>
+            <a:r>
+              <a:t>• Elegidos: @pasionalbirroja, @futbolentrepases, @pasiondepotrero, los tres en la celda 5. Filtro de al menos 40% de contenido de fútbol y orden por guardados por 1000. Comparamos solo los candidatos de fútbol de cada celda, no las medias de toda la celda. Cifras deterministas del catálogo, sin barras entre semillas.</a:t>
+            </a:r>
+          </a:p>
+          <a:p>
+            <a:r>
+              <a:t>• Fuente: enunciado 1.4; configs/campaigns.json; runs/campaigns/strategy_profiles.csv; ej1.md 1.4.</a:t>
             </a:r>
           </a:p>
         </p:txBody>
@@ -1681,32 +1707,42 @@
           <a:lstStyle/>
           <a:p>
             <a:r>
-              <a:t>• Campaña nueva con mismo catálogo: definir objetivo y revisar evidencia; puede cambiar la elección comercial sin cambiar los modelos.</a:t>
-            </a:r>
-          </a:p>
-          <a:p>
-            <a:r>
-              <a:t>• Datos mensuales o más creadores: revisar distribuciones, escalas, entrenamientos, grilla e interpretaciones.</a:t>
-            </a:r>
-          </a:p>
-          <a:p>
-            <a:r>
-              <a:t>• Variables nuevas cambian distancias y componentes: repetir representación, estandarización y modelos.</a:t>
-            </a:r>
-          </a:p>
-          <a:p>
-            <a:r>
-              <a:t>• Puede proyectarse un creador nuevo con la transformación existente si sigue siendo representativa; el repositorio regenera todo al actualizar el CSV.</a:t>
-            </a:r>
-          </a:p>
-          <a:p>
-            <a:r>
-              <a:t>• Guardar versión de datos, fecha, semillas y parámetros; celdas y signos no son etiquetas permanentes.</a:t>
-            </a:r>
-          </a:p>
-          <a:p>
-            <a:r>
-              <a:t>• Fuente: enunciado 1.4; modelo de Kohonen y proyección PCA; configs y runs.</a:t>
+              <a:t>• Pregunta del enunciado: comparar la selección con una estrategia basada únicamente en followers; ventajas y desventajas de cada una.</a:t>
+            </a:r>
+          </a:p>
+          <a:p>
+            <a:r>
+              <a:t>• Tres barras por campaña: nuestra selección, seguidores global (siempre @mateconideas, @golconmate y @brillourbano) y seguidores del tópico (los tres con más seguidores dentro del tópico).</a:t>
+            </a:r>
+          </a:p>
+          <a:p>
+            <a:r>
+              <a:t>• El control de seguidores del tópico separa el efecto de filtrar por tema del efecto del criterio elegido.</a:t>
+            </a:r>
+          </a:p>
+          <a:p>
+            <a:r>
+              <a:t>• Seguidores, ventajas: más alcance argentino estimado (la suma de alcances es una cota superior porque las audiencias se superponen). Desventajas: la estrategia global usa el mismo trío para todas las campañas, con contenido del tópico entre 9,5% y 46,0%; el costo total de las dos estrategias de seguidores va de USD 6.993 a 15.897; tienen menos guardados y tutoriales.</a:t>
+            </a:r>
+          </a:p>
+          <a:p>
+            <a:r>
+              <a:t>• Nuestra selección, ventajas: más contenido del tópico que seguidores global, más guardados y más tutoriales, con costo de USD 683 a 2.525. Desventajas: menos alcance, depende de supuestos comerciales (una publicación por creador, tres creadores, 40% de tópico) y, sin ventas en el catálogo, no prueba rentabilidad.</a:t>
+            </a:r>
+          </a:p>
+          <a:p>
+            <a:r>
+              <a:t>• Contenido del tópico: Perros 64,83% / 9,48% / 66,04%; Fútbol 56,95% / 34,56% / 68,88%; Belleza 64,44% / 45,97% / 66,25%; Arte 58,89% / 10,00% / 67,16% (selección / global / del tópico).</a:t>
+            </a:r>
+          </a:p>
+          <a:p>
+            <a:r>
+              <a:t>• Costo total en USD (selección / seguidores del tópico): Perros 683,23 / 6.992,95; Fútbol 740,15 / 10.712,71; Belleza 2.524,94 / 15.592,28; Arte 2.085,10 / 9.717,03.</a:t>
+            </a:r>
+          </a:p>
+          <a:p>
+            <a:r>
+              <a:t>• Fuente: enunciado 1.4; runs/campaigns/comparison.csv y baselines.csv; configs/campaigns.json; ej1.md 1.4.</a:t>
             </a:r>
           </a:p>
         </p:txBody>
@@ -1776,32 +1812,32 @@
           <a:lstStyle/>
           <a:p>
             <a:r>
-              <a:t>• Cada letra 5×5 se recorre por filas: 25 estados bipolares. Negro=+1, blanco=-1.</a:t>
-            </a:r>
-          </a:p>
-          <a:p>
-            <a:r>
-              <a:t>• G, R, T, V forman cuatro filas de P: matriz 4×25. Cada posición corresponde a una neurona.</a:t>
-            </a:r>
-          </a:p>
-          <a:p>
-            <a:r>
-              <a:t>• Hebb: W=PᵀP/25; W es 25×25 y su diagonal se fija en cero. Los cuatro patrones se almacenan juntos.</a:t>
-            </a:r>
-          </a:p>
-          <a:p>
-            <a:r>
-              <a:t>• Un patrón está almacenado por construcción de W; estar estable y recuperar desde ruido se comprueba después.</a:t>
-            </a:r>
-          </a:p>
-          <a:p>
-            <a:r>
-              <a:t>• Ejemplo introductorio antes del caso QR; fuente de patrones: datos/letras_5x5.json.</a:t>
-            </a:r>
-          </a:p>
-          <a:p>
-            <a:r>
-              <a:t>• Fuente: clase Hopfield, pp. 15, 20, 33-38; runs/hopfield_letters. Figura original de esta corrida: runs/hopfield_letters/storage.png.</a:t>
+              <a:t>• Preguntas del enunciado: ¿qué implica el mantenimiento del sistema?, ¿qué ocurre cuando llega una nueva campaña?, ¿qué cambios hacen falta si cambia la cantidad de creadores o se incorporan variables?, ¿qué implica actualizar los datos a fin de cada mes?</a:t>
+            </a:r>
+          </a:p>
+          <a:p>
+            <a:r>
+              <a:t>• Campaña nueva con el mismo catálogo: se definen objetivo, público y supuestos, se revisan las celdas y variables pertinentes y se comparan alternativas. Si sigue usando el mismo catálogo y variables, no obliga a cambiar las reglas de aprendizaje.</a:t>
+            </a:r>
+          </a:p>
+          <a:p>
+            <a:r>
+              <a:t>• Creador nuevo o actualización mensual: para un creador nuevo se aplican la media y el desvío existentes y se le asignan su ganadora y sus proyecciones, mientras no cambie la distribución. Más creadores o cambios mensuales justifican revisar distribuciones, correlaciones, escalas, entrenamientos y la selección de grilla. Este repositorio regenera el análisis completo al actualizar el CSV.</a:t>
+            </a:r>
+          </a:p>
+          <a:p>
+            <a:r>
+              <a:t>• Variables nuevas: cambian las distancias, los pesos y las componentes; exigen nueva selección y estandarización y repetir PCA, Kohonen y Oja.</a:t>
+            </a:r>
+          </a:p>
+          <a:p>
+            <a:r>
+              <a:t>• Registro: guardar datos, parámetros, semillas, fecha y versión de cada análisis. Las coordenadas, signos y números de celda no son etiquetas comerciales permanentes. Volver a contrastar los supuestos con resultados comerciales cuando existan.</a:t>
+            </a:r>
+          </a:p>
+          <a:p>
+            <a:r>
+              <a:t>• Fuente: enunciado 1.4; ej1.md 1.4, párrafo Mantenimiento; configs y runs.</a:t>
             </a:r>
           </a:p>
         </p:txBody>
@@ -1871,32 +1907,32 @@
           <a:lstStyle/>
           <a:p>
             <a:r>
-              <a:t>• Productos internos normalizados: (ξᵘ·ξᵛ)/(5×5), antes de agregar ruido. Norma de cada letra: 5.</a:t>
-            </a:r>
-          </a:p>
-          <a:p>
-            <a:r>
-              <a:t>• N=25 es impar: el producto interno de dos vectores bipolares no puede ser cero; mínimo absoluto posible: 1.</a:t>
-            </a:r>
-          </a:p>
-          <a:p>
-            <a:r>
-              <a:t>• Elegimos G, R, T, V minimizando máximo |producto|, luego promedio; producto bruto absoluto 1, normalizado 0,04.</a:t>
-            </a:r>
-          </a:p>
-          <a:p>
-            <a:r>
-              <a:t>• H, M, N, W tienen máximo absoluto 21/25=0,84 y solo una letra estable, almacenando la misma cantidad.</a:t>
-            </a:r>
-          </a:p>
-          <a:p>
-            <a:r>
-              <a:t>• La diagonal normalizada 1 se excluye del resumen entre patrones distintos; la figura conserva el signo.</a:t>
-            </a:r>
-          </a:p>
-          <a:p>
-            <a:r>
-              <a:t>• Fuente: clase Hopfield, pp. 15, 20, 33-38; runs/hopfield_letters. Datos: dot_products.csv, orthogonality.csv, stored.csv.</a:t>
+              <a:t>• Cada letra 5×5 se recorre por filas: 25 estados bipolares. Negro=+1, blanco=-1.</a:t>
+            </a:r>
+          </a:p>
+          <a:p>
+            <a:r>
+              <a:t>• G, R, T, V forman cuatro filas de P: matriz 4×25. Cada posición corresponde a una neurona.</a:t>
+            </a:r>
+          </a:p>
+          <a:p>
+            <a:r>
+              <a:t>• Hebb: W=PᵀP/25; W es 25×25 y su diagonal se fija en cero. Los cuatro patrones se almacenan juntos.</a:t>
+            </a:r>
+          </a:p>
+          <a:p>
+            <a:r>
+              <a:t>• Un patrón está almacenado por construcción de W; estar estable y recuperar desde ruido se comprueba después.</a:t>
+            </a:r>
+          </a:p>
+          <a:p>
+            <a:r>
+              <a:t>• Ejemplo introductorio antes del caso QR; fuente de patrones: datos/letras_5x5.json.</a:t>
+            </a:r>
+          </a:p>
+          <a:p>
+            <a:r>
+              <a:t>• Fuente: clase Hopfield, pp. 15, 20, 33-38; runs/hopfield_letters. Figura original de esta corrida: runs/hopfield_letters/storage.png.</a:t>
             </a:r>
           </a:p>
         </p:txBody>
@@ -1966,32 +2002,32 @@
           <a:lstStyle/>
           <a:p>
             <a:r>
-              <a:t>• Cada semilla contiene 50 consultas por letra y nivel. Se invierten posiciones distintas dentro de cada consulta.</a:t>
-            </a:r>
-          </a:p>
-          <a:p>
-            <a:r>
-              <a:t>• G, R, T, V asincrónica: 3 bits, 99,833% ± 0,240 pp; 5 bits, 93,417% ± 2,060 pp; 9 bits, 31,917% ± 2,910 pp.</a:t>
-            </a:r>
-          </a:p>
-          <a:p>
-            <a:r>
-              <a:t>• Media y DE muestral entre 30 tasas por semilla. Las consultas de una corrida se agregan antes de calcular dispersión.</a:t>
-            </a:r>
-          </a:p>
-          <a:p>
-            <a:r>
-              <a:t>• 192.000 consultas de la grilla estándar; 24.000 adicionales para nivel 0,4: 216.000 consultas totales.</a:t>
-            </a:r>
-          </a:p>
-          <a:p>
-            <a:r>
-              <a:t>• Actualización sincrónica puede formar ciclos; asincrónica tiene energía no creciente. No prometer recuperación para toda consulta.</a:t>
-            </a:r>
-          </a:p>
-          <a:p>
-            <a:r>
-              <a:t>• Fuente: clase Hopfield, pp. 15, 20, 33-38; runs/hopfield_letters. Datos: recall_by_seed.csv y recall_repetitions.csv.</a:t>
+              <a:t>• Productos internos normalizados: (ξᵘ·ξᵛ)/(5×5), antes de agregar ruido. Norma de cada letra: 5.</a:t>
+            </a:r>
+          </a:p>
+          <a:p>
+            <a:r>
+              <a:t>• N=25 es impar: el producto interno de dos vectores bipolares no puede ser cero; mínimo absoluto posible: 1.</a:t>
+            </a:r>
+          </a:p>
+          <a:p>
+            <a:r>
+              <a:t>• Elegimos G, R, T, V minimizando máximo |producto|, luego promedio; producto bruto absoluto 1, normalizado 0,04.</a:t>
+            </a:r>
+          </a:p>
+          <a:p>
+            <a:r>
+              <a:t>• H, M, N, W tienen máximo absoluto 21/25=0,84 y solo una letra estable, almacenando la misma cantidad.</a:t>
+            </a:r>
+          </a:p>
+          <a:p>
+            <a:r>
+              <a:t>• La diagonal normalizada 1 se excluye del resumen entre patrones distintos; la figura conserva el signo.</a:t>
+            </a:r>
+          </a:p>
+          <a:p>
+            <a:r>
+              <a:t>• Fuente: clase Hopfield, pp. 15, 20, 33-38; runs/hopfield_letters. Datos: dot_products.csv, orthogonality.csv, stored.csv.</a:t>
             </a:r>
           </a:p>
         </p:txBody>
@@ -2061,32 +2097,32 @@
           <a:lstStyle/>
           <a:p>
             <a:r>
-              <a:t>• Ejemplo de la semilla 42: consulta de G con 10/25 bits invertidos.</a:t>
-            </a:r>
-          </a:p>
-          <a:p>
-            <a:r>
-              <a:t>• El estado final es un punto fijo ajeno a las cuatro letras y sus inversas.</a:t>
-            </a:r>
-          </a:p>
-          <a:p>
-            <a:r>
-              <a:t>• Energía final -7,68; distancia mínima a una letra: 6 bits. Los recuerdos guardados tienen energía -10,56.</a:t>
-            </a:r>
-          </a:p>
-          <a:p>
-            <a:r>
-              <a:t>• La curva registra visitas individuales a neuronas, incluida la comprobación final. Un espurio puede tener energía estable.</a:t>
-            </a:r>
-          </a:p>
-          <a:p>
-            <a:r>
-              <a:t>• Distinguir convergencia a un punto fijo de recuperación del patrón objetivo.</a:t>
-            </a:r>
-          </a:p>
-          <a:p>
-            <a:r>
-              <a:t>• Fuente: clase Hopfield, pp. 15, 20, 33-38; runs/hopfield_letters. Datos: summary.json y energy_trace.csv, ejemplo spurious.</a:t>
+              <a:t>• Cada semilla contiene 50 consultas por letra y nivel. Se invierten posiciones distintas dentro de cada consulta.</a:t>
+            </a:r>
+          </a:p>
+          <a:p>
+            <a:r>
+              <a:t>• G, R, T, V asincrónica: 3 bits, 99,833% ± 0,240 pp; 5 bits, 93,417% ± 2,060 pp; 9 bits, 31,917% ± 2,910 pp.</a:t>
+            </a:r>
+          </a:p>
+          <a:p>
+            <a:r>
+              <a:t>• Media y DE muestral entre 30 tasas por semilla. Las consultas de una corrida se agregan antes de calcular dispersión.</a:t>
+            </a:r>
+          </a:p>
+          <a:p>
+            <a:r>
+              <a:t>• 192.000 consultas de la grilla estándar; 24.000 adicionales para nivel 0,4: 216.000 consultas totales.</a:t>
+            </a:r>
+          </a:p>
+          <a:p>
+            <a:r>
+              <a:t>• Actualización sincrónica puede formar ciclos; asincrónica tiene energía no creciente. No prometer recuperación para toda consulta.</a:t>
+            </a:r>
+          </a:p>
+          <a:p>
+            <a:r>
+              <a:t>• Fuente: clase Hopfield, pp. 15, 20, 33-38; runs/hopfield_letters. Datos: recall_by_seed.csv y recall_repetitions.csv.</a:t>
             </a:r>
           </a:p>
         </p:txBody>
@@ -2156,32 +2192,32 @@
           <a:lstStyle/>
           <a:p>
             <a:r>
-              <a:t>• Se prueban 200 subconjuntos aleatorios del alfabeto por cantidad, en 30 semillas.</a:t>
-            </a:r>
-          </a:p>
-          <a:p>
-            <a:r>
-              <a:t>• La curva muestra proporción de subconjuntos enteramente estables, con media ± DE entre semillas.</a:t>
-            </a:r>
-          </a:p>
-          <a:p>
-            <a:r>
-              <a:t>• Para 4 letras al azar: 48,35% ± 3,57 pp de conjuntos enteramente estables; la fracción de letras estables es 75,575%.</a:t>
-            </a:r>
-          </a:p>
-          <a:p>
-            <a:r>
-              <a:t>• 0,15N=3,75 es una aproximación para patrones poco correlacionados, sin garantía para cada conjunto de 25 neuronas.</a:t>
-            </a:r>
-          </a:p>
-          <a:p>
-            <a:r>
-              <a:t>• Las cuatro letras elegidas son estables pese a superar 3,75; compatible con una capacidad aproximada.</a:t>
-            </a:r>
-          </a:p>
-          <a:p>
-            <a:r>
-              <a:t>• Fuente: clase Hopfield, pp. 15, 20, 33-38; runs/hopfield_letters. Datos: capacity_by_seed.csv y capacity_repetitions.csv.</a:t>
+              <a:t>• Ejemplo de la semilla 42: consulta de G con 10/25 bits invertidos.</a:t>
+            </a:r>
+          </a:p>
+          <a:p>
+            <a:r>
+              <a:t>• El estado final es un punto fijo ajeno a las cuatro letras y sus inversas.</a:t>
+            </a:r>
+          </a:p>
+          <a:p>
+            <a:r>
+              <a:t>• Energía final -7,68; distancia mínima a una letra: 6 bits. Los recuerdos guardados tienen energía -10,56.</a:t>
+            </a:r>
+          </a:p>
+          <a:p>
+            <a:r>
+              <a:t>• La curva registra visitas individuales a neuronas, incluida la comprobación final. Un espurio puede tener energía estable.</a:t>
+            </a:r>
+          </a:p>
+          <a:p>
+            <a:r>
+              <a:t>• Distinguir convergencia a un punto fijo de recuperación del patrón objetivo.</a:t>
+            </a:r>
+          </a:p>
+          <a:p>
+            <a:r>
+              <a:t>• Fuente: clase Hopfield, pp. 15, 20, 33-38; runs/hopfield_letters. Datos: summary.json y energy_trace.csv, ejemplo spurious.</a:t>
             </a:r>
           </a:p>
         </p:txBody>
@@ -2251,32 +2287,32 @@
           <a:lstStyle/>
           <a:p>
             <a:r>
-              <a:t>• Las cinco imágenes coinciden byte a byte con el ZIP suministrado; inputs.csv registra SHA256, dimensiones y norma.</a:t>
-            </a:r>
-          </a:p>
-          <a:p>
-            <a:r>
-              <a:t>• Cada imagen 37×37 se recorre por filas. Negro=+1, blanco=-1; se conservan todos sus módulos.</a:t>
-            </a:r>
-          </a:p>
-          <a:p>
-            <a:r>
-              <a:t>• Cada vector tiene 1369 estados y norma √1369=37. P es 5×1369 y W es 1369×1369, con diagonal cero.</a:t>
-            </a:r>
-          </a:p>
-          <a:p>
-            <a:r>
-              <a:t>• La comparación usa coseno normalizado; la red utiliza estados bipolares ±1.</a:t>
-            </a:r>
-          </a:p>
-          <a:p>
-            <a:r>
-              <a:t>• El render de esta diapositiva solo amplía píxeles por vecino más próximo; no altera los archivos originales.</a:t>
-            </a:r>
-          </a:p>
-          <a:p>
-            <a:r>
-              <a:t>• Fuente: enunciado 2.1; datos/hopfield/*.png; runs/hopfield_qr/inputs.csv.</a:t>
+              <a:t>• Se prueban 200 subconjuntos aleatorios del alfabeto por cantidad, en 30 semillas.</a:t>
+            </a:r>
+          </a:p>
+          <a:p>
+            <a:r>
+              <a:t>• La curva muestra proporción de subconjuntos enteramente estables, con media ± DE entre semillas.</a:t>
+            </a:r>
+          </a:p>
+          <a:p>
+            <a:r>
+              <a:t>• Para 4 letras al azar: 48,35% ± 3,57 pp de conjuntos enteramente estables; la fracción de letras estables es 75,575%.</a:t>
+            </a:r>
+          </a:p>
+          <a:p>
+            <a:r>
+              <a:t>• 0,15N=3,75 es una aproximación para patrones poco correlacionados, sin garantía para cada conjunto de 25 neuronas.</a:t>
+            </a:r>
+          </a:p>
+          <a:p>
+            <a:r>
+              <a:t>• Las cuatro letras elegidas son estables pese a superar 3,75; compatible con una capacidad aproximada.</a:t>
+            </a:r>
+          </a:p>
+          <a:p>
+            <a:r>
+              <a:t>• Fuente: clase Hopfield, pp. 15, 20, 33-38; runs/hopfield_letters. Datos: capacity_by_seed.csv y capacity_repetitions.csv.</a:t>
             </a:r>
           </a:p>
         </p:txBody>
@@ -2346,32 +2382,32 @@
           <a:lstStyle/>
           <a:p>
             <a:r>
-              <a:t>• Coseno medio entre los 10 pares distintos: 0.670124; rango 0.576333 a 0.859752.</a:t>
-            </a:r>
-          </a:p>
-          <a:p>
-            <a:r>
-              <a:t>• Para ±1 y N=1369, cada norma es 37: el denominador es 37×37=1369.</a:t>
-            </a:r>
-          </a:p>
-          <a:p>
-            <a:r>
-              <a:t>• 1−coseno medio=0.329876; 0,3299 es disimilitud complementaria, una cantidad diferente del producto normalizado.</a:t>
-            </a:r>
-          </a:p>
-          <a:p>
-            <a:r>
-              <a:t>• La fracción de bits distintos es (1−coseno)/2: aproximadamente 16,49% en promedio.</a:t>
-            </a:r>
-          </a:p>
-          <a:p>
-            <a:r>
-              <a:t>• 955/1369 módulos son iguales en los cinco QR simultáneamente; esa proporción, 69,76%, es otra cantidad.</a:t>
-            </a:r>
-          </a:p>
-          <a:p>
-            <a:r>
-              <a:t>• Fuente: runs/hopfield_qr/{pairwise_similarity,overlaps,inputs}.csv; clase Hopfield p.33.</a:t>
+              <a:t>• Las cinco imágenes coinciden byte a byte con el ZIP suministrado; inputs.csv registra SHA256, dimensiones y norma.</a:t>
+            </a:r>
+          </a:p>
+          <a:p>
+            <a:r>
+              <a:t>• Cada imagen 37×37 se recorre por filas. Negro=+1, blanco=-1; se conservan todos sus módulos.</a:t>
+            </a:r>
+          </a:p>
+          <a:p>
+            <a:r>
+              <a:t>• Cada vector tiene 1369 estados y norma √1369=37. P es 5×1369 y W es 1369×1369, con diagonal cero.</a:t>
+            </a:r>
+          </a:p>
+          <a:p>
+            <a:r>
+              <a:t>• La comparación usa coseno normalizado; la red utiliza estados bipolares ±1.</a:t>
+            </a:r>
+          </a:p>
+          <a:p>
+            <a:r>
+              <a:t>• El render de esta diapositiva solo amplía píxeles por vecino más próximo; no altera los archivos originales.</a:t>
+            </a:r>
+          </a:p>
+          <a:p>
+            <a:r>
+              <a:t>• Fuente: enunciado 2.1; datos/hopfield/*.png; runs/hopfield_qr/inputs.csv.</a:t>
             </a:r>
           </a:p>
         </p:txBody>
@@ -2441,32 +2477,32 @@
           <a:lstStyle/>
           <a:p>
             <a:r>
-              <a:t>• Con los cinco juntos, ningún original es punto fijo: 71, 91, 225, 225 y 103 módulos inestables.</a:t>
-            </a:r>
-          </a:p>
-          <a:p>
-            <a:r>
-              <a:t>• 33.000 consultas conjuntas: 5 QR × 11 niveles × 20 consultas × 30 semillas. Recuperación exacta: 0% en todos los niveles.</a:t>
-            </a:r>
-          </a:p>
-          <a:p>
-            <a:r>
-              <a:t>• Ejemplo de la semilla 42: original principal sin ruido y estado final espurio. La curva de barridos usa 30 semillas.</a:t>
-            </a:r>
-          </a:p>
-          <a:p>
-            <a:r>
-              <a:t>• Máximo 2 barridos que cambian el estado; la comprobación final no cuenta como otro cambio.</a:t>
-            </a:r>
-          </a:p>
-          <a:p>
-            <a:r>
-              <a:t>• Energía asincrónica no creciente no garantiza recuerdo correcto. El fracaso aparece ya en estabilidad, antes del ruido.</a:t>
-            </a:r>
-          </a:p>
-          <a:p>
-            <a:r>
-              <a:t>• Fuente: clase Hopfield pp.34-38; runs/hopfield_qr/{stored,recall_repetitions,queries}.csv.</a:t>
+              <a:t>• Coseno medio entre los 10 pares distintos: 0.670124; rango 0.576333 a 0.859752.</a:t>
+            </a:r>
+          </a:p>
+          <a:p>
+            <a:r>
+              <a:t>• Para ±1 y N=1369, cada norma es 37: el denominador es 37×37=1369.</a:t>
+            </a:r>
+          </a:p>
+          <a:p>
+            <a:r>
+              <a:t>• 1−coseno medio=0.329876; 0,3299 es disimilitud complementaria, una cantidad diferente del producto normalizado.</a:t>
+            </a:r>
+          </a:p>
+          <a:p>
+            <a:r>
+              <a:t>• La fracción de bits distintos es (1−coseno)/2: aproximadamente 16,49% en promedio.</a:t>
+            </a:r>
+          </a:p>
+          <a:p>
+            <a:r>
+              <a:t>• 955/1369 módulos son iguales en los cinco QR simultáneamente; esa proporción, 69,76%, es otra cantidad.</a:t>
+            </a:r>
+          </a:p>
+          <a:p>
+            <a:r>
+              <a:t>• Fuente: runs/hopfield_qr/{pairwise_similarity,overlaps,inputs}.csv; clase Hopfield p.33.</a:t>
             </a:r>
           </a:p>
         </p:txBody>
@@ -2536,32 +2572,32 @@
           <a:lstStyle/>
           <a:p>
             <a:r>
-              <a:t>• Controles de estabilidad exhaustivos: 5 redes con un QR y 10 parejas; todos sus patrones son estables.</a:t>
-            </a:r>
-          </a:p>
-          <a:p>
-            <a:r>
-              <a:t>• Los 10 tríos, 5 cuartetos y la red de cinco tienen cero patrones originales estables.</a:t>
-            </a:r>
-          </a:p>
-          <a:p>
-            <a:r>
-              <a:t>• Un QR por red: 33.000 consultas adicionales; recuperación 100% hasta 684/1369 bits invertidos (49,963%), con DE 0 entre semillas.</a:t>
-            </a:r>
-          </a:p>
-          <a:p>
-            <a:r>
-              <a:t>• El fallo no es universal para QR ni atribuible solo a su tamaño. Estos patrones correlacionados interfieren cuando se almacenan juntos.</a:t>
-            </a:r>
-          </a:p>
-          <a:p>
-            <a:r>
-              <a:t>• El control cambia la matriz de pesos. No comparar energías absolutas entre redes como si fueran una misma función.</a:t>
-            </a:r>
-          </a:p>
-          <a:p>
-            <a:r>
-              <a:t>• Fuente: runs/hopfield_qr/{storage_control,single_pattern_control,recall_repetitions}.csv.</a:t>
+              <a:t>• Con los cinco juntos, ningún original es punto fijo: 71, 91, 225, 225 y 103 módulos inestables.</a:t>
+            </a:r>
+          </a:p>
+          <a:p>
+            <a:r>
+              <a:t>• 33.000 consultas conjuntas: 5 QR × 11 niveles × 20 consultas × 30 semillas. Recuperación exacta: 0% en todos los niveles.</a:t>
+            </a:r>
+          </a:p>
+          <a:p>
+            <a:r>
+              <a:t>• Ejemplo de la semilla 42: original principal sin ruido y estado final espurio. La curva de barridos usa 30 semillas.</a:t>
+            </a:r>
+          </a:p>
+          <a:p>
+            <a:r>
+              <a:t>• Máximo 2 barridos que cambian el estado; la comprobación final no cuenta como otro cambio.</a:t>
+            </a:r>
+          </a:p>
+          <a:p>
+            <a:r>
+              <a:t>• Energía asincrónica no creciente no garantiza recuerdo correcto. El fracaso aparece ya en estabilidad, antes del ruido.</a:t>
+            </a:r>
+          </a:p>
+          <a:p>
+            <a:r>
+              <a:t>• Fuente: clase Hopfield pp.34-38; runs/hopfield_qr/{stored,recall_repetitions,queries}.csv.</a:t>
             </a:r>
           </a:p>
         </p:txBody>
@@ -2677,6 +2713,101 @@
 </file>
 
 <file path=ppt/notesSlides/notesSlide30.xml><?xml version="1.0" encoding="utf-8"?>
+<p:notes xmlns:a="http://schemas.openxmlformats.org/drawingml/2006/main" xmlns:p="http://schemas.openxmlformats.org/presentationml/2006/main" xmlns:r="http://schemas.openxmlformats.org/officeDocument/2006/relationships">
+  <p:cSld>
+    <p:spTree>
+      <p:nvGrpSpPr>
+        <p:cNvPr id="1" name=""/>
+        <p:cNvGrpSpPr/>
+        <p:nvPr/>
+      </p:nvGrpSpPr>
+      <p:grpSpPr>
+        <a:xfrm>
+          <a:off x="0" y="0"/>
+          <a:ext cx="0" cy="0"/>
+          <a:chOff x="0" y="0"/>
+          <a:chExt cx="0" cy="0"/>
+        </a:xfrm>
+      </p:grpSpPr>
+      <p:sp>
+        <p:nvSpPr>
+          <p:cNvPr id="2" name="Slide Image Placeholder 1"/>
+          <p:cNvSpPr>
+            <a:spLocks noGrp="1"/>
+          </p:cNvSpPr>
+          <p:nvPr>
+            <p:ph type="sldImg" idx="2"/>
+          </p:nvPr>
+        </p:nvSpPr>
+        <p:spPr/>
+      </p:sp>
+      <p:sp>
+        <p:nvSpPr>
+          <p:cNvPr id="3" name="Notes Placeholder 2"/>
+          <p:cNvSpPr>
+            <a:spLocks noGrp="1"/>
+          </p:cNvSpPr>
+          <p:nvPr>
+            <p:ph type="body" idx="3" sz="quarter"/>
+          </p:nvPr>
+        </p:nvSpPr>
+        <p:spPr/>
+        <p:txBody>
+          <a:bodyPr/>
+          <a:lstStyle/>
+          <a:p>
+            <a:r>
+              <a:t>• Controles de estabilidad exhaustivos: 5 redes con un QR y 10 parejas; todos sus patrones son estables.</a:t>
+            </a:r>
+          </a:p>
+          <a:p>
+            <a:r>
+              <a:t>• Los 10 tríos, 5 cuartetos y la red de cinco tienen cero patrones originales estables.</a:t>
+            </a:r>
+          </a:p>
+          <a:p>
+            <a:r>
+              <a:t>• Un QR por red: 33.000 consultas adicionales; recuperación 100% hasta 684/1369 bits invertidos (49,963%), con DE 0 entre semillas.</a:t>
+            </a:r>
+          </a:p>
+          <a:p>
+            <a:r>
+              <a:t>• El fallo no es universal para QR ni atribuible solo a su tamaño. Estos patrones correlacionados interfieren cuando se almacenan juntos.</a:t>
+            </a:r>
+          </a:p>
+          <a:p>
+            <a:r>
+              <a:t>• El control cambia la matriz de pesos. No comparar energías absolutas entre redes como si fueran una misma función.</a:t>
+            </a:r>
+          </a:p>
+          <a:p>
+            <a:r>
+              <a:t>• Fuente: runs/hopfield_qr/{storage_control,single_pattern_control,recall_repetitions}.csv.</a:t>
+            </a:r>
+          </a:p>
+        </p:txBody>
+      </p:sp>
+      <p:sp>
+        <p:nvSpPr>
+          <p:cNvPr id="4" name="Slide Number Placeholder 3"/>
+          <p:cNvSpPr>
+            <a:spLocks noGrp="1"/>
+          </p:cNvSpPr>
+          <p:nvPr>
+            <p:ph type="sldNum" idx="5" sz="quarter"/>
+          </p:nvPr>
+        </p:nvSpPr>
+        <p:spPr/>
+      </p:sp>
+    </p:spTree>
+  </p:cSld>
+  <p:clrMapOvr>
+    <a:masterClrMapping/>
+  </p:clrMapOvr>
+</p:notes>
+</file>
+
+<file path=ppt/notesSlides/notesSlide31.xml><?xml version="1.0" encoding="utf-8"?>
 <p:notes xmlns:a="http://schemas.openxmlformats.org/drawingml/2006/main" xmlns:p="http://schemas.openxmlformats.org/presentationml/2006/main" xmlns:r="http://schemas.openxmlformats.org/officeDocument/2006/relationships">
   <p:cSld>
     <p:spTree>
@@ -8974,8 +9105,8 @@
         </p:blipFill>
         <p:spPr>
           <a:xfrm>
-            <a:off x="640080" y="1957027"/>
-            <a:ext cx="9601200" cy="4864184"/>
+            <a:off x="731520" y="1378402"/>
+            <a:ext cx="13167360" cy="5655674"/>
           </a:xfrm>
           <a:prstGeom prst="rect">
             <a:avLst/>
@@ -8990,151 +9121,39 @@
         </p:nvSpPr>
         <p:spPr>
           <a:xfrm>
-            <a:off x="10515600" y="2331720"/>
-            <a:ext cx="3657600" cy="822960"/>
-          </a:xfrm>
-          <a:prstGeom prst="rect">
-            <a:avLst/>
-          </a:prstGeom>
-          <a:noFill/>
-        </p:spPr>
-        <p:txBody>
-          <a:bodyPr wrap="square" lIns="0" rIns="0" tIns="0" bIns="0">
-            <a:spAutoFit/>
-          </a:bodyPr>
-          <a:lstStyle/>
-          <a:p>
-            <a:pPr>
-              <a:spcAft>
-                <a:spcPts val="500"/>
-              </a:spcAft>
-              <a:defRPr sz="4300" b="1">
-                <a:solidFill>
-                  <a:srgbClr val="176B72"/>
-                </a:solidFill>
-                <a:latin typeface="Arial"/>
-              </a:defRPr>
-            </a:pPr>
-            <a:r>
-              <a:rPr sz="4300" b="1">
-                <a:solidFill>
-                  <a:srgbClr val="176B72"/>
-                </a:solidFill>
-                <a:latin typeface="Arial"/>
-              </a:rPr>
-              <a:t>0,999891</a:t>
-            </a:r>
-          </a:p>
-        </p:txBody>
-      </p:sp>
-      <p:sp>
-        <p:nvSpPr>
-          <p:cNvPr id="8" name="TextBox 7"/>
-          <p:cNvSpPr txBox="1"/>
-          <p:nvPr/>
-        </p:nvSpPr>
-        <p:spPr>
-          <a:xfrm>
-            <a:off x="10515600" y="3291840"/>
-            <a:ext cx="3657600" cy="640080"/>
-          </a:xfrm>
-          <a:prstGeom prst="rect">
-            <a:avLst/>
-          </a:prstGeom>
-          <a:noFill/>
-        </p:spPr>
-        <p:txBody>
-          <a:bodyPr wrap="square" lIns="0" rIns="0" tIns="0" bIns="0">
-            <a:spAutoFit/>
-          </a:bodyPr>
-          <a:lstStyle/>
-          <a:p>
-            <a:pPr>
-              <a:spcAft>
-                <a:spcPts val="500"/>
-              </a:spcAft>
-              <a:defRPr sz="2600" b="0">
-                <a:solidFill>
-                  <a:srgbClr val="18242C"/>
-                </a:solidFill>
-                <a:latin typeface="Arial"/>
-              </a:defRPr>
-            </a:pPr>
-            <a:r>
-              <a:rPr sz="2600" b="0">
-                <a:solidFill>
-                  <a:srgbClr val="18242C"/>
-                </a:solidFill>
-                <a:latin typeface="Arial"/>
-              </a:rPr>
-              <a:t>± 0,000039</a:t>
-            </a:r>
-          </a:p>
-        </p:txBody>
-      </p:sp>
-      <p:sp>
-        <p:nvSpPr>
-          <p:cNvPr id="9" name="TextBox 8"/>
-          <p:cNvSpPr txBox="1"/>
-          <p:nvPr/>
-        </p:nvSpPr>
-        <p:spPr>
-          <a:xfrm>
-            <a:off x="10515600" y="4389120"/>
-            <a:ext cx="3657600" cy="1280160"/>
-          </a:xfrm>
-          <a:prstGeom prst="rect">
-            <a:avLst/>
-          </a:prstGeom>
-          <a:noFill/>
-        </p:spPr>
-        <p:txBody>
-          <a:bodyPr wrap="square" lIns="0" rIns="0" tIns="0" bIns="0">
-            <a:spAutoFit/>
-          </a:bodyPr>
-          <a:lstStyle/>
-          <a:p>
-            <a:pPr>
-              <a:spcAft>
-                <a:spcPts val="500"/>
-              </a:spcAft>
-              <a:defRPr sz="2300" b="0">
-                <a:solidFill>
-                  <a:srgbClr val="5E6B73"/>
-                </a:solidFill>
-                <a:latin typeface="Arial"/>
-              </a:defRPr>
-            </a:pPr>
-            <a:r>
-              <a:rPr sz="2300" b="0">
-                <a:solidFill>
-                  <a:srgbClr val="5E6B73"/>
-                </a:solidFill>
-                <a:latin typeface="Arial"/>
-              </a:rPr>
-              <a:t>Coseno con PC1</a:t>
-            </a:r>
-          </a:p>
-          <a:p>
-            <a:pPr>
-              <a:spcAft>
-                <a:spcPts val="500"/>
-              </a:spcAft>
-              <a:defRPr sz="2300" b="0">
-                <a:solidFill>
-                  <a:srgbClr val="5E6B73"/>
-                </a:solidFill>
-                <a:latin typeface="Arial"/>
-              </a:defRPr>
-            </a:pPr>
-            <a:r>
-              <a:rPr sz="2300" b="0">
-                <a:solidFill>
-                  <a:srgbClr val="5E6B73"/>
-                </a:solidFill>
-                <a:latin typeface="Arial"/>
-              </a:rPr>
-              <a:t>30 semillas</a:t>
+            <a:off x="777240" y="7269480"/>
+            <a:ext cx="12984480" cy="411480"/>
+          </a:xfrm>
+          <a:prstGeom prst="rect">
+            <a:avLst/>
+          </a:prstGeom>
+          <a:noFill/>
+        </p:spPr>
+        <p:txBody>
+          <a:bodyPr wrap="square" lIns="0" rIns="0" tIns="0" bIns="0">
+            <a:spAutoFit/>
+          </a:bodyPr>
+          <a:lstStyle/>
+          <a:p>
+            <a:pPr>
+              <a:spcAft>
+                <a:spcPts val="500"/>
+              </a:spcAft>
+              <a:defRPr sz="2000" b="0">
+                <a:solidFill>
+                  <a:srgbClr val="5E6B73"/>
+                </a:solidFill>
+                <a:latin typeface="Arial"/>
+              </a:defRPr>
+            </a:pPr>
+            <a:r>
+              <a:rPr sz="2000" b="0">
+                <a:solidFill>
+                  <a:srgbClr val="5E6B73"/>
+                </a:solidFill>
+                <a:latin typeface="Arial"/>
+              </a:rPr>
+              <a:t>Coseno con PC1: 0,999891 ± 0,000039 en 30 semillas</a:t>
             </a:r>
           </a:p>
         </p:txBody>
@@ -9250,7 +9269,7 @@
                 </a:solidFill>
                 <a:latin typeface="Arial"/>
               </a:rPr>
-              <a:t>El índice ordena un eje de variación</a:t>
+              <a:t>No elegimos al máximo del índice para cualquier campaña</a:t>
             </a:r>
           </a:p>
         </p:txBody>
@@ -9347,7 +9366,7 @@
       </p:sp>
       <p:pic>
         <p:nvPicPr>
-          <p:cNvPr id="6" name="Picture 5" descr="oja_scores.png"/>
+          <p:cNvPr id="6" name="Picture 5" descr="oja_index.png"/>
           <p:cNvPicPr>
             <a:picLocks noChangeAspect="1"/>
           </p:cNvPicPr>
@@ -9361,8 +9380,8 @@
         </p:blipFill>
         <p:spPr>
           <a:xfrm>
-            <a:off x="731520" y="1651946"/>
-            <a:ext cx="9875520" cy="5291467"/>
+            <a:off x="731520" y="1375966"/>
+            <a:ext cx="13167360" cy="3923187"/>
           </a:xfrm>
           <a:prstGeom prst="rect">
             <a:avLst/>
@@ -9377,25 +9396,25 @@
         </p:nvSpPr>
         <p:spPr>
           <a:xfrm>
-            <a:off x="10698480" y="2423160"/>
-            <a:ext cx="3383280" cy="731520"/>
-          </a:xfrm>
-          <a:prstGeom prst="rect">
-            <a:avLst/>
-          </a:prstGeom>
-          <a:noFill/>
-        </p:spPr>
-        <p:txBody>
-          <a:bodyPr wrap="square" lIns="0" rIns="0" tIns="0" bIns="0">
-            <a:spAutoFit/>
-          </a:bodyPr>
-          <a:lstStyle/>
-          <a:p>
-            <a:pPr>
-              <a:spcAft>
-                <a:spcPts val="500"/>
-              </a:spcAft>
-              <a:defRPr sz="2900" b="1">
+            <a:off x="822960" y="5532120"/>
+            <a:ext cx="12984480" cy="457200"/>
+          </a:xfrm>
+          <a:prstGeom prst="rect">
+            <a:avLst/>
+          </a:prstGeom>
+          <a:noFill/>
+        </p:spPr>
+        <p:txBody>
+          <a:bodyPr wrap="square" lIns="0" rIns="0" tIns="0" bIns="0">
+            <a:spAutoFit/>
+          </a:bodyPr>
+          <a:lstStyle/>
+          <a:p>
+            <a:pPr>
+              <a:spcAft>
+                <a:spcPts val="500"/>
+              </a:spcAft>
+              <a:defRPr sz="2100" b="0">
                 <a:solidFill>
                   <a:srgbClr val="18242C"/>
                 </a:solidFill>
@@ -9403,13 +9422,13 @@
               </a:defRPr>
             </a:pPr>
             <a:r>
-              <a:rPr sz="2900" b="1">
+              <a:rPr sz="2100" b="0">
                 <a:solidFill>
                   <a:srgbClr val="18242C"/>
                 </a:solidFill>
                 <a:latin typeface="Arial"/>
               </a:rPr>
-              <a:t>Top 5 estable</a:t>
+              <a:t>Proyección sobre PC1 (coseno 0,9999 con Oja): volumen contra profundidad, no calidad</a:t>
             </a:r>
           </a:p>
         </p:txBody>
@@ -9422,39 +9441,39 @@
         </p:nvSpPr>
         <p:spPr>
           <a:xfrm>
-            <a:off x="10698480" y="3429000"/>
-            <a:ext cx="3383280" cy="822960"/>
-          </a:xfrm>
-          <a:prstGeom prst="rect">
-            <a:avLst/>
-          </a:prstGeom>
-          <a:noFill/>
-        </p:spPr>
-        <p:txBody>
-          <a:bodyPr wrap="square" lIns="0" rIns="0" tIns="0" bIns="0">
-            <a:spAutoFit/>
-          </a:bodyPr>
-          <a:lstStyle/>
-          <a:p>
-            <a:pPr>
-              <a:spcAft>
-                <a:spcPts val="500"/>
-              </a:spcAft>
-              <a:defRPr sz="4400" b="0">
-                <a:solidFill>
-                  <a:srgbClr val="176B72"/>
-                </a:solidFill>
-                <a:latin typeface="Arial"/>
-              </a:defRPr>
-            </a:pPr>
-            <a:r>
-              <a:rPr sz="4400" b="0">
-                <a:solidFill>
-                  <a:srgbClr val="176B72"/>
-                </a:solidFill>
-                <a:latin typeface="Arial"/>
-              </a:rPr>
-              <a:t>30/30</a:t>
+            <a:off x="822960" y="6172200"/>
+            <a:ext cx="12984480" cy="457200"/>
+          </a:xfrm>
+          <a:prstGeom prst="rect">
+            <a:avLst/>
+          </a:prstGeom>
+          <a:noFill/>
+        </p:spPr>
+        <p:txBody>
+          <a:bodyPr wrap="square" lIns="0" rIns="0" tIns="0" bIns="0">
+            <a:spAutoFit/>
+          </a:bodyPr>
+          <a:lstStyle/>
+          <a:p>
+            <a:pPr>
+              <a:spcAft>
+                <a:spcPts val="500"/>
+              </a:spcAft>
+              <a:defRPr sz="2100" b="0">
+                <a:solidFill>
+                  <a:srgbClr val="18242C"/>
+                </a:solidFill>
+                <a:latin typeface="Arial"/>
+              </a:defRPr>
+            </a:pPr>
+            <a:r>
+              <a:rPr sz="2100" b="0">
+                <a:solidFill>
+                  <a:srgbClr val="18242C"/>
+                </a:solidFill>
+                <a:latin typeface="Arial"/>
+              </a:rPr>
+              <a:t>Los cinco más altos son de perros: el máximo ignora tópico, objetivo y precio</a:t>
             </a:r>
           </a:p>
         </p:txBody>
@@ -9467,25 +9486,25 @@
         </p:nvSpPr>
         <p:spPr>
           <a:xfrm>
-            <a:off x="10698480" y="4480560"/>
-            <a:ext cx="3383280" cy="640080"/>
-          </a:xfrm>
-          <a:prstGeom prst="rect">
-            <a:avLst/>
-          </a:prstGeom>
-          <a:noFill/>
-        </p:spPr>
-        <p:txBody>
-          <a:bodyPr wrap="square" lIns="0" rIns="0" tIns="0" bIns="0">
-            <a:spAutoFit/>
-          </a:bodyPr>
-          <a:lstStyle/>
-          <a:p>
-            <a:pPr>
-              <a:spcAft>
-                <a:spcPts val="500"/>
-              </a:spcAft>
-              <a:defRPr sz="2300" b="0">
+            <a:off x="822960" y="6812280"/>
+            <a:ext cx="12984480" cy="457200"/>
+          </a:xfrm>
+          <a:prstGeom prst="rect">
+            <a:avLst/>
+          </a:prstGeom>
+          <a:noFill/>
+        </p:spPr>
+        <p:txBody>
+          <a:bodyPr wrap="square" lIns="0" rIns="0" tIns="0" bIns="0">
+            <a:spAutoFit/>
+          </a:bodyPr>
+          <a:lstStyle/>
+          <a:p>
+            <a:pPr>
+              <a:spcAft>
+                <a:spcPts val="500"/>
+              </a:spcAft>
+              <a:defRPr sz="2100" b="0">
                 <a:solidFill>
                   <a:srgbClr val="18242C"/>
                 </a:solidFill>
@@ -9493,13 +9512,13 @@
               </a:defRPr>
             </a:pPr>
             <a:r>
-              <a:rPr sz="2300" b="0">
+              <a:rPr sz="2100" b="0">
                 <a:solidFill>
                   <a:srgbClr val="18242C"/>
                 </a:solidFill>
                 <a:latin typeface="Arial"/>
               </a:rPr>
-              <a:t>entrenamientos</a:t>
+              <a:t>Invertir el signo invierte el ranking</a:t>
             </a:r>
           </a:p>
         </p:txBody>
@@ -9615,7 +9634,7 @@
                 </a:solidFill>
                 <a:latin typeface="Arial"/>
               </a:rPr>
-              <a:t>Para fútbol priorizamos profundidad</a:t>
+              <a:t>Para fútbol priorizamos profundidad, no alcance</a:t>
             </a:r>
           </a:p>
         </p:txBody>
@@ -9712,7 +9731,7 @@
       </p:sp>
       <p:pic>
         <p:nvPicPr>
-          <p:cNvPr id="6" name="Picture 5" descr="football_profiles.png"/>
+          <p:cNvPr id="6" name="Picture 5" descr="football_strategies.png"/>
           <p:cNvPicPr>
             <a:picLocks noChangeAspect="1"/>
           </p:cNvPicPr>
@@ -9726,8 +9745,8 @@
         </p:blipFill>
         <p:spPr>
           <a:xfrm>
-            <a:off x="731520" y="1893149"/>
-            <a:ext cx="13167360" cy="4534740"/>
+            <a:off x="731520" y="1699422"/>
+            <a:ext cx="13167360" cy="3642035"/>
           </a:xfrm>
           <a:prstGeom prst="rect">
             <a:avLst/>
@@ -9742,39 +9761,39 @@
         </p:nvSpPr>
         <p:spPr>
           <a:xfrm>
-            <a:off x="777240" y="7269480"/>
-            <a:ext cx="12984480" cy="411480"/>
-          </a:xfrm>
-          <a:prstGeom prst="rect">
-            <a:avLst/>
-          </a:prstGeom>
-          <a:noFill/>
-        </p:spPr>
-        <p:txBody>
-          <a:bodyPr wrap="square" lIns="0" rIns="0" tIns="0" bIns="0">
-            <a:spAutoFit/>
-          </a:bodyPr>
-          <a:lstStyle/>
-          <a:p>
-            <a:pPr>
-              <a:spcAft>
-                <a:spcPts val="500"/>
-              </a:spcAft>
-              <a:defRPr sz="2000" b="0">
-                <a:solidFill>
-                  <a:srgbClr val="5E6B73"/>
-                </a:solidFill>
-                <a:latin typeface="Arial"/>
-              </a:defRPr>
-            </a:pPr>
-            <a:r>
-              <a:rPr sz="2000" b="0">
-                <a:solidFill>
-                  <a:srgbClr val="5E6B73"/>
-                </a:solidFill>
-                <a:latin typeface="Arial"/>
-              </a:rPr>
-              <a:t>Candidatos con ≥40% de fútbol · ejemplo de la semilla 42</a:t>
+            <a:off x="822960" y="5989320"/>
+            <a:ext cx="12984480" cy="1097280"/>
+          </a:xfrm>
+          <a:prstGeom prst="rect">
+            <a:avLst/>
+          </a:prstGeom>
+          <a:noFill/>
+        </p:spPr>
+        <p:txBody>
+          <a:bodyPr wrap="square" lIns="0" rIns="0" tIns="0" bIns="0">
+            <a:spAutoFit/>
+          </a:bodyPr>
+          <a:lstStyle/>
+          <a:p>
+            <a:pPr>
+              <a:spcAft>
+                <a:spcPts val="500"/>
+              </a:spcAft>
+              <a:defRPr sz="2100" b="0">
+                <a:solidFill>
+                  <a:srgbClr val="5E6B73"/>
+                </a:solidFill>
+                <a:latin typeface="Arial"/>
+              </a:defRPr>
+            </a:pPr>
+            <a:r>
+              <a:rPr sz="2100" b="0">
+                <a:solidFill>
+                  <a:srgbClr val="5E6B73"/>
+                </a:solidFill>
+                <a:latin typeface="Arial"/>
+              </a:rPr>
+              <a:t>Supuesto comercial: la ropa de entrenamiento se compra tras aprender a usarla, así que guardados y tutoriales pesan más que los seguidores. Sin ventas no se prueba rentabilidad.</a:t>
             </a:r>
           </a:p>
         </p:txBody>
@@ -11517,7 +11536,7 @@
                 </a:solidFill>
                 <a:latin typeface="Arial"/>
               </a:rPr>
-              <a:t>Los cambios de datos obligan a revisar el análisis</a:t>
+              <a:t>Solo seguidores: más alcance, más costo y menos foco</a:t>
             </a:r>
           </a:p>
         </p:txBody>
@@ -11612,33 +11631,57 @@
           </a:p>
         </p:txBody>
       </p:sp>
-      <p:sp>
-        <p:nvSpPr>
-          <p:cNvPr id="6" name="TextBox 5"/>
-          <p:cNvSpPr txBox="1"/>
-          <p:nvPr/>
-        </p:nvSpPr>
-        <p:spPr>
-          <a:xfrm>
-            <a:off x="868680" y="2194560"/>
-            <a:ext cx="4754880" cy="731520"/>
-          </a:xfrm>
-          <a:prstGeom prst="rect">
-            <a:avLst/>
-          </a:prstGeom>
-          <a:noFill/>
-        </p:spPr>
-        <p:txBody>
-          <a:bodyPr wrap="square" lIns="0" rIns="0" tIns="0" bIns="0">
-            <a:spAutoFit/>
-          </a:bodyPr>
-          <a:lstStyle/>
-          <a:p>
-            <a:pPr>
-              <a:spcAft>
-                <a:spcPts val="500"/>
-              </a:spcAft>
-              <a:defRPr sz="3000" b="1">
+      <p:pic>
+        <p:nvPicPr>
+          <p:cNvPr id="6" name="Picture 5" descr="followers_vs_selection.png"/>
+          <p:cNvPicPr>
+            <a:picLocks noChangeAspect="1"/>
+          </p:cNvPicPr>
+          <p:nvPr/>
+        </p:nvPicPr>
+        <p:blipFill>
+          <a:blip r:embed="rId3"/>
+          <a:stretch>
+            <a:fillRect/>
+          </a:stretch>
+        </p:blipFill>
+        <p:spPr>
+          <a:xfrm>
+            <a:off x="731520" y="1393368"/>
+            <a:ext cx="13167360" cy="3614063"/>
+          </a:xfrm>
+          <a:prstGeom prst="rect">
+            <a:avLst/>
+          </a:prstGeom>
+        </p:spPr>
+      </p:pic>
+      <p:sp>
+        <p:nvSpPr>
+          <p:cNvPr id="7" name="TextBox 6"/>
+          <p:cNvSpPr txBox="1"/>
+          <p:nvPr/>
+        </p:nvSpPr>
+        <p:spPr>
+          <a:xfrm>
+            <a:off x="822960" y="5212080"/>
+            <a:ext cx="6217920" cy="457200"/>
+          </a:xfrm>
+          <a:prstGeom prst="rect">
+            <a:avLst/>
+          </a:prstGeom>
+          <a:noFill/>
+        </p:spPr>
+        <p:txBody>
+          <a:bodyPr wrap="square" lIns="0" rIns="0" tIns="0" bIns="0">
+            <a:spAutoFit/>
+          </a:bodyPr>
+          <a:lstStyle/>
+          <a:p>
+            <a:pPr>
+              <a:spcAft>
+                <a:spcPts val="500"/>
+              </a:spcAft>
+              <a:defRPr sz="2400" b="1">
                 <a:solidFill>
                   <a:srgbClr val="18242C"/>
                 </a:solidFill>
@@ -11646,58 +11689,13 @@
               </a:defRPr>
             </a:pPr>
             <a:r>
-              <a:rPr sz="3000" b="1">
+              <a:rPr sz="2400" b="1">
                 <a:solidFill>
                   <a:srgbClr val="18242C"/>
                 </a:solidFill>
                 <a:latin typeface="Arial"/>
               </a:rPr>
-              <a:t>Campaña nueva</a:t>
-            </a:r>
-          </a:p>
-        </p:txBody>
-      </p:sp>
-      <p:sp>
-        <p:nvSpPr>
-          <p:cNvPr id="7" name="TextBox 6"/>
-          <p:cNvSpPr txBox="1"/>
-          <p:nvPr/>
-        </p:nvSpPr>
-        <p:spPr>
-          <a:xfrm>
-            <a:off x="5897880" y="2194560"/>
-            <a:ext cx="914400" cy="731520"/>
-          </a:xfrm>
-          <a:prstGeom prst="rect">
-            <a:avLst/>
-          </a:prstGeom>
-          <a:noFill/>
-        </p:spPr>
-        <p:txBody>
-          <a:bodyPr wrap="square" lIns="0" rIns="0" tIns="0" bIns="0">
-            <a:spAutoFit/>
-          </a:bodyPr>
-          <a:lstStyle/>
-          <a:p>
-            <a:pPr>
-              <a:spcAft>
-                <a:spcPts val="500"/>
-              </a:spcAft>
-              <a:defRPr sz="3400" b="0">
-                <a:solidFill>
-                  <a:srgbClr val="5E6B73"/>
-                </a:solidFill>
-                <a:latin typeface="Arial"/>
-              </a:defRPr>
-            </a:pPr>
-            <a:r>
-              <a:rPr sz="3400" b="0">
-                <a:solidFill>
-                  <a:srgbClr val="5E6B73"/>
-                </a:solidFill>
-                <a:latin typeface="Arial"/>
-              </a:rPr>
-              <a:t>→</a:t>
+              <a:t>Solo seguidores</a:t>
             </a:r>
           </a:p>
         </p:txBody>
@@ -11710,25 +11708,92 @@
         </p:nvSpPr>
         <p:spPr>
           <a:xfrm>
-            <a:off x="7315200" y="2194560"/>
-            <a:ext cx="6400800" cy="914400"/>
-          </a:xfrm>
-          <a:prstGeom prst="rect">
-            <a:avLst/>
-          </a:prstGeom>
-          <a:noFill/>
-        </p:spPr>
-        <p:txBody>
-          <a:bodyPr wrap="square" lIns="0" rIns="0" tIns="0" bIns="0">
-            <a:spAutoFit/>
-          </a:bodyPr>
-          <a:lstStyle/>
-          <a:p>
-            <a:pPr>
-              <a:spcAft>
-                <a:spcPts val="500"/>
-              </a:spcAft>
-              <a:defRPr sz="2800" b="0">
+            <a:off x="822960" y="5760720"/>
+            <a:ext cx="6217920" cy="1737360"/>
+          </a:xfrm>
+          <a:prstGeom prst="rect">
+            <a:avLst/>
+          </a:prstGeom>
+          <a:noFill/>
+        </p:spPr>
+        <p:txBody>
+          <a:bodyPr wrap="square" lIns="0" rIns="0" tIns="0" bIns="0">
+            <a:spAutoFit/>
+          </a:bodyPr>
+          <a:lstStyle/>
+          <a:p>
+            <a:pPr>
+              <a:spcAft>
+                <a:spcPts val="500"/>
+              </a:spcAft>
+              <a:defRPr sz="1900" b="0">
+                <a:solidFill>
+                  <a:srgbClr val="5E6B73"/>
+                </a:solidFill>
+                <a:latin typeface="Arial"/>
+              </a:defRPr>
+            </a:pPr>
+            <a:r>
+              <a:rPr sz="1900" b="0">
+                <a:solidFill>
+                  <a:srgbClr val="5E6B73"/>
+                </a:solidFill>
+                <a:latin typeface="Arial"/>
+              </a:rPr>
+              <a:t>Más alcance bruto y audiencia argentina</a:t>
+            </a:r>
+          </a:p>
+          <a:p>
+            <a:pPr>
+              <a:spcAft>
+                <a:spcPts val="500"/>
+              </a:spcAft>
+              <a:defRPr sz="1900" b="0">
+                <a:solidFill>
+                  <a:srgbClr val="5E6B73"/>
+                </a:solidFill>
+                <a:latin typeface="Arial"/>
+              </a:defRPr>
+            </a:pPr>
+            <a:r>
+              <a:rPr sz="1900" b="0">
+                <a:solidFill>
+                  <a:srgbClr val="5E6B73"/>
+                </a:solidFill>
+                <a:latin typeface="Arial"/>
+              </a:rPr>
+              <a:t>Mismo trío para todas; tópico 9,5% a 46,0%; USD 6.993 a 15.897</a:t>
+            </a:r>
+          </a:p>
+        </p:txBody>
+      </p:sp>
+      <p:sp>
+        <p:nvSpPr>
+          <p:cNvPr id="9" name="TextBox 8"/>
+          <p:cNvSpPr txBox="1"/>
+          <p:nvPr/>
+        </p:nvSpPr>
+        <p:spPr>
+          <a:xfrm>
+            <a:off x="7680960" y="5212080"/>
+            <a:ext cx="6217920" cy="457200"/>
+          </a:xfrm>
+          <a:prstGeom prst="rect">
+            <a:avLst/>
+          </a:prstGeom>
+          <a:noFill/>
+        </p:spPr>
+        <p:txBody>
+          <a:bodyPr wrap="square" lIns="0" rIns="0" tIns="0" bIns="0">
+            <a:spAutoFit/>
+          </a:bodyPr>
+          <a:lstStyle/>
+          <a:p>
+            <a:pPr>
+              <a:spcAft>
+                <a:spcPts val="500"/>
+              </a:spcAft>
+              <a:defRPr sz="2400" b="1">
                 <a:solidFill>
                   <a:srgbClr val="176B72"/>
                 </a:solidFill>
@@ -11736,58 +11801,13 @@
               </a:defRPr>
             </a:pPr>
             <a:r>
-              <a:rPr sz="2800" b="0">
+              <a:rPr sz="2400" b="1">
                 <a:solidFill>
                   <a:srgbClr val="176B72"/>
                 </a:solidFill>
                 <a:latin typeface="Arial"/>
               </a:rPr>
-              <a:t>Revisar objetivo y criterios</a:t>
-            </a:r>
-          </a:p>
-        </p:txBody>
-      </p:sp>
-      <p:sp>
-        <p:nvSpPr>
-          <p:cNvPr id="9" name="TextBox 8"/>
-          <p:cNvSpPr txBox="1"/>
-          <p:nvPr/>
-        </p:nvSpPr>
-        <p:spPr>
-          <a:xfrm>
-            <a:off x="868680" y="3749039"/>
-            <a:ext cx="4754880" cy="731520"/>
-          </a:xfrm>
-          <a:prstGeom prst="rect">
-            <a:avLst/>
-          </a:prstGeom>
-          <a:noFill/>
-        </p:spPr>
-        <p:txBody>
-          <a:bodyPr wrap="square" lIns="0" rIns="0" tIns="0" bIns="0">
-            <a:spAutoFit/>
-          </a:bodyPr>
-          <a:lstStyle/>
-          <a:p>
-            <a:pPr>
-              <a:spcAft>
-                <a:spcPts val="500"/>
-              </a:spcAft>
-              <a:defRPr sz="3000" b="1">
-                <a:solidFill>
-                  <a:srgbClr val="18242C"/>
-                </a:solidFill>
-                <a:latin typeface="Arial"/>
-              </a:defRPr>
-            </a:pPr>
-            <a:r>
-              <a:rPr sz="3000" b="1">
-                <a:solidFill>
-                  <a:srgbClr val="18242C"/>
-                </a:solidFill>
-                <a:latin typeface="Arial"/>
-              </a:rPr>
-              <a:t>Datos actualizados</a:t>
+              <a:t>Nuestra selección</a:t>
             </a:r>
           </a:p>
         </p:txBody>
@@ -11800,70 +11820,25 @@
         </p:nvSpPr>
         <p:spPr>
           <a:xfrm>
-            <a:off x="5897880" y="3749039"/>
-            <a:ext cx="914400" cy="731520"/>
-          </a:xfrm>
-          <a:prstGeom prst="rect">
-            <a:avLst/>
-          </a:prstGeom>
-          <a:noFill/>
-        </p:spPr>
-        <p:txBody>
-          <a:bodyPr wrap="square" lIns="0" rIns="0" tIns="0" bIns="0">
-            <a:spAutoFit/>
-          </a:bodyPr>
-          <a:lstStyle/>
-          <a:p>
-            <a:pPr>
-              <a:spcAft>
-                <a:spcPts val="500"/>
-              </a:spcAft>
-              <a:defRPr sz="3400" b="0">
-                <a:solidFill>
-                  <a:srgbClr val="5E6B73"/>
-                </a:solidFill>
-                <a:latin typeface="Arial"/>
-              </a:defRPr>
-            </a:pPr>
-            <a:r>
-              <a:rPr sz="3400" b="0">
-                <a:solidFill>
-                  <a:srgbClr val="5E6B73"/>
-                </a:solidFill>
-                <a:latin typeface="Arial"/>
-              </a:rPr>
-              <a:t>→</a:t>
-            </a:r>
-          </a:p>
-        </p:txBody>
-      </p:sp>
-      <p:sp>
-        <p:nvSpPr>
-          <p:cNvPr id="11" name="TextBox 10"/>
-          <p:cNvSpPr txBox="1"/>
-          <p:nvPr/>
-        </p:nvSpPr>
-        <p:spPr>
-          <a:xfrm>
-            <a:off x="7315200" y="3749039"/>
-            <a:ext cx="6400800" cy="914400"/>
-          </a:xfrm>
-          <a:prstGeom prst="rect">
-            <a:avLst/>
-          </a:prstGeom>
-          <a:noFill/>
-        </p:spPr>
-        <p:txBody>
-          <a:bodyPr wrap="square" lIns="0" rIns="0" tIns="0" bIns="0">
-            <a:spAutoFit/>
-          </a:bodyPr>
-          <a:lstStyle/>
-          <a:p>
-            <a:pPr>
-              <a:spcAft>
-                <a:spcPts val="500"/>
-              </a:spcAft>
-              <a:defRPr sz="2800" b="0">
+            <a:off x="7680960" y="5760720"/>
+            <a:ext cx="6217920" cy="1737360"/>
+          </a:xfrm>
+          <a:prstGeom prst="rect">
+            <a:avLst/>
+          </a:prstGeom>
+          <a:noFill/>
+        </p:spPr>
+        <p:txBody>
+          <a:bodyPr wrap="square" lIns="0" rIns="0" tIns="0" bIns="0">
+            <a:spAutoFit/>
+          </a:bodyPr>
+          <a:lstStyle/>
+          <a:p>
+            <a:pPr>
+              <a:spcAft>
+                <a:spcPts val="500"/>
+              </a:spcAft>
+              <a:defRPr sz="1900" b="0">
                 <a:solidFill>
                   <a:srgbClr val="176B72"/>
                 </a:solidFill>
@@ -11871,134 +11846,21 @@
               </a:defRPr>
             </a:pPr>
             <a:r>
-              <a:rPr sz="2800" b="0">
+              <a:rPr sz="1900" b="0">
                 <a:solidFill>
                   <a:srgbClr val="176B72"/>
                 </a:solidFill>
                 <a:latin typeface="Arial"/>
               </a:rPr>
-              <a:t>Revisar escalas y entrenamientos</a:t>
-            </a:r>
-          </a:p>
-        </p:txBody>
-      </p:sp>
-      <p:sp>
-        <p:nvSpPr>
-          <p:cNvPr id="12" name="TextBox 11"/>
-          <p:cNvSpPr txBox="1"/>
-          <p:nvPr/>
-        </p:nvSpPr>
-        <p:spPr>
-          <a:xfrm>
-            <a:off x="868680" y="5303520"/>
-            <a:ext cx="4754880" cy="731520"/>
-          </a:xfrm>
-          <a:prstGeom prst="rect">
-            <a:avLst/>
-          </a:prstGeom>
-          <a:noFill/>
-        </p:spPr>
-        <p:txBody>
-          <a:bodyPr wrap="square" lIns="0" rIns="0" tIns="0" bIns="0">
-            <a:spAutoFit/>
-          </a:bodyPr>
-          <a:lstStyle/>
-          <a:p>
-            <a:pPr>
-              <a:spcAft>
-                <a:spcPts val="500"/>
-              </a:spcAft>
-              <a:defRPr sz="3000" b="1">
-                <a:solidFill>
-                  <a:srgbClr val="18242C"/>
-                </a:solidFill>
-                <a:latin typeface="Arial"/>
-              </a:defRPr>
-            </a:pPr>
-            <a:r>
-              <a:rPr sz="3000" b="1">
-                <a:solidFill>
-                  <a:srgbClr val="18242C"/>
-                </a:solidFill>
-                <a:latin typeface="Arial"/>
-              </a:rPr>
-              <a:t>Variables nuevas</a:t>
-            </a:r>
-          </a:p>
-        </p:txBody>
-      </p:sp>
-      <p:sp>
-        <p:nvSpPr>
-          <p:cNvPr id="13" name="TextBox 12"/>
-          <p:cNvSpPr txBox="1"/>
-          <p:nvPr/>
-        </p:nvSpPr>
-        <p:spPr>
-          <a:xfrm>
-            <a:off x="5897880" y="5303520"/>
-            <a:ext cx="914400" cy="731520"/>
-          </a:xfrm>
-          <a:prstGeom prst="rect">
-            <a:avLst/>
-          </a:prstGeom>
-          <a:noFill/>
-        </p:spPr>
-        <p:txBody>
-          <a:bodyPr wrap="square" lIns="0" rIns="0" tIns="0" bIns="0">
-            <a:spAutoFit/>
-          </a:bodyPr>
-          <a:lstStyle/>
-          <a:p>
-            <a:pPr>
-              <a:spcAft>
-                <a:spcPts val="500"/>
-              </a:spcAft>
-              <a:defRPr sz="3400" b="0">
-                <a:solidFill>
-                  <a:srgbClr val="5E6B73"/>
-                </a:solidFill>
-                <a:latin typeface="Arial"/>
-              </a:defRPr>
-            </a:pPr>
-            <a:r>
-              <a:rPr sz="3400" b="0">
-                <a:solidFill>
-                  <a:srgbClr val="5E6B73"/>
-                </a:solidFill>
-                <a:latin typeface="Arial"/>
-              </a:rPr>
-              <a:t>→</a:t>
-            </a:r>
-          </a:p>
-        </p:txBody>
-      </p:sp>
-      <p:sp>
-        <p:nvSpPr>
-          <p:cNvPr id="14" name="TextBox 13"/>
-          <p:cNvSpPr txBox="1"/>
-          <p:nvPr/>
-        </p:nvSpPr>
-        <p:spPr>
-          <a:xfrm>
-            <a:off x="7315200" y="5303520"/>
-            <a:ext cx="6400800" cy="914400"/>
-          </a:xfrm>
-          <a:prstGeom prst="rect">
-            <a:avLst/>
-          </a:prstGeom>
-          <a:noFill/>
-        </p:spPr>
-        <p:txBody>
-          <a:bodyPr wrap="square" lIns="0" rIns="0" tIns="0" bIns="0">
-            <a:spAutoFit/>
-          </a:bodyPr>
-          <a:lstStyle/>
-          <a:p>
-            <a:pPr>
-              <a:spcAft>
-                <a:spcPts val="500"/>
-              </a:spcAft>
-              <a:defRPr sz="2800" b="0">
+              <a:t>Más tópico, guardados y tutoriales; USD 683 a 2.525</a:t>
+            </a:r>
+          </a:p>
+          <a:p>
+            <a:pPr>
+              <a:spcAft>
+                <a:spcPts val="500"/>
+              </a:spcAft>
+              <a:defRPr sz="1900" b="0">
                 <a:solidFill>
                   <a:srgbClr val="176B72"/>
                 </a:solidFill>
@@ -12006,13 +11868,13 @@
               </a:defRPr>
             </a:pPr>
             <a:r>
-              <a:rPr sz="2800" b="0">
+              <a:rPr sz="1900" b="0">
                 <a:solidFill>
                   <a:srgbClr val="176B72"/>
                 </a:solidFill>
                 <a:latin typeface="Arial"/>
               </a:rPr>
-              <a:t>Repetir representación y modelos</a:t>
+              <a:t>Menos alcance; depende de supuestos; sin ventas no prueba rentabilidad</a:t>
             </a:r>
           </a:p>
         </p:txBody>
@@ -12083,7 +11945,7 @@
                 </a:solidFill>
                 <a:latin typeface="Arial"/>
               </a:rPr>
-              <a:t>Ejercicio 2: Memoria asociativa · 2.1 Hopfield: letras 5×5 y códigos QR</a:t>
+              <a:t>Ejercicio 1: Creadores de contenido · 1.4 Campañas y cambios de datos</a:t>
             </a:r>
           </a:p>
         </p:txBody>
@@ -12128,7 +11990,7 @@
                 </a:solidFill>
                 <a:latin typeface="Arial"/>
               </a:rPr>
-              <a:t>Primero almacenamos cuatro letras</a:t>
+              <a:t>Cada cambio de datos obliga a rehacer algo distinto</a:t>
             </a:r>
           </a:p>
         </p:txBody>
@@ -12223,30 +12085,498 @@
           </a:p>
         </p:txBody>
       </p:sp>
-      <p:pic>
-        <p:nvPicPr>
-          <p:cNvPr id="6" name="Picture 5" descr="hopfield_letters__storage.png"/>
-          <p:cNvPicPr>
-            <a:picLocks noChangeAspect="1"/>
-          </p:cNvPicPr>
-          <p:nvPr/>
-        </p:nvPicPr>
-        <p:blipFill>
-          <a:blip r:embed="rId3"/>
-          <a:stretch>
-            <a:fillRect/>
-          </a:stretch>
-        </p:blipFill>
-        <p:spPr>
-          <a:xfrm>
-            <a:off x="594360" y="1529053"/>
-            <a:ext cx="13533120" cy="5674413"/>
-          </a:xfrm>
-          <a:prstGeom prst="rect">
-            <a:avLst/>
-          </a:prstGeom>
-        </p:spPr>
-      </p:pic>
+      <p:sp>
+        <p:nvSpPr>
+          <p:cNvPr id="6" name="TextBox 5"/>
+          <p:cNvSpPr txBox="1"/>
+          <p:nvPr/>
+        </p:nvSpPr>
+        <p:spPr>
+          <a:xfrm>
+            <a:off x="822960" y="1600200"/>
+            <a:ext cx="4206240" cy="914400"/>
+          </a:xfrm>
+          <a:prstGeom prst="rect">
+            <a:avLst/>
+          </a:prstGeom>
+          <a:noFill/>
+        </p:spPr>
+        <p:txBody>
+          <a:bodyPr wrap="square" lIns="0" rIns="0" tIns="0" bIns="0">
+            <a:spAutoFit/>
+          </a:bodyPr>
+          <a:lstStyle/>
+          <a:p>
+            <a:pPr>
+              <a:spcAft>
+                <a:spcPts val="500"/>
+              </a:spcAft>
+              <a:defRPr sz="2200" b="1">
+                <a:solidFill>
+                  <a:srgbClr val="18242C"/>
+                </a:solidFill>
+                <a:latin typeface="Arial"/>
+              </a:defRPr>
+            </a:pPr>
+            <a:r>
+              <a:rPr sz="2200" b="1">
+                <a:solidFill>
+                  <a:srgbClr val="18242C"/>
+                </a:solidFill>
+                <a:latin typeface="Arial"/>
+              </a:rPr>
+              <a:t>Campaña nueva</a:t>
+            </a:r>
+          </a:p>
+        </p:txBody>
+      </p:sp>
+      <p:sp>
+        <p:nvSpPr>
+          <p:cNvPr id="7" name="TextBox 6"/>
+          <p:cNvSpPr txBox="1"/>
+          <p:nvPr/>
+        </p:nvSpPr>
+        <p:spPr>
+          <a:xfrm>
+            <a:off x="5212080" y="1600200"/>
+            <a:ext cx="8595360" cy="1005840"/>
+          </a:xfrm>
+          <a:prstGeom prst="rect">
+            <a:avLst/>
+          </a:prstGeom>
+          <a:noFill/>
+        </p:spPr>
+        <p:txBody>
+          <a:bodyPr wrap="square" lIns="0" rIns="0" tIns="0" bIns="0">
+            <a:spAutoFit/>
+          </a:bodyPr>
+          <a:lstStyle/>
+          <a:p>
+            <a:pPr>
+              <a:spcAft>
+                <a:spcPts val="500"/>
+              </a:spcAft>
+              <a:defRPr sz="2100" b="0">
+                <a:solidFill>
+                  <a:srgbClr val="176B72"/>
+                </a:solidFill>
+                <a:latin typeface="Arial"/>
+              </a:defRPr>
+            </a:pPr>
+            <a:r>
+              <a:rPr sz="2100" b="0">
+                <a:solidFill>
+                  <a:srgbClr val="176B72"/>
+                </a:solidFill>
+                <a:latin typeface="Arial"/>
+              </a:rPr>
+              <a:t>Se redefinen objetivo y supuestos; los modelos no cambian</a:t>
+            </a:r>
+          </a:p>
+        </p:txBody>
+      </p:sp>
+      <p:sp>
+        <p:nvSpPr>
+          <p:cNvPr id="8" name="Rectangle 7"/>
+          <p:cNvSpPr/>
+          <p:nvPr/>
+        </p:nvSpPr>
+        <p:spPr>
+          <a:xfrm>
+            <a:off x="822960" y="2651760"/>
+            <a:ext cx="12984480" cy="18288"/>
+          </a:xfrm>
+          <a:prstGeom prst="rect">
+            <a:avLst/>
+          </a:prstGeom>
+          <a:solidFill>
+            <a:srgbClr val="DDE3E5"/>
+          </a:solidFill>
+          <a:ln>
+            <a:noFill/>
+          </a:ln>
+          <a:effectLst/>
+        </p:spPr>
+        <p:style>
+          <a:lnRef idx="1">
+            <a:schemeClr val="accent1"/>
+          </a:lnRef>
+          <a:fillRef idx="3">
+            <a:schemeClr val="accent1"/>
+          </a:fillRef>
+          <a:effectRef idx="2">
+            <a:schemeClr val="accent1"/>
+          </a:effectRef>
+          <a:fontRef idx="minor">
+            <a:schemeClr val="lt1"/>
+          </a:fontRef>
+        </p:style>
+        <p:txBody>
+          <a:bodyPr rtlCol="0" anchor="ctr"/>
+          <a:lstStyle/>
+          <a:p>
+            <a:pPr algn="ctr"/>
+          </a:p>
+        </p:txBody>
+      </p:sp>
+      <p:sp>
+        <p:nvSpPr>
+          <p:cNvPr id="9" name="TextBox 8"/>
+          <p:cNvSpPr txBox="1"/>
+          <p:nvPr/>
+        </p:nvSpPr>
+        <p:spPr>
+          <a:xfrm>
+            <a:off x="822960" y="2834640"/>
+            <a:ext cx="4206240" cy="914400"/>
+          </a:xfrm>
+          <a:prstGeom prst="rect">
+            <a:avLst/>
+          </a:prstGeom>
+          <a:noFill/>
+        </p:spPr>
+        <p:txBody>
+          <a:bodyPr wrap="square" lIns="0" rIns="0" tIns="0" bIns="0">
+            <a:spAutoFit/>
+          </a:bodyPr>
+          <a:lstStyle/>
+          <a:p>
+            <a:pPr>
+              <a:spcAft>
+                <a:spcPts val="500"/>
+              </a:spcAft>
+              <a:defRPr sz="2200" b="1">
+                <a:solidFill>
+                  <a:srgbClr val="18242C"/>
+                </a:solidFill>
+                <a:latin typeface="Arial"/>
+              </a:defRPr>
+            </a:pPr>
+            <a:r>
+              <a:rPr sz="2200" b="1">
+                <a:solidFill>
+                  <a:srgbClr val="18242C"/>
+                </a:solidFill>
+                <a:latin typeface="Arial"/>
+              </a:rPr>
+              <a:t>Creador nuevo o mes nuevo</a:t>
+            </a:r>
+          </a:p>
+        </p:txBody>
+      </p:sp>
+      <p:sp>
+        <p:nvSpPr>
+          <p:cNvPr id="10" name="TextBox 9"/>
+          <p:cNvSpPr txBox="1"/>
+          <p:nvPr/>
+        </p:nvSpPr>
+        <p:spPr>
+          <a:xfrm>
+            <a:off x="5212080" y="2834640"/>
+            <a:ext cx="8595360" cy="1005840"/>
+          </a:xfrm>
+          <a:prstGeom prst="rect">
+            <a:avLst/>
+          </a:prstGeom>
+          <a:noFill/>
+        </p:spPr>
+        <p:txBody>
+          <a:bodyPr wrap="square" lIns="0" rIns="0" tIns="0" bIns="0">
+            <a:spAutoFit/>
+          </a:bodyPr>
+          <a:lstStyle/>
+          <a:p>
+            <a:pPr>
+              <a:spcAft>
+                <a:spcPts val="500"/>
+              </a:spcAft>
+              <a:defRPr sz="2100" b="0">
+                <a:solidFill>
+                  <a:srgbClr val="176B72"/>
+                </a:solidFill>
+                <a:latin typeface="Arial"/>
+              </a:defRPr>
+            </a:pPr>
+            <a:r>
+              <a:rPr sz="2100" b="0">
+                <a:solidFill>
+                  <a:srgbClr val="176B72"/>
+                </a:solidFill>
+                <a:latin typeface="Arial"/>
+              </a:rPr>
+              <a:t>Se proyecta con lo existente; si cambia la distribución, se rehace</a:t>
+            </a:r>
+          </a:p>
+        </p:txBody>
+      </p:sp>
+      <p:sp>
+        <p:nvSpPr>
+          <p:cNvPr id="11" name="Rectangle 10"/>
+          <p:cNvSpPr/>
+          <p:nvPr/>
+        </p:nvSpPr>
+        <p:spPr>
+          <a:xfrm>
+            <a:off x="822960" y="3886200"/>
+            <a:ext cx="12984480" cy="18288"/>
+          </a:xfrm>
+          <a:prstGeom prst="rect">
+            <a:avLst/>
+          </a:prstGeom>
+          <a:solidFill>
+            <a:srgbClr val="DDE3E5"/>
+          </a:solidFill>
+          <a:ln>
+            <a:noFill/>
+          </a:ln>
+          <a:effectLst/>
+        </p:spPr>
+        <p:style>
+          <a:lnRef idx="1">
+            <a:schemeClr val="accent1"/>
+          </a:lnRef>
+          <a:fillRef idx="3">
+            <a:schemeClr val="accent1"/>
+          </a:fillRef>
+          <a:effectRef idx="2">
+            <a:schemeClr val="accent1"/>
+          </a:effectRef>
+          <a:fontRef idx="minor">
+            <a:schemeClr val="lt1"/>
+          </a:fontRef>
+        </p:style>
+        <p:txBody>
+          <a:bodyPr rtlCol="0" anchor="ctr"/>
+          <a:lstStyle/>
+          <a:p>
+            <a:pPr algn="ctr"/>
+          </a:p>
+        </p:txBody>
+      </p:sp>
+      <p:sp>
+        <p:nvSpPr>
+          <p:cNvPr id="12" name="TextBox 11"/>
+          <p:cNvSpPr txBox="1"/>
+          <p:nvPr/>
+        </p:nvSpPr>
+        <p:spPr>
+          <a:xfrm>
+            <a:off x="822960" y="4069080"/>
+            <a:ext cx="4206240" cy="914400"/>
+          </a:xfrm>
+          <a:prstGeom prst="rect">
+            <a:avLst/>
+          </a:prstGeom>
+          <a:noFill/>
+        </p:spPr>
+        <p:txBody>
+          <a:bodyPr wrap="square" lIns="0" rIns="0" tIns="0" bIns="0">
+            <a:spAutoFit/>
+          </a:bodyPr>
+          <a:lstStyle/>
+          <a:p>
+            <a:pPr>
+              <a:spcAft>
+                <a:spcPts val="500"/>
+              </a:spcAft>
+              <a:defRPr sz="2200" b="1">
+                <a:solidFill>
+                  <a:srgbClr val="18242C"/>
+                </a:solidFill>
+                <a:latin typeface="Arial"/>
+              </a:defRPr>
+            </a:pPr>
+            <a:r>
+              <a:rPr sz="2200" b="1">
+                <a:solidFill>
+                  <a:srgbClr val="18242C"/>
+                </a:solidFill>
+                <a:latin typeface="Arial"/>
+              </a:rPr>
+              <a:t>Variables nuevas</a:t>
+            </a:r>
+          </a:p>
+        </p:txBody>
+      </p:sp>
+      <p:sp>
+        <p:nvSpPr>
+          <p:cNvPr id="13" name="TextBox 12"/>
+          <p:cNvSpPr txBox="1"/>
+          <p:nvPr/>
+        </p:nvSpPr>
+        <p:spPr>
+          <a:xfrm>
+            <a:off x="5212080" y="4069080"/>
+            <a:ext cx="8595360" cy="1005840"/>
+          </a:xfrm>
+          <a:prstGeom prst="rect">
+            <a:avLst/>
+          </a:prstGeom>
+          <a:noFill/>
+        </p:spPr>
+        <p:txBody>
+          <a:bodyPr wrap="square" lIns="0" rIns="0" tIns="0" bIns="0">
+            <a:spAutoFit/>
+          </a:bodyPr>
+          <a:lstStyle/>
+          <a:p>
+            <a:pPr>
+              <a:spcAft>
+                <a:spcPts val="500"/>
+              </a:spcAft>
+              <a:defRPr sz="2100" b="0">
+                <a:solidFill>
+                  <a:srgbClr val="176B72"/>
+                </a:solidFill>
+                <a:latin typeface="Arial"/>
+              </a:defRPr>
+            </a:pPr>
+            <a:r>
+              <a:rPr sz="2100" b="0">
+                <a:solidFill>
+                  <a:srgbClr val="176B72"/>
+                </a:solidFill>
+                <a:latin typeface="Arial"/>
+              </a:rPr>
+              <a:t>Cambian distancias y componentes: repetir PCA, Kohonen y Oja</a:t>
+            </a:r>
+          </a:p>
+        </p:txBody>
+      </p:sp>
+      <p:sp>
+        <p:nvSpPr>
+          <p:cNvPr id="14" name="Rectangle 13"/>
+          <p:cNvSpPr/>
+          <p:nvPr/>
+        </p:nvSpPr>
+        <p:spPr>
+          <a:xfrm>
+            <a:off x="822960" y="5120640"/>
+            <a:ext cx="12984480" cy="18288"/>
+          </a:xfrm>
+          <a:prstGeom prst="rect">
+            <a:avLst/>
+          </a:prstGeom>
+          <a:solidFill>
+            <a:srgbClr val="DDE3E5"/>
+          </a:solidFill>
+          <a:ln>
+            <a:noFill/>
+          </a:ln>
+          <a:effectLst/>
+        </p:spPr>
+        <p:style>
+          <a:lnRef idx="1">
+            <a:schemeClr val="accent1"/>
+          </a:lnRef>
+          <a:fillRef idx="3">
+            <a:schemeClr val="accent1"/>
+          </a:fillRef>
+          <a:effectRef idx="2">
+            <a:schemeClr val="accent1"/>
+          </a:effectRef>
+          <a:fontRef idx="minor">
+            <a:schemeClr val="lt1"/>
+          </a:fontRef>
+        </p:style>
+        <p:txBody>
+          <a:bodyPr rtlCol="0" anchor="ctr"/>
+          <a:lstStyle/>
+          <a:p>
+            <a:pPr algn="ctr"/>
+          </a:p>
+        </p:txBody>
+      </p:sp>
+      <p:sp>
+        <p:nvSpPr>
+          <p:cNvPr id="15" name="TextBox 14"/>
+          <p:cNvSpPr txBox="1"/>
+          <p:nvPr/>
+        </p:nvSpPr>
+        <p:spPr>
+          <a:xfrm>
+            <a:off x="822960" y="5303520"/>
+            <a:ext cx="4206240" cy="914400"/>
+          </a:xfrm>
+          <a:prstGeom prst="rect">
+            <a:avLst/>
+          </a:prstGeom>
+          <a:noFill/>
+        </p:spPr>
+        <p:txBody>
+          <a:bodyPr wrap="square" lIns="0" rIns="0" tIns="0" bIns="0">
+            <a:spAutoFit/>
+          </a:bodyPr>
+          <a:lstStyle/>
+          <a:p>
+            <a:pPr>
+              <a:spcAft>
+                <a:spcPts val="500"/>
+              </a:spcAft>
+              <a:defRPr sz="2200" b="1">
+                <a:solidFill>
+                  <a:srgbClr val="18242C"/>
+                </a:solidFill>
+                <a:latin typeface="Arial"/>
+              </a:defRPr>
+            </a:pPr>
+            <a:r>
+              <a:rPr sz="2200" b="1">
+                <a:solidFill>
+                  <a:srgbClr val="18242C"/>
+                </a:solidFill>
+                <a:latin typeface="Arial"/>
+              </a:rPr>
+              <a:t>Registro</a:t>
+            </a:r>
+          </a:p>
+        </p:txBody>
+      </p:sp>
+      <p:sp>
+        <p:nvSpPr>
+          <p:cNvPr id="16" name="TextBox 15"/>
+          <p:cNvSpPr txBox="1"/>
+          <p:nvPr/>
+        </p:nvSpPr>
+        <p:spPr>
+          <a:xfrm>
+            <a:off x="5212080" y="5303520"/>
+            <a:ext cx="8595360" cy="1005840"/>
+          </a:xfrm>
+          <a:prstGeom prst="rect">
+            <a:avLst/>
+          </a:prstGeom>
+          <a:noFill/>
+        </p:spPr>
+        <p:txBody>
+          <a:bodyPr wrap="square" lIns="0" rIns="0" tIns="0" bIns="0">
+            <a:spAutoFit/>
+          </a:bodyPr>
+          <a:lstStyle/>
+          <a:p>
+            <a:pPr>
+              <a:spcAft>
+                <a:spcPts val="500"/>
+              </a:spcAft>
+              <a:defRPr sz="2100" b="0">
+                <a:solidFill>
+                  <a:srgbClr val="176B72"/>
+                </a:solidFill>
+                <a:latin typeface="Arial"/>
+              </a:defRPr>
+            </a:pPr>
+            <a:r>
+              <a:rPr sz="2100" b="0">
+                <a:solidFill>
+                  <a:srgbClr val="176B72"/>
+                </a:solidFill>
+                <a:latin typeface="Arial"/>
+              </a:rPr>
+              <a:t>Datos, parámetros, semillas y fecha; las celdas no son etiquetas</a:t>
+            </a:r>
+          </a:p>
+        </p:txBody>
+      </p:sp>
     </p:spTree>
   </p:cSld>
   <p:clrMapOvr>
@@ -12358,7 +12688,7 @@
                 </a:solidFill>
                 <a:latin typeface="Arial"/>
               </a:rPr>
-              <a:t>La semejanza entre recuerdos cambia su estabilidad</a:t>
+              <a:t>Primero almacenamos cuatro letras</a:t>
             </a:r>
           </a:p>
         </p:txBody>
@@ -12455,7 +12785,7 @@
       </p:sp>
       <p:pic>
         <p:nvPicPr>
-          <p:cNvPr id="6" name="Picture 5" descr="letters_dots.png"/>
+          <p:cNvPr id="6" name="Picture 5" descr="hopfield_letters__storage.png"/>
           <p:cNvPicPr>
             <a:picLocks noChangeAspect="1"/>
           </p:cNvPicPr>
@@ -12469,59 +12799,14 @@
         </p:blipFill>
         <p:spPr>
           <a:xfrm>
-            <a:off x="1265785" y="1417320"/>
-            <a:ext cx="12098828" cy="5577840"/>
+            <a:off x="594360" y="1529053"/>
+            <a:ext cx="13533120" cy="5674413"/>
           </a:xfrm>
           <a:prstGeom prst="rect">
             <a:avLst/>
           </a:prstGeom>
         </p:spPr>
       </p:pic>
-      <p:sp>
-        <p:nvSpPr>
-          <p:cNvPr id="7" name="TextBox 6"/>
-          <p:cNvSpPr txBox="1"/>
-          <p:nvPr/>
-        </p:nvSpPr>
-        <p:spPr>
-          <a:xfrm>
-            <a:off x="777240" y="7269480"/>
-            <a:ext cx="12984480" cy="411480"/>
-          </a:xfrm>
-          <a:prstGeom prst="rect">
-            <a:avLst/>
-          </a:prstGeom>
-          <a:noFill/>
-        </p:spPr>
-        <p:txBody>
-          <a:bodyPr wrap="square" lIns="0" rIns="0" tIns="0" bIns="0">
-            <a:spAutoFit/>
-          </a:bodyPr>
-          <a:lstStyle/>
-          <a:p>
-            <a:pPr>
-              <a:spcAft>
-                <a:spcPts val="500"/>
-              </a:spcAft>
-              <a:defRPr sz="2000" b="0">
-                <a:solidFill>
-                  <a:srgbClr val="5E6B73"/>
-                </a:solidFill>
-                <a:latin typeface="Arial"/>
-              </a:defRPr>
-            </a:pPr>
-            <a:r>
-              <a:rPr sz="2000" b="0">
-                <a:solidFill>
-                  <a:srgbClr val="5E6B73"/>
-                </a:solidFill>
-                <a:latin typeface="Arial"/>
-              </a:rPr>
-              <a:t>G,R,T,V: 4/4 estables · H,M,N,W: 1/4</a:t>
-            </a:r>
-          </a:p>
-        </p:txBody>
-      </p:sp>
     </p:spTree>
   </p:cSld>
   <p:clrMapOvr>
@@ -12633,7 +12918,7 @@
                 </a:solidFill>
                 <a:latin typeface="Arial"/>
               </a:rPr>
-              <a:t>La recuperación cae al aumentar el ruido</a:t>
+              <a:t>La semejanza entre recuerdos cambia su estabilidad</a:t>
             </a:r>
           </a:p>
         </p:txBody>
@@ -12730,7 +13015,7 @@
       </p:sp>
       <p:pic>
         <p:nvPicPr>
-          <p:cNvPr id="6" name="Picture 5" descr="letters_noise.png"/>
+          <p:cNvPr id="6" name="Picture 5" descr="letters_dots.png"/>
           <p:cNvPicPr>
             <a:picLocks noChangeAspect="1"/>
           </p:cNvPicPr>
@@ -12744,8 +13029,8 @@
         </p:blipFill>
         <p:spPr>
           <a:xfrm>
-            <a:off x="1206500" y="1508760"/>
-            <a:ext cx="12217400" cy="5486400"/>
+            <a:off x="1265785" y="1417320"/>
+            <a:ext cx="12098828" cy="5577840"/>
           </a:xfrm>
           <a:prstGeom prst="rect">
             <a:avLst/>
@@ -12792,7 +13077,7 @@
                 </a:solidFill>
                 <a:latin typeface="Arial"/>
               </a:rPr>
-              <a:t>30 semillas · media ± DE · 50 consultas por letra y nivel</a:t>
+              <a:t>G,R,T,V: 4/4 estables · H,M,N,W: 1/4</a:t>
             </a:r>
           </a:p>
         </p:txBody>
@@ -12908,7 +13193,7 @@
                 </a:solidFill>
                 <a:latin typeface="Arial"/>
               </a:rPr>
-              <a:t>La energía puede bajar hacia un espurio</a:t>
+              <a:t>La recuperación cae al aumentar el ruido</a:t>
             </a:r>
           </a:p>
         </p:txBody>
@@ -13005,7 +13290,7 @@
       </p:sp>
       <p:pic>
         <p:nvPicPr>
-          <p:cNvPr id="6" name="Picture 5" descr="letters_spurious.png"/>
+          <p:cNvPr id="6" name="Picture 5" descr="letters_noise.png"/>
           <p:cNvPicPr>
             <a:picLocks noChangeAspect="1"/>
           </p:cNvPicPr>
@@ -13019,8 +13304,8 @@
         </p:blipFill>
         <p:spPr>
           <a:xfrm>
-            <a:off x="731520" y="2203938"/>
-            <a:ext cx="13167360" cy="4370363"/>
+            <a:off x="1206500" y="1508760"/>
+            <a:ext cx="12217400" cy="5486400"/>
           </a:xfrm>
           <a:prstGeom prst="rect">
             <a:avLst/>
@@ -13067,7 +13352,7 @@
                 </a:solidFill>
                 <a:latin typeface="Arial"/>
               </a:rPr>
-              <a:t>Consulta de G con 10 bits invertidos · semilla 42</a:t>
+              <a:t>30 semillas · media ± DE · 50 consultas por letra y nivel</a:t>
             </a:r>
           </a:p>
         </p:txBody>
@@ -13183,7 +13468,7 @@
                 </a:solidFill>
                 <a:latin typeface="Arial"/>
               </a:rPr>
-              <a:t>La capacidad depende también de los patrones</a:t>
+              <a:t>La energía puede bajar hacia un espurio</a:t>
             </a:r>
           </a:p>
         </p:txBody>
@@ -13280,7 +13565,7 @@
       </p:sp>
       <p:pic>
         <p:nvPicPr>
-          <p:cNvPr id="6" name="Picture 5" descr="letters_capacity.png"/>
+          <p:cNvPr id="6" name="Picture 5" descr="letters_spurious.png"/>
           <p:cNvPicPr>
             <a:picLocks noChangeAspect="1"/>
           </p:cNvPicPr>
@@ -13294,8 +13579,8 @@
         </p:blipFill>
         <p:spPr>
           <a:xfrm>
-            <a:off x="1045028" y="1463040"/>
-            <a:ext cx="12540342" cy="5486400"/>
+            <a:off x="731520" y="2203938"/>
+            <a:ext cx="13167360" cy="4370363"/>
           </a:xfrm>
           <a:prstGeom prst="rect">
             <a:avLst/>
@@ -13342,7 +13627,7 @@
                 </a:solidFill>
                 <a:latin typeface="Arial"/>
               </a:rPr>
-              <a:t>200 subconjuntos por cantidad · 30 semillas · media ± DE</a:t>
+              <a:t>Consulta de G con 10 bits invertidos · semilla 42</a:t>
             </a:r>
           </a:p>
         </p:txBody>
@@ -13458,7 +13743,7 @@
                 </a:solidFill>
                 <a:latin typeface="Arial"/>
               </a:rPr>
-              <a:t>Usamos los cinco QR originales de 37×37</a:t>
+              <a:t>La capacidad depende también de los patrones</a:t>
             </a:r>
           </a:p>
         </p:txBody>
@@ -13555,7 +13840,7 @@
       </p:sp>
       <p:pic>
         <p:nvPicPr>
-          <p:cNvPr id="6" name="Picture 5" descr="qr_originals.png"/>
+          <p:cNvPr id="6" name="Picture 5" descr="letters_capacity.png"/>
           <p:cNvPicPr>
             <a:picLocks noChangeAspect="1"/>
           </p:cNvPicPr>
@@ -13569,8 +13854,8 @@
         </p:blipFill>
         <p:spPr>
           <a:xfrm>
-            <a:off x="731520" y="2320560"/>
-            <a:ext cx="13167360" cy="2856960"/>
+            <a:off x="1045028" y="1463040"/>
+            <a:ext cx="12540342" cy="5486400"/>
           </a:xfrm>
           <a:prstGeom prst="rect">
             <a:avLst/>
@@ -13585,84 +13870,39 @@
         </p:nvSpPr>
         <p:spPr>
           <a:xfrm>
-            <a:off x="868680" y="6080760"/>
-            <a:ext cx="12984480" cy="640080"/>
-          </a:xfrm>
-          <a:prstGeom prst="rect">
-            <a:avLst/>
-          </a:prstGeom>
-          <a:noFill/>
-        </p:spPr>
-        <p:txBody>
-          <a:bodyPr wrap="square" lIns="0" rIns="0" tIns="0" bIns="0">
-            <a:spAutoFit/>
-          </a:bodyPr>
-          <a:lstStyle/>
-          <a:p>
-            <a:pPr>
-              <a:spcAft>
-                <a:spcPts val="500"/>
-              </a:spcAft>
-              <a:defRPr sz="3600" b="0">
-                <a:solidFill>
-                  <a:srgbClr val="176B72"/>
-                </a:solidFill>
-                <a:latin typeface="Arial"/>
-              </a:defRPr>
-            </a:pPr>
-            <a:r>
-              <a:rPr sz="3600" b="0">
-                <a:solidFill>
-                  <a:srgbClr val="176B72"/>
-                </a:solidFill>
-                <a:latin typeface="Arial"/>
-              </a:rPr>
-              <a:t>37×37 → 1369 estados ±1</a:t>
-            </a:r>
-          </a:p>
-        </p:txBody>
-      </p:sp>
-      <p:sp>
-        <p:nvSpPr>
-          <p:cNvPr id="8" name="TextBox 7"/>
-          <p:cNvSpPr txBox="1"/>
-          <p:nvPr/>
-        </p:nvSpPr>
-        <p:spPr>
-          <a:xfrm>
-            <a:off x="914400" y="6995160"/>
-            <a:ext cx="12801600" cy="548640"/>
-          </a:xfrm>
-          <a:prstGeom prst="rect">
-            <a:avLst/>
-          </a:prstGeom>
-          <a:noFill/>
-        </p:spPr>
-        <p:txBody>
-          <a:bodyPr wrap="square" lIns="0" rIns="0" tIns="0" bIns="0">
-            <a:spAutoFit/>
-          </a:bodyPr>
-          <a:lstStyle/>
-          <a:p>
-            <a:pPr>
-              <a:spcAft>
-                <a:spcPts val="500"/>
-              </a:spcAft>
-              <a:defRPr sz="2500" b="0">
-                <a:solidFill>
-                  <a:srgbClr val="18242C"/>
-                </a:solidFill>
-                <a:latin typeface="Arial"/>
-              </a:defRPr>
-            </a:pPr>
-            <a:r>
-              <a:rPr sz="2500" b="0">
-                <a:solidFill>
-                  <a:srgbClr val="18242C"/>
-                </a:solidFill>
-                <a:latin typeface="Arial"/>
-              </a:rPr>
-              <a:t>P: 5×1369     W: 1369×1369</a:t>
+            <a:off x="777240" y="7269480"/>
+            <a:ext cx="12984480" cy="411480"/>
+          </a:xfrm>
+          <a:prstGeom prst="rect">
+            <a:avLst/>
+          </a:prstGeom>
+          <a:noFill/>
+        </p:spPr>
+        <p:txBody>
+          <a:bodyPr wrap="square" lIns="0" rIns="0" tIns="0" bIns="0">
+            <a:spAutoFit/>
+          </a:bodyPr>
+          <a:lstStyle/>
+          <a:p>
+            <a:pPr>
+              <a:spcAft>
+                <a:spcPts val="500"/>
+              </a:spcAft>
+              <a:defRPr sz="2000" b="0">
+                <a:solidFill>
+                  <a:srgbClr val="5E6B73"/>
+                </a:solidFill>
+                <a:latin typeface="Arial"/>
+              </a:defRPr>
+            </a:pPr>
+            <a:r>
+              <a:rPr sz="2000" b="0">
+                <a:solidFill>
+                  <a:srgbClr val="5E6B73"/>
+                </a:solidFill>
+                <a:latin typeface="Arial"/>
+              </a:rPr>
+              <a:t>200 subconjuntos por cantidad · 30 semillas · media ± DE</a:t>
             </a:r>
           </a:p>
         </p:txBody>
@@ -13778,7 +14018,7 @@
                 </a:solidFill>
                 <a:latin typeface="Arial"/>
               </a:rPr>
-              <a:t>Los QR comparten una similitud alta</a:t>
+              <a:t>Usamos los cinco QR originales de 37×37</a:t>
             </a:r>
           </a:p>
         </p:txBody>
@@ -13875,7 +14115,7 @@
       </p:sp>
       <p:pic>
         <p:nvPicPr>
-          <p:cNvPr id="6" name="Picture 5" descr="qr_similarity.png"/>
+          <p:cNvPr id="6" name="Picture 5" descr="qr_originals.png"/>
           <p:cNvPicPr>
             <a:picLocks noChangeAspect="1"/>
           </p:cNvPicPr>
@@ -13889,8 +14129,8 @@
         </p:blipFill>
         <p:spPr>
           <a:xfrm>
-            <a:off x="1338896" y="1371599"/>
-            <a:ext cx="6557647" cy="6035040"/>
+            <a:off x="731520" y="2320560"/>
+            <a:ext cx="13167360" cy="2856960"/>
           </a:xfrm>
           <a:prstGeom prst="rect">
             <a:avLst/>
@@ -13905,25 +14145,25 @@
         </p:nvSpPr>
         <p:spPr>
           <a:xfrm>
-            <a:off x="9144000" y="2240280"/>
-            <a:ext cx="4572000" cy="1005840"/>
-          </a:xfrm>
-          <a:prstGeom prst="rect">
-            <a:avLst/>
-          </a:prstGeom>
-          <a:noFill/>
-        </p:spPr>
-        <p:txBody>
-          <a:bodyPr wrap="square" lIns="0" rIns="0" tIns="0" bIns="0">
-            <a:spAutoFit/>
-          </a:bodyPr>
-          <a:lstStyle/>
-          <a:p>
-            <a:pPr>
-              <a:spcAft>
-                <a:spcPts val="500"/>
-              </a:spcAft>
-              <a:defRPr sz="6200" b="1">
+            <a:off x="868680" y="6080760"/>
+            <a:ext cx="12984480" cy="640080"/>
+          </a:xfrm>
+          <a:prstGeom prst="rect">
+            <a:avLst/>
+          </a:prstGeom>
+          <a:noFill/>
+        </p:spPr>
+        <p:txBody>
+          <a:bodyPr wrap="square" lIns="0" rIns="0" tIns="0" bIns="0">
+            <a:spAutoFit/>
+          </a:bodyPr>
+          <a:lstStyle/>
+          <a:p>
+            <a:pPr>
+              <a:spcAft>
+                <a:spcPts val="500"/>
+              </a:spcAft>
+              <a:defRPr sz="3600" b="0">
                 <a:solidFill>
                   <a:srgbClr val="176B72"/>
                 </a:solidFill>
@@ -13931,13 +14171,13 @@
               </a:defRPr>
             </a:pPr>
             <a:r>
-              <a:rPr sz="6200" b="1">
+              <a:rPr sz="3600" b="0">
                 <a:solidFill>
                   <a:srgbClr val="176B72"/>
                 </a:solidFill>
                 <a:latin typeface="Arial"/>
               </a:rPr>
-              <a:t>0,6701</a:t>
+              <a:t>37×37 → 1369 estados ±1</a:t>
             </a:r>
           </a:p>
         </p:txBody>
@@ -13950,25 +14190,25 @@
         </p:nvSpPr>
         <p:spPr>
           <a:xfrm>
-            <a:off x="9144000" y="3566160"/>
-            <a:ext cx="4572000" cy="640080"/>
-          </a:xfrm>
-          <a:prstGeom prst="rect">
-            <a:avLst/>
-          </a:prstGeom>
-          <a:noFill/>
-        </p:spPr>
-        <p:txBody>
-          <a:bodyPr wrap="square" lIns="0" rIns="0" tIns="0" bIns="0">
-            <a:spAutoFit/>
-          </a:bodyPr>
-          <a:lstStyle/>
-          <a:p>
-            <a:pPr>
-              <a:spcAft>
-                <a:spcPts val="500"/>
-              </a:spcAft>
-              <a:defRPr sz="2700" b="0">
+            <a:off x="914400" y="6995160"/>
+            <a:ext cx="12801600" cy="548640"/>
+          </a:xfrm>
+          <a:prstGeom prst="rect">
+            <a:avLst/>
+          </a:prstGeom>
+          <a:noFill/>
+        </p:spPr>
+        <p:txBody>
+          <a:bodyPr wrap="square" lIns="0" rIns="0" tIns="0" bIns="0">
+            <a:spAutoFit/>
+          </a:bodyPr>
+          <a:lstStyle/>
+          <a:p>
+            <a:pPr>
+              <a:spcAft>
+                <a:spcPts val="500"/>
+              </a:spcAft>
+              <a:defRPr sz="2500" b="0">
                 <a:solidFill>
                   <a:srgbClr val="18242C"/>
                 </a:solidFill>
@@ -13976,58 +14216,13 @@
               </a:defRPr>
             </a:pPr>
             <a:r>
-              <a:rPr sz="2700" b="0">
+              <a:rPr sz="2500" b="0">
                 <a:solidFill>
                   <a:srgbClr val="18242C"/>
                 </a:solidFill>
                 <a:latin typeface="Arial"/>
               </a:rPr>
-              <a:t>Similitud media</a:t>
-            </a:r>
-          </a:p>
-        </p:txBody>
-      </p:sp>
-      <p:sp>
-        <p:nvSpPr>
-          <p:cNvPr id="9" name="TextBox 8"/>
-          <p:cNvSpPr txBox="1"/>
-          <p:nvPr/>
-        </p:nvSpPr>
-        <p:spPr>
-          <a:xfrm>
-            <a:off x="8595360" y="4983480"/>
-            <a:ext cx="5486400" cy="1097280"/>
-          </a:xfrm>
-          <a:prstGeom prst="rect">
-            <a:avLst/>
-          </a:prstGeom>
-          <a:noFill/>
-        </p:spPr>
-        <p:txBody>
-          <a:bodyPr wrap="square" lIns="0" rIns="0" tIns="0" bIns="0">
-            <a:spAutoFit/>
-          </a:bodyPr>
-          <a:lstStyle/>
-          <a:p>
-            <a:pPr>
-              <a:spcAft>
-                <a:spcPts val="500"/>
-              </a:spcAft>
-              <a:defRPr sz="2700" b="0">
-                <a:solidFill>
-                  <a:srgbClr val="18242C"/>
-                </a:solidFill>
-                <a:latin typeface="Arial"/>
-              </a:defRPr>
-            </a:pPr>
-            <a:r>
-              <a:rPr sz="2700" b="0">
-                <a:solidFill>
-                  <a:srgbClr val="18242C"/>
-                </a:solidFill>
-                <a:latin typeface="Arial"/>
-              </a:rPr>
-              <a:t>sᵘᵛ = (ξᵘ·ξᵛ) / (37·37)</a:t>
+              <a:t>P: 5×1369     W: 1369×1369</a:t>
             </a:r>
           </a:p>
         </p:txBody>
@@ -14143,7 +14338,7 @@
                 </a:solidFill>
                 <a:latin typeface="Arial"/>
               </a:rPr>
-              <a:t>Cinco QR juntos pierden el recuerdo consultado</a:t>
+              <a:t>Los QR comparten una similitud alta</a:t>
             </a:r>
           </a:p>
         </p:txBody>
@@ -14240,7 +14435,7 @@
       </p:sp>
       <p:pic>
         <p:nvPicPr>
-          <p:cNvPr id="6" name="Picture 5" descr="qr_failure.png"/>
+          <p:cNvPr id="6" name="Picture 5" descr="qr_similarity.png"/>
           <p:cNvPicPr>
             <a:picLocks noChangeAspect="1"/>
           </p:cNvPicPr>
@@ -14254,8 +14449,8 @@
         </p:blipFill>
         <p:spPr>
           <a:xfrm>
-            <a:off x="731520" y="1886224"/>
-            <a:ext cx="13167360" cy="4365711"/>
+            <a:off x="1338896" y="1371599"/>
+            <a:ext cx="6557647" cy="6035040"/>
           </a:xfrm>
           <a:prstGeom prst="rect">
             <a:avLst/>
@@ -14270,39 +14465,129 @@
         </p:nvSpPr>
         <p:spPr>
           <a:xfrm>
-            <a:off x="777240" y="7269480"/>
-            <a:ext cx="12984480" cy="411480"/>
-          </a:xfrm>
-          <a:prstGeom prst="rect">
-            <a:avLst/>
-          </a:prstGeom>
-          <a:noFill/>
-        </p:spPr>
-        <p:txBody>
-          <a:bodyPr wrap="square" lIns="0" rIns="0" tIns="0" bIns="0">
-            <a:spAutoFit/>
-          </a:bodyPr>
-          <a:lstStyle/>
-          <a:p>
-            <a:pPr>
-              <a:spcAft>
-                <a:spcPts val="500"/>
-              </a:spcAft>
-              <a:defRPr sz="2000" b="0">
-                <a:solidFill>
-                  <a:srgbClr val="5E6B73"/>
-                </a:solidFill>
-                <a:latin typeface="Arial"/>
-              </a:defRPr>
-            </a:pPr>
-            <a:r>
-              <a:rPr sz="2000" b="0">
-                <a:solidFill>
-                  <a:srgbClr val="5E6B73"/>
-                </a:solidFill>
-                <a:latin typeface="Arial"/>
-              </a:rPr>
-              <a:t>0% de recuperación exacta · 33.000 consultas conjuntas</a:t>
+            <a:off x="9144000" y="2240280"/>
+            <a:ext cx="4572000" cy="1005840"/>
+          </a:xfrm>
+          <a:prstGeom prst="rect">
+            <a:avLst/>
+          </a:prstGeom>
+          <a:noFill/>
+        </p:spPr>
+        <p:txBody>
+          <a:bodyPr wrap="square" lIns="0" rIns="0" tIns="0" bIns="0">
+            <a:spAutoFit/>
+          </a:bodyPr>
+          <a:lstStyle/>
+          <a:p>
+            <a:pPr>
+              <a:spcAft>
+                <a:spcPts val="500"/>
+              </a:spcAft>
+              <a:defRPr sz="6200" b="1">
+                <a:solidFill>
+                  <a:srgbClr val="176B72"/>
+                </a:solidFill>
+                <a:latin typeface="Arial"/>
+              </a:defRPr>
+            </a:pPr>
+            <a:r>
+              <a:rPr sz="6200" b="1">
+                <a:solidFill>
+                  <a:srgbClr val="176B72"/>
+                </a:solidFill>
+                <a:latin typeface="Arial"/>
+              </a:rPr>
+              <a:t>0,6701</a:t>
+            </a:r>
+          </a:p>
+        </p:txBody>
+      </p:sp>
+      <p:sp>
+        <p:nvSpPr>
+          <p:cNvPr id="8" name="TextBox 7"/>
+          <p:cNvSpPr txBox="1"/>
+          <p:nvPr/>
+        </p:nvSpPr>
+        <p:spPr>
+          <a:xfrm>
+            <a:off x="9144000" y="3566160"/>
+            <a:ext cx="4572000" cy="640080"/>
+          </a:xfrm>
+          <a:prstGeom prst="rect">
+            <a:avLst/>
+          </a:prstGeom>
+          <a:noFill/>
+        </p:spPr>
+        <p:txBody>
+          <a:bodyPr wrap="square" lIns="0" rIns="0" tIns="0" bIns="0">
+            <a:spAutoFit/>
+          </a:bodyPr>
+          <a:lstStyle/>
+          <a:p>
+            <a:pPr>
+              <a:spcAft>
+                <a:spcPts val="500"/>
+              </a:spcAft>
+              <a:defRPr sz="2700" b="0">
+                <a:solidFill>
+                  <a:srgbClr val="18242C"/>
+                </a:solidFill>
+                <a:latin typeface="Arial"/>
+              </a:defRPr>
+            </a:pPr>
+            <a:r>
+              <a:rPr sz="2700" b="0">
+                <a:solidFill>
+                  <a:srgbClr val="18242C"/>
+                </a:solidFill>
+                <a:latin typeface="Arial"/>
+              </a:rPr>
+              <a:t>Similitud media</a:t>
+            </a:r>
+          </a:p>
+        </p:txBody>
+      </p:sp>
+      <p:sp>
+        <p:nvSpPr>
+          <p:cNvPr id="9" name="TextBox 8"/>
+          <p:cNvSpPr txBox="1"/>
+          <p:nvPr/>
+        </p:nvSpPr>
+        <p:spPr>
+          <a:xfrm>
+            <a:off x="8595360" y="4983480"/>
+            <a:ext cx="5486400" cy="1097280"/>
+          </a:xfrm>
+          <a:prstGeom prst="rect">
+            <a:avLst/>
+          </a:prstGeom>
+          <a:noFill/>
+        </p:spPr>
+        <p:txBody>
+          <a:bodyPr wrap="square" lIns="0" rIns="0" tIns="0" bIns="0">
+            <a:spAutoFit/>
+          </a:bodyPr>
+          <a:lstStyle/>
+          <a:p>
+            <a:pPr>
+              <a:spcAft>
+                <a:spcPts val="500"/>
+              </a:spcAft>
+              <a:defRPr sz="2700" b="0">
+                <a:solidFill>
+                  <a:srgbClr val="18242C"/>
+                </a:solidFill>
+                <a:latin typeface="Arial"/>
+              </a:defRPr>
+            </a:pPr>
+            <a:r>
+              <a:rPr sz="2700" b="0">
+                <a:solidFill>
+                  <a:srgbClr val="18242C"/>
+                </a:solidFill>
+                <a:latin typeface="Arial"/>
+              </a:rPr>
+              <a:t>sᵘᵛ = (ξᵘ·ξᵛ) / (37·37)</a:t>
             </a:r>
           </a:p>
         </p:txBody>
@@ -14418,7 +14703,7 @@
                 </a:solidFill>
                 <a:latin typeface="Arial"/>
               </a:rPr>
-              <a:t>Al reducir la carga, estos QR sí se recuperan</a:t>
+              <a:t>Cinco QR juntos pierden el recuerdo consultado</a:t>
             </a:r>
           </a:p>
         </p:txBody>
@@ -14515,7 +14800,7 @@
       </p:sp>
       <p:pic>
         <p:nvPicPr>
-          <p:cNvPr id="6" name="Picture 5" descr="qr_controls.png"/>
+          <p:cNvPr id="6" name="Picture 5" descr="qr_failure.png"/>
           <p:cNvPicPr>
             <a:picLocks noChangeAspect="1"/>
           </p:cNvPicPr>
@@ -14529,8 +14814,8 @@
         </p:blipFill>
         <p:spPr>
           <a:xfrm>
-            <a:off x="731520" y="1892043"/>
-            <a:ext cx="13167360" cy="4811273"/>
+            <a:off x="731520" y="1886224"/>
+            <a:ext cx="13167360" cy="4365711"/>
           </a:xfrm>
           <a:prstGeom prst="rect">
             <a:avLst/>
@@ -14577,7 +14862,7 @@
                 </a:solidFill>
                 <a:latin typeface="Arial"/>
               </a:rPr>
-              <a:t>Mismos originales, distinta cantidad almacenada por red</a:t>
+              <a:t>0% de recuperación exacta · 33.000 consultas conjuntas</a:t>
             </a:r>
           </a:p>
         </p:txBody>
@@ -14923,7 +15208,7 @@
                 </a:solidFill>
                 <a:latin typeface="Arial"/>
               </a:rPr>
-              <a:t>Recuperar el patrón y leer la URL son pruebas distintas</a:t>
+              <a:t>Al reducir la carga, estos QR sí se recuperan</a:t>
             </a:r>
           </a:p>
         </p:txBody>
@@ -15014,6 +15299,281 @@
                 <a:latin typeface="Arial"/>
               </a:rPr>
               <a:t>30</a:t>
+            </a:r>
+          </a:p>
+        </p:txBody>
+      </p:sp>
+      <p:pic>
+        <p:nvPicPr>
+          <p:cNvPr id="6" name="Picture 5" descr="qr_controls.png"/>
+          <p:cNvPicPr>
+            <a:picLocks noChangeAspect="1"/>
+          </p:cNvPicPr>
+          <p:nvPr/>
+        </p:nvPicPr>
+        <p:blipFill>
+          <a:blip r:embed="rId3"/>
+          <a:stretch>
+            <a:fillRect/>
+          </a:stretch>
+        </p:blipFill>
+        <p:spPr>
+          <a:xfrm>
+            <a:off x="731520" y="1892043"/>
+            <a:ext cx="13167360" cy="4811273"/>
+          </a:xfrm>
+          <a:prstGeom prst="rect">
+            <a:avLst/>
+          </a:prstGeom>
+        </p:spPr>
+      </p:pic>
+      <p:sp>
+        <p:nvSpPr>
+          <p:cNvPr id="7" name="TextBox 6"/>
+          <p:cNvSpPr txBox="1"/>
+          <p:nvPr/>
+        </p:nvSpPr>
+        <p:spPr>
+          <a:xfrm>
+            <a:off x="777240" y="7269480"/>
+            <a:ext cx="12984480" cy="411480"/>
+          </a:xfrm>
+          <a:prstGeom prst="rect">
+            <a:avLst/>
+          </a:prstGeom>
+          <a:noFill/>
+        </p:spPr>
+        <p:txBody>
+          <a:bodyPr wrap="square" lIns="0" rIns="0" tIns="0" bIns="0">
+            <a:spAutoFit/>
+          </a:bodyPr>
+          <a:lstStyle/>
+          <a:p>
+            <a:pPr>
+              <a:spcAft>
+                <a:spcPts val="500"/>
+              </a:spcAft>
+              <a:defRPr sz="2000" b="0">
+                <a:solidFill>
+                  <a:srgbClr val="5E6B73"/>
+                </a:solidFill>
+                <a:latin typeface="Arial"/>
+              </a:defRPr>
+            </a:pPr>
+            <a:r>
+              <a:rPr sz="2000" b="0">
+                <a:solidFill>
+                  <a:srgbClr val="5E6B73"/>
+                </a:solidFill>
+                <a:latin typeface="Arial"/>
+              </a:rPr>
+              <a:t>Mismos originales, distinta cantidad almacenada por red</a:t>
+            </a:r>
+          </a:p>
+        </p:txBody>
+      </p:sp>
+    </p:spTree>
+  </p:cSld>
+  <p:clrMapOvr>
+    <a:masterClrMapping/>
+  </p:clrMapOvr>
+</p:sld>
+</file>
+
+<file path=ppt/slides/slide31.xml><?xml version="1.0" encoding="utf-8"?>
+<p:sld xmlns:a="http://schemas.openxmlformats.org/drawingml/2006/main" xmlns:p="http://schemas.openxmlformats.org/presentationml/2006/main" xmlns:r="http://schemas.openxmlformats.org/officeDocument/2006/relationships">
+  <p:cSld>
+    <p:bg>
+      <p:bgPr>
+        <a:solidFill>
+          <a:srgbClr val="FFFFFF"/>
+        </a:solidFill>
+        <a:effectLst/>
+      </p:bgPr>
+    </p:bg>
+    <p:spTree>
+      <p:nvGrpSpPr>
+        <p:cNvPr id="1" name=""/>
+        <p:cNvGrpSpPr/>
+        <p:nvPr/>
+      </p:nvGrpSpPr>
+      <p:grpSpPr/>
+      <p:sp>
+        <p:nvSpPr>
+          <p:cNvPr id="2" name="TextBox 1"/>
+          <p:cNvSpPr txBox="1"/>
+          <p:nvPr/>
+        </p:nvSpPr>
+        <p:spPr>
+          <a:xfrm>
+            <a:off x="658368" y="109728"/>
+            <a:ext cx="13258800" cy="274320"/>
+          </a:xfrm>
+          <a:prstGeom prst="rect">
+            <a:avLst/>
+          </a:prstGeom>
+          <a:noFill/>
+        </p:spPr>
+        <p:txBody>
+          <a:bodyPr wrap="square" lIns="0" rIns="0" tIns="0" bIns="0">
+            <a:spAutoFit/>
+          </a:bodyPr>
+          <a:lstStyle/>
+          <a:p>
+            <a:pPr>
+              <a:spcAft>
+                <a:spcPts val="500"/>
+              </a:spcAft>
+              <a:defRPr sz="1500" b="0">
+                <a:solidFill>
+                  <a:srgbClr val="5E6B73"/>
+                </a:solidFill>
+                <a:latin typeface="Arial"/>
+              </a:defRPr>
+            </a:pPr>
+            <a:r>
+              <a:rPr sz="1500" b="0">
+                <a:solidFill>
+                  <a:srgbClr val="5E6B73"/>
+                </a:solidFill>
+                <a:latin typeface="Arial"/>
+              </a:rPr>
+              <a:t>Ejercicio 2: Memoria asociativa · 2.1 Hopfield: letras 5×5 y códigos QR</a:t>
+            </a:r>
+          </a:p>
+        </p:txBody>
+      </p:sp>
+      <p:sp>
+        <p:nvSpPr>
+          <p:cNvPr id="3" name="TextBox 2"/>
+          <p:cNvSpPr txBox="1"/>
+          <p:nvPr/>
+        </p:nvSpPr>
+        <p:spPr>
+          <a:xfrm>
+            <a:off x="658368" y="411480"/>
+            <a:ext cx="13258800" cy="822960"/>
+          </a:xfrm>
+          <a:prstGeom prst="rect">
+            <a:avLst/>
+          </a:prstGeom>
+          <a:noFill/>
+        </p:spPr>
+        <p:txBody>
+          <a:bodyPr wrap="square" lIns="0" rIns="0" tIns="0" bIns="0">
+            <a:spAutoFit/>
+          </a:bodyPr>
+          <a:lstStyle/>
+          <a:p>
+            <a:pPr>
+              <a:spcAft>
+                <a:spcPts val="500"/>
+              </a:spcAft>
+              <a:defRPr sz="3200" b="1">
+                <a:solidFill>
+                  <a:srgbClr val="18242C"/>
+                </a:solidFill>
+                <a:latin typeface="Arial"/>
+              </a:defRPr>
+            </a:pPr>
+            <a:r>
+              <a:rPr sz="3200" b="1">
+                <a:solidFill>
+                  <a:srgbClr val="18242C"/>
+                </a:solidFill>
+                <a:latin typeface="Arial"/>
+              </a:rPr>
+              <a:t>Recuperar el patrón y leer la URL son pruebas distintas</a:t>
+            </a:r>
+          </a:p>
+        </p:txBody>
+      </p:sp>
+      <p:sp>
+        <p:nvSpPr>
+          <p:cNvPr id="4" name="TextBox 3"/>
+          <p:cNvSpPr txBox="1"/>
+          <p:nvPr/>
+        </p:nvSpPr>
+        <p:spPr>
+          <a:xfrm>
+            <a:off x="658368" y="7818120"/>
+            <a:ext cx="2743200" cy="228600"/>
+          </a:xfrm>
+          <a:prstGeom prst="rect">
+            <a:avLst/>
+          </a:prstGeom>
+          <a:noFill/>
+        </p:spPr>
+        <p:txBody>
+          <a:bodyPr wrap="square" lIns="0" rIns="0" tIns="0" bIns="0">
+            <a:spAutoFit/>
+          </a:bodyPr>
+          <a:lstStyle/>
+          <a:p>
+            <a:pPr>
+              <a:spcAft>
+                <a:spcPts val="500"/>
+              </a:spcAft>
+              <a:defRPr sz="1200" b="0">
+                <a:solidFill>
+                  <a:srgbClr val="5E6B73"/>
+                </a:solidFill>
+                <a:latin typeface="Arial"/>
+              </a:defRPr>
+            </a:pPr>
+            <a:r>
+              <a:rPr sz="1200" b="0">
+                <a:solidFill>
+                  <a:srgbClr val="5E6B73"/>
+                </a:solidFill>
+                <a:latin typeface="Arial"/>
+              </a:rPr>
+              <a:t>TP4 · Grupo 3</a:t>
+            </a:r>
+          </a:p>
+        </p:txBody>
+      </p:sp>
+      <p:sp>
+        <p:nvSpPr>
+          <p:cNvPr id="5" name="TextBox 4"/>
+          <p:cNvSpPr txBox="1"/>
+          <p:nvPr/>
+        </p:nvSpPr>
+        <p:spPr>
+          <a:xfrm>
+            <a:off x="13441680" y="7772400"/>
+            <a:ext cx="548640" cy="274320"/>
+          </a:xfrm>
+          <a:prstGeom prst="rect">
+            <a:avLst/>
+          </a:prstGeom>
+          <a:noFill/>
+        </p:spPr>
+        <p:txBody>
+          <a:bodyPr wrap="square" lIns="0" rIns="0" tIns="0" bIns="0">
+            <a:spAutoFit/>
+          </a:bodyPr>
+          <a:lstStyle/>
+          <a:p>
+            <a:pPr algn="r">
+              <a:spcAft>
+                <a:spcPts val="500"/>
+              </a:spcAft>
+              <a:defRPr sz="1300" b="0">
+                <a:solidFill>
+                  <a:srgbClr val="5E6B73"/>
+                </a:solidFill>
+                <a:latin typeface="Arial"/>
+              </a:defRPr>
+            </a:pPr>
+            <a:r>
+              <a:rPr sz="1300" b="0">
+                <a:solidFill>
+                  <a:srgbClr val="5E6B73"/>
+                </a:solidFill>
+                <a:latin typeface="Arial"/>
+              </a:rPr>
+              <a:t>31</a:t>
             </a:r>
           </a:p>
         </p:txBody>

</xml_diff>

<commit_message>
docs(261025-r6p): ejercicio 2 con alfabeto, ruido, iteraciones, energía y limitaciones
- diapositiva 22: ortogonalidad de las 26 letras y elección de las 4
- diapositivas 30, 32 y 33: procedimiento de ruido, barridos y energía
- diapositiva 31 ampliada y diapositiva 36 de limitaciones
- el mazo pasa a 36 diapositivas
</commit_message>
<xml_diff>
--- a/TP4/docs/presentacion/TP4-presentacion.pptx
+++ b/TP4/docs/presentacion/TP4-presentacion.pptx
@@ -36,6 +36,11 @@
     <p:sldId id="284" r:id="rId36"/>
     <p:sldId id="285" r:id="rId37"/>
     <p:sldId id="286" r:id="rId38"/>
+    <p:sldId id="287" r:id="rId39"/>
+    <p:sldId id="288" r:id="rId40"/>
+    <p:sldId id="289" r:id="rId41"/>
+    <p:sldId id="290" r:id="rId42"/>
+    <p:sldId id="291" r:id="rId43"/>
   </p:sldIdLst>
   <p:sldSz cx="14630400" cy="8229600" type="screen4x3"/>
   <p:notesSz cx="6858000" cy="9144000"/>
@@ -1022,7 +1027,7 @@
           </a:p>
           <a:p>
             <a:r>
-              <a:t>• Revisión de la matriz: recomputamos U desde los 27 pesos de cada prototipo en runs/som/weights.csv (vecinas a distancia de grilla ≤ 1) y coincide con neurons.csv; desvío máximo 6.4e-10. No hay error de cálculo.</a:t>
+              <a:t>• Revisión de la matriz: recomputamos U desde los 27 pesos de cada prototipo en runs/som/weights.csv (vecinas a distancia de grilla ≤ 1) y coincide con neurons.csv; desvío máximo 6,4e-10. No hay error de cálculo.</a:t>
             </a:r>
           </a:p>
           <a:p>
@@ -1137,7 +1142,7 @@
           </a:p>
           <a:p>
             <a:r>
-              <a:t>• Celda 5, profundidad: la media de PC1 de sus creadores es +4,83 y su prototipo +3,28. Celda 13, volumen: −5,01 y −3,84. Celda 1, arte: PC2 media +1,78 (ej1.md 1.2). Las diapositivas muestran la proyección del prototipo; los valores de ej1.md son medias de los creadores asignados.</a:t>
+              <a:t>• Celda 5, profundidad: la media de PC1 de sus creadores es +4,83 y su prototipo +3,28. Celda 13, volumen: −5,01 y −3,84. Celda 1, arte: PC2 media +1,78 (ej1.md 1.2). Los mapas muestran la proyección del prototipo; los valores de ej1.md son medias de los creadores asignados.</a:t>
             </a:r>
           </a:p>
           <a:p>
@@ -1907,32 +1912,37 @@
           <a:lstStyle/>
           <a:p>
             <a:r>
-              <a:t>• Cada letra 5×5 se recorre por filas: 25 estados bipolares. Negro=+1, blanco=-1.</a:t>
-            </a:r>
-          </a:p>
-          <a:p>
-            <a:r>
-              <a:t>• G, R, T, V forman cuatro filas de P: matriz 4×25. Cada posición corresponde a una neurona.</a:t>
-            </a:r>
-          </a:p>
-          <a:p>
-            <a:r>
-              <a:t>• Hebb: W=PᵀP/25; W es 25×25 y su diagonal se fija en cero. Los cuatro patrones se almacenan juntos.</a:t>
-            </a:r>
-          </a:p>
-          <a:p>
-            <a:r>
-              <a:t>• Un patrón está almacenado por construcción de W; estar estable y recuperar desde ruido se comprueba después.</a:t>
-            </a:r>
-          </a:p>
-          <a:p>
-            <a:r>
-              <a:t>• Ejemplo introductorio antes del caso QR; fuente de patrones: datos/letras_5x5.json.</a:t>
-            </a:r>
-          </a:p>
-          <a:p>
-            <a:r>
-              <a:t>• Fuente: clase Hopfield, pp. 15, 20, 33-38; runs/hopfield_letters. Figura original de esta corrida: runs/hopfield_letters/storage.png.</a:t>
+              <a:t>• El enunciado pide un análisis de ortogonalidad. Comparamos los productos internos de las 14.950 combinaciones de 4 letras entre las 26 del alfabeto.</a:t>
+            </a:r>
+          </a:p>
+          <a:p>
+            <a:r>
+              <a:t>• Para cada combinación miramos el mayor producto interno absoluto entre pares de letras distintas; desempata el menor promedio absoluto. Es una comparación de ortogonalidad, no otra regla de aprendizaje.</a:t>
+            </a:r>
+          </a:p>
+          <a:p>
+            <a:r>
+              <a:t>• Elegidas G, R, T, V: máximo 1 de 25, es decir 0,04 normalizado. La siguiente mejor combinación llega a 3. Las cuatro letras son puntos fijos de la red.</a:t>
+            </a:r>
+          </a:p>
+          <a:p>
+            <a:r>
+              <a:t>• No se puede bajar de 1: con 25 neuronas (impar) el producto interno de dos vectores ±1 es 25 − 2d y nunca vale cero.</a:t>
+            </a:r>
+          </a:p>
+          <a:p>
+            <a:r>
+              <a:t>• Las más correlacionadas, H, M, N, W, llegan a 21 de 25 (0,84) y solo 1 de 4 letras queda estable.</a:t>
+            </a:r>
+          </a:p>
+          <a:p>
+            <a:r>
+              <a:t>• Por qué importa: con Hebb W=PᵀP/N, el campo sobre un patrón almacenado es el propio patrón más términos cruzados proporcionales a los productos internos. Si son pequeños, los recuerdos no interfieren; la diapositiva 24 muestra la consecuencia.</a:t>
+            </a:r>
+          </a:p>
+          <a:p>
+            <a:r>
+              <a:t>• Fuente: enunciado 2.2; clase Hopfield pp. 15, 20, 33-38; runs/hopfield_letters/{orthogonality,dot_products,stored}.csv y summary.json; ej2.md 2.2.</a:t>
             </a:r>
           </a:p>
         </p:txBody>
@@ -2002,32 +2012,32 @@
           <a:lstStyle/>
           <a:p>
             <a:r>
-              <a:t>• Productos internos normalizados: (ξᵘ·ξᵛ)/(5×5), antes de agregar ruido. Norma de cada letra: 5.</a:t>
-            </a:r>
-          </a:p>
-          <a:p>
-            <a:r>
-              <a:t>• N=25 es impar: el producto interno de dos vectores bipolares no puede ser cero; mínimo absoluto posible: 1.</a:t>
-            </a:r>
-          </a:p>
-          <a:p>
-            <a:r>
-              <a:t>• Elegimos G, R, T, V minimizando máximo |producto|, luego promedio; producto bruto absoluto 1, normalizado 0,04.</a:t>
-            </a:r>
-          </a:p>
-          <a:p>
-            <a:r>
-              <a:t>• H, M, N, W tienen máximo absoluto 21/25=0,84 y solo una letra estable, almacenando la misma cantidad.</a:t>
-            </a:r>
-          </a:p>
-          <a:p>
-            <a:r>
-              <a:t>• La diagonal normalizada 1 se excluye del resumen entre patrones distintos; la figura conserva el signo.</a:t>
-            </a:r>
-          </a:p>
-          <a:p>
-            <a:r>
-              <a:t>• Fuente: clase Hopfield, pp. 15, 20, 33-38; runs/hopfield_letters. Datos: dot_products.csv, orthogonality.csv, stored.csv.</a:t>
+              <a:t>• Cada letra 5×5 se recorre por filas: 25 estados bipolares. Negro=+1, blanco=-1.</a:t>
+            </a:r>
+          </a:p>
+          <a:p>
+            <a:r>
+              <a:t>• G, R, T, V forman cuatro filas de P: matriz 4×25. Cada posición corresponde a una neurona.</a:t>
+            </a:r>
+          </a:p>
+          <a:p>
+            <a:r>
+              <a:t>• Hebb: W=PᵀP/25; W es 25×25 y su diagonal se fija en cero. Los cuatro patrones se almacenan juntos.</a:t>
+            </a:r>
+          </a:p>
+          <a:p>
+            <a:r>
+              <a:t>• Un patrón está almacenado por construcción de W; estar estable y recuperar desde ruido se comprueba después.</a:t>
+            </a:r>
+          </a:p>
+          <a:p>
+            <a:r>
+              <a:t>• Ejemplo introductorio antes del caso QR; fuente de patrones: datos/letras_5x5.json.</a:t>
+            </a:r>
+          </a:p>
+          <a:p>
+            <a:r>
+              <a:t>• Fuente: clase Hopfield, pp. 15, 20, 33-38; runs/hopfield_letters. Figura original de esta corrida: runs/hopfield_letters/storage.png.</a:t>
             </a:r>
           </a:p>
         </p:txBody>
@@ -2097,32 +2107,32 @@
           <a:lstStyle/>
           <a:p>
             <a:r>
-              <a:t>• Cada semilla contiene 50 consultas por letra y nivel. Se invierten posiciones distintas dentro de cada consulta.</a:t>
-            </a:r>
-          </a:p>
-          <a:p>
-            <a:r>
-              <a:t>• G, R, T, V asincrónica: 3 bits, 99,833% ± 0,240 pp; 5 bits, 93,417% ± 2,060 pp; 9 bits, 31,917% ± 2,910 pp.</a:t>
-            </a:r>
-          </a:p>
-          <a:p>
-            <a:r>
-              <a:t>• Media y DE muestral entre 30 tasas por semilla. Las consultas de una corrida se agregan antes de calcular dispersión.</a:t>
-            </a:r>
-          </a:p>
-          <a:p>
-            <a:r>
-              <a:t>• 192.000 consultas de la grilla estándar; 24.000 adicionales para nivel 0,4: 216.000 consultas totales.</a:t>
-            </a:r>
-          </a:p>
-          <a:p>
-            <a:r>
-              <a:t>• Actualización sincrónica puede formar ciclos; asincrónica tiene energía no creciente. No prometer recuperación para toda consulta.</a:t>
-            </a:r>
-          </a:p>
-          <a:p>
-            <a:r>
-              <a:t>• Fuente: clase Hopfield, pp. 15, 20, 33-38; runs/hopfield_letters. Datos: recall_by_seed.csv y recall_repetitions.csv.</a:t>
+              <a:t>• Productos internos normalizados: (ξᵘ·ξᵛ)/(5×5), antes de agregar ruido. Norma de cada letra: 5.</a:t>
+            </a:r>
+          </a:p>
+          <a:p>
+            <a:r>
+              <a:t>• N=25 es impar: el producto interno de dos vectores bipolares no puede ser cero; mínimo absoluto posible: 1.</a:t>
+            </a:r>
+          </a:p>
+          <a:p>
+            <a:r>
+              <a:t>• Elegimos G, R, T, V minimizando máximo |producto|, luego promedio; producto bruto absoluto 1, normalizado 0,04.</a:t>
+            </a:r>
+          </a:p>
+          <a:p>
+            <a:r>
+              <a:t>• H, M, N, W tienen máximo absoluto 21/25=0,84 y solo una letra estable, almacenando la misma cantidad.</a:t>
+            </a:r>
+          </a:p>
+          <a:p>
+            <a:r>
+              <a:t>• La diagonal normalizada 1 se excluye del resumen entre patrones distintos; la figura conserva el signo.</a:t>
+            </a:r>
+          </a:p>
+          <a:p>
+            <a:r>
+              <a:t>• Fuente: clase Hopfield, pp. 15, 20, 33-38; runs/hopfield_letters. Datos: dot_products.csv, orthogonality.csv, stored.csv.</a:t>
             </a:r>
           </a:p>
         </p:txBody>
@@ -2192,32 +2202,32 @@
           <a:lstStyle/>
           <a:p>
             <a:r>
-              <a:t>• Ejemplo de la semilla 42: consulta de G con 10/25 bits invertidos.</a:t>
-            </a:r>
-          </a:p>
-          <a:p>
-            <a:r>
-              <a:t>• El estado final es un punto fijo ajeno a las cuatro letras y sus inversas.</a:t>
-            </a:r>
-          </a:p>
-          <a:p>
-            <a:r>
-              <a:t>• Energía final -7,68; distancia mínima a una letra: 6 bits. Los recuerdos guardados tienen energía -10,56.</a:t>
-            </a:r>
-          </a:p>
-          <a:p>
-            <a:r>
-              <a:t>• La curva registra visitas individuales a neuronas, incluida la comprobación final. Un espurio puede tener energía estable.</a:t>
-            </a:r>
-          </a:p>
-          <a:p>
-            <a:r>
-              <a:t>• Distinguir convergencia a un punto fijo de recuperación del patrón objetivo.</a:t>
-            </a:r>
-          </a:p>
-          <a:p>
-            <a:r>
-              <a:t>• Fuente: clase Hopfield, pp. 15, 20, 33-38; runs/hopfield_letters. Datos: summary.json y energy_trace.csv, ejemplo spurious.</a:t>
+              <a:t>• Cada semilla contiene 50 consultas por letra y nivel. Se invierten posiciones distintas dentro de cada consulta.</a:t>
+            </a:r>
+          </a:p>
+          <a:p>
+            <a:r>
+              <a:t>• G, R, T, V asincrónica: 3 bits, 99,833% ± 0,240 pp; 5 bits, 93,417% ± 2,060 pp; 9 bits, 31,917% ± 2,910 pp.</a:t>
+            </a:r>
+          </a:p>
+          <a:p>
+            <a:r>
+              <a:t>• Media y DE muestral entre 30 tasas por semilla. Las consultas de una corrida se agregan antes de calcular dispersión.</a:t>
+            </a:r>
+          </a:p>
+          <a:p>
+            <a:r>
+              <a:t>• 192.000 consultas de la grilla estándar; 24.000 adicionales para nivel 0,4: 216.000 consultas totales.</a:t>
+            </a:r>
+          </a:p>
+          <a:p>
+            <a:r>
+              <a:t>• Actualización sincrónica puede formar ciclos; asincrónica tiene energía no creciente. No prometer recuperación para toda consulta.</a:t>
+            </a:r>
+          </a:p>
+          <a:p>
+            <a:r>
+              <a:t>• Fuente: clase Hopfield, pp. 15, 20, 33-38; runs/hopfield_letters. Datos: recall_by_seed.csv y recall_repetitions.csv.</a:t>
             </a:r>
           </a:p>
         </p:txBody>
@@ -2287,32 +2297,32 @@
           <a:lstStyle/>
           <a:p>
             <a:r>
-              <a:t>• Se prueban 200 subconjuntos aleatorios del alfabeto por cantidad, en 30 semillas.</a:t>
-            </a:r>
-          </a:p>
-          <a:p>
-            <a:r>
-              <a:t>• La curva muestra proporción de subconjuntos enteramente estables, con media ± DE entre semillas.</a:t>
-            </a:r>
-          </a:p>
-          <a:p>
-            <a:r>
-              <a:t>• Para 4 letras al azar: 48,35% ± 3,57 pp de conjuntos enteramente estables; la fracción de letras estables es 75,575%.</a:t>
-            </a:r>
-          </a:p>
-          <a:p>
-            <a:r>
-              <a:t>• 0,15N=3,75 es una aproximación para patrones poco correlacionados, sin garantía para cada conjunto de 25 neuronas.</a:t>
-            </a:r>
-          </a:p>
-          <a:p>
-            <a:r>
-              <a:t>• Las cuatro letras elegidas son estables pese a superar 3,75; compatible con una capacidad aproximada.</a:t>
-            </a:r>
-          </a:p>
-          <a:p>
-            <a:r>
-              <a:t>• Fuente: clase Hopfield, pp. 15, 20, 33-38; runs/hopfield_letters. Datos: capacity_by_seed.csv y capacity_repetitions.csv.</a:t>
+              <a:t>• Ejemplo de la semilla 42: consulta de G con 10/25 bits invertidos.</a:t>
+            </a:r>
+          </a:p>
+          <a:p>
+            <a:r>
+              <a:t>• El estado final es un punto fijo ajeno a las cuatro letras y sus inversas.</a:t>
+            </a:r>
+          </a:p>
+          <a:p>
+            <a:r>
+              <a:t>• Energía final -7,68; distancia mínima a una letra: 6 bits. Los recuerdos guardados tienen energía -10,56.</a:t>
+            </a:r>
+          </a:p>
+          <a:p>
+            <a:r>
+              <a:t>• La curva registra visitas individuales a neuronas, incluida la comprobación final. Un espurio puede tener energía estable.</a:t>
+            </a:r>
+          </a:p>
+          <a:p>
+            <a:r>
+              <a:t>• Distinguir convergencia a un punto fijo de recuperación del patrón objetivo.</a:t>
+            </a:r>
+          </a:p>
+          <a:p>
+            <a:r>
+              <a:t>• Fuente: clase Hopfield, pp. 15, 20, 33-38; runs/hopfield_letters. Datos: summary.json y energy_trace.csv, ejemplo spurious.</a:t>
             </a:r>
           </a:p>
         </p:txBody>
@@ -2382,32 +2392,32 @@
           <a:lstStyle/>
           <a:p>
             <a:r>
-              <a:t>• Las cinco imágenes coinciden byte a byte con el ZIP suministrado; inputs.csv registra SHA256, dimensiones y norma.</a:t>
-            </a:r>
-          </a:p>
-          <a:p>
-            <a:r>
-              <a:t>• Cada imagen 37×37 se recorre por filas. Negro=+1, blanco=-1; se conservan todos sus módulos.</a:t>
-            </a:r>
-          </a:p>
-          <a:p>
-            <a:r>
-              <a:t>• Cada vector tiene 1369 estados y norma √1369=37. P es 5×1369 y W es 1369×1369, con diagonal cero.</a:t>
-            </a:r>
-          </a:p>
-          <a:p>
-            <a:r>
-              <a:t>• La comparación usa coseno normalizado; la red utiliza estados bipolares ±1.</a:t>
-            </a:r>
-          </a:p>
-          <a:p>
-            <a:r>
-              <a:t>• El render de esta diapositiva solo amplía píxeles por vecino más próximo; no altera los archivos originales.</a:t>
-            </a:r>
-          </a:p>
-          <a:p>
-            <a:r>
-              <a:t>• Fuente: enunciado 2.1; datos/hopfield/*.png; runs/hopfield_qr/inputs.csv.</a:t>
+              <a:t>• Se prueban 200 subconjuntos aleatorios del alfabeto por cantidad, en 30 semillas.</a:t>
+            </a:r>
+          </a:p>
+          <a:p>
+            <a:r>
+              <a:t>• La curva muestra proporción de subconjuntos enteramente estables, con media ± DE entre semillas.</a:t>
+            </a:r>
+          </a:p>
+          <a:p>
+            <a:r>
+              <a:t>• Para 4 letras al azar: 48,35% ± 3,57 pp de conjuntos enteramente estables; la fracción de letras estables es 75,575%.</a:t>
+            </a:r>
+          </a:p>
+          <a:p>
+            <a:r>
+              <a:t>• 0,15N=3,75 es una aproximación para patrones poco correlacionados, sin garantía para cada conjunto de 25 neuronas.</a:t>
+            </a:r>
+          </a:p>
+          <a:p>
+            <a:r>
+              <a:t>• Las cuatro letras elegidas son estables pese a superar 3,75; compatible con una capacidad aproximada.</a:t>
+            </a:r>
+          </a:p>
+          <a:p>
+            <a:r>
+              <a:t>• Fuente: clase Hopfield, pp. 15, 20, 33-38; runs/hopfield_letters. Datos: capacity_by_seed.csv y capacity_repetitions.csv.</a:t>
             </a:r>
           </a:p>
         </p:txBody>
@@ -2477,32 +2487,32 @@
           <a:lstStyle/>
           <a:p>
             <a:r>
-              <a:t>• Coseno medio entre los 10 pares distintos: 0.670124; rango 0.576333 a 0.859752.</a:t>
-            </a:r>
-          </a:p>
-          <a:p>
-            <a:r>
-              <a:t>• Para ±1 y N=1369, cada norma es 37: el denominador es 37×37=1369.</a:t>
-            </a:r>
-          </a:p>
-          <a:p>
-            <a:r>
-              <a:t>• 1−coseno medio=0.329876; 0,3299 es disimilitud complementaria, una cantidad diferente del producto normalizado.</a:t>
-            </a:r>
-          </a:p>
-          <a:p>
-            <a:r>
-              <a:t>• La fracción de bits distintos es (1−coseno)/2: aproximadamente 16,49% en promedio.</a:t>
-            </a:r>
-          </a:p>
-          <a:p>
-            <a:r>
-              <a:t>• 955/1369 módulos son iguales en los cinco QR simultáneamente; esa proporción, 69,76%, es otra cantidad.</a:t>
-            </a:r>
-          </a:p>
-          <a:p>
-            <a:r>
-              <a:t>• Fuente: runs/hopfield_qr/{pairwise_similarity,overlaps,inputs}.csv; clase Hopfield p.33.</a:t>
+              <a:t>• Las cinco imágenes coinciden byte a byte con el ZIP suministrado; inputs.csv registra SHA256, dimensiones y norma.</a:t>
+            </a:r>
+          </a:p>
+          <a:p>
+            <a:r>
+              <a:t>• Cada imagen 37×37 se recorre por filas. Negro=+1, blanco=-1; se conservan todos sus módulos.</a:t>
+            </a:r>
+          </a:p>
+          <a:p>
+            <a:r>
+              <a:t>• Cada vector tiene 1369 estados y norma √1369=37. P es 5×1369 y W es 1369×1369, con diagonal cero.</a:t>
+            </a:r>
+          </a:p>
+          <a:p>
+            <a:r>
+              <a:t>• La comparación usa coseno normalizado; la red utiliza estados bipolares ±1.</a:t>
+            </a:r>
+          </a:p>
+          <a:p>
+            <a:r>
+              <a:t>• El render de esta diapositiva solo amplía píxeles por vecino más próximo; no altera los archivos originales.</a:t>
+            </a:r>
+          </a:p>
+          <a:p>
+            <a:r>
+              <a:t>• Fuente: enunciado 2.1; datos/hopfield/*.png; runs/hopfield_qr/inputs.csv.</a:t>
             </a:r>
           </a:p>
         </p:txBody>
@@ -2572,32 +2582,32 @@
           <a:lstStyle/>
           <a:p>
             <a:r>
-              <a:t>• Con los cinco juntos, ningún original es punto fijo: 71, 91, 225, 225 y 103 módulos inestables.</a:t>
-            </a:r>
-          </a:p>
-          <a:p>
-            <a:r>
-              <a:t>• 33.000 consultas conjuntas: 5 QR × 11 niveles × 20 consultas × 30 semillas. Recuperación exacta: 0% en todos los niveles.</a:t>
-            </a:r>
-          </a:p>
-          <a:p>
-            <a:r>
-              <a:t>• Ejemplo de la semilla 42: original principal sin ruido y estado final espurio. La curva de barridos usa 30 semillas.</a:t>
-            </a:r>
-          </a:p>
-          <a:p>
-            <a:r>
-              <a:t>• Máximo 2 barridos que cambian el estado; la comprobación final no cuenta como otro cambio.</a:t>
-            </a:r>
-          </a:p>
-          <a:p>
-            <a:r>
-              <a:t>• Energía asincrónica no creciente no garantiza recuerdo correcto. El fracaso aparece ya en estabilidad, antes del ruido.</a:t>
-            </a:r>
-          </a:p>
-          <a:p>
-            <a:r>
-              <a:t>• Fuente: clase Hopfield pp.34-38; runs/hopfield_qr/{stored,recall_repetitions,queries}.csv.</a:t>
+              <a:t>• Coseno medio entre los 10 pares distintos: 0.670124; rango 0.576333 a 0.859752.</a:t>
+            </a:r>
+          </a:p>
+          <a:p>
+            <a:r>
+              <a:t>• Para ±1 y N=1369, cada norma es 37: el denominador es 37×37=1369.</a:t>
+            </a:r>
+          </a:p>
+          <a:p>
+            <a:r>
+              <a:t>• 1−coseno medio=0.329876; 0,3299 es disimilitud complementaria, una cantidad diferente del producto normalizado.</a:t>
+            </a:r>
+          </a:p>
+          <a:p>
+            <a:r>
+              <a:t>• La fracción de bits distintos es (1−coseno)/2: aproximadamente 16,49% en promedio.</a:t>
+            </a:r>
+          </a:p>
+          <a:p>
+            <a:r>
+              <a:t>• 955/1369 módulos son iguales en los cinco QR simultáneamente; esa proporción, 69,76%, es otra cantidad.</a:t>
+            </a:r>
+          </a:p>
+          <a:p>
+            <a:r>
+              <a:t>• Fuente: runs/hopfield_qr/{pairwise_similarity,overlaps,inputs}.csv; clase Hopfield p.33.</a:t>
             </a:r>
           </a:p>
         </p:txBody>
@@ -2757,32 +2767,32 @@
           <a:lstStyle/>
           <a:p>
             <a:r>
-              <a:t>• Controles de estabilidad exhaustivos: 5 redes con un QR y 10 parejas; todos sus patrones son estables.</a:t>
-            </a:r>
-          </a:p>
-          <a:p>
-            <a:r>
-              <a:t>• Los 10 tríos, 5 cuartetos y la red de cinco tienen cero patrones originales estables.</a:t>
-            </a:r>
-          </a:p>
-          <a:p>
-            <a:r>
-              <a:t>• Un QR por red: 33.000 consultas adicionales; recuperación 100% hasta 684/1369 bits invertidos (49,963%), con DE 0 entre semillas.</a:t>
-            </a:r>
-          </a:p>
-          <a:p>
-            <a:r>
-              <a:t>• El fallo no es universal para QR ni atribuible solo a su tamaño. Estos patrones correlacionados interfieren cuando se almacenan juntos.</a:t>
-            </a:r>
-          </a:p>
-          <a:p>
-            <a:r>
-              <a:t>• El control cambia la matriz de pesos. No comparar energías absolutas entre redes como si fueran una misma función.</a:t>
-            </a:r>
-          </a:p>
-          <a:p>
-            <a:r>
-              <a:t>• Fuente: runs/hopfield_qr/{storage_control,single_pattern_control,recall_repetitions}.csv.</a:t>
+              <a:t>• Cómo se agrega el ruido: cada consulta parte de un QR original (±1, negro +1, umbral 128, 37×37) e invierte exactamente round(p × 1369) módulos distintos, de +1 a −1 o al revés. Los módulos se sortean sin repetición.</a:t>
+            </a:r>
+          </a:p>
+          <a:p>
+            <a:r>
+              <a:t>• La figura es una ilustración del procedimiento sobre el QR principal, con numpy.random.default_rng(42) y rng.choice(1369, k, replace=False): p = 15% invierte 205 módulos, p = 30% invierte 411 módulos, p = 45% invierte 616 módulos. El experimento sortea sus propios conjuntos en cada consulta y semilla.</a:t>
+            </a:r>
+          </a:p>
+          <a:p>
+            <a:r>
+              <a:t>• Diseño: 11 niveles de 0 a 50% en pasos de 5, 20 consultas por QR y nivel, 30 semillas (33.000 consultas con los cinco QR juntos y otras 33.000 en el control de un QR por red). Niveles en configs/hopfield_qr.json.</a:t>
+            </a:r>
+          </a:p>
+          <a:p>
+            <a:r>
+              <a:t>• Por qué el máximo es 50%: más allá de la mitad, la consulta queda más cerca del patrón invertido que del original.</a:t>
+            </a:r>
+          </a:p>
+          <a:p>
+            <a:r>
+              <a:t>• En el código, tp4/experiments/hopfield_qr.py usa flip_bits (tp4/analysis/hopfield_eval.py) para invertir la cantidad exacta de posiciones.</a:t>
+            </a:r>
+          </a:p>
+          <a:p>
+            <a:r>
+              <a:t>• Fuente: enunciado 2.1, tercera viñeta; configs/hopfield_qr.json; datos/hopfield/food_menu_qr.png; ej2.md 2.1.</a:t>
             </a:r>
           </a:p>
         </p:txBody>
@@ -2852,6 +2862,381 @@
           <a:lstStyle/>
           <a:p>
             <a:r>
+              <a:t>• Con los cinco juntos, ningún original es punto fijo: 71, 91, 225, 225 y 103 módulos inestables.</a:t>
+            </a:r>
+          </a:p>
+          <a:p>
+            <a:r>
+              <a:t>• 33.000 consultas conjuntas: 5 QR × 11 niveles × 20 consultas × 30 semillas. Recuperación exacta: 0% en todos los niveles.</a:t>
+            </a:r>
+          </a:p>
+          <a:p>
+            <a:r>
+              <a:t>• Ejemplo de la semilla 42: original principal sin ruido y estado final espurio. Las iteraciones y la energía se analizan en las dos diapositivas siguientes.</a:t>
+            </a:r>
+          </a:p>
+          <a:p>
+            <a:r>
+              <a:t>• Energía asincrónica no creciente no garantiza recuerdo correcto. El fracaso aparece ya en estabilidad, antes del ruido.</a:t>
+            </a:r>
+          </a:p>
+          <a:p>
+            <a:r>
+              <a:t>• Fuente: clase Hopfield pp.34-38; runs/hopfield_qr/{stored,recall_repetitions,queries}.csv.</a:t>
+            </a:r>
+          </a:p>
+        </p:txBody>
+      </p:sp>
+      <p:sp>
+        <p:nvSpPr>
+          <p:cNvPr id="4" name="Slide Number Placeholder 3"/>
+          <p:cNvSpPr>
+            <a:spLocks noGrp="1"/>
+          </p:cNvSpPr>
+          <p:nvPr>
+            <p:ph type="sldNum" idx="5" sz="quarter"/>
+          </p:nvPr>
+        </p:nvSpPr>
+        <p:spPr/>
+      </p:sp>
+    </p:spTree>
+  </p:cSld>
+  <p:clrMapOvr>
+    <a:masterClrMapping/>
+  </p:clrMapOvr>
+</p:notes>
+</file>
+
+<file path=ppt/notesSlides/notesSlide32.xml><?xml version="1.0" encoding="utf-8"?>
+<p:notes xmlns:a="http://schemas.openxmlformats.org/drawingml/2006/main" xmlns:p="http://schemas.openxmlformats.org/presentationml/2006/main" xmlns:r="http://schemas.openxmlformats.org/officeDocument/2006/relationships">
+  <p:cSld>
+    <p:spTree>
+      <p:nvGrpSpPr>
+        <p:cNvPr id="1" name=""/>
+        <p:cNvGrpSpPr/>
+        <p:nvPr/>
+      </p:nvGrpSpPr>
+      <p:grpSpPr>
+        <a:xfrm>
+          <a:off x="0" y="0"/>
+          <a:ext cx="0" cy="0"/>
+          <a:chOff x="0" y="0"/>
+          <a:chExt cx="0" cy="0"/>
+        </a:xfrm>
+      </p:grpSpPr>
+      <p:sp>
+        <p:nvSpPr>
+          <p:cNvPr id="2" name="Slide Image Placeholder 1"/>
+          <p:cNvSpPr>
+            <a:spLocks noGrp="1"/>
+          </p:cNvSpPr>
+          <p:nvPr>
+            <p:ph type="sldImg" idx="2"/>
+          </p:nvPr>
+        </p:nvSpPr>
+        <p:spPr/>
+      </p:sp>
+      <p:sp>
+        <p:nvSpPr>
+          <p:cNvPr id="3" name="Notes Placeholder 2"/>
+          <p:cNvSpPr>
+            <a:spLocks noGrp="1"/>
+          </p:cNvSpPr>
+          <p:nvPr>
+            <p:ph type="body" idx="3" sz="quarter"/>
+          </p:nvPr>
+        </p:nvSpPr>
+        <p:spPr/>
+        <p:txBody>
+          <a:bodyPr/>
+          <a:lstStyle/>
+          <a:p>
+            <a:r>
+              <a:t>• Una iteración es un barrido de actualización asincrónica que cambió el estado; el último barrido sin cambios solo comprueba el punto fijo. Un barrido visita una vez las 1369 neuronas.</a:t>
+            </a:r>
+          </a:p>
+          <a:p>
+            <a:r>
+              <a:t>• Cinco QR juntos: 1,000 barridos sin ruido, 1,914 con 50% invertido (±0,072). Sube porque más módulos invertidos piden una segunda pasada de corrección.</a:t>
+            </a:r>
+          </a:p>
+          <a:p>
+            <a:r>
+              <a:t>• Un QR por red: 0 barridos sin ruido (el original ya es un punto fijo) y 1 con cualquier ruido.</a:t>
+            </a:r>
+          </a:p>
+          <a:p>
+            <a:r>
+              <a:t>• Máximo observado: 2 barridos. Pocas iteraciones no significan recuperación correcta: la recuperación exacta es 0% en todos los niveles con los cinco QR juntos.</a:t>
+            </a:r>
+          </a:p>
+          <a:p>
+            <a:r>
+              <a:t>• Estadísticas entre 30 semillas, media ± DE; definición de iteración en ej2.md, Modelo y mediciones.</a:t>
+            </a:r>
+          </a:p>
+          <a:p>
+            <a:r>
+              <a:t>• Fuente: enunciado 2.1, cuarta viñeta; runs/hopfield_qr/recall_repetitions.csv y summary.json; ej2.md.</a:t>
+            </a:r>
+          </a:p>
+        </p:txBody>
+      </p:sp>
+      <p:sp>
+        <p:nvSpPr>
+          <p:cNvPr id="4" name="Slide Number Placeholder 3"/>
+          <p:cNvSpPr>
+            <a:spLocks noGrp="1"/>
+          </p:cNvSpPr>
+          <p:nvPr>
+            <p:ph type="sldNum" idx="5" sz="quarter"/>
+          </p:nvPr>
+        </p:nvSpPr>
+        <p:spPr/>
+      </p:sp>
+    </p:spTree>
+  </p:cSld>
+  <p:clrMapOvr>
+    <a:masterClrMapping/>
+  </p:clrMapOvr>
+</p:notes>
+</file>
+
+<file path=ppt/notesSlides/notesSlide33.xml><?xml version="1.0" encoding="utf-8"?>
+<p:notes xmlns:a="http://schemas.openxmlformats.org/drawingml/2006/main" xmlns:p="http://schemas.openxmlformats.org/presentationml/2006/main" xmlns:r="http://schemas.openxmlformats.org/officeDocument/2006/relationships">
+  <p:cSld>
+    <p:spTree>
+      <p:nvGrpSpPr>
+        <p:cNvPr id="1" name=""/>
+        <p:cNvGrpSpPr/>
+        <p:nvPr/>
+      </p:nvGrpSpPr>
+      <p:grpSpPr>
+        <a:xfrm>
+          <a:off x="0" y="0"/>
+          <a:ext cx="0" cy="0"/>
+          <a:chOff x="0" y="0"/>
+          <a:chExt cx="0" cy="0"/>
+        </a:xfrm>
+      </p:grpSpPr>
+      <p:sp>
+        <p:nvSpPr>
+          <p:cNvPr id="2" name="Slide Image Placeholder 1"/>
+          <p:cNvSpPr>
+            <a:spLocks noGrp="1"/>
+          </p:cNvSpPr>
+          <p:nvPr>
+            <p:ph type="sldImg" idx="2"/>
+          </p:nvPr>
+        </p:nvSpPr>
+        <p:spPr/>
+      </p:sp>
+      <p:sp>
+        <p:nvSpPr>
+          <p:cNvPr id="3" name="Notes Placeholder 2"/>
+          <p:cNvSpPr>
+            <a:spLocks noGrp="1"/>
+          </p:cNvSpPr>
+          <p:nvPr>
+            <p:ph type="body" idx="3" sz="quarter"/>
+          </p:nvPr>
+        </p:nvSpPr>
+        <p:spPr/>
+        <p:txBody>
+          <a:bodyPr/>
+          <a:lstStyle/>
+          <a:p>
+            <a:r>
+              <a:t>• Energía H = −½ sᵀWs. En actualización asincrónica con pesos simétricos y diagonal cero no aumenta con ninguna actualización: summary.json informa energy_never_increased y la tasa de aumentos es cero en todos los niveles.</a:t>
+            </a:r>
+          </a:p>
+          <a:p>
+            <a:r>
+              <a:t>• Trazas de ejemplo (semilla 42), energía inicial y visitas hasta el punto fijo: 10% invertido, −1.347 y 2.738 visitas (2,0 barridos); 30% invertido, −325 y 2.738 visitas (2,0 barridos); 45% invertido, −20 y 4.107 visitas (3,0 barridos).</a:t>
+            </a:r>
+          </a:p>
+          <a:p>
+            <a:r>
+              <a:t>• Todas las consultas terminan con la misma energía final, −2.172,88, menor que la de cualquier QR original (−2.077,45 a −1.789,71): los originales no son puntos fijos y la red prefiere el estado espurio.</a:t>
+            </a:r>
+          </a:p>
+          <a:p>
+            <a:r>
+              <a:t>• Con un QR por red la energía final es −684, la del propio patrón: −(N−1)/2 con N=1369.</a:t>
+            </a:r>
+          </a:p>
+          <a:p>
+            <a:r>
+              <a:t>• Que la energía baje no garantiza recordar el menú consultado: una recuperación rápida y con energía decreciente puede ser completamente incorrecta.</a:t>
+            </a:r>
+          </a:p>
+          <a:p>
+            <a:r>
+              <a:t>• Fuente: enunciado 2.1, cuarta viñeta; runs/hopfield_qr/{energy_trace,stored,recall_repetitions}.csv y summary.json; ej2.md.</a:t>
+            </a:r>
+          </a:p>
+        </p:txBody>
+      </p:sp>
+      <p:sp>
+        <p:nvSpPr>
+          <p:cNvPr id="4" name="Slide Number Placeholder 3"/>
+          <p:cNvSpPr>
+            <a:spLocks noGrp="1"/>
+          </p:cNvSpPr>
+          <p:nvPr>
+            <p:ph type="sldNum" idx="5" sz="quarter"/>
+          </p:nvPr>
+        </p:nvSpPr>
+        <p:spPr/>
+      </p:sp>
+    </p:spTree>
+  </p:cSld>
+  <p:clrMapOvr>
+    <a:masterClrMapping/>
+  </p:clrMapOvr>
+</p:notes>
+</file>
+
+<file path=ppt/notesSlides/notesSlide34.xml><?xml version="1.0" encoding="utf-8"?>
+<p:notes xmlns:a="http://schemas.openxmlformats.org/drawingml/2006/main" xmlns:p="http://schemas.openxmlformats.org/presentationml/2006/main" xmlns:r="http://schemas.openxmlformats.org/officeDocument/2006/relationships">
+  <p:cSld>
+    <p:spTree>
+      <p:nvGrpSpPr>
+        <p:cNvPr id="1" name=""/>
+        <p:cNvGrpSpPr/>
+        <p:nvPr/>
+      </p:nvGrpSpPr>
+      <p:grpSpPr>
+        <a:xfrm>
+          <a:off x="0" y="0"/>
+          <a:ext cx="0" cy="0"/>
+          <a:chOff x="0" y="0"/>
+          <a:chExt cx="0" cy="0"/>
+        </a:xfrm>
+      </p:grpSpPr>
+      <p:sp>
+        <p:nvSpPr>
+          <p:cNvPr id="2" name="Slide Image Placeholder 1"/>
+          <p:cNvSpPr>
+            <a:spLocks noGrp="1"/>
+          </p:cNvSpPr>
+          <p:nvPr>
+            <p:ph type="sldImg" idx="2"/>
+          </p:nvPr>
+        </p:nvSpPr>
+        <p:spPr/>
+      </p:sp>
+      <p:sp>
+        <p:nvSpPr>
+          <p:cNvPr id="3" name="Notes Placeholder 2"/>
+          <p:cNvSpPr>
+            <a:spLocks noGrp="1"/>
+          </p:cNvSpPr>
+          <p:nvPr>
+            <p:ph type="body" idx="3" sz="quarter"/>
+          </p:nvPr>
+        </p:nvSpPr>
+        <p:spPr/>
+        <p:txBody>
+          <a:bodyPr/>
+          <a:lstStyle/>
+          <a:p>
+            <a:r>
+              <a:t>• Controles de estabilidad exhaustivos: 5 redes con un QR y 10 parejas; todos sus patrones son estables.</a:t>
+            </a:r>
+          </a:p>
+          <a:p>
+            <a:r>
+              <a:t>• Los 10 tríos, 5 cuartetos y la red de cinco tienen cero patrones originales estables.</a:t>
+            </a:r>
+          </a:p>
+          <a:p>
+            <a:r>
+              <a:t>• Un QR por red: 33.000 consultas adicionales; recuperación 100% hasta 684/1369 bits invertidos (49,963%), con DE 0 entre semillas.</a:t>
+            </a:r>
+          </a:p>
+          <a:p>
+            <a:r>
+              <a:t>• El fallo no es universal para QR ni atribuible solo a su tamaño. Estos patrones correlacionados interfieren cuando se almacenan juntos.</a:t>
+            </a:r>
+          </a:p>
+          <a:p>
+            <a:r>
+              <a:t>• El control cambia la matriz de pesos. No comparar energías absolutas entre redes como si fueran una misma función.</a:t>
+            </a:r>
+          </a:p>
+          <a:p>
+            <a:r>
+              <a:t>• Fuente: runs/hopfield_qr/{storage_control,single_pattern_control,recall_repetitions}.csv.</a:t>
+            </a:r>
+          </a:p>
+        </p:txBody>
+      </p:sp>
+      <p:sp>
+        <p:nvSpPr>
+          <p:cNvPr id="4" name="Slide Number Placeholder 3"/>
+          <p:cNvSpPr>
+            <a:spLocks noGrp="1"/>
+          </p:cNvSpPr>
+          <p:nvPr>
+            <p:ph type="sldNum" idx="5" sz="quarter"/>
+          </p:nvPr>
+        </p:nvSpPr>
+        <p:spPr/>
+      </p:sp>
+    </p:spTree>
+  </p:cSld>
+  <p:clrMapOvr>
+    <a:masterClrMapping/>
+  </p:clrMapOvr>
+</p:notes>
+</file>
+
+<file path=ppt/notesSlides/notesSlide35.xml><?xml version="1.0" encoding="utf-8"?>
+<p:notes xmlns:a="http://schemas.openxmlformats.org/drawingml/2006/main" xmlns:p="http://schemas.openxmlformats.org/presentationml/2006/main" xmlns:r="http://schemas.openxmlformats.org/officeDocument/2006/relationships">
+  <p:cSld>
+    <p:spTree>
+      <p:nvGrpSpPr>
+        <p:cNvPr id="1" name=""/>
+        <p:cNvGrpSpPr/>
+        <p:nvPr/>
+      </p:nvGrpSpPr>
+      <p:grpSpPr>
+        <a:xfrm>
+          <a:off x="0" y="0"/>
+          <a:ext cx="0" cy="0"/>
+          <a:chOff x="0" y="0"/>
+          <a:chExt cx="0" cy="0"/>
+        </a:xfrm>
+      </p:grpSpPr>
+      <p:sp>
+        <p:nvSpPr>
+          <p:cNvPr id="2" name="Slide Image Placeholder 1"/>
+          <p:cNvSpPr>
+            <a:spLocks noGrp="1"/>
+          </p:cNvSpPr>
+          <p:nvPr>
+            <p:ph type="sldImg" idx="2"/>
+          </p:nvPr>
+        </p:nvSpPr>
+        <p:spPr/>
+      </p:sp>
+      <p:sp>
+        <p:nvSpPr>
+          <p:cNvPr id="3" name="Notes Placeholder 2"/>
+          <p:cNvSpPr>
+            <a:spLocks noGrp="1"/>
+          </p:cNvSpPr>
+          <p:nvPr>
+            <p:ph type="body" idx="3" sz="quarter"/>
+          </p:nvPr>
+        </p:nvSpPr>
+        <p:spPr/>
+        <p:txBody>
+          <a:bodyPr/>
+          <a:lstStyle/>
+          <a:p>
+            <a:r>
               <a:t>• El lector opcional decodifica 5/5 originales. Se compara la URL con la del patrón objetivo.</a:t>
             </a:r>
           </a:p>
@@ -2878,6 +3263,106 @@
           <a:p>
             <a:r>
               <a:t>• Fuente: enunciado 2.1; runs/hopfield_qr/recall_repetitions.csv y summary.json; lector zxing-cpp.</a:t>
+            </a:r>
+          </a:p>
+        </p:txBody>
+      </p:sp>
+      <p:sp>
+        <p:nvSpPr>
+          <p:cNvPr id="4" name="Slide Number Placeholder 3"/>
+          <p:cNvSpPr>
+            <a:spLocks noGrp="1"/>
+          </p:cNvSpPr>
+          <p:nvPr>
+            <p:ph type="sldNum" idx="5" sz="quarter"/>
+          </p:nvPr>
+        </p:nvSpPr>
+        <p:spPr/>
+      </p:sp>
+    </p:spTree>
+  </p:cSld>
+  <p:clrMapOvr>
+    <a:masterClrMapping/>
+  </p:clrMapOvr>
+</p:notes>
+</file>
+
+<file path=ppt/notesSlides/notesSlide36.xml><?xml version="1.0" encoding="utf-8"?>
+<p:notes xmlns:a="http://schemas.openxmlformats.org/drawingml/2006/main" xmlns:p="http://schemas.openxmlformats.org/presentationml/2006/main" xmlns:r="http://schemas.openxmlformats.org/officeDocument/2006/relationships">
+  <p:cSld>
+    <p:spTree>
+      <p:nvGrpSpPr>
+        <p:cNvPr id="1" name=""/>
+        <p:cNvGrpSpPr/>
+        <p:nvPr/>
+      </p:nvGrpSpPr>
+      <p:grpSpPr>
+        <a:xfrm>
+          <a:off x="0" y="0"/>
+          <a:ext cx="0" cy="0"/>
+          <a:chOff x="0" y="0"/>
+          <a:chExt cx="0" cy="0"/>
+        </a:xfrm>
+      </p:grpSpPr>
+      <p:sp>
+        <p:nvSpPr>
+          <p:cNvPr id="2" name="Slide Image Placeholder 1"/>
+          <p:cNvSpPr>
+            <a:spLocks noGrp="1"/>
+          </p:cNvSpPr>
+          <p:nvPr>
+            <p:ph type="sldImg" idx="2"/>
+          </p:nvPr>
+        </p:nvSpPr>
+        <p:spPr/>
+      </p:sp>
+      <p:sp>
+        <p:nvSpPr>
+          <p:cNvPr id="3" name="Notes Placeholder 2"/>
+          <p:cNvSpPr>
+            <a:spLocks noGrp="1"/>
+          </p:cNvSpPr>
+          <p:nvPr>
+            <p:ph type="body" idx="3" sz="quarter"/>
+          </p:nvPr>
+        </p:nvSpPr>
+        <p:spPr/>
+        <p:txBody>
+          <a:bodyPr/>
+          <a:lstStyle/>
+          <a:p>
+            <a:r>
+              <a:t>• Pregunta del enunciado: explicar las limitaciones del caso de uso.</a:t>
+            </a:r>
+          </a:p>
+          <a:p>
+            <a:r>
+              <a:t>• Interferencia: con los cinco menús juntos hay 0 de 5 patrones estables y 955 de 1369 módulos compartidos. La referencia 0,15 N ≈ 205 no aplica como garantía con patrones tan correlacionados: estar muy por debajo de la capacidad no resuelve la correlación.</a:t>
+            </a:r>
+          </a:p>
+          <a:p>
+            <a:r>
+              <a:t>• Daño simulado: trabajamos con matrices alineadas de 37×37 e inversiones al azar, como delimita el enunciado. Una foto real exigiría detectar, alinear y binarizar los módulos.</a:t>
+            </a:r>
+          </a:p>
+          <a:p>
+            <a:r>
+              <a:t>• Menús nuevos: la red no conoce menús que no se almacenaron; cambiar una carta obliga a recalcular W y volver a comprobar estabilidad e interferencia.</a:t>
+            </a:r>
+          </a:p>
+          <a:p>
+            <a:r>
+              <a:t>• Salida sin garantía: poca energía y pocos barridos no prueban que la salida corresponda al menú consultado.</a:t>
+            </a:r>
+          </a:p>
+          <a:p>
+            <a:r>
+              <a:t>• Control: con un QR por red la recuperación es 100% hasta 684 de 1369 módulos invertidos (49,963%). La limitación corresponde a la memoria conjunta y su interferencia, no al formato QR.</a:t>
+            </a:r>
+          </a:p>
+          <a:p>
+            <a:r>
+              <a:t>• Fuente: enunciado 2.1, última viñeta; ej2.md, Limitaciones del caso de uso; runs/hopfield_qr/summary.json y recall_repetitions.csv.</a:t>
             </a:r>
           </a:p>
         </p:txBody>
@@ -2962,7 +3447,7 @@
           </a:p>
           <a:p>
             <a:r>
-              <a:t>• Conservamos completos los cuatro tópicos y los cuatro formatos de contenido. Cada grupo es un conjunto de porcentajes que suma 100% en los 50 creadores (desvío máximo 1.4e-14). Son variables dependientes, pero PCA admite esa dependencia, y así todas las categorías pesan igual en las distancias de Kohonen y Oja. Cambiar columnas o pesos obliga a repetir el análisis.</a:t>
+              <a:t>• Conservamos completos los cuatro tópicos y los cuatro formatos de contenido. Cada grupo es un conjunto de porcentajes que suma 100% en los 50 creadores (desvío máximo 1,4e-14). Son variables dependientes, pero PCA admite esa dependencia, y así todas las categorías pesan igual en las distancias de Kohonen y Oja. Cambiar columnas o pesos obliga a repetir el análisis.</a:t>
             </a:r>
           </a:p>
           <a:p>
@@ -12688,7 +13173,7 @@
                 </a:solidFill>
                 <a:latin typeface="Arial"/>
               </a:rPr>
-              <a:t>Primero almacenamos cuatro letras</a:t>
+              <a:t>Elegimos las 4 letras más ortogonales de las 26</a:t>
             </a:r>
           </a:p>
         </p:txBody>
@@ -12785,7 +13270,7 @@
       </p:sp>
       <p:pic>
         <p:nvPicPr>
-          <p:cNvPr id="6" name="Picture 5" descr="hopfield_letters__storage.png"/>
+          <p:cNvPr id="6" name="Picture 5" descr="letters_alphabet.png"/>
           <p:cNvPicPr>
             <a:picLocks noChangeAspect="1"/>
           </p:cNvPicPr>
@@ -12799,14 +13284,284 @@
         </p:blipFill>
         <p:spPr>
           <a:xfrm>
-            <a:off x="594360" y="1529053"/>
-            <a:ext cx="13533120" cy="5674413"/>
+            <a:off x="824634" y="1371600"/>
+            <a:ext cx="8226250" cy="5852160"/>
           </a:xfrm>
           <a:prstGeom prst="rect">
             <a:avLst/>
           </a:prstGeom>
         </p:spPr>
       </p:pic>
+      <p:sp>
+        <p:nvSpPr>
+          <p:cNvPr id="7" name="TextBox 6"/>
+          <p:cNvSpPr txBox="1"/>
+          <p:nvPr/>
+        </p:nvSpPr>
+        <p:spPr>
+          <a:xfrm>
+            <a:off x="9692640" y="1737360"/>
+            <a:ext cx="4389120" cy="457200"/>
+          </a:xfrm>
+          <a:prstGeom prst="rect">
+            <a:avLst/>
+          </a:prstGeom>
+          <a:noFill/>
+        </p:spPr>
+        <p:txBody>
+          <a:bodyPr wrap="square" lIns="0" rIns="0" tIns="0" bIns="0">
+            <a:spAutoFit/>
+          </a:bodyPr>
+          <a:lstStyle/>
+          <a:p>
+            <a:pPr>
+              <a:spcAft>
+                <a:spcPts val="500"/>
+              </a:spcAft>
+              <a:defRPr sz="2400" b="1">
+                <a:solidFill>
+                  <a:srgbClr val="176B72"/>
+                </a:solidFill>
+                <a:latin typeface="Arial"/>
+              </a:defRPr>
+            </a:pPr>
+            <a:r>
+              <a:rPr sz="2400" b="1">
+                <a:solidFill>
+                  <a:srgbClr val="176B72"/>
+                </a:solidFill>
+                <a:latin typeface="Arial"/>
+              </a:rPr>
+              <a:t>Cómo</a:t>
+            </a:r>
+          </a:p>
+        </p:txBody>
+      </p:sp>
+      <p:sp>
+        <p:nvSpPr>
+          <p:cNvPr id="8" name="TextBox 7"/>
+          <p:cNvSpPr txBox="1"/>
+          <p:nvPr/>
+        </p:nvSpPr>
+        <p:spPr>
+          <a:xfrm>
+            <a:off x="9692640" y="2194560"/>
+            <a:ext cx="4389120" cy="1188720"/>
+          </a:xfrm>
+          <a:prstGeom prst="rect">
+            <a:avLst/>
+          </a:prstGeom>
+          <a:noFill/>
+        </p:spPr>
+        <p:txBody>
+          <a:bodyPr wrap="square" lIns="0" rIns="0" tIns="0" bIns="0">
+            <a:spAutoFit/>
+          </a:bodyPr>
+          <a:lstStyle/>
+          <a:p>
+            <a:pPr>
+              <a:spcAft>
+                <a:spcPts val="500"/>
+              </a:spcAft>
+              <a:defRPr sz="1800" b="0">
+                <a:solidFill>
+                  <a:srgbClr val="18242C"/>
+                </a:solidFill>
+                <a:latin typeface="Arial"/>
+              </a:defRPr>
+            </a:pPr>
+            <a:r>
+              <a:rPr sz="1800" b="0">
+                <a:solidFill>
+                  <a:srgbClr val="18242C"/>
+                </a:solidFill>
+                <a:latin typeface="Arial"/>
+              </a:rPr>
+              <a:t>14.950 subconjuntos de 4 letras; mayor |producto interno| entre pares</a:t>
+            </a:r>
+          </a:p>
+        </p:txBody>
+      </p:sp>
+      <p:sp>
+        <p:nvSpPr>
+          <p:cNvPr id="9" name="TextBox 8"/>
+          <p:cNvSpPr txBox="1"/>
+          <p:nvPr/>
+        </p:nvSpPr>
+        <p:spPr>
+          <a:xfrm>
+            <a:off x="9692640" y="3474720"/>
+            <a:ext cx="4389120" cy="457200"/>
+          </a:xfrm>
+          <a:prstGeom prst="rect">
+            <a:avLst/>
+          </a:prstGeom>
+          <a:noFill/>
+        </p:spPr>
+        <p:txBody>
+          <a:bodyPr wrap="square" lIns="0" rIns="0" tIns="0" bIns="0">
+            <a:spAutoFit/>
+          </a:bodyPr>
+          <a:lstStyle/>
+          <a:p>
+            <a:pPr>
+              <a:spcAft>
+                <a:spcPts val="500"/>
+              </a:spcAft>
+              <a:defRPr sz="2400" b="1">
+                <a:solidFill>
+                  <a:srgbClr val="176B72"/>
+                </a:solidFill>
+                <a:latin typeface="Arial"/>
+              </a:defRPr>
+            </a:pPr>
+            <a:r>
+              <a:rPr sz="2400" b="1">
+                <a:solidFill>
+                  <a:srgbClr val="176B72"/>
+                </a:solidFill>
+                <a:latin typeface="Arial"/>
+              </a:rPr>
+              <a:t>Resultado</a:t>
+            </a:r>
+          </a:p>
+        </p:txBody>
+      </p:sp>
+      <p:sp>
+        <p:nvSpPr>
+          <p:cNvPr id="10" name="TextBox 9"/>
+          <p:cNvSpPr txBox="1"/>
+          <p:nvPr/>
+        </p:nvSpPr>
+        <p:spPr>
+          <a:xfrm>
+            <a:off x="9692640" y="3931920"/>
+            <a:ext cx="4389120" cy="1188720"/>
+          </a:xfrm>
+          <a:prstGeom prst="rect">
+            <a:avLst/>
+          </a:prstGeom>
+          <a:noFill/>
+        </p:spPr>
+        <p:txBody>
+          <a:bodyPr wrap="square" lIns="0" rIns="0" tIns="0" bIns="0">
+            <a:spAutoFit/>
+          </a:bodyPr>
+          <a:lstStyle/>
+          <a:p>
+            <a:pPr>
+              <a:spcAft>
+                <a:spcPts val="500"/>
+              </a:spcAft>
+              <a:defRPr sz="1800" b="0">
+                <a:solidFill>
+                  <a:srgbClr val="18242C"/>
+                </a:solidFill>
+                <a:latin typeface="Arial"/>
+              </a:defRPr>
+            </a:pPr>
+            <a:r>
+              <a:rPr sz="1800" b="0">
+                <a:solidFill>
+                  <a:srgbClr val="18242C"/>
+                </a:solidFill>
+                <a:latin typeface="Arial"/>
+              </a:rPr>
+              <a:t>G, R, T, V: máximo 1 de 25 (0,04); el siguiente, 3</a:t>
+            </a:r>
+          </a:p>
+        </p:txBody>
+      </p:sp>
+      <p:sp>
+        <p:nvSpPr>
+          <p:cNvPr id="11" name="TextBox 10"/>
+          <p:cNvSpPr txBox="1"/>
+          <p:nvPr/>
+        </p:nvSpPr>
+        <p:spPr>
+          <a:xfrm>
+            <a:off x="9692640" y="5212080"/>
+            <a:ext cx="4389120" cy="457200"/>
+          </a:xfrm>
+          <a:prstGeom prst="rect">
+            <a:avLst/>
+          </a:prstGeom>
+          <a:noFill/>
+        </p:spPr>
+        <p:txBody>
+          <a:bodyPr wrap="square" lIns="0" rIns="0" tIns="0" bIns="0">
+            <a:spAutoFit/>
+          </a:bodyPr>
+          <a:lstStyle/>
+          <a:p>
+            <a:pPr>
+              <a:spcAft>
+                <a:spcPts val="500"/>
+              </a:spcAft>
+              <a:defRPr sz="2400" b="1">
+                <a:solidFill>
+                  <a:srgbClr val="176B72"/>
+                </a:solidFill>
+                <a:latin typeface="Arial"/>
+              </a:defRPr>
+            </a:pPr>
+            <a:r>
+              <a:rPr sz="2400" b="1">
+                <a:solidFill>
+                  <a:srgbClr val="176B72"/>
+                </a:solidFill>
+                <a:latin typeface="Arial"/>
+              </a:rPr>
+              <a:t>Por qué no menos</a:t>
+            </a:r>
+          </a:p>
+        </p:txBody>
+      </p:sp>
+      <p:sp>
+        <p:nvSpPr>
+          <p:cNvPr id="12" name="TextBox 11"/>
+          <p:cNvSpPr txBox="1"/>
+          <p:nvPr/>
+        </p:nvSpPr>
+        <p:spPr>
+          <a:xfrm>
+            <a:off x="9692640" y="5669280"/>
+            <a:ext cx="4389120" cy="1188720"/>
+          </a:xfrm>
+          <a:prstGeom prst="rect">
+            <a:avLst/>
+          </a:prstGeom>
+          <a:noFill/>
+        </p:spPr>
+        <p:txBody>
+          <a:bodyPr wrap="square" lIns="0" rIns="0" tIns="0" bIns="0">
+            <a:spAutoFit/>
+          </a:bodyPr>
+          <a:lstStyle/>
+          <a:p>
+            <a:pPr>
+              <a:spcAft>
+                <a:spcPts val="500"/>
+              </a:spcAft>
+              <a:defRPr sz="1800" b="0">
+                <a:solidFill>
+                  <a:srgbClr val="18242C"/>
+                </a:solidFill>
+                <a:latin typeface="Arial"/>
+              </a:defRPr>
+            </a:pPr>
+            <a:r>
+              <a:rPr sz="1800" b="0">
+                <a:solidFill>
+                  <a:srgbClr val="18242C"/>
+                </a:solidFill>
+                <a:latin typeface="Arial"/>
+              </a:rPr>
+              <a:t>25 es impar: dos vectores ±1 nunca dan 0. H, M, N, W llegan a 21 de 25 (0,84)</a:t>
+            </a:r>
+          </a:p>
+        </p:txBody>
+      </p:sp>
     </p:spTree>
   </p:cSld>
   <p:clrMapOvr>
@@ -12918,7 +13673,7 @@
                 </a:solidFill>
                 <a:latin typeface="Arial"/>
               </a:rPr>
-              <a:t>La semejanza entre recuerdos cambia su estabilidad</a:t>
+              <a:t>Primero almacenamos cuatro letras</a:t>
             </a:r>
           </a:p>
         </p:txBody>
@@ -13015,7 +13770,7 @@
       </p:sp>
       <p:pic>
         <p:nvPicPr>
-          <p:cNvPr id="6" name="Picture 5" descr="letters_dots.png"/>
+          <p:cNvPr id="6" name="Picture 5" descr="hopfield_letters__storage.png"/>
           <p:cNvPicPr>
             <a:picLocks noChangeAspect="1"/>
           </p:cNvPicPr>
@@ -13029,59 +13784,14 @@
         </p:blipFill>
         <p:spPr>
           <a:xfrm>
-            <a:off x="1265785" y="1417320"/>
-            <a:ext cx="12098828" cy="5577840"/>
+            <a:off x="594360" y="1529053"/>
+            <a:ext cx="13533120" cy="5674413"/>
           </a:xfrm>
           <a:prstGeom prst="rect">
             <a:avLst/>
           </a:prstGeom>
         </p:spPr>
       </p:pic>
-      <p:sp>
-        <p:nvSpPr>
-          <p:cNvPr id="7" name="TextBox 6"/>
-          <p:cNvSpPr txBox="1"/>
-          <p:nvPr/>
-        </p:nvSpPr>
-        <p:spPr>
-          <a:xfrm>
-            <a:off x="777240" y="7269480"/>
-            <a:ext cx="12984480" cy="411480"/>
-          </a:xfrm>
-          <a:prstGeom prst="rect">
-            <a:avLst/>
-          </a:prstGeom>
-          <a:noFill/>
-        </p:spPr>
-        <p:txBody>
-          <a:bodyPr wrap="square" lIns="0" rIns="0" tIns="0" bIns="0">
-            <a:spAutoFit/>
-          </a:bodyPr>
-          <a:lstStyle/>
-          <a:p>
-            <a:pPr>
-              <a:spcAft>
-                <a:spcPts val="500"/>
-              </a:spcAft>
-              <a:defRPr sz="2000" b="0">
-                <a:solidFill>
-                  <a:srgbClr val="5E6B73"/>
-                </a:solidFill>
-                <a:latin typeface="Arial"/>
-              </a:defRPr>
-            </a:pPr>
-            <a:r>
-              <a:rPr sz="2000" b="0">
-                <a:solidFill>
-                  <a:srgbClr val="5E6B73"/>
-                </a:solidFill>
-                <a:latin typeface="Arial"/>
-              </a:rPr>
-              <a:t>G,R,T,V: 4/4 estables · H,M,N,W: 1/4</a:t>
-            </a:r>
-          </a:p>
-        </p:txBody>
-      </p:sp>
     </p:spTree>
   </p:cSld>
   <p:clrMapOvr>
@@ -13193,7 +13903,7 @@
                 </a:solidFill>
                 <a:latin typeface="Arial"/>
               </a:rPr>
-              <a:t>La recuperación cae al aumentar el ruido</a:t>
+              <a:t>La semejanza entre recuerdos cambia su estabilidad</a:t>
             </a:r>
           </a:p>
         </p:txBody>
@@ -13290,7 +14000,7 @@
       </p:sp>
       <p:pic>
         <p:nvPicPr>
-          <p:cNvPr id="6" name="Picture 5" descr="letters_noise.png"/>
+          <p:cNvPr id="6" name="Picture 5" descr="letters_dots.png"/>
           <p:cNvPicPr>
             <a:picLocks noChangeAspect="1"/>
           </p:cNvPicPr>
@@ -13304,8 +14014,8 @@
         </p:blipFill>
         <p:spPr>
           <a:xfrm>
-            <a:off x="1206500" y="1508760"/>
-            <a:ext cx="12217400" cy="5486400"/>
+            <a:off x="1265785" y="1417320"/>
+            <a:ext cx="12098828" cy="5577840"/>
           </a:xfrm>
           <a:prstGeom prst="rect">
             <a:avLst/>
@@ -13352,7 +14062,7 @@
                 </a:solidFill>
                 <a:latin typeface="Arial"/>
               </a:rPr>
-              <a:t>30 semillas · media ± DE · 50 consultas por letra y nivel</a:t>
+              <a:t>G,R,T,V: 4/4 estables · H,M,N,W: 1/4</a:t>
             </a:r>
           </a:p>
         </p:txBody>
@@ -13468,7 +14178,7 @@
                 </a:solidFill>
                 <a:latin typeface="Arial"/>
               </a:rPr>
-              <a:t>La energía puede bajar hacia un espurio</a:t>
+              <a:t>La recuperación cae al aumentar el ruido</a:t>
             </a:r>
           </a:p>
         </p:txBody>
@@ -13565,7 +14275,7 @@
       </p:sp>
       <p:pic>
         <p:nvPicPr>
-          <p:cNvPr id="6" name="Picture 5" descr="letters_spurious.png"/>
+          <p:cNvPr id="6" name="Picture 5" descr="letters_noise.png"/>
           <p:cNvPicPr>
             <a:picLocks noChangeAspect="1"/>
           </p:cNvPicPr>
@@ -13579,8 +14289,8 @@
         </p:blipFill>
         <p:spPr>
           <a:xfrm>
-            <a:off x="731520" y="2203938"/>
-            <a:ext cx="13167360" cy="4370363"/>
+            <a:off x="1206500" y="1508760"/>
+            <a:ext cx="12217400" cy="5486400"/>
           </a:xfrm>
           <a:prstGeom prst="rect">
             <a:avLst/>
@@ -13627,7 +14337,7 @@
                 </a:solidFill>
                 <a:latin typeface="Arial"/>
               </a:rPr>
-              <a:t>Consulta de G con 10 bits invertidos · semilla 42</a:t>
+              <a:t>30 semillas · media ± DE · 50 consultas por letra y nivel</a:t>
             </a:r>
           </a:p>
         </p:txBody>
@@ -13743,7 +14453,7 @@
                 </a:solidFill>
                 <a:latin typeface="Arial"/>
               </a:rPr>
-              <a:t>La capacidad depende también de los patrones</a:t>
+              <a:t>La energía puede bajar hacia un espurio</a:t>
             </a:r>
           </a:p>
         </p:txBody>
@@ -13840,7 +14550,7 @@
       </p:sp>
       <p:pic>
         <p:nvPicPr>
-          <p:cNvPr id="6" name="Picture 5" descr="letters_capacity.png"/>
+          <p:cNvPr id="6" name="Picture 5" descr="letters_spurious.png"/>
           <p:cNvPicPr>
             <a:picLocks noChangeAspect="1"/>
           </p:cNvPicPr>
@@ -13854,8 +14564,8 @@
         </p:blipFill>
         <p:spPr>
           <a:xfrm>
-            <a:off x="1045028" y="1463040"/>
-            <a:ext cx="12540342" cy="5486400"/>
+            <a:off x="731520" y="2203938"/>
+            <a:ext cx="13167360" cy="4370363"/>
           </a:xfrm>
           <a:prstGeom prst="rect">
             <a:avLst/>
@@ -13902,7 +14612,7 @@
                 </a:solidFill>
                 <a:latin typeface="Arial"/>
               </a:rPr>
-              <a:t>200 subconjuntos por cantidad · 30 semillas · media ± DE</a:t>
+              <a:t>Consulta de G con 10 bits invertidos · semilla 42</a:t>
             </a:r>
           </a:p>
         </p:txBody>
@@ -14018,7 +14728,7 @@
                 </a:solidFill>
                 <a:latin typeface="Arial"/>
               </a:rPr>
-              <a:t>Usamos los cinco QR originales de 37×37</a:t>
+              <a:t>La capacidad depende también de los patrones</a:t>
             </a:r>
           </a:p>
         </p:txBody>
@@ -14115,7 +14825,7 @@
       </p:sp>
       <p:pic>
         <p:nvPicPr>
-          <p:cNvPr id="6" name="Picture 5" descr="qr_originals.png"/>
+          <p:cNvPr id="6" name="Picture 5" descr="letters_capacity.png"/>
           <p:cNvPicPr>
             <a:picLocks noChangeAspect="1"/>
           </p:cNvPicPr>
@@ -14129,8 +14839,8 @@
         </p:blipFill>
         <p:spPr>
           <a:xfrm>
-            <a:off x="731520" y="2320560"/>
-            <a:ext cx="13167360" cy="2856960"/>
+            <a:off x="1045028" y="1463040"/>
+            <a:ext cx="12540342" cy="5486400"/>
           </a:xfrm>
           <a:prstGeom prst="rect">
             <a:avLst/>
@@ -14145,84 +14855,39 @@
         </p:nvSpPr>
         <p:spPr>
           <a:xfrm>
-            <a:off x="868680" y="6080760"/>
-            <a:ext cx="12984480" cy="640080"/>
-          </a:xfrm>
-          <a:prstGeom prst="rect">
-            <a:avLst/>
-          </a:prstGeom>
-          <a:noFill/>
-        </p:spPr>
-        <p:txBody>
-          <a:bodyPr wrap="square" lIns="0" rIns="0" tIns="0" bIns="0">
-            <a:spAutoFit/>
-          </a:bodyPr>
-          <a:lstStyle/>
-          <a:p>
-            <a:pPr>
-              <a:spcAft>
-                <a:spcPts val="500"/>
-              </a:spcAft>
-              <a:defRPr sz="3600" b="0">
-                <a:solidFill>
-                  <a:srgbClr val="176B72"/>
-                </a:solidFill>
-                <a:latin typeface="Arial"/>
-              </a:defRPr>
-            </a:pPr>
-            <a:r>
-              <a:rPr sz="3600" b="0">
-                <a:solidFill>
-                  <a:srgbClr val="176B72"/>
-                </a:solidFill>
-                <a:latin typeface="Arial"/>
-              </a:rPr>
-              <a:t>37×37 → 1369 estados ±1</a:t>
-            </a:r>
-          </a:p>
-        </p:txBody>
-      </p:sp>
-      <p:sp>
-        <p:nvSpPr>
-          <p:cNvPr id="8" name="TextBox 7"/>
-          <p:cNvSpPr txBox="1"/>
-          <p:nvPr/>
-        </p:nvSpPr>
-        <p:spPr>
-          <a:xfrm>
-            <a:off x="914400" y="6995160"/>
-            <a:ext cx="12801600" cy="548640"/>
-          </a:xfrm>
-          <a:prstGeom prst="rect">
-            <a:avLst/>
-          </a:prstGeom>
-          <a:noFill/>
-        </p:spPr>
-        <p:txBody>
-          <a:bodyPr wrap="square" lIns="0" rIns="0" tIns="0" bIns="0">
-            <a:spAutoFit/>
-          </a:bodyPr>
-          <a:lstStyle/>
-          <a:p>
-            <a:pPr>
-              <a:spcAft>
-                <a:spcPts val="500"/>
-              </a:spcAft>
-              <a:defRPr sz="2500" b="0">
-                <a:solidFill>
-                  <a:srgbClr val="18242C"/>
-                </a:solidFill>
-                <a:latin typeface="Arial"/>
-              </a:defRPr>
-            </a:pPr>
-            <a:r>
-              <a:rPr sz="2500" b="0">
-                <a:solidFill>
-                  <a:srgbClr val="18242C"/>
-                </a:solidFill>
-                <a:latin typeface="Arial"/>
-              </a:rPr>
-              <a:t>P: 5×1369     W: 1369×1369</a:t>
+            <a:off x="777240" y="7269480"/>
+            <a:ext cx="12984480" cy="411480"/>
+          </a:xfrm>
+          <a:prstGeom prst="rect">
+            <a:avLst/>
+          </a:prstGeom>
+          <a:noFill/>
+        </p:spPr>
+        <p:txBody>
+          <a:bodyPr wrap="square" lIns="0" rIns="0" tIns="0" bIns="0">
+            <a:spAutoFit/>
+          </a:bodyPr>
+          <a:lstStyle/>
+          <a:p>
+            <a:pPr>
+              <a:spcAft>
+                <a:spcPts val="500"/>
+              </a:spcAft>
+              <a:defRPr sz="2000" b="0">
+                <a:solidFill>
+                  <a:srgbClr val="5E6B73"/>
+                </a:solidFill>
+                <a:latin typeface="Arial"/>
+              </a:defRPr>
+            </a:pPr>
+            <a:r>
+              <a:rPr sz="2000" b="0">
+                <a:solidFill>
+                  <a:srgbClr val="5E6B73"/>
+                </a:solidFill>
+                <a:latin typeface="Arial"/>
+              </a:rPr>
+              <a:t>200 subconjuntos por cantidad · 30 semillas · media ± DE</a:t>
             </a:r>
           </a:p>
         </p:txBody>
@@ -14338,7 +15003,7 @@
                 </a:solidFill>
                 <a:latin typeface="Arial"/>
               </a:rPr>
-              <a:t>Los QR comparten una similitud alta</a:t>
+              <a:t>Usamos los cinco QR originales de 37×37</a:t>
             </a:r>
           </a:p>
         </p:txBody>
@@ -14435,7 +15100,7 @@
       </p:sp>
       <p:pic>
         <p:nvPicPr>
-          <p:cNvPr id="6" name="Picture 5" descr="qr_similarity.png"/>
+          <p:cNvPr id="6" name="Picture 5" descr="qr_originals.png"/>
           <p:cNvPicPr>
             <a:picLocks noChangeAspect="1"/>
           </p:cNvPicPr>
@@ -14449,8 +15114,8 @@
         </p:blipFill>
         <p:spPr>
           <a:xfrm>
-            <a:off x="1338896" y="1371599"/>
-            <a:ext cx="6557647" cy="6035040"/>
+            <a:off x="731520" y="2320560"/>
+            <a:ext cx="13167360" cy="2856960"/>
           </a:xfrm>
           <a:prstGeom prst="rect">
             <a:avLst/>
@@ -14465,25 +15130,25 @@
         </p:nvSpPr>
         <p:spPr>
           <a:xfrm>
-            <a:off x="9144000" y="2240280"/>
-            <a:ext cx="4572000" cy="1005840"/>
-          </a:xfrm>
-          <a:prstGeom prst="rect">
-            <a:avLst/>
-          </a:prstGeom>
-          <a:noFill/>
-        </p:spPr>
-        <p:txBody>
-          <a:bodyPr wrap="square" lIns="0" rIns="0" tIns="0" bIns="0">
-            <a:spAutoFit/>
-          </a:bodyPr>
-          <a:lstStyle/>
-          <a:p>
-            <a:pPr>
-              <a:spcAft>
-                <a:spcPts val="500"/>
-              </a:spcAft>
-              <a:defRPr sz="6200" b="1">
+            <a:off x="868680" y="6080760"/>
+            <a:ext cx="12984480" cy="640080"/>
+          </a:xfrm>
+          <a:prstGeom prst="rect">
+            <a:avLst/>
+          </a:prstGeom>
+          <a:noFill/>
+        </p:spPr>
+        <p:txBody>
+          <a:bodyPr wrap="square" lIns="0" rIns="0" tIns="0" bIns="0">
+            <a:spAutoFit/>
+          </a:bodyPr>
+          <a:lstStyle/>
+          <a:p>
+            <a:pPr>
+              <a:spcAft>
+                <a:spcPts val="500"/>
+              </a:spcAft>
+              <a:defRPr sz="3600" b="0">
                 <a:solidFill>
                   <a:srgbClr val="176B72"/>
                 </a:solidFill>
@@ -14491,13 +15156,13 @@
               </a:defRPr>
             </a:pPr>
             <a:r>
-              <a:rPr sz="6200" b="1">
+              <a:rPr sz="3600" b="0">
                 <a:solidFill>
                   <a:srgbClr val="176B72"/>
                 </a:solidFill>
                 <a:latin typeface="Arial"/>
               </a:rPr>
-              <a:t>0,6701</a:t>
+              <a:t>37×37 → 1369 estados ±1</a:t>
             </a:r>
           </a:p>
         </p:txBody>
@@ -14510,25 +15175,25 @@
         </p:nvSpPr>
         <p:spPr>
           <a:xfrm>
-            <a:off x="9144000" y="3566160"/>
-            <a:ext cx="4572000" cy="640080"/>
-          </a:xfrm>
-          <a:prstGeom prst="rect">
-            <a:avLst/>
-          </a:prstGeom>
-          <a:noFill/>
-        </p:spPr>
-        <p:txBody>
-          <a:bodyPr wrap="square" lIns="0" rIns="0" tIns="0" bIns="0">
-            <a:spAutoFit/>
-          </a:bodyPr>
-          <a:lstStyle/>
-          <a:p>
-            <a:pPr>
-              <a:spcAft>
-                <a:spcPts val="500"/>
-              </a:spcAft>
-              <a:defRPr sz="2700" b="0">
+            <a:off x="914400" y="6995160"/>
+            <a:ext cx="12801600" cy="548640"/>
+          </a:xfrm>
+          <a:prstGeom prst="rect">
+            <a:avLst/>
+          </a:prstGeom>
+          <a:noFill/>
+        </p:spPr>
+        <p:txBody>
+          <a:bodyPr wrap="square" lIns="0" rIns="0" tIns="0" bIns="0">
+            <a:spAutoFit/>
+          </a:bodyPr>
+          <a:lstStyle/>
+          <a:p>
+            <a:pPr>
+              <a:spcAft>
+                <a:spcPts val="500"/>
+              </a:spcAft>
+              <a:defRPr sz="2500" b="0">
                 <a:solidFill>
                   <a:srgbClr val="18242C"/>
                 </a:solidFill>
@@ -14536,58 +15201,13 @@
               </a:defRPr>
             </a:pPr>
             <a:r>
-              <a:rPr sz="2700" b="0">
+              <a:rPr sz="2500" b="0">
                 <a:solidFill>
                   <a:srgbClr val="18242C"/>
                 </a:solidFill>
                 <a:latin typeface="Arial"/>
               </a:rPr>
-              <a:t>Similitud media</a:t>
-            </a:r>
-          </a:p>
-        </p:txBody>
-      </p:sp>
-      <p:sp>
-        <p:nvSpPr>
-          <p:cNvPr id="9" name="TextBox 8"/>
-          <p:cNvSpPr txBox="1"/>
-          <p:nvPr/>
-        </p:nvSpPr>
-        <p:spPr>
-          <a:xfrm>
-            <a:off x="8595360" y="4983480"/>
-            <a:ext cx="5486400" cy="1097280"/>
-          </a:xfrm>
-          <a:prstGeom prst="rect">
-            <a:avLst/>
-          </a:prstGeom>
-          <a:noFill/>
-        </p:spPr>
-        <p:txBody>
-          <a:bodyPr wrap="square" lIns="0" rIns="0" tIns="0" bIns="0">
-            <a:spAutoFit/>
-          </a:bodyPr>
-          <a:lstStyle/>
-          <a:p>
-            <a:pPr>
-              <a:spcAft>
-                <a:spcPts val="500"/>
-              </a:spcAft>
-              <a:defRPr sz="2700" b="0">
-                <a:solidFill>
-                  <a:srgbClr val="18242C"/>
-                </a:solidFill>
-                <a:latin typeface="Arial"/>
-              </a:defRPr>
-            </a:pPr>
-            <a:r>
-              <a:rPr sz="2700" b="0">
-                <a:solidFill>
-                  <a:srgbClr val="18242C"/>
-                </a:solidFill>
-                <a:latin typeface="Arial"/>
-              </a:rPr>
-              <a:t>sᵘᵛ = (ξᵘ·ξᵛ) / (37·37)</a:t>
+              <a:t>P: 5×1369     W: 1369×1369</a:t>
             </a:r>
           </a:p>
         </p:txBody>
@@ -14703,7 +15323,7 @@
                 </a:solidFill>
                 <a:latin typeface="Arial"/>
               </a:rPr>
-              <a:t>Cinco QR juntos pierden el recuerdo consultado</a:t>
+              <a:t>Los QR comparten una similitud alta</a:t>
             </a:r>
           </a:p>
         </p:txBody>
@@ -14800,7 +15420,7 @@
       </p:sp>
       <p:pic>
         <p:nvPicPr>
-          <p:cNvPr id="6" name="Picture 5" descr="qr_failure.png"/>
+          <p:cNvPr id="6" name="Picture 5" descr="qr_similarity.png"/>
           <p:cNvPicPr>
             <a:picLocks noChangeAspect="1"/>
           </p:cNvPicPr>
@@ -14814,8 +15434,8 @@
         </p:blipFill>
         <p:spPr>
           <a:xfrm>
-            <a:off x="731520" y="1886224"/>
-            <a:ext cx="13167360" cy="4365711"/>
+            <a:off x="1338896" y="1371599"/>
+            <a:ext cx="6557647" cy="6035040"/>
           </a:xfrm>
           <a:prstGeom prst="rect">
             <a:avLst/>
@@ -14830,39 +15450,129 @@
         </p:nvSpPr>
         <p:spPr>
           <a:xfrm>
-            <a:off x="777240" y="7269480"/>
-            <a:ext cx="12984480" cy="411480"/>
-          </a:xfrm>
-          <a:prstGeom prst="rect">
-            <a:avLst/>
-          </a:prstGeom>
-          <a:noFill/>
-        </p:spPr>
-        <p:txBody>
-          <a:bodyPr wrap="square" lIns="0" rIns="0" tIns="0" bIns="0">
-            <a:spAutoFit/>
-          </a:bodyPr>
-          <a:lstStyle/>
-          <a:p>
-            <a:pPr>
-              <a:spcAft>
-                <a:spcPts val="500"/>
-              </a:spcAft>
-              <a:defRPr sz="2000" b="0">
-                <a:solidFill>
-                  <a:srgbClr val="5E6B73"/>
-                </a:solidFill>
-                <a:latin typeface="Arial"/>
-              </a:defRPr>
-            </a:pPr>
-            <a:r>
-              <a:rPr sz="2000" b="0">
-                <a:solidFill>
-                  <a:srgbClr val="5E6B73"/>
-                </a:solidFill>
-                <a:latin typeface="Arial"/>
-              </a:rPr>
-              <a:t>0% de recuperación exacta · 33.000 consultas conjuntas</a:t>
+            <a:off x="9144000" y="2240280"/>
+            <a:ext cx="4572000" cy="1005840"/>
+          </a:xfrm>
+          <a:prstGeom prst="rect">
+            <a:avLst/>
+          </a:prstGeom>
+          <a:noFill/>
+        </p:spPr>
+        <p:txBody>
+          <a:bodyPr wrap="square" lIns="0" rIns="0" tIns="0" bIns="0">
+            <a:spAutoFit/>
+          </a:bodyPr>
+          <a:lstStyle/>
+          <a:p>
+            <a:pPr>
+              <a:spcAft>
+                <a:spcPts val="500"/>
+              </a:spcAft>
+              <a:defRPr sz="6200" b="1">
+                <a:solidFill>
+                  <a:srgbClr val="176B72"/>
+                </a:solidFill>
+                <a:latin typeface="Arial"/>
+              </a:defRPr>
+            </a:pPr>
+            <a:r>
+              <a:rPr sz="6200" b="1">
+                <a:solidFill>
+                  <a:srgbClr val="176B72"/>
+                </a:solidFill>
+                <a:latin typeface="Arial"/>
+              </a:rPr>
+              <a:t>0,6701</a:t>
+            </a:r>
+          </a:p>
+        </p:txBody>
+      </p:sp>
+      <p:sp>
+        <p:nvSpPr>
+          <p:cNvPr id="8" name="TextBox 7"/>
+          <p:cNvSpPr txBox="1"/>
+          <p:nvPr/>
+        </p:nvSpPr>
+        <p:spPr>
+          <a:xfrm>
+            <a:off x="9144000" y="3566160"/>
+            <a:ext cx="4572000" cy="640080"/>
+          </a:xfrm>
+          <a:prstGeom prst="rect">
+            <a:avLst/>
+          </a:prstGeom>
+          <a:noFill/>
+        </p:spPr>
+        <p:txBody>
+          <a:bodyPr wrap="square" lIns="0" rIns="0" tIns="0" bIns="0">
+            <a:spAutoFit/>
+          </a:bodyPr>
+          <a:lstStyle/>
+          <a:p>
+            <a:pPr>
+              <a:spcAft>
+                <a:spcPts val="500"/>
+              </a:spcAft>
+              <a:defRPr sz="2700" b="0">
+                <a:solidFill>
+                  <a:srgbClr val="18242C"/>
+                </a:solidFill>
+                <a:latin typeface="Arial"/>
+              </a:defRPr>
+            </a:pPr>
+            <a:r>
+              <a:rPr sz="2700" b="0">
+                <a:solidFill>
+                  <a:srgbClr val="18242C"/>
+                </a:solidFill>
+                <a:latin typeface="Arial"/>
+              </a:rPr>
+              <a:t>Similitud media</a:t>
+            </a:r>
+          </a:p>
+        </p:txBody>
+      </p:sp>
+      <p:sp>
+        <p:nvSpPr>
+          <p:cNvPr id="9" name="TextBox 8"/>
+          <p:cNvSpPr txBox="1"/>
+          <p:nvPr/>
+        </p:nvSpPr>
+        <p:spPr>
+          <a:xfrm>
+            <a:off x="8595360" y="4983480"/>
+            <a:ext cx="5486400" cy="1097280"/>
+          </a:xfrm>
+          <a:prstGeom prst="rect">
+            <a:avLst/>
+          </a:prstGeom>
+          <a:noFill/>
+        </p:spPr>
+        <p:txBody>
+          <a:bodyPr wrap="square" lIns="0" rIns="0" tIns="0" bIns="0">
+            <a:spAutoFit/>
+          </a:bodyPr>
+          <a:lstStyle/>
+          <a:p>
+            <a:pPr>
+              <a:spcAft>
+                <a:spcPts val="500"/>
+              </a:spcAft>
+              <a:defRPr sz="2700" b="0">
+                <a:solidFill>
+                  <a:srgbClr val="18242C"/>
+                </a:solidFill>
+                <a:latin typeface="Arial"/>
+              </a:defRPr>
+            </a:pPr>
+            <a:r>
+              <a:rPr sz="2700" b="0">
+                <a:solidFill>
+                  <a:srgbClr val="18242C"/>
+                </a:solidFill>
+                <a:latin typeface="Arial"/>
+              </a:rPr>
+              <a:t>sᵘᵛ = (ξᵘ·ξᵛ) / (37·37)</a:t>
             </a:r>
           </a:p>
         </p:txBody>
@@ -15208,7 +15918,7 @@
                 </a:solidFill>
                 <a:latin typeface="Arial"/>
               </a:rPr>
-              <a:t>Al reducir la carga, estos QR sí se recuperan</a:t>
+              <a:t>Deterioramos el QR invirtiendo módulos al azar</a:t>
             </a:r>
           </a:p>
         </p:txBody>
@@ -15305,7 +16015,7 @@
       </p:sp>
       <p:pic>
         <p:nvPicPr>
-          <p:cNvPr id="6" name="Picture 5" descr="qr_controls.png"/>
+          <p:cNvPr id="6" name="Picture 5" descr="qr_noise.png"/>
           <p:cNvPicPr>
             <a:picLocks noChangeAspect="1"/>
           </p:cNvPicPr>
@@ -15319,8 +16029,8 @@
         </p:blipFill>
         <p:spPr>
           <a:xfrm>
-            <a:off x="731520" y="1892043"/>
-            <a:ext cx="13167360" cy="4811273"/>
+            <a:off x="731520" y="1545542"/>
+            <a:ext cx="13167360" cy="3492595"/>
           </a:xfrm>
           <a:prstGeom prst="rect">
             <a:avLst/>
@@ -15330,6 +16040,96 @@
       <p:sp>
         <p:nvSpPr>
           <p:cNvPr id="7" name="TextBox 6"/>
+          <p:cNvSpPr txBox="1"/>
+          <p:nvPr/>
+        </p:nvSpPr>
+        <p:spPr>
+          <a:xfrm>
+            <a:off x="822960" y="5440680"/>
+            <a:ext cx="12984480" cy="457200"/>
+          </a:xfrm>
+          <a:prstGeom prst="rect">
+            <a:avLst/>
+          </a:prstGeom>
+          <a:noFill/>
+        </p:spPr>
+        <p:txBody>
+          <a:bodyPr wrap="square" lIns="0" rIns="0" tIns="0" bIns="0">
+            <a:spAutoFit/>
+          </a:bodyPr>
+          <a:lstStyle/>
+          <a:p>
+            <a:pPr>
+              <a:spcAft>
+                <a:spcPts val="500"/>
+              </a:spcAft>
+              <a:defRPr sz="2300" b="0">
+                <a:solidFill>
+                  <a:srgbClr val="176B72"/>
+                </a:solidFill>
+                <a:latin typeface="Arial"/>
+              </a:defRPr>
+            </a:pPr>
+            <a:r>
+              <a:rPr sz="2300" b="0">
+                <a:solidFill>
+                  <a:srgbClr val="176B72"/>
+                </a:solidFill>
+                <a:latin typeface="Arial"/>
+              </a:rPr>
+              <a:t>Cada consulta invierte round(p × 1369) módulos distintos, de +1 a −1 o al revés</a:t>
+            </a:r>
+          </a:p>
+        </p:txBody>
+      </p:sp>
+      <p:sp>
+        <p:nvSpPr>
+          <p:cNvPr id="8" name="TextBox 7"/>
+          <p:cNvSpPr txBox="1"/>
+          <p:nvPr/>
+        </p:nvSpPr>
+        <p:spPr>
+          <a:xfrm>
+            <a:off x="822960" y="6172200"/>
+            <a:ext cx="12984480" cy="457200"/>
+          </a:xfrm>
+          <a:prstGeom prst="rect">
+            <a:avLst/>
+          </a:prstGeom>
+          <a:noFill/>
+        </p:spPr>
+        <p:txBody>
+          <a:bodyPr wrap="square" lIns="0" rIns="0" tIns="0" bIns="0">
+            <a:spAutoFit/>
+          </a:bodyPr>
+          <a:lstStyle/>
+          <a:p>
+            <a:pPr>
+              <a:spcAft>
+                <a:spcPts val="500"/>
+              </a:spcAft>
+              <a:defRPr sz="2000" b="0">
+                <a:solidFill>
+                  <a:srgbClr val="18242C"/>
+                </a:solidFill>
+                <a:latin typeface="Arial"/>
+              </a:defRPr>
+            </a:pPr>
+            <a:r>
+              <a:rPr sz="2000" b="0">
+                <a:solidFill>
+                  <a:srgbClr val="18242C"/>
+                </a:solidFill>
+                <a:latin typeface="Arial"/>
+              </a:rPr>
+              <a:t>11 niveles de 0 a 50% · 20 consultas por QR y nivel · 30 semillas</a:t>
+            </a:r>
+          </a:p>
+        </p:txBody>
+      </p:sp>
+      <p:sp>
+        <p:nvSpPr>
+          <p:cNvPr id="9" name="TextBox 8"/>
           <p:cNvSpPr txBox="1"/>
           <p:nvPr/>
         </p:nvSpPr>
@@ -15367,7 +16167,7 @@
                 </a:solidFill>
                 <a:latin typeface="Arial"/>
               </a:rPr>
-              <a:t>Mismos originales, distinta cantidad almacenada por red</a:t>
+              <a:t>Ilustración con semilla 42; el experimento sortea sus propios módulos</a:t>
             </a:r>
           </a:p>
         </p:txBody>
@@ -15483,7 +16283,7 @@
                 </a:solidFill>
                 <a:latin typeface="Arial"/>
               </a:rPr>
-              <a:t>Recuperar el patrón y leer la URL son pruebas distintas</a:t>
+              <a:t>Cinco QR juntos pierden el recuerdo consultado</a:t>
             </a:r>
           </a:p>
         </p:txBody>
@@ -15580,7 +16380,7 @@
       </p:sp>
       <p:pic>
         <p:nvPicPr>
-          <p:cNvPr id="6" name="Picture 5" descr="qr_reader.png"/>
+          <p:cNvPr id="6" name="Picture 5" descr="qr_failure.png"/>
           <p:cNvPicPr>
             <a:picLocks noChangeAspect="1"/>
           </p:cNvPicPr>
@@ -15594,6 +16394,1151 @@
         </p:blipFill>
         <p:spPr>
           <a:xfrm>
+            <a:off x="2067966" y="1463040"/>
+            <a:ext cx="10494467" cy="5394960"/>
+          </a:xfrm>
+          <a:prstGeom prst="rect">
+            <a:avLst/>
+          </a:prstGeom>
+        </p:spPr>
+      </p:pic>
+      <p:sp>
+        <p:nvSpPr>
+          <p:cNvPr id="7" name="TextBox 6"/>
+          <p:cNvSpPr txBox="1"/>
+          <p:nvPr/>
+        </p:nvSpPr>
+        <p:spPr>
+          <a:xfrm>
+            <a:off x="777240" y="7269480"/>
+            <a:ext cx="12984480" cy="411480"/>
+          </a:xfrm>
+          <a:prstGeom prst="rect">
+            <a:avLst/>
+          </a:prstGeom>
+          <a:noFill/>
+        </p:spPr>
+        <p:txBody>
+          <a:bodyPr wrap="square" lIns="0" rIns="0" tIns="0" bIns="0">
+            <a:spAutoFit/>
+          </a:bodyPr>
+          <a:lstStyle/>
+          <a:p>
+            <a:pPr>
+              <a:spcAft>
+                <a:spcPts val="500"/>
+              </a:spcAft>
+              <a:defRPr sz="2000" b="0">
+                <a:solidFill>
+                  <a:srgbClr val="5E6B73"/>
+                </a:solidFill>
+                <a:latin typeface="Arial"/>
+              </a:defRPr>
+            </a:pPr>
+            <a:r>
+              <a:rPr sz="2000" b="0">
+                <a:solidFill>
+                  <a:srgbClr val="5E6B73"/>
+                </a:solidFill>
+                <a:latin typeface="Arial"/>
+              </a:rPr>
+              <a:t>0% de recuperación exacta · 33.000 consultas conjuntas</a:t>
+            </a:r>
+          </a:p>
+        </p:txBody>
+      </p:sp>
+    </p:spTree>
+  </p:cSld>
+  <p:clrMapOvr>
+    <a:masterClrMapping/>
+  </p:clrMapOvr>
+</p:sld>
+</file>
+
+<file path=ppt/slides/slide32.xml><?xml version="1.0" encoding="utf-8"?>
+<p:sld xmlns:a="http://schemas.openxmlformats.org/drawingml/2006/main" xmlns:p="http://schemas.openxmlformats.org/presentationml/2006/main" xmlns:r="http://schemas.openxmlformats.org/officeDocument/2006/relationships">
+  <p:cSld>
+    <p:bg>
+      <p:bgPr>
+        <a:solidFill>
+          <a:srgbClr val="FFFFFF"/>
+        </a:solidFill>
+        <a:effectLst/>
+      </p:bgPr>
+    </p:bg>
+    <p:spTree>
+      <p:nvGrpSpPr>
+        <p:cNvPr id="1" name=""/>
+        <p:cNvGrpSpPr/>
+        <p:nvPr/>
+      </p:nvGrpSpPr>
+      <p:grpSpPr/>
+      <p:sp>
+        <p:nvSpPr>
+          <p:cNvPr id="2" name="TextBox 1"/>
+          <p:cNvSpPr txBox="1"/>
+          <p:nvPr/>
+        </p:nvSpPr>
+        <p:spPr>
+          <a:xfrm>
+            <a:off x="658368" y="109728"/>
+            <a:ext cx="13258800" cy="274320"/>
+          </a:xfrm>
+          <a:prstGeom prst="rect">
+            <a:avLst/>
+          </a:prstGeom>
+          <a:noFill/>
+        </p:spPr>
+        <p:txBody>
+          <a:bodyPr wrap="square" lIns="0" rIns="0" tIns="0" bIns="0">
+            <a:spAutoFit/>
+          </a:bodyPr>
+          <a:lstStyle/>
+          <a:p>
+            <a:pPr>
+              <a:spcAft>
+                <a:spcPts val="500"/>
+              </a:spcAft>
+              <a:defRPr sz="1500" b="0">
+                <a:solidFill>
+                  <a:srgbClr val="5E6B73"/>
+                </a:solidFill>
+                <a:latin typeface="Arial"/>
+              </a:defRPr>
+            </a:pPr>
+            <a:r>
+              <a:rPr sz="1500" b="0">
+                <a:solidFill>
+                  <a:srgbClr val="5E6B73"/>
+                </a:solidFill>
+                <a:latin typeface="Arial"/>
+              </a:rPr>
+              <a:t>Ejercicio 2: Memoria asociativa · 2.1 Hopfield: letras 5×5 y códigos QR</a:t>
+            </a:r>
+          </a:p>
+        </p:txBody>
+      </p:sp>
+      <p:sp>
+        <p:nvSpPr>
+          <p:cNvPr id="3" name="TextBox 2"/>
+          <p:cNvSpPr txBox="1"/>
+          <p:nvPr/>
+        </p:nvSpPr>
+        <p:spPr>
+          <a:xfrm>
+            <a:off x="658368" y="411480"/>
+            <a:ext cx="13258800" cy="822960"/>
+          </a:xfrm>
+          <a:prstGeom prst="rect">
+            <a:avLst/>
+          </a:prstGeom>
+          <a:noFill/>
+        </p:spPr>
+        <p:txBody>
+          <a:bodyPr wrap="square" lIns="0" rIns="0" tIns="0" bIns="0">
+            <a:spAutoFit/>
+          </a:bodyPr>
+          <a:lstStyle/>
+          <a:p>
+            <a:pPr>
+              <a:spcAft>
+                <a:spcPts val="500"/>
+              </a:spcAft>
+              <a:defRPr sz="3200" b="1">
+                <a:solidFill>
+                  <a:srgbClr val="18242C"/>
+                </a:solidFill>
+                <a:latin typeface="Arial"/>
+              </a:defRPr>
+            </a:pPr>
+            <a:r>
+              <a:rPr sz="3200" b="1">
+                <a:solidFill>
+                  <a:srgbClr val="18242C"/>
+                </a:solidFill>
+                <a:latin typeface="Arial"/>
+              </a:rPr>
+              <a:t>Converge en uno o dos barridos, sin acertar</a:t>
+            </a:r>
+          </a:p>
+        </p:txBody>
+      </p:sp>
+      <p:sp>
+        <p:nvSpPr>
+          <p:cNvPr id="4" name="TextBox 3"/>
+          <p:cNvSpPr txBox="1"/>
+          <p:nvPr/>
+        </p:nvSpPr>
+        <p:spPr>
+          <a:xfrm>
+            <a:off x="658368" y="7818120"/>
+            <a:ext cx="2743200" cy="228600"/>
+          </a:xfrm>
+          <a:prstGeom prst="rect">
+            <a:avLst/>
+          </a:prstGeom>
+          <a:noFill/>
+        </p:spPr>
+        <p:txBody>
+          <a:bodyPr wrap="square" lIns="0" rIns="0" tIns="0" bIns="0">
+            <a:spAutoFit/>
+          </a:bodyPr>
+          <a:lstStyle/>
+          <a:p>
+            <a:pPr>
+              <a:spcAft>
+                <a:spcPts val="500"/>
+              </a:spcAft>
+              <a:defRPr sz="1200" b="0">
+                <a:solidFill>
+                  <a:srgbClr val="5E6B73"/>
+                </a:solidFill>
+                <a:latin typeface="Arial"/>
+              </a:defRPr>
+            </a:pPr>
+            <a:r>
+              <a:rPr sz="1200" b="0">
+                <a:solidFill>
+                  <a:srgbClr val="5E6B73"/>
+                </a:solidFill>
+                <a:latin typeface="Arial"/>
+              </a:rPr>
+              <a:t>TP4 · Grupo 3</a:t>
+            </a:r>
+          </a:p>
+        </p:txBody>
+      </p:sp>
+      <p:sp>
+        <p:nvSpPr>
+          <p:cNvPr id="5" name="TextBox 4"/>
+          <p:cNvSpPr txBox="1"/>
+          <p:nvPr/>
+        </p:nvSpPr>
+        <p:spPr>
+          <a:xfrm>
+            <a:off x="13441680" y="7772400"/>
+            <a:ext cx="548640" cy="274320"/>
+          </a:xfrm>
+          <a:prstGeom prst="rect">
+            <a:avLst/>
+          </a:prstGeom>
+          <a:noFill/>
+        </p:spPr>
+        <p:txBody>
+          <a:bodyPr wrap="square" lIns="0" rIns="0" tIns="0" bIns="0">
+            <a:spAutoFit/>
+          </a:bodyPr>
+          <a:lstStyle/>
+          <a:p>
+            <a:pPr algn="r">
+              <a:spcAft>
+                <a:spcPts val="500"/>
+              </a:spcAft>
+              <a:defRPr sz="1300" b="0">
+                <a:solidFill>
+                  <a:srgbClr val="5E6B73"/>
+                </a:solidFill>
+                <a:latin typeface="Arial"/>
+              </a:defRPr>
+            </a:pPr>
+            <a:r>
+              <a:rPr sz="1300" b="0">
+                <a:solidFill>
+                  <a:srgbClr val="5E6B73"/>
+                </a:solidFill>
+                <a:latin typeface="Arial"/>
+              </a:rPr>
+              <a:t>32</a:t>
+            </a:r>
+          </a:p>
+        </p:txBody>
+      </p:sp>
+      <p:pic>
+        <p:nvPicPr>
+          <p:cNvPr id="6" name="Picture 5" descr="qr_iterations.png"/>
+          <p:cNvPicPr>
+            <a:picLocks noChangeAspect="1"/>
+          </p:cNvPicPr>
+          <p:nvPr/>
+        </p:nvPicPr>
+        <p:blipFill>
+          <a:blip r:embed="rId3"/>
+          <a:stretch>
+            <a:fillRect/>
+          </a:stretch>
+        </p:blipFill>
+        <p:spPr>
+          <a:xfrm>
+            <a:off x="731520" y="1870681"/>
+            <a:ext cx="13167360" cy="4671117"/>
+          </a:xfrm>
+          <a:prstGeom prst="rect">
+            <a:avLst/>
+          </a:prstGeom>
+        </p:spPr>
+      </p:pic>
+      <p:sp>
+        <p:nvSpPr>
+          <p:cNvPr id="7" name="TextBox 6"/>
+          <p:cNvSpPr txBox="1"/>
+          <p:nvPr/>
+        </p:nvSpPr>
+        <p:spPr>
+          <a:xfrm>
+            <a:off x="777240" y="7269480"/>
+            <a:ext cx="12984480" cy="411480"/>
+          </a:xfrm>
+          <a:prstGeom prst="rect">
+            <a:avLst/>
+          </a:prstGeom>
+          <a:noFill/>
+        </p:spPr>
+        <p:txBody>
+          <a:bodyPr wrap="square" lIns="0" rIns="0" tIns="0" bIns="0">
+            <a:spAutoFit/>
+          </a:bodyPr>
+          <a:lstStyle/>
+          <a:p>
+            <a:pPr>
+              <a:spcAft>
+                <a:spcPts val="500"/>
+              </a:spcAft>
+              <a:defRPr sz="2000" b="0">
+                <a:solidFill>
+                  <a:srgbClr val="5E6B73"/>
+                </a:solidFill>
+                <a:latin typeface="Arial"/>
+              </a:defRPr>
+            </a:pPr>
+            <a:r>
+              <a:rPr sz="2000" b="0">
+                <a:solidFill>
+                  <a:srgbClr val="5E6B73"/>
+                </a:solidFill>
+                <a:latin typeface="Arial"/>
+              </a:rPr>
+              <a:t>Un barrido visita las 1369 neuronas; el último, sin cambios, solo confirma el punto fijo</a:t>
+            </a:r>
+          </a:p>
+        </p:txBody>
+      </p:sp>
+    </p:spTree>
+  </p:cSld>
+  <p:clrMapOvr>
+    <a:masterClrMapping/>
+  </p:clrMapOvr>
+</p:sld>
+</file>
+
+<file path=ppt/slides/slide33.xml><?xml version="1.0" encoding="utf-8"?>
+<p:sld xmlns:a="http://schemas.openxmlformats.org/drawingml/2006/main" xmlns:p="http://schemas.openxmlformats.org/presentationml/2006/main" xmlns:r="http://schemas.openxmlformats.org/officeDocument/2006/relationships">
+  <p:cSld>
+    <p:bg>
+      <p:bgPr>
+        <a:solidFill>
+          <a:srgbClr val="FFFFFF"/>
+        </a:solidFill>
+        <a:effectLst/>
+      </p:bgPr>
+    </p:bg>
+    <p:spTree>
+      <p:nvGrpSpPr>
+        <p:cNvPr id="1" name=""/>
+        <p:cNvGrpSpPr/>
+        <p:nvPr/>
+      </p:nvGrpSpPr>
+      <p:grpSpPr/>
+      <p:sp>
+        <p:nvSpPr>
+          <p:cNvPr id="2" name="TextBox 1"/>
+          <p:cNvSpPr txBox="1"/>
+          <p:nvPr/>
+        </p:nvSpPr>
+        <p:spPr>
+          <a:xfrm>
+            <a:off x="658368" y="109728"/>
+            <a:ext cx="13258800" cy="274320"/>
+          </a:xfrm>
+          <a:prstGeom prst="rect">
+            <a:avLst/>
+          </a:prstGeom>
+          <a:noFill/>
+        </p:spPr>
+        <p:txBody>
+          <a:bodyPr wrap="square" lIns="0" rIns="0" tIns="0" bIns="0">
+            <a:spAutoFit/>
+          </a:bodyPr>
+          <a:lstStyle/>
+          <a:p>
+            <a:pPr>
+              <a:spcAft>
+                <a:spcPts val="500"/>
+              </a:spcAft>
+              <a:defRPr sz="1500" b="0">
+                <a:solidFill>
+                  <a:srgbClr val="5E6B73"/>
+                </a:solidFill>
+                <a:latin typeface="Arial"/>
+              </a:defRPr>
+            </a:pPr>
+            <a:r>
+              <a:rPr sz="1500" b="0">
+                <a:solidFill>
+                  <a:srgbClr val="5E6B73"/>
+                </a:solidFill>
+                <a:latin typeface="Arial"/>
+              </a:rPr>
+              <a:t>Ejercicio 2: Memoria asociativa · 2.1 Hopfield: letras 5×5 y códigos QR</a:t>
+            </a:r>
+          </a:p>
+        </p:txBody>
+      </p:sp>
+      <p:sp>
+        <p:nvSpPr>
+          <p:cNvPr id="3" name="TextBox 2"/>
+          <p:cNvSpPr txBox="1"/>
+          <p:nvPr/>
+        </p:nvSpPr>
+        <p:spPr>
+          <a:xfrm>
+            <a:off x="658368" y="411480"/>
+            <a:ext cx="13258800" cy="822960"/>
+          </a:xfrm>
+          <a:prstGeom prst="rect">
+            <a:avLst/>
+          </a:prstGeom>
+          <a:noFill/>
+        </p:spPr>
+        <p:txBody>
+          <a:bodyPr wrap="square" lIns="0" rIns="0" tIns="0" bIns="0">
+            <a:spAutoFit/>
+          </a:bodyPr>
+          <a:lstStyle/>
+          <a:p>
+            <a:pPr>
+              <a:spcAft>
+                <a:spcPts val="500"/>
+              </a:spcAft>
+              <a:defRPr sz="3200" b="1">
+                <a:solidFill>
+                  <a:srgbClr val="18242C"/>
+                </a:solidFill>
+                <a:latin typeface="Arial"/>
+              </a:defRPr>
+            </a:pPr>
+            <a:r>
+              <a:rPr sz="3200" b="1">
+                <a:solidFill>
+                  <a:srgbClr val="18242C"/>
+                </a:solidFill>
+                <a:latin typeface="Arial"/>
+              </a:rPr>
+              <a:t>La energía baja en cada paso, pero hacia un espurio</a:t>
+            </a:r>
+          </a:p>
+        </p:txBody>
+      </p:sp>
+      <p:sp>
+        <p:nvSpPr>
+          <p:cNvPr id="4" name="TextBox 3"/>
+          <p:cNvSpPr txBox="1"/>
+          <p:nvPr/>
+        </p:nvSpPr>
+        <p:spPr>
+          <a:xfrm>
+            <a:off x="658368" y="7818120"/>
+            <a:ext cx="2743200" cy="228600"/>
+          </a:xfrm>
+          <a:prstGeom prst="rect">
+            <a:avLst/>
+          </a:prstGeom>
+          <a:noFill/>
+        </p:spPr>
+        <p:txBody>
+          <a:bodyPr wrap="square" lIns="0" rIns="0" tIns="0" bIns="0">
+            <a:spAutoFit/>
+          </a:bodyPr>
+          <a:lstStyle/>
+          <a:p>
+            <a:pPr>
+              <a:spcAft>
+                <a:spcPts val="500"/>
+              </a:spcAft>
+              <a:defRPr sz="1200" b="0">
+                <a:solidFill>
+                  <a:srgbClr val="5E6B73"/>
+                </a:solidFill>
+                <a:latin typeface="Arial"/>
+              </a:defRPr>
+            </a:pPr>
+            <a:r>
+              <a:rPr sz="1200" b="0">
+                <a:solidFill>
+                  <a:srgbClr val="5E6B73"/>
+                </a:solidFill>
+                <a:latin typeface="Arial"/>
+              </a:rPr>
+              <a:t>TP4 · Grupo 3</a:t>
+            </a:r>
+          </a:p>
+        </p:txBody>
+      </p:sp>
+      <p:sp>
+        <p:nvSpPr>
+          <p:cNvPr id="5" name="TextBox 4"/>
+          <p:cNvSpPr txBox="1"/>
+          <p:nvPr/>
+        </p:nvSpPr>
+        <p:spPr>
+          <a:xfrm>
+            <a:off x="13441680" y="7772400"/>
+            <a:ext cx="548640" cy="274320"/>
+          </a:xfrm>
+          <a:prstGeom prst="rect">
+            <a:avLst/>
+          </a:prstGeom>
+          <a:noFill/>
+        </p:spPr>
+        <p:txBody>
+          <a:bodyPr wrap="square" lIns="0" rIns="0" tIns="0" bIns="0">
+            <a:spAutoFit/>
+          </a:bodyPr>
+          <a:lstStyle/>
+          <a:p>
+            <a:pPr algn="r">
+              <a:spcAft>
+                <a:spcPts val="500"/>
+              </a:spcAft>
+              <a:defRPr sz="1300" b="0">
+                <a:solidFill>
+                  <a:srgbClr val="5E6B73"/>
+                </a:solidFill>
+                <a:latin typeface="Arial"/>
+              </a:defRPr>
+            </a:pPr>
+            <a:r>
+              <a:rPr sz="1300" b="0">
+                <a:solidFill>
+                  <a:srgbClr val="5E6B73"/>
+                </a:solidFill>
+                <a:latin typeface="Arial"/>
+              </a:rPr>
+              <a:t>33</a:t>
+            </a:r>
+          </a:p>
+        </p:txBody>
+      </p:sp>
+      <p:pic>
+        <p:nvPicPr>
+          <p:cNvPr id="6" name="Picture 5" descr="qr_energy.png"/>
+          <p:cNvPicPr>
+            <a:picLocks noChangeAspect="1"/>
+          </p:cNvPicPr>
+          <p:nvPr/>
+        </p:nvPicPr>
+        <p:blipFill>
+          <a:blip r:embed="rId3"/>
+          <a:stretch>
+            <a:fillRect/>
+          </a:stretch>
+        </p:blipFill>
+        <p:spPr>
+          <a:xfrm>
+            <a:off x="1204957" y="1325880"/>
+            <a:ext cx="12220485" cy="4572000"/>
+          </a:xfrm>
+          <a:prstGeom prst="rect">
+            <a:avLst/>
+          </a:prstGeom>
+        </p:spPr>
+      </p:pic>
+      <p:sp>
+        <p:nvSpPr>
+          <p:cNvPr id="7" name="TextBox 6"/>
+          <p:cNvSpPr txBox="1"/>
+          <p:nvPr/>
+        </p:nvSpPr>
+        <p:spPr>
+          <a:xfrm>
+            <a:off x="822960" y="6080760"/>
+            <a:ext cx="12984480" cy="457200"/>
+          </a:xfrm>
+          <a:prstGeom prst="rect">
+            <a:avLst/>
+          </a:prstGeom>
+          <a:noFill/>
+        </p:spPr>
+        <p:txBody>
+          <a:bodyPr wrap="square" lIns="0" rIns="0" tIns="0" bIns="0">
+            <a:spAutoFit/>
+          </a:bodyPr>
+          <a:lstStyle/>
+          <a:p>
+            <a:pPr>
+              <a:spcAft>
+                <a:spcPts val="500"/>
+              </a:spcAft>
+              <a:defRPr sz="2200" b="0">
+                <a:solidFill>
+                  <a:srgbClr val="18242C"/>
+                </a:solidFill>
+                <a:latin typeface="Arial"/>
+              </a:defRPr>
+            </a:pPr>
+            <a:r>
+              <a:rPr sz="2200" b="0">
+                <a:solidFill>
+                  <a:srgbClr val="18242C"/>
+                </a:solidFill>
+                <a:latin typeface="Arial"/>
+              </a:rPr>
+              <a:t>La energía nunca aumentó en ninguna medición</a:t>
+            </a:r>
+          </a:p>
+        </p:txBody>
+      </p:sp>
+      <p:sp>
+        <p:nvSpPr>
+          <p:cNvPr id="8" name="TextBox 7"/>
+          <p:cNvSpPr txBox="1"/>
+          <p:nvPr/>
+        </p:nvSpPr>
+        <p:spPr>
+          <a:xfrm>
+            <a:off x="822960" y="6720840"/>
+            <a:ext cx="12984480" cy="822960"/>
+          </a:xfrm>
+          <a:prstGeom prst="rect">
+            <a:avLst/>
+          </a:prstGeom>
+          <a:noFill/>
+        </p:spPr>
+        <p:txBody>
+          <a:bodyPr wrap="square" lIns="0" rIns="0" tIns="0" bIns="0">
+            <a:spAutoFit/>
+          </a:bodyPr>
+          <a:lstStyle/>
+          <a:p>
+            <a:pPr>
+              <a:spcAft>
+                <a:spcPts val="500"/>
+              </a:spcAft>
+              <a:defRPr sz="2200" b="0">
+                <a:solidFill>
+                  <a:srgbClr val="A25D35"/>
+                </a:solidFill>
+                <a:latin typeface="Arial"/>
+              </a:defRPr>
+            </a:pPr>
+            <a:r>
+              <a:rPr sz="2200" b="0">
+                <a:solidFill>
+                  <a:srgbClr val="A25D35"/>
+                </a:solidFill>
+                <a:latin typeface="Arial"/>
+              </a:rPr>
+              <a:t>Todas terminan en el mismo estado, con energía menor que la de cualquier QR original: la red prefiere el espurio</a:t>
+            </a:r>
+          </a:p>
+        </p:txBody>
+      </p:sp>
+    </p:spTree>
+  </p:cSld>
+  <p:clrMapOvr>
+    <a:masterClrMapping/>
+  </p:clrMapOvr>
+</p:sld>
+</file>
+
+<file path=ppt/slides/slide34.xml><?xml version="1.0" encoding="utf-8"?>
+<p:sld xmlns:a="http://schemas.openxmlformats.org/drawingml/2006/main" xmlns:p="http://schemas.openxmlformats.org/presentationml/2006/main" xmlns:r="http://schemas.openxmlformats.org/officeDocument/2006/relationships">
+  <p:cSld>
+    <p:bg>
+      <p:bgPr>
+        <a:solidFill>
+          <a:srgbClr val="FFFFFF"/>
+        </a:solidFill>
+        <a:effectLst/>
+      </p:bgPr>
+    </p:bg>
+    <p:spTree>
+      <p:nvGrpSpPr>
+        <p:cNvPr id="1" name=""/>
+        <p:cNvGrpSpPr/>
+        <p:nvPr/>
+      </p:nvGrpSpPr>
+      <p:grpSpPr/>
+      <p:sp>
+        <p:nvSpPr>
+          <p:cNvPr id="2" name="TextBox 1"/>
+          <p:cNvSpPr txBox="1"/>
+          <p:nvPr/>
+        </p:nvSpPr>
+        <p:spPr>
+          <a:xfrm>
+            <a:off x="658368" y="109728"/>
+            <a:ext cx="13258800" cy="274320"/>
+          </a:xfrm>
+          <a:prstGeom prst="rect">
+            <a:avLst/>
+          </a:prstGeom>
+          <a:noFill/>
+        </p:spPr>
+        <p:txBody>
+          <a:bodyPr wrap="square" lIns="0" rIns="0" tIns="0" bIns="0">
+            <a:spAutoFit/>
+          </a:bodyPr>
+          <a:lstStyle/>
+          <a:p>
+            <a:pPr>
+              <a:spcAft>
+                <a:spcPts val="500"/>
+              </a:spcAft>
+              <a:defRPr sz="1500" b="0">
+                <a:solidFill>
+                  <a:srgbClr val="5E6B73"/>
+                </a:solidFill>
+                <a:latin typeface="Arial"/>
+              </a:defRPr>
+            </a:pPr>
+            <a:r>
+              <a:rPr sz="1500" b="0">
+                <a:solidFill>
+                  <a:srgbClr val="5E6B73"/>
+                </a:solidFill>
+                <a:latin typeface="Arial"/>
+              </a:rPr>
+              <a:t>Ejercicio 2: Memoria asociativa · 2.1 Hopfield: letras 5×5 y códigos QR</a:t>
+            </a:r>
+          </a:p>
+        </p:txBody>
+      </p:sp>
+      <p:sp>
+        <p:nvSpPr>
+          <p:cNvPr id="3" name="TextBox 2"/>
+          <p:cNvSpPr txBox="1"/>
+          <p:nvPr/>
+        </p:nvSpPr>
+        <p:spPr>
+          <a:xfrm>
+            <a:off x="658368" y="411480"/>
+            <a:ext cx="13258800" cy="822960"/>
+          </a:xfrm>
+          <a:prstGeom prst="rect">
+            <a:avLst/>
+          </a:prstGeom>
+          <a:noFill/>
+        </p:spPr>
+        <p:txBody>
+          <a:bodyPr wrap="square" lIns="0" rIns="0" tIns="0" bIns="0">
+            <a:spAutoFit/>
+          </a:bodyPr>
+          <a:lstStyle/>
+          <a:p>
+            <a:pPr>
+              <a:spcAft>
+                <a:spcPts val="500"/>
+              </a:spcAft>
+              <a:defRPr sz="3200" b="1">
+                <a:solidFill>
+                  <a:srgbClr val="18242C"/>
+                </a:solidFill>
+                <a:latin typeface="Arial"/>
+              </a:defRPr>
+            </a:pPr>
+            <a:r>
+              <a:rPr sz="3200" b="1">
+                <a:solidFill>
+                  <a:srgbClr val="18242C"/>
+                </a:solidFill>
+                <a:latin typeface="Arial"/>
+              </a:rPr>
+              <a:t>Al reducir la carga, estos QR sí se recuperan</a:t>
+            </a:r>
+          </a:p>
+        </p:txBody>
+      </p:sp>
+      <p:sp>
+        <p:nvSpPr>
+          <p:cNvPr id="4" name="TextBox 3"/>
+          <p:cNvSpPr txBox="1"/>
+          <p:nvPr/>
+        </p:nvSpPr>
+        <p:spPr>
+          <a:xfrm>
+            <a:off x="658368" y="7818120"/>
+            <a:ext cx="2743200" cy="228600"/>
+          </a:xfrm>
+          <a:prstGeom prst="rect">
+            <a:avLst/>
+          </a:prstGeom>
+          <a:noFill/>
+        </p:spPr>
+        <p:txBody>
+          <a:bodyPr wrap="square" lIns="0" rIns="0" tIns="0" bIns="0">
+            <a:spAutoFit/>
+          </a:bodyPr>
+          <a:lstStyle/>
+          <a:p>
+            <a:pPr>
+              <a:spcAft>
+                <a:spcPts val="500"/>
+              </a:spcAft>
+              <a:defRPr sz="1200" b="0">
+                <a:solidFill>
+                  <a:srgbClr val="5E6B73"/>
+                </a:solidFill>
+                <a:latin typeface="Arial"/>
+              </a:defRPr>
+            </a:pPr>
+            <a:r>
+              <a:rPr sz="1200" b="0">
+                <a:solidFill>
+                  <a:srgbClr val="5E6B73"/>
+                </a:solidFill>
+                <a:latin typeface="Arial"/>
+              </a:rPr>
+              <a:t>TP4 · Grupo 3</a:t>
+            </a:r>
+          </a:p>
+        </p:txBody>
+      </p:sp>
+      <p:sp>
+        <p:nvSpPr>
+          <p:cNvPr id="5" name="TextBox 4"/>
+          <p:cNvSpPr txBox="1"/>
+          <p:nvPr/>
+        </p:nvSpPr>
+        <p:spPr>
+          <a:xfrm>
+            <a:off x="13441680" y="7772400"/>
+            <a:ext cx="548640" cy="274320"/>
+          </a:xfrm>
+          <a:prstGeom prst="rect">
+            <a:avLst/>
+          </a:prstGeom>
+          <a:noFill/>
+        </p:spPr>
+        <p:txBody>
+          <a:bodyPr wrap="square" lIns="0" rIns="0" tIns="0" bIns="0">
+            <a:spAutoFit/>
+          </a:bodyPr>
+          <a:lstStyle/>
+          <a:p>
+            <a:pPr algn="r">
+              <a:spcAft>
+                <a:spcPts val="500"/>
+              </a:spcAft>
+              <a:defRPr sz="1300" b="0">
+                <a:solidFill>
+                  <a:srgbClr val="5E6B73"/>
+                </a:solidFill>
+                <a:latin typeface="Arial"/>
+              </a:defRPr>
+            </a:pPr>
+            <a:r>
+              <a:rPr sz="1300" b="0">
+                <a:solidFill>
+                  <a:srgbClr val="5E6B73"/>
+                </a:solidFill>
+                <a:latin typeface="Arial"/>
+              </a:rPr>
+              <a:t>34</a:t>
+            </a:r>
+          </a:p>
+        </p:txBody>
+      </p:sp>
+      <p:pic>
+        <p:nvPicPr>
+          <p:cNvPr id="6" name="Picture 5" descr="qr_controls.png"/>
+          <p:cNvPicPr>
+            <a:picLocks noChangeAspect="1"/>
+          </p:cNvPicPr>
+          <p:nvPr/>
+        </p:nvPicPr>
+        <p:blipFill>
+          <a:blip r:embed="rId3"/>
+          <a:stretch>
+            <a:fillRect/>
+          </a:stretch>
+        </p:blipFill>
+        <p:spPr>
+          <a:xfrm>
+            <a:off x="731520" y="1892043"/>
+            <a:ext cx="13167360" cy="4811273"/>
+          </a:xfrm>
+          <a:prstGeom prst="rect">
+            <a:avLst/>
+          </a:prstGeom>
+        </p:spPr>
+      </p:pic>
+      <p:sp>
+        <p:nvSpPr>
+          <p:cNvPr id="7" name="TextBox 6"/>
+          <p:cNvSpPr txBox="1"/>
+          <p:nvPr/>
+        </p:nvSpPr>
+        <p:spPr>
+          <a:xfrm>
+            <a:off x="777240" y="7269480"/>
+            <a:ext cx="12984480" cy="411480"/>
+          </a:xfrm>
+          <a:prstGeom prst="rect">
+            <a:avLst/>
+          </a:prstGeom>
+          <a:noFill/>
+        </p:spPr>
+        <p:txBody>
+          <a:bodyPr wrap="square" lIns="0" rIns="0" tIns="0" bIns="0">
+            <a:spAutoFit/>
+          </a:bodyPr>
+          <a:lstStyle/>
+          <a:p>
+            <a:pPr>
+              <a:spcAft>
+                <a:spcPts val="500"/>
+              </a:spcAft>
+              <a:defRPr sz="2000" b="0">
+                <a:solidFill>
+                  <a:srgbClr val="5E6B73"/>
+                </a:solidFill>
+                <a:latin typeface="Arial"/>
+              </a:defRPr>
+            </a:pPr>
+            <a:r>
+              <a:rPr sz="2000" b="0">
+                <a:solidFill>
+                  <a:srgbClr val="5E6B73"/>
+                </a:solidFill>
+                <a:latin typeface="Arial"/>
+              </a:rPr>
+              <a:t>Mismos originales, distinta cantidad almacenada por red</a:t>
+            </a:r>
+          </a:p>
+        </p:txBody>
+      </p:sp>
+    </p:spTree>
+  </p:cSld>
+  <p:clrMapOvr>
+    <a:masterClrMapping/>
+  </p:clrMapOvr>
+</p:sld>
+</file>
+
+<file path=ppt/slides/slide35.xml><?xml version="1.0" encoding="utf-8"?>
+<p:sld xmlns:a="http://schemas.openxmlformats.org/drawingml/2006/main" xmlns:p="http://schemas.openxmlformats.org/presentationml/2006/main" xmlns:r="http://schemas.openxmlformats.org/officeDocument/2006/relationships">
+  <p:cSld>
+    <p:bg>
+      <p:bgPr>
+        <a:solidFill>
+          <a:srgbClr val="FFFFFF"/>
+        </a:solidFill>
+        <a:effectLst/>
+      </p:bgPr>
+    </p:bg>
+    <p:spTree>
+      <p:nvGrpSpPr>
+        <p:cNvPr id="1" name=""/>
+        <p:cNvGrpSpPr/>
+        <p:nvPr/>
+      </p:nvGrpSpPr>
+      <p:grpSpPr/>
+      <p:sp>
+        <p:nvSpPr>
+          <p:cNvPr id="2" name="TextBox 1"/>
+          <p:cNvSpPr txBox="1"/>
+          <p:nvPr/>
+        </p:nvSpPr>
+        <p:spPr>
+          <a:xfrm>
+            <a:off x="658368" y="109728"/>
+            <a:ext cx="13258800" cy="274320"/>
+          </a:xfrm>
+          <a:prstGeom prst="rect">
+            <a:avLst/>
+          </a:prstGeom>
+          <a:noFill/>
+        </p:spPr>
+        <p:txBody>
+          <a:bodyPr wrap="square" lIns="0" rIns="0" tIns="0" bIns="0">
+            <a:spAutoFit/>
+          </a:bodyPr>
+          <a:lstStyle/>
+          <a:p>
+            <a:pPr>
+              <a:spcAft>
+                <a:spcPts val="500"/>
+              </a:spcAft>
+              <a:defRPr sz="1500" b="0">
+                <a:solidFill>
+                  <a:srgbClr val="5E6B73"/>
+                </a:solidFill>
+                <a:latin typeface="Arial"/>
+              </a:defRPr>
+            </a:pPr>
+            <a:r>
+              <a:rPr sz="1500" b="0">
+                <a:solidFill>
+                  <a:srgbClr val="5E6B73"/>
+                </a:solidFill>
+                <a:latin typeface="Arial"/>
+              </a:rPr>
+              <a:t>Ejercicio 2: Memoria asociativa · 2.1 Hopfield: letras 5×5 y códigos QR</a:t>
+            </a:r>
+          </a:p>
+        </p:txBody>
+      </p:sp>
+      <p:sp>
+        <p:nvSpPr>
+          <p:cNvPr id="3" name="TextBox 2"/>
+          <p:cNvSpPr txBox="1"/>
+          <p:nvPr/>
+        </p:nvSpPr>
+        <p:spPr>
+          <a:xfrm>
+            <a:off x="658368" y="411480"/>
+            <a:ext cx="13258800" cy="822960"/>
+          </a:xfrm>
+          <a:prstGeom prst="rect">
+            <a:avLst/>
+          </a:prstGeom>
+          <a:noFill/>
+        </p:spPr>
+        <p:txBody>
+          <a:bodyPr wrap="square" lIns="0" rIns="0" tIns="0" bIns="0">
+            <a:spAutoFit/>
+          </a:bodyPr>
+          <a:lstStyle/>
+          <a:p>
+            <a:pPr>
+              <a:spcAft>
+                <a:spcPts val="500"/>
+              </a:spcAft>
+              <a:defRPr sz="3200" b="1">
+                <a:solidFill>
+                  <a:srgbClr val="18242C"/>
+                </a:solidFill>
+                <a:latin typeface="Arial"/>
+              </a:defRPr>
+            </a:pPr>
+            <a:r>
+              <a:rPr sz="3200" b="1">
+                <a:solidFill>
+                  <a:srgbClr val="18242C"/>
+                </a:solidFill>
+                <a:latin typeface="Arial"/>
+              </a:rPr>
+              <a:t>Recuperar el patrón y leer la URL son pruebas distintas</a:t>
+            </a:r>
+          </a:p>
+        </p:txBody>
+      </p:sp>
+      <p:sp>
+        <p:nvSpPr>
+          <p:cNvPr id="4" name="TextBox 3"/>
+          <p:cNvSpPr txBox="1"/>
+          <p:nvPr/>
+        </p:nvSpPr>
+        <p:spPr>
+          <a:xfrm>
+            <a:off x="658368" y="7818120"/>
+            <a:ext cx="2743200" cy="228600"/>
+          </a:xfrm>
+          <a:prstGeom prst="rect">
+            <a:avLst/>
+          </a:prstGeom>
+          <a:noFill/>
+        </p:spPr>
+        <p:txBody>
+          <a:bodyPr wrap="square" lIns="0" rIns="0" tIns="0" bIns="0">
+            <a:spAutoFit/>
+          </a:bodyPr>
+          <a:lstStyle/>
+          <a:p>
+            <a:pPr>
+              <a:spcAft>
+                <a:spcPts val="500"/>
+              </a:spcAft>
+              <a:defRPr sz="1200" b="0">
+                <a:solidFill>
+                  <a:srgbClr val="5E6B73"/>
+                </a:solidFill>
+                <a:latin typeface="Arial"/>
+              </a:defRPr>
+            </a:pPr>
+            <a:r>
+              <a:rPr sz="1200" b="0">
+                <a:solidFill>
+                  <a:srgbClr val="5E6B73"/>
+                </a:solidFill>
+                <a:latin typeface="Arial"/>
+              </a:rPr>
+              <a:t>TP4 · Grupo 3</a:t>
+            </a:r>
+          </a:p>
+        </p:txBody>
+      </p:sp>
+      <p:sp>
+        <p:nvSpPr>
+          <p:cNvPr id="5" name="TextBox 4"/>
+          <p:cNvSpPr txBox="1"/>
+          <p:nvPr/>
+        </p:nvSpPr>
+        <p:spPr>
+          <a:xfrm>
+            <a:off x="13441680" y="7772400"/>
+            <a:ext cx="548640" cy="274320"/>
+          </a:xfrm>
+          <a:prstGeom prst="rect">
+            <a:avLst/>
+          </a:prstGeom>
+          <a:noFill/>
+        </p:spPr>
+        <p:txBody>
+          <a:bodyPr wrap="square" lIns="0" rIns="0" tIns="0" bIns="0">
+            <a:spAutoFit/>
+          </a:bodyPr>
+          <a:lstStyle/>
+          <a:p>
+            <a:pPr algn="r">
+              <a:spcAft>
+                <a:spcPts val="500"/>
+              </a:spcAft>
+              <a:defRPr sz="1300" b="0">
+                <a:solidFill>
+                  <a:srgbClr val="5E6B73"/>
+                </a:solidFill>
+                <a:latin typeface="Arial"/>
+              </a:defRPr>
+            </a:pPr>
+            <a:r>
+              <a:rPr sz="1300" b="0">
+                <a:solidFill>
+                  <a:srgbClr val="5E6B73"/>
+                </a:solidFill>
+                <a:latin typeface="Arial"/>
+              </a:rPr>
+              <a:t>35</a:t>
+            </a:r>
+          </a:p>
+        </p:txBody>
+      </p:sp>
+      <p:pic>
+        <p:nvPicPr>
+          <p:cNvPr id="6" name="Picture 5" descr="qr_reader.png"/>
+          <p:cNvPicPr>
+            <a:picLocks noChangeAspect="1"/>
+          </p:cNvPicPr>
+          <p:nvPr/>
+        </p:nvPicPr>
+        <p:blipFill>
+          <a:blip r:embed="rId3"/>
+          <a:stretch>
+            <a:fillRect/>
+          </a:stretch>
+        </p:blipFill>
+        <p:spPr>
+          <a:xfrm>
             <a:off x="731520" y="1587558"/>
             <a:ext cx="13167360" cy="5420243"/>
           </a:xfrm>
@@ -15643,6 +17588,749 @@
                 <a:latin typeface="Arial"/>
               </a:rPr>
               <a:t>Matrices alineadas de 37×37; fotografías reales quedan fuera de esta prueba</a:t>
+            </a:r>
+          </a:p>
+        </p:txBody>
+      </p:sp>
+    </p:spTree>
+  </p:cSld>
+  <p:clrMapOvr>
+    <a:masterClrMapping/>
+  </p:clrMapOvr>
+</p:sld>
+</file>
+
+<file path=ppt/slides/slide36.xml><?xml version="1.0" encoding="utf-8"?>
+<p:sld xmlns:a="http://schemas.openxmlformats.org/drawingml/2006/main" xmlns:p="http://schemas.openxmlformats.org/presentationml/2006/main" xmlns:r="http://schemas.openxmlformats.org/officeDocument/2006/relationships">
+  <p:cSld>
+    <p:bg>
+      <p:bgPr>
+        <a:solidFill>
+          <a:srgbClr val="FFFFFF"/>
+        </a:solidFill>
+        <a:effectLst/>
+      </p:bgPr>
+    </p:bg>
+    <p:spTree>
+      <p:nvGrpSpPr>
+        <p:cNvPr id="1" name=""/>
+        <p:cNvGrpSpPr/>
+        <p:nvPr/>
+      </p:nvGrpSpPr>
+      <p:grpSpPr/>
+      <p:sp>
+        <p:nvSpPr>
+          <p:cNvPr id="2" name="TextBox 1"/>
+          <p:cNvSpPr txBox="1"/>
+          <p:nvPr/>
+        </p:nvSpPr>
+        <p:spPr>
+          <a:xfrm>
+            <a:off x="658368" y="109728"/>
+            <a:ext cx="13258800" cy="274320"/>
+          </a:xfrm>
+          <a:prstGeom prst="rect">
+            <a:avLst/>
+          </a:prstGeom>
+          <a:noFill/>
+        </p:spPr>
+        <p:txBody>
+          <a:bodyPr wrap="square" lIns="0" rIns="0" tIns="0" bIns="0">
+            <a:spAutoFit/>
+          </a:bodyPr>
+          <a:lstStyle/>
+          <a:p>
+            <a:pPr>
+              <a:spcAft>
+                <a:spcPts val="500"/>
+              </a:spcAft>
+              <a:defRPr sz="1500" b="0">
+                <a:solidFill>
+                  <a:srgbClr val="5E6B73"/>
+                </a:solidFill>
+                <a:latin typeface="Arial"/>
+              </a:defRPr>
+            </a:pPr>
+            <a:r>
+              <a:rPr sz="1500" b="0">
+                <a:solidFill>
+                  <a:srgbClr val="5E6B73"/>
+                </a:solidFill>
+                <a:latin typeface="Arial"/>
+              </a:rPr>
+              <a:t>Ejercicio 2: Memoria asociativa · 2.1 Hopfield: letras 5×5 y códigos QR</a:t>
+            </a:r>
+          </a:p>
+        </p:txBody>
+      </p:sp>
+      <p:sp>
+        <p:nvSpPr>
+          <p:cNvPr id="3" name="TextBox 2"/>
+          <p:cNvSpPr txBox="1"/>
+          <p:nvPr/>
+        </p:nvSpPr>
+        <p:spPr>
+          <a:xfrm>
+            <a:off x="658368" y="411480"/>
+            <a:ext cx="13258800" cy="822960"/>
+          </a:xfrm>
+          <a:prstGeom prst="rect">
+            <a:avLst/>
+          </a:prstGeom>
+          <a:noFill/>
+        </p:spPr>
+        <p:txBody>
+          <a:bodyPr wrap="square" lIns="0" rIns="0" tIns="0" bIns="0">
+            <a:spAutoFit/>
+          </a:bodyPr>
+          <a:lstStyle/>
+          <a:p>
+            <a:pPr>
+              <a:spcAft>
+                <a:spcPts val="500"/>
+              </a:spcAft>
+              <a:defRPr sz="3200" b="1">
+                <a:solidFill>
+                  <a:srgbClr val="18242C"/>
+                </a:solidFill>
+                <a:latin typeface="Arial"/>
+              </a:defRPr>
+            </a:pPr>
+            <a:r>
+              <a:rPr sz="3200" b="1">
+                <a:solidFill>
+                  <a:srgbClr val="18242C"/>
+                </a:solidFill>
+                <a:latin typeface="Arial"/>
+              </a:rPr>
+              <a:t>Limitaciones: interferencia, daño simulado y menús fijos</a:t>
+            </a:r>
+          </a:p>
+        </p:txBody>
+      </p:sp>
+      <p:sp>
+        <p:nvSpPr>
+          <p:cNvPr id="4" name="TextBox 3"/>
+          <p:cNvSpPr txBox="1"/>
+          <p:nvPr/>
+        </p:nvSpPr>
+        <p:spPr>
+          <a:xfrm>
+            <a:off x="658368" y="7818120"/>
+            <a:ext cx="2743200" cy="228600"/>
+          </a:xfrm>
+          <a:prstGeom prst="rect">
+            <a:avLst/>
+          </a:prstGeom>
+          <a:noFill/>
+        </p:spPr>
+        <p:txBody>
+          <a:bodyPr wrap="square" lIns="0" rIns="0" tIns="0" bIns="0">
+            <a:spAutoFit/>
+          </a:bodyPr>
+          <a:lstStyle/>
+          <a:p>
+            <a:pPr>
+              <a:spcAft>
+                <a:spcPts val="500"/>
+              </a:spcAft>
+              <a:defRPr sz="1200" b="0">
+                <a:solidFill>
+                  <a:srgbClr val="5E6B73"/>
+                </a:solidFill>
+                <a:latin typeface="Arial"/>
+              </a:defRPr>
+            </a:pPr>
+            <a:r>
+              <a:rPr sz="1200" b="0">
+                <a:solidFill>
+                  <a:srgbClr val="5E6B73"/>
+                </a:solidFill>
+                <a:latin typeface="Arial"/>
+              </a:rPr>
+              <a:t>TP4 · Grupo 3</a:t>
+            </a:r>
+          </a:p>
+        </p:txBody>
+      </p:sp>
+      <p:sp>
+        <p:nvSpPr>
+          <p:cNvPr id="5" name="TextBox 4"/>
+          <p:cNvSpPr txBox="1"/>
+          <p:nvPr/>
+        </p:nvSpPr>
+        <p:spPr>
+          <a:xfrm>
+            <a:off x="13441680" y="7772400"/>
+            <a:ext cx="548640" cy="274320"/>
+          </a:xfrm>
+          <a:prstGeom prst="rect">
+            <a:avLst/>
+          </a:prstGeom>
+          <a:noFill/>
+        </p:spPr>
+        <p:txBody>
+          <a:bodyPr wrap="square" lIns="0" rIns="0" tIns="0" bIns="0">
+            <a:spAutoFit/>
+          </a:bodyPr>
+          <a:lstStyle/>
+          <a:p>
+            <a:pPr algn="r">
+              <a:spcAft>
+                <a:spcPts val="500"/>
+              </a:spcAft>
+              <a:defRPr sz="1300" b="0">
+                <a:solidFill>
+                  <a:srgbClr val="5E6B73"/>
+                </a:solidFill>
+                <a:latin typeface="Arial"/>
+              </a:defRPr>
+            </a:pPr>
+            <a:r>
+              <a:rPr sz="1300" b="0">
+                <a:solidFill>
+                  <a:srgbClr val="5E6B73"/>
+                </a:solidFill>
+                <a:latin typeface="Arial"/>
+              </a:rPr>
+              <a:t>36</a:t>
+            </a:r>
+          </a:p>
+        </p:txBody>
+      </p:sp>
+      <p:sp>
+        <p:nvSpPr>
+          <p:cNvPr id="6" name="TextBox 5"/>
+          <p:cNvSpPr txBox="1"/>
+          <p:nvPr/>
+        </p:nvSpPr>
+        <p:spPr>
+          <a:xfrm>
+            <a:off x="822960" y="1554480"/>
+            <a:ext cx="4206240" cy="914400"/>
+          </a:xfrm>
+          <a:prstGeom prst="rect">
+            <a:avLst/>
+          </a:prstGeom>
+          <a:noFill/>
+        </p:spPr>
+        <p:txBody>
+          <a:bodyPr wrap="square" lIns="0" rIns="0" tIns="0" bIns="0">
+            <a:spAutoFit/>
+          </a:bodyPr>
+          <a:lstStyle/>
+          <a:p>
+            <a:pPr>
+              <a:spcAft>
+                <a:spcPts val="500"/>
+              </a:spcAft>
+              <a:defRPr sz="2200" b="1">
+                <a:solidFill>
+                  <a:srgbClr val="18242C"/>
+                </a:solidFill>
+                <a:latin typeface="Arial"/>
+              </a:defRPr>
+            </a:pPr>
+            <a:r>
+              <a:rPr sz="2200" b="1">
+                <a:solidFill>
+                  <a:srgbClr val="18242C"/>
+                </a:solidFill>
+                <a:latin typeface="Arial"/>
+              </a:rPr>
+              <a:t>Interferencia</a:t>
+            </a:r>
+          </a:p>
+        </p:txBody>
+      </p:sp>
+      <p:sp>
+        <p:nvSpPr>
+          <p:cNvPr id="7" name="TextBox 6"/>
+          <p:cNvSpPr txBox="1"/>
+          <p:nvPr/>
+        </p:nvSpPr>
+        <p:spPr>
+          <a:xfrm>
+            <a:off x="5212080" y="1554480"/>
+            <a:ext cx="8595360" cy="1005840"/>
+          </a:xfrm>
+          <a:prstGeom prst="rect">
+            <a:avLst/>
+          </a:prstGeom>
+          <a:noFill/>
+        </p:spPr>
+        <p:txBody>
+          <a:bodyPr wrap="square" lIns="0" rIns="0" tIns="0" bIns="0">
+            <a:spAutoFit/>
+          </a:bodyPr>
+          <a:lstStyle/>
+          <a:p>
+            <a:pPr>
+              <a:spcAft>
+                <a:spcPts val="500"/>
+              </a:spcAft>
+              <a:defRPr sz="2100" b="0">
+                <a:solidFill>
+                  <a:srgbClr val="176B72"/>
+                </a:solidFill>
+                <a:latin typeface="Arial"/>
+              </a:defRPr>
+            </a:pPr>
+            <a:r>
+              <a:rPr sz="2100" b="0">
+                <a:solidFill>
+                  <a:srgbClr val="176B72"/>
+                </a:solidFill>
+                <a:latin typeface="Arial"/>
+              </a:rPr>
+              <a:t>0 de 5 estables: comparten 955 de 1369 módulos y 0,15 N no aplica</a:t>
+            </a:r>
+          </a:p>
+        </p:txBody>
+      </p:sp>
+      <p:sp>
+        <p:nvSpPr>
+          <p:cNvPr id="8" name="Rectangle 7"/>
+          <p:cNvSpPr/>
+          <p:nvPr/>
+        </p:nvSpPr>
+        <p:spPr>
+          <a:xfrm>
+            <a:off x="822960" y="2468879"/>
+            <a:ext cx="12984480" cy="18288"/>
+          </a:xfrm>
+          <a:prstGeom prst="rect">
+            <a:avLst/>
+          </a:prstGeom>
+          <a:solidFill>
+            <a:srgbClr val="DDE3E5"/>
+          </a:solidFill>
+          <a:ln>
+            <a:noFill/>
+          </a:ln>
+          <a:effectLst/>
+        </p:spPr>
+        <p:style>
+          <a:lnRef idx="1">
+            <a:schemeClr val="accent1"/>
+          </a:lnRef>
+          <a:fillRef idx="3">
+            <a:schemeClr val="accent1"/>
+          </a:fillRef>
+          <a:effectRef idx="2">
+            <a:schemeClr val="accent1"/>
+          </a:effectRef>
+          <a:fontRef idx="minor">
+            <a:schemeClr val="lt1"/>
+          </a:fontRef>
+        </p:style>
+        <p:txBody>
+          <a:bodyPr rtlCol="0" anchor="ctr"/>
+          <a:lstStyle/>
+          <a:p>
+            <a:pPr algn="ctr"/>
+          </a:p>
+        </p:txBody>
+      </p:sp>
+      <p:sp>
+        <p:nvSpPr>
+          <p:cNvPr id="9" name="TextBox 8"/>
+          <p:cNvSpPr txBox="1"/>
+          <p:nvPr/>
+        </p:nvSpPr>
+        <p:spPr>
+          <a:xfrm>
+            <a:off x="822960" y="2651760"/>
+            <a:ext cx="4206240" cy="914400"/>
+          </a:xfrm>
+          <a:prstGeom prst="rect">
+            <a:avLst/>
+          </a:prstGeom>
+          <a:noFill/>
+        </p:spPr>
+        <p:txBody>
+          <a:bodyPr wrap="square" lIns="0" rIns="0" tIns="0" bIns="0">
+            <a:spAutoFit/>
+          </a:bodyPr>
+          <a:lstStyle/>
+          <a:p>
+            <a:pPr>
+              <a:spcAft>
+                <a:spcPts val="500"/>
+              </a:spcAft>
+              <a:defRPr sz="2200" b="1">
+                <a:solidFill>
+                  <a:srgbClr val="18242C"/>
+                </a:solidFill>
+                <a:latin typeface="Arial"/>
+              </a:defRPr>
+            </a:pPr>
+            <a:r>
+              <a:rPr sz="2200" b="1">
+                <a:solidFill>
+                  <a:srgbClr val="18242C"/>
+                </a:solidFill>
+                <a:latin typeface="Arial"/>
+              </a:rPr>
+              <a:t>Daño simulado</a:t>
+            </a:r>
+          </a:p>
+        </p:txBody>
+      </p:sp>
+      <p:sp>
+        <p:nvSpPr>
+          <p:cNvPr id="10" name="TextBox 9"/>
+          <p:cNvSpPr txBox="1"/>
+          <p:nvPr/>
+        </p:nvSpPr>
+        <p:spPr>
+          <a:xfrm>
+            <a:off x="5212080" y="2651760"/>
+            <a:ext cx="8595360" cy="1005840"/>
+          </a:xfrm>
+          <a:prstGeom prst="rect">
+            <a:avLst/>
+          </a:prstGeom>
+          <a:noFill/>
+        </p:spPr>
+        <p:txBody>
+          <a:bodyPr wrap="square" lIns="0" rIns="0" tIns="0" bIns="0">
+            <a:spAutoFit/>
+          </a:bodyPr>
+          <a:lstStyle/>
+          <a:p>
+            <a:pPr>
+              <a:spcAft>
+                <a:spcPts val="500"/>
+              </a:spcAft>
+              <a:defRPr sz="2100" b="0">
+                <a:solidFill>
+                  <a:srgbClr val="176B72"/>
+                </a:solidFill>
+                <a:latin typeface="Arial"/>
+              </a:defRPr>
+            </a:pPr>
+            <a:r>
+              <a:rPr sz="2100" b="0">
+                <a:solidFill>
+                  <a:srgbClr val="176B72"/>
+                </a:solidFill>
+                <a:latin typeface="Arial"/>
+              </a:rPr>
+              <a:t>Solo matrices alineadas y ruido al azar; una foto real exige alinear y binarizar</a:t>
+            </a:r>
+          </a:p>
+        </p:txBody>
+      </p:sp>
+      <p:sp>
+        <p:nvSpPr>
+          <p:cNvPr id="11" name="Rectangle 10"/>
+          <p:cNvSpPr/>
+          <p:nvPr/>
+        </p:nvSpPr>
+        <p:spPr>
+          <a:xfrm>
+            <a:off x="822960" y="3566159"/>
+            <a:ext cx="12984480" cy="18288"/>
+          </a:xfrm>
+          <a:prstGeom prst="rect">
+            <a:avLst/>
+          </a:prstGeom>
+          <a:solidFill>
+            <a:srgbClr val="DDE3E5"/>
+          </a:solidFill>
+          <a:ln>
+            <a:noFill/>
+          </a:ln>
+          <a:effectLst/>
+        </p:spPr>
+        <p:style>
+          <a:lnRef idx="1">
+            <a:schemeClr val="accent1"/>
+          </a:lnRef>
+          <a:fillRef idx="3">
+            <a:schemeClr val="accent1"/>
+          </a:fillRef>
+          <a:effectRef idx="2">
+            <a:schemeClr val="accent1"/>
+          </a:effectRef>
+          <a:fontRef idx="minor">
+            <a:schemeClr val="lt1"/>
+          </a:fontRef>
+        </p:style>
+        <p:txBody>
+          <a:bodyPr rtlCol="0" anchor="ctr"/>
+          <a:lstStyle/>
+          <a:p>
+            <a:pPr algn="ctr"/>
+          </a:p>
+        </p:txBody>
+      </p:sp>
+      <p:sp>
+        <p:nvSpPr>
+          <p:cNvPr id="12" name="TextBox 11"/>
+          <p:cNvSpPr txBox="1"/>
+          <p:nvPr/>
+        </p:nvSpPr>
+        <p:spPr>
+          <a:xfrm>
+            <a:off x="822960" y="3749039"/>
+            <a:ext cx="4206240" cy="914400"/>
+          </a:xfrm>
+          <a:prstGeom prst="rect">
+            <a:avLst/>
+          </a:prstGeom>
+          <a:noFill/>
+        </p:spPr>
+        <p:txBody>
+          <a:bodyPr wrap="square" lIns="0" rIns="0" tIns="0" bIns="0">
+            <a:spAutoFit/>
+          </a:bodyPr>
+          <a:lstStyle/>
+          <a:p>
+            <a:pPr>
+              <a:spcAft>
+                <a:spcPts val="500"/>
+              </a:spcAft>
+              <a:defRPr sz="2200" b="1">
+                <a:solidFill>
+                  <a:srgbClr val="18242C"/>
+                </a:solidFill>
+                <a:latin typeface="Arial"/>
+              </a:defRPr>
+            </a:pPr>
+            <a:r>
+              <a:rPr sz="2200" b="1">
+                <a:solidFill>
+                  <a:srgbClr val="18242C"/>
+                </a:solidFill>
+                <a:latin typeface="Arial"/>
+              </a:rPr>
+              <a:t>Menús nuevos</a:t>
+            </a:r>
+          </a:p>
+        </p:txBody>
+      </p:sp>
+      <p:sp>
+        <p:nvSpPr>
+          <p:cNvPr id="13" name="TextBox 12"/>
+          <p:cNvSpPr txBox="1"/>
+          <p:nvPr/>
+        </p:nvSpPr>
+        <p:spPr>
+          <a:xfrm>
+            <a:off x="5212080" y="3749039"/>
+            <a:ext cx="8595360" cy="1005840"/>
+          </a:xfrm>
+          <a:prstGeom prst="rect">
+            <a:avLst/>
+          </a:prstGeom>
+          <a:noFill/>
+        </p:spPr>
+        <p:txBody>
+          <a:bodyPr wrap="square" lIns="0" rIns="0" tIns="0" bIns="0">
+            <a:spAutoFit/>
+          </a:bodyPr>
+          <a:lstStyle/>
+          <a:p>
+            <a:pPr>
+              <a:spcAft>
+                <a:spcPts val="500"/>
+              </a:spcAft>
+              <a:defRPr sz="2100" b="0">
+                <a:solidFill>
+                  <a:srgbClr val="176B72"/>
+                </a:solidFill>
+                <a:latin typeface="Arial"/>
+              </a:defRPr>
+            </a:pPr>
+            <a:r>
+              <a:rPr sz="2100" b="0">
+                <a:solidFill>
+                  <a:srgbClr val="176B72"/>
+                </a:solidFill>
+                <a:latin typeface="Arial"/>
+              </a:rPr>
+              <a:t>La red no los conoce: cambiar una carta exige recalcular W</a:t>
+            </a:r>
+          </a:p>
+        </p:txBody>
+      </p:sp>
+      <p:sp>
+        <p:nvSpPr>
+          <p:cNvPr id="14" name="Rectangle 13"/>
+          <p:cNvSpPr/>
+          <p:nvPr/>
+        </p:nvSpPr>
+        <p:spPr>
+          <a:xfrm>
+            <a:off x="822960" y="4663440"/>
+            <a:ext cx="12984480" cy="18288"/>
+          </a:xfrm>
+          <a:prstGeom prst="rect">
+            <a:avLst/>
+          </a:prstGeom>
+          <a:solidFill>
+            <a:srgbClr val="DDE3E5"/>
+          </a:solidFill>
+          <a:ln>
+            <a:noFill/>
+          </a:ln>
+          <a:effectLst/>
+        </p:spPr>
+        <p:style>
+          <a:lnRef idx="1">
+            <a:schemeClr val="accent1"/>
+          </a:lnRef>
+          <a:fillRef idx="3">
+            <a:schemeClr val="accent1"/>
+          </a:fillRef>
+          <a:effectRef idx="2">
+            <a:schemeClr val="accent1"/>
+          </a:effectRef>
+          <a:fontRef idx="minor">
+            <a:schemeClr val="lt1"/>
+          </a:fontRef>
+        </p:style>
+        <p:txBody>
+          <a:bodyPr rtlCol="0" anchor="ctr"/>
+          <a:lstStyle/>
+          <a:p>
+            <a:pPr algn="ctr"/>
+          </a:p>
+        </p:txBody>
+      </p:sp>
+      <p:sp>
+        <p:nvSpPr>
+          <p:cNvPr id="15" name="TextBox 14"/>
+          <p:cNvSpPr txBox="1"/>
+          <p:nvPr/>
+        </p:nvSpPr>
+        <p:spPr>
+          <a:xfrm>
+            <a:off x="822960" y="4846320"/>
+            <a:ext cx="4206240" cy="914400"/>
+          </a:xfrm>
+          <a:prstGeom prst="rect">
+            <a:avLst/>
+          </a:prstGeom>
+          <a:noFill/>
+        </p:spPr>
+        <p:txBody>
+          <a:bodyPr wrap="square" lIns="0" rIns="0" tIns="0" bIns="0">
+            <a:spAutoFit/>
+          </a:bodyPr>
+          <a:lstStyle/>
+          <a:p>
+            <a:pPr>
+              <a:spcAft>
+                <a:spcPts val="500"/>
+              </a:spcAft>
+              <a:defRPr sz="2200" b="1">
+                <a:solidFill>
+                  <a:srgbClr val="18242C"/>
+                </a:solidFill>
+                <a:latin typeface="Arial"/>
+              </a:defRPr>
+            </a:pPr>
+            <a:r>
+              <a:rPr sz="2200" b="1">
+                <a:solidFill>
+                  <a:srgbClr val="18242C"/>
+                </a:solidFill>
+                <a:latin typeface="Arial"/>
+              </a:rPr>
+              <a:t>Salida sin garantía</a:t>
+            </a:r>
+          </a:p>
+        </p:txBody>
+      </p:sp>
+      <p:sp>
+        <p:nvSpPr>
+          <p:cNvPr id="16" name="TextBox 15"/>
+          <p:cNvSpPr txBox="1"/>
+          <p:nvPr/>
+        </p:nvSpPr>
+        <p:spPr>
+          <a:xfrm>
+            <a:off x="5212080" y="4846320"/>
+            <a:ext cx="8595360" cy="1005840"/>
+          </a:xfrm>
+          <a:prstGeom prst="rect">
+            <a:avLst/>
+          </a:prstGeom>
+          <a:noFill/>
+        </p:spPr>
+        <p:txBody>
+          <a:bodyPr wrap="square" lIns="0" rIns="0" tIns="0" bIns="0">
+            <a:spAutoFit/>
+          </a:bodyPr>
+          <a:lstStyle/>
+          <a:p>
+            <a:pPr>
+              <a:spcAft>
+                <a:spcPts val="500"/>
+              </a:spcAft>
+              <a:defRPr sz="2100" b="0">
+                <a:solidFill>
+                  <a:srgbClr val="176B72"/>
+                </a:solidFill>
+                <a:latin typeface="Arial"/>
+              </a:defRPr>
+            </a:pPr>
+            <a:r>
+              <a:rPr sz="2100" b="0">
+                <a:solidFill>
+                  <a:srgbClr val="176B72"/>
+                </a:solidFill>
+                <a:latin typeface="Arial"/>
+              </a:rPr>
+              <a:t>Energía baja y pocos barridos no prueban el menú correcto</a:t>
+            </a:r>
+          </a:p>
+        </p:txBody>
+      </p:sp>
+      <p:sp>
+        <p:nvSpPr>
+          <p:cNvPr id="17" name="TextBox 16"/>
+          <p:cNvSpPr txBox="1"/>
+          <p:nvPr/>
+        </p:nvSpPr>
+        <p:spPr>
+          <a:xfrm>
+            <a:off x="822960" y="6126480"/>
+            <a:ext cx="12984480" cy="1097280"/>
+          </a:xfrm>
+          <a:prstGeom prst="rect">
+            <a:avLst/>
+          </a:prstGeom>
+          <a:noFill/>
+        </p:spPr>
+        <p:txBody>
+          <a:bodyPr wrap="square" lIns="0" rIns="0" tIns="0" bIns="0">
+            <a:spAutoFit/>
+          </a:bodyPr>
+          <a:lstStyle/>
+          <a:p>
+            <a:pPr>
+              <a:spcAft>
+                <a:spcPts val="500"/>
+              </a:spcAft>
+              <a:defRPr sz="2300" b="0">
+                <a:solidFill>
+                  <a:srgbClr val="176B72"/>
+                </a:solidFill>
+                <a:latin typeface="Arial"/>
+              </a:defRPr>
+            </a:pPr>
+            <a:r>
+              <a:rPr sz="2300" b="0">
+                <a:solidFill>
+                  <a:srgbClr val="176B72"/>
+                </a:solidFill>
+                <a:latin typeface="Arial"/>
+              </a:rPr>
+              <a:t>Un QR por red recupera 100% hasta 684 de 1369 módulos invertidos: el límite es la memoria conjunta</a:t>
             </a:r>
           </a:p>
         </p:txBody>

</xml_diff>